<commit_message>
Rebuild the IC deck with corrected PB-loss and exclusion wording
Co-Authored-By: Claude Opus 5.5 <noreply@anthropic.com>
Claude-Session: https://claude.ai/code/session_011Cy4jTfjKbxPfMRQvaZwVT
</commit_message>
<xml_diff>
--- a/projects/bora_bidding/out/Bora_Bid_IC.pptx
+++ b/projects/bora_bidding/out/Bora_Bid_IC.pptx
@@ -7142,7 +7142,7 @@
                 </a:solidFill>
                 <a:latin typeface="Aptos"/>
               </a:rPr>
-              <a:t>Post-tax, FEP share, EU turbine, base case (overbuild not built, BESS built, pro-rata PB call); RtB exit 31‑Dec‑2029. Zero bid = every commitment at its zero level.</a:t>
+              <a:t>Post-tax, FEP share, EU turbine, base case (overbuild not built, BESS built, PB lost pro rata to the shortfall); RtB exit 31‑Dec‑2029. Zero bid = every commitment at its zero level.</a:t>
             </a:r>
           </a:p>
           <a:p>
@@ -8229,7 +8229,7 @@
                           </a:solidFill>
                           <a:latin typeface="Aptos"/>
                         </a:rPr>
-                        <a:t>Not built: the cost is the larger PB and its pro-rata call.</a:t>
+                        <a:t>Not built: the cost is the larger PB, lost pro rata to the shortfall.</a:t>
                       </a:r>
                     </a:p>
                   </a:txBody>
@@ -8964,7 +8964,7 @@
                 </a:solidFill>
                 <a:latin typeface="Aptos"/>
               </a:rPr>
-              <a:t>Δ = zero bid plus that commitment alone, minus the zero bid. Zero levels: municipal 0, community 0, overbuild 0%, BESS 0%, PB 1.0x, yes/no items no. Δ deposits and guarantees = extra security posted, not a call. ÖSZ-6: 5 points at 2.0x (Kiírás X.4 bf, Annex 4). Brownfield (ÖSZ-7) is not offered.</a:t>
+              <a:t>Δ = zero bid plus that commitment alone, minus the zero bid. Zero levels: municipal 0, community 0, overbuild 0%, BESS 0%, PB 1.0x, yes/no items no. Δ deposits and guarantees = extra security posted, not a PB loss. ÖSZ-6: 5 points at 2.0x (Kiírás X.4 bf, Annex 4). Brownfield (ÖSZ-7) is not offered.</a:t>
             </a:r>
           </a:p>
           <a:p>
@@ -12317,7 +12317,7 @@
                           </a:solidFill>
                           <a:latin typeface="Aptos"/>
                         </a:rPr>
-                        <a:t>Memo, not in the commitment: PB call, overbuild not built</a:t>
+                        <a:t>Memo, not in the commitment: PB lost pro rata, overbuild not built</a:t>
                       </a:r>
                     </a:p>
                   </a:txBody>
@@ -12631,7 +12631,7 @@
           <a:lstStyle/>
           <a:p>
             <a:r>
-              <a:t>Main risk: the unbuilt overbuild – a PB call, a 3-year group exclusion and 33.8 / 28.6 MVA of connection right lost</a:t>
+              <a:t>Unbuilt overbuild: €1.4m / €1.1m of PB and 33.8 / 28.6 MVA of connection right lost pro rata; a full call is unresolved</a:t>
             </a:r>
           </a:p>
         </p:txBody>
@@ -12937,7 +12937,7 @@
                 </a:solidFill>
                 <a:latin typeface="Aptos"/>
               </a:rPr>
-              <a:t>The base COD and HTM returns include the pro-rata call; the lost MVA and any deduction from the RtB price are not in the returns.</a:t>
+              <a:t>The base COD and HTM returns include the pro-rata PB loss; the lost MVA, any RtB price deduction and a possible group exclusion are not in the returns.</a:t>
             </a:r>
           </a:p>
         </p:txBody>
@@ -12952,7 +12952,7 @@
         </p:nvGraphicFramePr>
         <p:xfrm>
           <a:off x="4498848" y="2240280"/>
-          <a:ext cx="13716000" cy="4160520"/>
+          <a:ext cx="13716000" cy="4489704"/>
         </p:xfrm>
         <a:graphic>
           <a:graphicData uri="http://schemas.openxmlformats.org/drawingml/2006/table">
@@ -12961,8 +12961,8 @@
                 <a:tableStyleId>{5C22544A-7EE6-4342-B048-85BDC9FD1C3A}</a:tableStyleId>
               </a:tblPr>
               <a:tblGrid>
-                <a:gridCol w="4023360"/>
-                <a:gridCol w="5486400"/>
+                <a:gridCol w="4572000"/>
+                <a:gridCol w="4937760"/>
                 <a:gridCol w="4206240"/>
               </a:tblGrid>
               <a:tr h="539496">
@@ -13036,7 +13036,7 @@
                   </a:tcPr>
                 </a:tc>
               </a:tr>
-              <a:tr h="603504">
+              <a:tr h="658368">
                 <a:tc>
                   <a:txBody>
                     <a:bodyPr/>
@@ -13050,7 +13050,7 @@
                           </a:solidFill>
                           <a:latin typeface="Aptos"/>
                         </a:rPr>
-                        <a:t>PB call on the unbuilt overbuild: pro rata (Kiírás XII.12) or full (XIII.17, GYIK Q72)</a:t>
+                        <a:t>Overbuild not built: PB lost pro rata to the shortfall above 10% (Kiírás XII.12; GYIK Q28/30/44) – base</a:t>
                       </a:r>
                     </a:p>
                   </a:txBody>
@@ -13073,7 +13073,7 @@
                           </a:solidFill>
                           <a:latin typeface="Aptos"/>
                         </a:rPr>
-                        <a:t>Pro rata €1.4m / €1.1m (base). Full call €7.0m / €6.1m: COD IRR 35.8% / 38.7%, HTM IRR 9.1% / 9.5%</a:t>
+                        <a:t>€1.4m / €1.1m, the PB on the extra MW.</a:t>
                       </a:r>
                     </a:p>
                   </a:txBody>
@@ -13094,7 +13094,7 @@
                           </a:solidFill>
                           <a:latin typeface="Aptos"/>
                         </a:rPr>
-                        <a:t>PB at the 1.0x minimum. Part of the call may be deducted from the RtB price.</a:t>
+                        <a:t>PB at the 1.0x minimum. Part of the loss may be deducted from the RtB price.</a:t>
                       </a:r>
                     </a:p>
                   </a:txBody>
@@ -13103,7 +13103,7 @@
                   </a:tcPr>
                 </a:tc>
               </a:tr>
-              <a:tr h="603504">
+              <a:tr h="658368">
                 <a:tc>
                   <a:txBody>
                     <a:bodyPr/>
@@ -13117,7 +13117,7 @@
                           </a:solidFill>
                           <a:latin typeface="Aptos"/>
                         </a:rPr>
-                        <a:t>3-year group exclusion (Kiírás VII.2 n, GYIK Q71)</a:t>
+                        <a:t>Full PB call if the points-commitment rule (Kiírás XIII.17; GYIK Q72) also applies to the overbuild – unresolved</a:t>
                       </a:r>
                     </a:p>
                   </a:txBody>
@@ -13140,7 +13140,7 @@
                           </a:solidFill>
                           <a:latin typeface="Aptos"/>
                         </a:rPr>
-                        <a:t>Any PB call triggers it, the base pro-rata call included, for both bids. The call falls after COD, so it is likely to hit the group then holding the SPV.</a:t>
+                        <a:t>€7.0m / €6.1m: COD IRR 35.8% / 38.7%, HTM IRR 9.1% / 9.5%.</a:t>
                       </a:r>
                     </a:p>
                   </a:txBody>
@@ -13161,7 +13161,7 @@
                           </a:solidFill>
                           <a:latin typeface="Aptos"/>
                         </a:rPr>
-                        <a:t>Allocate it in the RtB SPA.</a:t>
+                        <a:t>Downside case, not the base. PB at the minimum limits it.</a:t>
                       </a:r>
                     </a:p>
                   </a:txBody>
@@ -13170,7 +13170,7 @@
                   </a:tcPr>
                 </a:tc>
               </a:tr>
-              <a:tr h="603504">
+              <a:tr h="658368">
                 <a:tc>
                   <a:txBody>
                     <a:bodyPr/>
@@ -13184,7 +13184,7 @@
                           </a:solidFill>
                           <a:latin typeface="Aptos"/>
                         </a:rPr>
-                        <a:t>Connection right lost pro rata (Kiírás XII.12, GYIK Q28)</a:t>
+                        <a:t>3-year group exclusion (Kiírás VII.2 n; GYIK Q71)</a:t>
                       </a:r>
                     </a:p>
                   </a:txBody>
@@ -13207,7 +13207,7 @@
                           </a:solidFill>
                           <a:latin typeface="Aptos"/>
                         </a:rPr>
-                        <a:t>33.8 / 28.6 MVA; not reflected in generation or price.</a:t>
+                        <a:t>Possible if the PB is called; unclear whether a pro-rata loss counts as a call. A call after COD would likely hit the group then holding the SPV.</a:t>
                       </a:r>
                     </a:p>
                   </a:txBody>
@@ -13228,7 +13228,7 @@
                           </a:solidFill>
                           <a:latin typeface="Aptos"/>
                         </a:rPr>
-                        <a:t>The buyer can build the overbuild (card).</a:t>
+                        <a:t>Allocate it in the RtB SPA.</a:t>
                       </a:r>
                     </a:p>
                   </a:txBody>
@@ -13237,7 +13237,7 @@
                   </a:tcPr>
                 </a:tc>
               </a:tr>
-              <a:tr h="603504">
+              <a:tr h="658368">
                 <a:tc>
                   <a:txBody>
                     <a:bodyPr/>
@@ -13251,7 +13251,7 @@
                           </a:solidFill>
                           <a:latin typeface="Aptos"/>
                         </a:rPr>
-                        <a:t>100 MVA group cap per node (Kiírás V.7, GYIK Q52)</a:t>
+                        <a:t>Connection right lost pro rata (GYIK Q28/30)</a:t>
                       </a:r>
                     </a:p>
                   </a:txBody>
@@ -13274,7 +13274,7 @@
                           </a:solidFill>
                           <a:latin typeface="Aptos"/>
                         </a:rPr>
-                        <a:t>Both bids are invalid if FEP, A.RES and the SPVs count as one company group.</a:t>
+                        <a:t>33.8 / 28.6 MVA, in the pro-rata reading only (GYIK Q72: a full call keeps the right). Not reflected in generation or price.</a:t>
                       </a:r>
                     </a:p>
                   </a:txBody>
@@ -13295,7 +13295,7 @@
                           </a:solidFill>
                           <a:latin typeface="Aptos"/>
                         </a:rPr>
-                        <a:t>Legal confirmation before submission.</a:t>
+                        <a:t>The buyer can build the overbuild (card).</a:t>
                       </a:r>
                     </a:p>
                   </a:txBody>
@@ -13304,7 +13304,7 @@
                   </a:tcPr>
                 </a:tc>
               </a:tr>
-              <a:tr h="603504">
+              <a:tr h="658368">
                 <a:tc>
                   <a:txBody>
                     <a:bodyPr/>
@@ -13318,7 +13318,7 @@
                           </a:solidFill>
                           <a:latin typeface="Aptos"/>
                         </a:rPr>
-                        <a:t>ÖSZ-4 scored on installed wind (GYIK Q20)</a:t>
+                        <a:t>100 MVA group cap per node (Kiírás V.7; GYIK Q52)</a:t>
                       </a:r>
                     </a:p>
                   </a:txBody>
@@ -13341,7 +13341,7 @@
                           </a:solidFill>
                           <a:latin typeface="Aptos"/>
                         </a:rPr>
-                        <a:t>Points fall to 80.50 / 63.75; returns unchanged.</a:t>
+                        <a:t>Both bids are invalid if FEP, A.RES and the SPVs count as one company group.</a:t>
                       </a:r>
                     </a:p>
                   </a:txBody>
@@ -13362,7 +13362,7 @@
                           </a:solidFill>
                           <a:latin typeface="Aptos"/>
                         </a:rPr>
-                        <a:t>Ranking risk only; the commitment is the same.</a:t>
+                        <a:t>Legal confirmation before submission.</a:t>
                       </a:r>
                     </a:p>
                   </a:txBody>
@@ -13371,7 +13371,7 @@
                   </a:tcPr>
                 </a:tc>
               </a:tr>
-              <a:tr h="603504">
+              <a:tr h="658368">
                 <a:tc>
                   <a:txBody>
                     <a:bodyPr/>
@@ -13385,7 +13385,7 @@
                           </a:solidFill>
                           <a:latin typeface="Aptos"/>
                         </a:rPr>
-                        <a:t>BESS valued at cost only</a:t>
+                        <a:t>ÖSZ-4 scored on installed wind (GYIK Q20); BESS valued at cost only</a:t>
                       </a:r>
                     </a:p>
                   </a:txBody>
@@ -13408,7 +13408,7 @@
                           </a:solidFill>
                           <a:latin typeface="Aptos"/>
                         </a:rPr>
-                        <a:t>−6.5 / −5.1 pp of COD IRR, with no BESS revenue or sale value.</a:t>
+                        <a:t>Points 80.50 / 63.75, returns unchanged. BESS costs −6.5 / −5.1 pp of COD IRR with no BESS revenue.</a:t>
                       </a:r>
                     </a:p>
                   </a:txBody>
@@ -13429,7 +13429,7 @@
                           </a:solidFill>
                           <a:latin typeface="Aptos"/>
                         </a:rPr>
-                        <a:t>Conservative: any BESS revenue is upside.</a:t>
+                        <a:t>Ranking risk only. Any BESS revenue is upside.</a:t>
                       </a:r>
                     </a:p>
                   </a:txBody>
@@ -13450,7 +13450,7 @@
         </p:nvSpPr>
         <p:spPr>
           <a:xfrm>
-            <a:off x="4498848" y="6812280"/>
+            <a:off x="4498848" y="7360920"/>
             <a:ext cx="13716000" cy="1234440"/>
           </a:xfrm>
           <a:prstGeom prst="rect">
@@ -13549,7 +13549,7 @@
                 </a:solidFill>
                 <a:latin typeface="Aptos"/>
               </a:rPr>
-              <a:t>PB call tested 6 months after COD. Pro rata = shortfall share × the wind PB (GYIK Q28/Q30). Full-call and overbuild-built figures are alternative cases.</a:t>
+              <a:t>Shortfall tested 6 months after COD. Pro rata = shortfall share × the wind PB (GYIK Q28/30). The full-call and overbuild-built figures are alternative cases.</a:t>
             </a:r>
           </a:p>
           <a:p>

</xml_diff>

<commit_message>
Rebind the IC deck to the devex-style RtB waterfall with a two-bid total
Co-Authored-By: Claude Opus 5.5 <noreply@anthropic.com>
Claude-Session: https://claude.ai/code/session_011Cy4jTfjKbxPfMRQvaZwVT
</commit_message>
<xml_diff>
--- a/projects/bora_bidding/out/Bora_Bid_IC.pptx
+++ b/projects/bora_bidding/out/Bora_Bid_IC.pptx
@@ -9325,7 +9325,7 @@
                 </a:solidFill>
                 <a:latin typeface="Aptos"/>
               </a:rPr>
-              <a:t>FEP funds €24.9m per bid to 31‑Dec‑2029 and carries the PB guarantee. Of the €14.5m RtB price net of sale costs, FEP takes €11.1m / €11.1m.</a:t>
+              <a:t>Of the €15.0m exit premium per bid, FEP nets €8.4m / €8.4m and A.RES €3.4m / €3.4m; at a 100 k€/MVA premium FEP's RtB profit falls to €3.0m / €3.2m.</a:t>
             </a:r>
           </a:p>
         </p:txBody>
@@ -9340,7 +9340,7 @@
         </p:nvGraphicFramePr>
         <p:xfrm>
           <a:off x="4498848" y="2240280"/>
-          <a:ext cx="9015984" cy="4745736"/>
+          <a:ext cx="9125712" cy="5806440"/>
         </p:xfrm>
         <a:graphic>
           <a:graphicData uri="http://schemas.openxmlformats.org/drawingml/2006/table">
@@ -9349,10 +9349,11 @@
                 <a:tableStyleId>{5C22544A-7EE6-4342-B048-85BDC9FD1C3A}</a:tableStyleId>
               </a:tblPr>
               <a:tblGrid>
-                <a:gridCol w="4626864"/>
-                <a:gridCol w="1463040"/>
-                <a:gridCol w="1463040"/>
-                <a:gridCol w="1463040"/>
+                <a:gridCol w="4279392"/>
+                <a:gridCol w="731520"/>
+                <a:gridCol w="1371600"/>
+                <a:gridCol w="1371600"/>
+                <a:gridCol w="1371600"/>
               </a:tblGrid>
               <a:tr h="539496">
                 <a:tc>
@@ -9368,7 +9369,7 @@
                           </a:solidFill>
                           <a:latin typeface="Aptos"/>
                         </a:rPr>
-                        <a:t>Item</a:t>
+                        <a:t>RtB exit waterfall (paid)</a:t>
                       </a:r>
                     </a:p>
                   </a:txBody>
@@ -9447,8 +9448,31 @@
                     </a:solidFill>
                   </a:tcPr>
                 </a:tc>
+                <a:tc>
+                  <a:txBody>
+                    <a:bodyPr/>
+                    <a:lstStyle/>
+                    <a:p>
+                      <a:pPr algn="r"/>
+                      <a:r>
+                        <a:rPr sz="1300" b="1">
+                          <a:solidFill>
+                            <a:srgbClr val="FFFFFF"/>
+                          </a:solidFill>
+                          <a:latin typeface="Aptos"/>
+                        </a:rPr>
+                        <a:t>Total</a:t>
+                      </a:r>
+                    </a:p>
+                  </a:txBody>
+                  <a:tcPr marL="73152" marR="73152" marT="27432" marB="27432" anchor="ctr">
+                    <a:solidFill>
+                      <a:srgbClr val="00A651"/>
+                    </a:solidFill>
+                  </a:tcPr>
+                </a:tc>
               </a:tr>
-              <a:tr h="420624">
+              <a:tr h="329184">
                 <a:tc>
                   <a:txBody>
                     <a:bodyPr/>
@@ -9462,7 +9486,7 @@
                           </a:solidFill>
                           <a:latin typeface="Aptos"/>
                         </a:rPr>
-                        <a:t>RtB price</a:t>
+                        <a:t>Memo: buyer reimbursement (deposits, fees, land)</a:t>
                       </a:r>
                     </a:p>
                   </a:txBody>
@@ -9508,28 +9532,49 @@
                           </a:solidFill>
                           <a:latin typeface="Aptos"/>
                         </a:rPr>
-                        <a:t>15.0</a:t>
-                      </a:r>
-                    </a:p>
-                  </a:txBody>
-                  <a:tcPr marL="73152" marR="73152" marT="27432" marB="27432" anchor="ctr">
-                    <a:noFill/>
-                  </a:tcPr>
-                </a:tc>
-                <a:tc>
-                  <a:txBody>
-                    <a:bodyPr/>
-                    <a:lstStyle/>
-                    <a:p>
-                      <a:pPr algn="r"/>
-                      <a:r>
-                        <a:rPr sz="1300" b="0">
-                          <a:solidFill>
-                            <a:srgbClr val="3C3C3B"/>
-                          </a:solidFill>
-                          <a:latin typeface="Aptos"/>
-                        </a:rPr>
-                        <a:t>15.0</a:t>
+                        <a:t>21.8</a:t>
+                      </a:r>
+                    </a:p>
+                  </a:txBody>
+                  <a:tcPr marL="73152" marR="73152" marT="27432" marB="27432" anchor="ctr">
+                    <a:noFill/>
+                  </a:tcPr>
+                </a:tc>
+                <a:tc>
+                  <a:txBody>
+                    <a:bodyPr/>
+                    <a:lstStyle/>
+                    <a:p>
+                      <a:pPr algn="r"/>
+                      <a:r>
+                        <a:rPr sz="1300" b="0">
+                          <a:solidFill>
+                            <a:srgbClr val="3C3C3B"/>
+                          </a:solidFill>
+                          <a:latin typeface="Aptos"/>
+                        </a:rPr>
+                        <a:t>21.8</a:t>
+                      </a:r>
+                    </a:p>
+                  </a:txBody>
+                  <a:tcPr marL="73152" marR="73152" marT="27432" marB="27432" anchor="ctr">
+                    <a:noFill/>
+                  </a:tcPr>
+                </a:tc>
+                <a:tc>
+                  <a:txBody>
+                    <a:bodyPr/>
+                    <a:lstStyle/>
+                    <a:p>
+                      <a:pPr algn="r"/>
+                      <a:r>
+                        <a:rPr sz="1300" b="0">
+                          <a:solidFill>
+                            <a:srgbClr val="3C3C3B"/>
+                          </a:solidFill>
+                          <a:latin typeface="Aptos"/>
+                        </a:rPr>
+                        <a:t>43.7</a:t>
                       </a:r>
                     </a:p>
                   </a:txBody>
@@ -9538,7 +9583,7 @@
                   </a:tcPr>
                 </a:tc>
               </a:tr>
-              <a:tr h="420624">
+              <a:tr h="329184">
                 <a:tc>
                   <a:txBody>
                     <a:bodyPr/>
@@ -9552,7 +9597,7 @@
                           </a:solidFill>
                           <a:latin typeface="Aptos"/>
                         </a:rPr>
-                        <a:t>Receipts at the exit</a:t>
+                        <a:t>Exit premium (RtB price)</a:t>
                       </a:r>
                     </a:p>
                   </a:txBody>
@@ -9598,28 +9643,49 @@
                           </a:solidFill>
                           <a:latin typeface="Aptos"/>
                         </a:rPr>
-                        <a:t>32.9</a:t>
-                      </a:r>
-                    </a:p>
-                  </a:txBody>
-                  <a:tcPr marL="73152" marR="73152" marT="27432" marB="27432" anchor="ctr">
-                    <a:noFill/>
-                  </a:tcPr>
-                </a:tc>
-                <a:tc>
-                  <a:txBody>
-                    <a:bodyPr/>
-                    <a:lstStyle/>
-                    <a:p>
-                      <a:pPr algn="r"/>
-                      <a:r>
-                        <a:rPr sz="1300" b="0">
-                          <a:solidFill>
-                            <a:srgbClr val="3C3C3B"/>
-                          </a:solidFill>
-                          <a:latin typeface="Aptos"/>
-                        </a:rPr>
-                        <a:t>32.9</a:t>
+                        <a:t>15.0</a:t>
+                      </a:r>
+                    </a:p>
+                  </a:txBody>
+                  <a:tcPr marL="73152" marR="73152" marT="27432" marB="27432" anchor="ctr">
+                    <a:noFill/>
+                  </a:tcPr>
+                </a:tc>
+                <a:tc>
+                  <a:txBody>
+                    <a:bodyPr/>
+                    <a:lstStyle/>
+                    <a:p>
+                      <a:pPr algn="r"/>
+                      <a:r>
+                        <a:rPr sz="1300" b="0">
+                          <a:solidFill>
+                            <a:srgbClr val="3C3C3B"/>
+                          </a:solidFill>
+                          <a:latin typeface="Aptos"/>
+                        </a:rPr>
+                        <a:t>15.0</a:t>
+                      </a:r>
+                    </a:p>
+                  </a:txBody>
+                  <a:tcPr marL="73152" marR="73152" marT="27432" marB="27432" anchor="ctr">
+                    <a:noFill/>
+                  </a:tcPr>
+                </a:tc>
+                <a:tc>
+                  <a:txBody>
+                    <a:bodyPr/>
+                    <a:lstStyle/>
+                    <a:p>
+                      <a:pPr algn="r"/>
+                      <a:r>
+                        <a:rPr sz="1300" b="0">
+                          <a:solidFill>
+                            <a:srgbClr val="3C3C3B"/>
+                          </a:solidFill>
+                          <a:latin typeface="Aptos"/>
+                        </a:rPr>
+                        <a:t>30.0</a:t>
                       </a:r>
                     </a:p>
                   </a:txBody>
@@ -9628,7 +9694,7 @@
                   </a:tcPr>
                 </a:tc>
               </a:tr>
-              <a:tr h="420624">
+              <a:tr h="329184">
                 <a:tc>
                   <a:txBody>
                     <a:bodyPr/>
@@ -9642,7 +9708,7 @@
                           </a:solidFill>
                           <a:latin typeface="Aptos"/>
                         </a:rPr>
-                        <a:t>Outlays: devex, land, deposits, connection fees, signing</a:t>
+                        <a:t>Less sale costs</a:t>
                       </a:r>
                     </a:p>
                   </a:txBody>
@@ -9688,28 +9754,49 @@
                           </a:solidFill>
                           <a:latin typeface="Aptos"/>
                         </a:rPr>
-                        <a:t>(24.9)</a:t>
-                      </a:r>
-                    </a:p>
-                  </a:txBody>
-                  <a:tcPr marL="73152" marR="73152" marT="27432" marB="27432" anchor="ctr">
-                    <a:noFill/>
-                  </a:tcPr>
-                </a:tc>
-                <a:tc>
-                  <a:txBody>
-                    <a:bodyPr/>
-                    <a:lstStyle/>
-                    <a:p>
-                      <a:pPr algn="r"/>
-                      <a:r>
-                        <a:rPr sz="1300" b="0">
-                          <a:solidFill>
-                            <a:srgbClr val="3C3C3B"/>
-                          </a:solidFill>
-                          <a:latin typeface="Aptos"/>
-                        </a:rPr>
-                        <a:t>(24.9)</a:t>
+                        <a:t>(0.5)</a:t>
+                      </a:r>
+                    </a:p>
+                  </a:txBody>
+                  <a:tcPr marL="73152" marR="73152" marT="27432" marB="27432" anchor="ctr">
+                    <a:noFill/>
+                  </a:tcPr>
+                </a:tc>
+                <a:tc>
+                  <a:txBody>
+                    <a:bodyPr/>
+                    <a:lstStyle/>
+                    <a:p>
+                      <a:pPr algn="r"/>
+                      <a:r>
+                        <a:rPr sz="1300" b="0">
+                          <a:solidFill>
+                            <a:srgbClr val="3C3C3B"/>
+                          </a:solidFill>
+                          <a:latin typeface="Aptos"/>
+                        </a:rPr>
+                        <a:t>(0.5)</a:t>
+                      </a:r>
+                    </a:p>
+                  </a:txBody>
+                  <a:tcPr marL="73152" marR="73152" marT="27432" marB="27432" anchor="ctr">
+                    <a:noFill/>
+                  </a:tcPr>
+                </a:tc>
+                <a:tc>
+                  <a:txBody>
+                    <a:bodyPr/>
+                    <a:lstStyle/>
+                    <a:p>
+                      <a:pPr algn="r"/>
+                      <a:r>
+                        <a:rPr sz="1300" b="0">
+                          <a:solidFill>
+                            <a:srgbClr val="3C3C3B"/>
+                          </a:solidFill>
+                          <a:latin typeface="Aptos"/>
+                        </a:rPr>
+                        <a:t>(1.0)</a:t>
                       </a:r>
                     </a:p>
                   </a:txBody>
@@ -9718,7 +9805,7 @@
                   </a:tcPr>
                 </a:tc>
               </a:tr>
-              <a:tr h="420624">
+              <a:tr h="329184">
                 <a:tc>
                   <a:txBody>
                     <a:bodyPr/>
@@ -9732,7 +9819,7 @@
                           </a:solidFill>
                           <a:latin typeface="Aptos"/>
                         </a:rPr>
-                        <a:t>Guarantee fees (6% carry)</a:t>
+                        <a:t>Less FEP claim 12% on deposits and connection fees</a:t>
                       </a:r>
                     </a:p>
                   </a:txBody>
@@ -9778,28 +9865,49 @@
                           </a:solidFill>
                           <a:latin typeface="Aptos"/>
                         </a:rPr>
-                        <a:t>(1.3)</a:t>
-                      </a:r>
-                    </a:p>
-                  </a:txBody>
-                  <a:tcPr marL="73152" marR="73152" marT="27432" marB="27432" anchor="ctr">
-                    <a:noFill/>
-                  </a:tcPr>
-                </a:tc>
-                <a:tc>
-                  <a:txBody>
-                    <a:bodyPr/>
-                    <a:lstStyle/>
-                    <a:p>
-                      <a:pPr algn="r"/>
-                      <a:r>
-                        <a:rPr sz="1300" b="0">
-                          <a:solidFill>
-                            <a:srgbClr val="3C3C3B"/>
-                          </a:solidFill>
-                          <a:latin typeface="Aptos"/>
-                        </a:rPr>
-                        <a:t>(1.1)</a:t>
+                        <a:t>(1.6)</a:t>
+                      </a:r>
+                    </a:p>
+                  </a:txBody>
+                  <a:tcPr marL="73152" marR="73152" marT="27432" marB="27432" anchor="ctr">
+                    <a:noFill/>
+                  </a:tcPr>
+                </a:tc>
+                <a:tc>
+                  <a:txBody>
+                    <a:bodyPr/>
+                    <a:lstStyle/>
+                    <a:p>
+                      <a:pPr algn="r"/>
+                      <a:r>
+                        <a:rPr sz="1300" b="0">
+                          <a:solidFill>
+                            <a:srgbClr val="3C3C3B"/>
+                          </a:solidFill>
+                          <a:latin typeface="Aptos"/>
+                        </a:rPr>
+                        <a:t>(1.6)</a:t>
+                      </a:r>
+                    </a:p>
+                  </a:txBody>
+                  <a:tcPr marL="73152" marR="73152" marT="27432" marB="27432" anchor="ctr">
+                    <a:noFill/>
+                  </a:tcPr>
+                </a:tc>
+                <a:tc>
+                  <a:txBody>
+                    <a:bodyPr/>
+                    <a:lstStyle/>
+                    <a:p>
+                      <a:pPr algn="r"/>
+                      <a:r>
+                        <a:rPr sz="1300" b="0">
+                          <a:solidFill>
+                            <a:srgbClr val="3C3C3B"/>
+                          </a:solidFill>
+                          <a:latin typeface="Aptos"/>
+                        </a:rPr>
+                        <a:t>(3.1)</a:t>
                       </a:r>
                     </a:p>
                   </a:txBody>
@@ -9808,7 +9916,7 @@
                   </a:tcPr>
                 </a:tc>
               </a:tr>
-              <a:tr h="420624">
+              <a:tr h="329184">
                 <a:tc>
                   <a:txBody>
                     <a:bodyPr/>
@@ -9822,7 +9930,7 @@
                           </a:solidFill>
                           <a:latin typeface="Aptos"/>
                         </a:rPr>
-                        <a:t>Tax at the exit</a:t>
+                        <a:t>Less FEP claim 20% / 2× on devex and land</a:t>
                       </a:r>
                     </a:p>
                   </a:txBody>
@@ -9868,28 +9976,49 @@
                           </a:solidFill>
                           <a:latin typeface="Aptos"/>
                         </a:rPr>
-                        <a:t>(0.1)</a:t>
-                      </a:r>
-                    </a:p>
-                  </a:txBody>
-                  <a:tcPr marL="73152" marR="73152" marT="27432" marB="27432" anchor="ctr">
-                    <a:noFill/>
-                  </a:tcPr>
-                </a:tc>
-                <a:tc>
-                  <a:txBody>
-                    <a:bodyPr/>
-                    <a:lstStyle/>
-                    <a:p>
-                      <a:pPr algn="r"/>
-                      <a:r>
-                        <a:rPr sz="1300" b="0">
-                          <a:solidFill>
-                            <a:srgbClr val="3C3C3B"/>
-                          </a:solidFill>
-                          <a:latin typeface="Aptos"/>
-                        </a:rPr>
-                        <a:t>(0.1)</a:t>
+                        <a:t>(3.1)</a:t>
+                      </a:r>
+                    </a:p>
+                  </a:txBody>
+                  <a:tcPr marL="73152" marR="73152" marT="27432" marB="27432" anchor="ctr">
+                    <a:noFill/>
+                  </a:tcPr>
+                </a:tc>
+                <a:tc>
+                  <a:txBody>
+                    <a:bodyPr/>
+                    <a:lstStyle/>
+                    <a:p>
+                      <a:pPr algn="r"/>
+                      <a:r>
+                        <a:rPr sz="1300" b="0">
+                          <a:solidFill>
+                            <a:srgbClr val="3C3C3B"/>
+                          </a:solidFill>
+                          <a:latin typeface="Aptos"/>
+                        </a:rPr>
+                        <a:t>(3.1)</a:t>
+                      </a:r>
+                    </a:p>
+                  </a:txBody>
+                  <a:tcPr marL="73152" marR="73152" marT="27432" marB="27432" anchor="ctr">
+                    <a:noFill/>
+                  </a:tcPr>
+                </a:tc>
+                <a:tc>
+                  <a:txBody>
+                    <a:bodyPr/>
+                    <a:lstStyle/>
+                    <a:p>
+                      <a:pPr algn="r"/>
+                      <a:r>
+                        <a:rPr sz="1300" b="0">
+                          <a:solidFill>
+                            <a:srgbClr val="3C3C3B"/>
+                          </a:solidFill>
+                          <a:latin typeface="Aptos"/>
+                        </a:rPr>
+                        <a:t>(6.2)</a:t>
                       </a:r>
                     </a:p>
                   </a:txBody>
@@ -9898,7 +10027,7 @@
                   </a:tcPr>
                 </a:tc>
               </a:tr>
-              <a:tr h="420624">
+              <a:tr h="329184">
                 <a:tc>
                   <a:txBody>
                     <a:bodyPr/>
@@ -9906,13 +10035,13 @@
                     <a:p>
                       <a:pPr algn="l"/>
                       <a:r>
-                        <a:rPr sz="1300" b="1">
-                          <a:solidFill>
-                            <a:srgbClr val="3C3C3B"/>
-                          </a:solidFill>
-                          <a:latin typeface="Aptos"/>
-                        </a:rPr>
-                        <a:t>FEP profit – RtB route</a:t>
+                        <a:rPr sz="1300" b="0">
+                          <a:solidFill>
+                            <a:srgbClr val="3C3C3B"/>
+                          </a:solidFill>
+                          <a:latin typeface="Aptos"/>
+                        </a:rPr>
+                        <a:t>Less FEP claim 6% on guarantees</a:t>
                       </a:r>
                     </a:p>
                   </a:txBody>
@@ -9929,7 +10058,7 @@
                     <a:p>
                       <a:pPr algn="l"/>
                       <a:r>
-                        <a:rPr sz="1300" b="1">
+                        <a:rPr sz="1300" b="0">
                           <a:solidFill>
                             <a:srgbClr val="919191"/>
                           </a:solidFill>
@@ -9952,13 +10081,679 @@
                     <a:p>
                       <a:pPr algn="r"/>
                       <a:r>
+                        <a:rPr sz="1300" b="0">
+                          <a:solidFill>
+                            <a:srgbClr val="3C3C3B"/>
+                          </a:solidFill>
+                          <a:latin typeface="Aptos"/>
+                        </a:rPr>
+                        <a:t>(1.1)</a:t>
+                      </a:r>
+                    </a:p>
+                  </a:txBody>
+                  <a:tcPr marL="73152" marR="73152" marT="27432" marB="27432" anchor="ctr">
+                    <a:noFill/>
+                  </a:tcPr>
+                </a:tc>
+                <a:tc>
+                  <a:txBody>
+                    <a:bodyPr/>
+                    <a:lstStyle/>
+                    <a:p>
+                      <a:pPr algn="r"/>
+                      <a:r>
+                        <a:rPr sz="1300" b="0">
+                          <a:solidFill>
+                            <a:srgbClr val="3C3C3B"/>
+                          </a:solidFill>
+                          <a:latin typeface="Aptos"/>
+                        </a:rPr>
+                        <a:t>(1.0)</a:t>
+                      </a:r>
+                    </a:p>
+                  </a:txBody>
+                  <a:tcPr marL="73152" marR="73152" marT="27432" marB="27432" anchor="ctr">
+                    <a:noFill/>
+                  </a:tcPr>
+                </a:tc>
+                <a:tc>
+                  <a:txBody>
+                    <a:bodyPr/>
+                    <a:lstStyle/>
+                    <a:p>
+                      <a:pPr algn="r"/>
+                      <a:r>
+                        <a:rPr sz="1300" b="0">
+                          <a:solidFill>
+                            <a:srgbClr val="3C3C3B"/>
+                          </a:solidFill>
+                          <a:latin typeface="Aptos"/>
+                        </a:rPr>
+                        <a:t>(2.1)</a:t>
+                      </a:r>
+                    </a:p>
+                  </a:txBody>
+                  <a:tcPr marL="73152" marR="73152" marT="27432" marB="27432" anchor="ctr">
+                    <a:noFill/>
+                  </a:tcPr>
+                </a:tc>
+              </a:tr>
+              <a:tr h="329184">
+                <a:tc>
+                  <a:txBody>
+                    <a:bodyPr/>
+                    <a:lstStyle/>
+                    <a:p>
+                      <a:pPr algn="l"/>
+                      <a:r>
+                        <a:rPr sz="1300" b="0">
+                          <a:solidFill>
+                            <a:srgbClr val="3C3C3B"/>
+                          </a:solidFill>
+                          <a:latin typeface="Aptos"/>
+                        </a:rPr>
+                        <a:t>Less FEP interest claims, total</a:t>
+                      </a:r>
+                    </a:p>
+                  </a:txBody>
+                  <a:tcPr marL="73152" marR="73152" marT="27432" marB="27432" anchor="ctr">
+                    <a:solidFill>
+                      <a:srgbClr val="F2F2F2"/>
+                    </a:solidFill>
+                  </a:tcPr>
+                </a:tc>
+                <a:tc>
+                  <a:txBody>
+                    <a:bodyPr/>
+                    <a:lstStyle/>
+                    <a:p>
+                      <a:pPr algn="l"/>
+                      <a:r>
+                        <a:rPr sz="1300" b="0">
+                          <a:solidFill>
+                            <a:srgbClr val="919191"/>
+                          </a:solidFill>
+                          <a:latin typeface="Aptos"/>
+                        </a:rPr>
+                        <a:t>€ m</a:t>
+                      </a:r>
+                    </a:p>
+                  </a:txBody>
+                  <a:tcPr marL="73152" marR="73152" marT="27432" marB="27432" anchor="ctr">
+                    <a:solidFill>
+                      <a:srgbClr val="F2F2F2"/>
+                    </a:solidFill>
+                  </a:tcPr>
+                </a:tc>
+                <a:tc>
+                  <a:txBody>
+                    <a:bodyPr/>
+                    <a:lstStyle/>
+                    <a:p>
+                      <a:pPr algn="r"/>
+                      <a:r>
+                        <a:rPr sz="1300" b="0">
+                          <a:solidFill>
+                            <a:srgbClr val="3C3C3B"/>
+                          </a:solidFill>
+                          <a:latin typeface="Aptos"/>
+                        </a:rPr>
+                        <a:t>(5.8)</a:t>
+                      </a:r>
+                    </a:p>
+                  </a:txBody>
+                  <a:tcPr marL="73152" marR="73152" marT="27432" marB="27432" anchor="ctr">
+                    <a:noFill/>
+                  </a:tcPr>
+                </a:tc>
+                <a:tc>
+                  <a:txBody>
+                    <a:bodyPr/>
+                    <a:lstStyle/>
+                    <a:p>
+                      <a:pPr algn="r"/>
+                      <a:r>
+                        <a:rPr sz="1300" b="0">
+                          <a:solidFill>
+                            <a:srgbClr val="3C3C3B"/>
+                          </a:solidFill>
+                          <a:latin typeface="Aptos"/>
+                        </a:rPr>
+                        <a:t>(5.7)</a:t>
+                      </a:r>
+                    </a:p>
+                  </a:txBody>
+                  <a:tcPr marL="73152" marR="73152" marT="27432" marB="27432" anchor="ctr">
+                    <a:noFill/>
+                  </a:tcPr>
+                </a:tc>
+                <a:tc>
+                  <a:txBody>
+                    <a:bodyPr/>
+                    <a:lstStyle/>
+                    <a:p>
+                      <a:pPr algn="r"/>
+                      <a:r>
+                        <a:rPr sz="1300" b="0">
+                          <a:solidFill>
+                            <a:srgbClr val="3C3C3B"/>
+                          </a:solidFill>
+                          <a:latin typeface="Aptos"/>
+                        </a:rPr>
+                        <a:t>(11.5)</a:t>
+                      </a:r>
+                    </a:p>
+                  </a:txBody>
+                  <a:tcPr marL="73152" marR="73152" marT="27432" marB="27432" anchor="ctr">
+                    <a:noFill/>
+                  </a:tcPr>
+                </a:tc>
+              </a:tr>
+              <a:tr h="329184">
+                <a:tc>
+                  <a:txBody>
+                    <a:bodyPr/>
+                    <a:lstStyle/>
+                    <a:p>
+                      <a:pPr algn="l"/>
+                      <a:r>
+                        <a:rPr sz="1300" b="0">
+                          <a:solidFill>
+                            <a:srgbClr val="3C3C3B"/>
+                          </a:solidFill>
+                          <a:latin typeface="Aptos"/>
+                        </a:rPr>
+                        <a:t>Less DSA</a:t>
+                      </a:r>
+                    </a:p>
+                  </a:txBody>
+                  <a:tcPr marL="73152" marR="73152" marT="27432" marB="27432" anchor="ctr">
+                    <a:solidFill>
+                      <a:srgbClr val="F2F2F2"/>
+                    </a:solidFill>
+                  </a:tcPr>
+                </a:tc>
+                <a:tc>
+                  <a:txBody>
+                    <a:bodyPr/>
+                    <a:lstStyle/>
+                    <a:p>
+                      <a:pPr algn="l"/>
+                      <a:r>
+                        <a:rPr sz="1300" b="0">
+                          <a:solidFill>
+                            <a:srgbClr val="919191"/>
+                          </a:solidFill>
+                          <a:latin typeface="Aptos"/>
+                        </a:rPr>
+                        <a:t>€ m</a:t>
+                      </a:r>
+                    </a:p>
+                  </a:txBody>
+                  <a:tcPr marL="73152" marR="73152" marT="27432" marB="27432" anchor="ctr">
+                    <a:solidFill>
+                      <a:srgbClr val="F2F2F2"/>
+                    </a:solidFill>
+                  </a:tcPr>
+                </a:tc>
+                <a:tc>
+                  <a:txBody>
+                    <a:bodyPr/>
+                    <a:lstStyle/>
+                    <a:p>
+                      <a:pPr algn="r"/>
+                      <a:r>
+                        <a:rPr sz="1300" b="0">
+                          <a:solidFill>
+                            <a:srgbClr val="3C3C3B"/>
+                          </a:solidFill>
+                          <a:latin typeface="Aptos"/>
+                        </a:rPr>
+                        <a:t>(1.2)</a:t>
+                      </a:r>
+                    </a:p>
+                  </a:txBody>
+                  <a:tcPr marL="73152" marR="73152" marT="27432" marB="27432" anchor="ctr">
+                    <a:noFill/>
+                  </a:tcPr>
+                </a:tc>
+                <a:tc>
+                  <a:txBody>
+                    <a:bodyPr/>
+                    <a:lstStyle/>
+                    <a:p>
+                      <a:pPr algn="r"/>
+                      <a:r>
+                        <a:rPr sz="1300" b="0">
+                          <a:solidFill>
+                            <a:srgbClr val="3C3C3B"/>
+                          </a:solidFill>
+                          <a:latin typeface="Aptos"/>
+                        </a:rPr>
+                        <a:t>(1.1)</a:t>
+                      </a:r>
+                    </a:p>
+                  </a:txBody>
+                  <a:tcPr marL="73152" marR="73152" marT="27432" marB="27432" anchor="ctr">
+                    <a:noFill/>
+                  </a:tcPr>
+                </a:tc>
+                <a:tc>
+                  <a:txBody>
+                    <a:bodyPr/>
+                    <a:lstStyle/>
+                    <a:p>
+                      <a:pPr algn="r"/>
+                      <a:r>
+                        <a:rPr sz="1300" b="0">
+                          <a:solidFill>
+                            <a:srgbClr val="3C3C3B"/>
+                          </a:solidFill>
+                          <a:latin typeface="Aptos"/>
+                        </a:rPr>
+                        <a:t>(2.3)</a:t>
+                      </a:r>
+                    </a:p>
+                  </a:txBody>
+                  <a:tcPr marL="73152" marR="73152" marT="27432" marB="27432" anchor="ctr">
+                    <a:noFill/>
+                  </a:tcPr>
+                </a:tc>
+              </a:tr>
+              <a:tr h="329184">
+                <a:tc>
+                  <a:txBody>
+                    <a:bodyPr/>
+                    <a:lstStyle/>
+                    <a:p>
+                      <a:pPr algn="l"/>
+                      <a:r>
+                        <a:rPr sz="1300" b="0">
+                          <a:solidFill>
+                            <a:srgbClr val="3C3C3B"/>
+                          </a:solidFill>
+                          <a:latin typeface="Aptos"/>
+                        </a:rPr>
+                        <a:t>Distributable</a:t>
+                      </a:r>
+                    </a:p>
+                  </a:txBody>
+                  <a:tcPr marL="73152" marR="73152" marT="27432" marB="27432" anchor="ctr">
+                    <a:solidFill>
+                      <a:srgbClr val="F2F2F2"/>
+                    </a:solidFill>
+                  </a:tcPr>
+                </a:tc>
+                <a:tc>
+                  <a:txBody>
+                    <a:bodyPr/>
+                    <a:lstStyle/>
+                    <a:p>
+                      <a:pPr algn="l"/>
+                      <a:r>
+                        <a:rPr sz="1300" b="0">
+                          <a:solidFill>
+                            <a:srgbClr val="919191"/>
+                          </a:solidFill>
+                          <a:latin typeface="Aptos"/>
+                        </a:rPr>
+                        <a:t>€ m</a:t>
+                      </a:r>
+                    </a:p>
+                  </a:txBody>
+                  <a:tcPr marL="73152" marR="73152" marT="27432" marB="27432" anchor="ctr">
+                    <a:solidFill>
+                      <a:srgbClr val="F2F2F2"/>
+                    </a:solidFill>
+                  </a:tcPr>
+                </a:tc>
+                <a:tc>
+                  <a:txBody>
+                    <a:bodyPr/>
+                    <a:lstStyle/>
+                    <a:p>
+                      <a:pPr algn="r"/>
+                      <a:r>
+                        <a:rPr sz="1300" b="0">
+                          <a:solidFill>
+                            <a:srgbClr val="3C3C3B"/>
+                          </a:solidFill>
+                          <a:latin typeface="Aptos"/>
+                        </a:rPr>
+                        <a:t>7.5</a:t>
+                      </a:r>
+                    </a:p>
+                  </a:txBody>
+                  <a:tcPr marL="73152" marR="73152" marT="27432" marB="27432" anchor="ctr">
+                    <a:noFill/>
+                  </a:tcPr>
+                </a:tc>
+                <a:tc>
+                  <a:txBody>
+                    <a:bodyPr/>
+                    <a:lstStyle/>
+                    <a:p>
+                      <a:pPr algn="r"/>
+                      <a:r>
+                        <a:rPr sz="1300" b="0">
+                          <a:solidFill>
+                            <a:srgbClr val="3C3C3B"/>
+                          </a:solidFill>
+                          <a:latin typeface="Aptos"/>
+                        </a:rPr>
+                        <a:t>7.7</a:t>
+                      </a:r>
+                    </a:p>
+                  </a:txBody>
+                  <a:tcPr marL="73152" marR="73152" marT="27432" marB="27432" anchor="ctr">
+                    <a:noFill/>
+                  </a:tcPr>
+                </a:tc>
+                <a:tc>
+                  <a:txBody>
+                    <a:bodyPr/>
+                    <a:lstStyle/>
+                    <a:p>
+                      <a:pPr algn="r"/>
+                      <a:r>
+                        <a:rPr sz="1300" b="0">
+                          <a:solidFill>
+                            <a:srgbClr val="3C3C3B"/>
+                          </a:solidFill>
+                          <a:latin typeface="Aptos"/>
+                        </a:rPr>
+                        <a:t>15.2</a:t>
+                      </a:r>
+                    </a:p>
+                  </a:txBody>
+                  <a:tcPr marL="73152" marR="73152" marT="27432" marB="27432" anchor="ctr">
+                    <a:noFill/>
+                  </a:tcPr>
+                </a:tc>
+              </a:tr>
+              <a:tr h="329184">
+                <a:tc>
+                  <a:txBody>
+                    <a:bodyPr/>
+                    <a:lstStyle/>
+                    <a:p>
+                      <a:pPr algn="l"/>
+                      <a:r>
+                        <a:rPr sz="1300" b="0">
+                          <a:solidFill>
+                            <a:srgbClr val="3C3C3B"/>
+                          </a:solidFill>
+                          <a:latin typeface="Aptos"/>
+                        </a:rPr>
+                        <a:t>FEP 70%</a:t>
+                      </a:r>
+                    </a:p>
+                  </a:txBody>
+                  <a:tcPr marL="73152" marR="73152" marT="27432" marB="27432" anchor="ctr">
+                    <a:solidFill>
+                      <a:srgbClr val="F2F2F2"/>
+                    </a:solidFill>
+                  </a:tcPr>
+                </a:tc>
+                <a:tc>
+                  <a:txBody>
+                    <a:bodyPr/>
+                    <a:lstStyle/>
+                    <a:p>
+                      <a:pPr algn="l"/>
+                      <a:r>
+                        <a:rPr sz="1300" b="0">
+                          <a:solidFill>
+                            <a:srgbClr val="919191"/>
+                          </a:solidFill>
+                          <a:latin typeface="Aptos"/>
+                        </a:rPr>
+                        <a:t>€ m</a:t>
+                      </a:r>
+                    </a:p>
+                  </a:txBody>
+                  <a:tcPr marL="73152" marR="73152" marT="27432" marB="27432" anchor="ctr">
+                    <a:solidFill>
+                      <a:srgbClr val="F2F2F2"/>
+                    </a:solidFill>
+                  </a:tcPr>
+                </a:tc>
+                <a:tc>
+                  <a:txBody>
+                    <a:bodyPr/>
+                    <a:lstStyle/>
+                    <a:p>
+                      <a:pPr algn="r"/>
+                      <a:r>
+                        <a:rPr sz="1300" b="0">
+                          <a:solidFill>
+                            <a:srgbClr val="3C3C3B"/>
+                          </a:solidFill>
+                          <a:latin typeface="Aptos"/>
+                        </a:rPr>
+                        <a:t>5.2</a:t>
+                      </a:r>
+                    </a:p>
+                  </a:txBody>
+                  <a:tcPr marL="73152" marR="73152" marT="27432" marB="27432" anchor="ctr">
+                    <a:noFill/>
+                  </a:tcPr>
+                </a:tc>
+                <a:tc>
+                  <a:txBody>
+                    <a:bodyPr/>
+                    <a:lstStyle/>
+                    <a:p>
+                      <a:pPr algn="r"/>
+                      <a:r>
+                        <a:rPr sz="1300" b="0">
+                          <a:solidFill>
+                            <a:srgbClr val="3C3C3B"/>
+                          </a:solidFill>
+                          <a:latin typeface="Aptos"/>
+                        </a:rPr>
+                        <a:t>5.4</a:t>
+                      </a:r>
+                    </a:p>
+                  </a:txBody>
+                  <a:tcPr marL="73152" marR="73152" marT="27432" marB="27432" anchor="ctr">
+                    <a:noFill/>
+                  </a:tcPr>
+                </a:tc>
+                <a:tc>
+                  <a:txBody>
+                    <a:bodyPr/>
+                    <a:lstStyle/>
+                    <a:p>
+                      <a:pPr algn="r"/>
+                      <a:r>
+                        <a:rPr sz="1300" b="0">
+                          <a:solidFill>
+                            <a:srgbClr val="3C3C3B"/>
+                          </a:solidFill>
+                          <a:latin typeface="Aptos"/>
+                        </a:rPr>
+                        <a:t>10.7</a:t>
+                      </a:r>
+                    </a:p>
+                  </a:txBody>
+                  <a:tcPr marL="73152" marR="73152" marT="27432" marB="27432" anchor="ctr">
+                    <a:noFill/>
+                  </a:tcPr>
+                </a:tc>
+              </a:tr>
+              <a:tr h="329184">
+                <a:tc>
+                  <a:txBody>
+                    <a:bodyPr/>
+                    <a:lstStyle/>
+                    <a:p>
+                      <a:pPr algn="l"/>
+                      <a:r>
+                        <a:rPr sz="1300" b="0">
+                          <a:solidFill>
+                            <a:srgbClr val="3C3C3B"/>
+                          </a:solidFill>
+                          <a:latin typeface="Aptos"/>
+                        </a:rPr>
+                        <a:t>FEP-borne devex principal</a:t>
+                      </a:r>
+                    </a:p>
+                  </a:txBody>
+                  <a:tcPr marL="73152" marR="73152" marT="27432" marB="27432" anchor="ctr">
+                    <a:solidFill>
+                      <a:srgbClr val="F2F2F2"/>
+                    </a:solidFill>
+                  </a:tcPr>
+                </a:tc>
+                <a:tc>
+                  <a:txBody>
+                    <a:bodyPr/>
+                    <a:lstStyle/>
+                    <a:p>
+                      <a:pPr algn="l"/>
+                      <a:r>
+                        <a:rPr sz="1300" b="0">
+                          <a:solidFill>
+                            <a:srgbClr val="919191"/>
+                          </a:solidFill>
+                          <a:latin typeface="Aptos"/>
+                        </a:rPr>
+                        <a:t>€ m</a:t>
+                      </a:r>
+                    </a:p>
+                  </a:txBody>
+                  <a:tcPr marL="73152" marR="73152" marT="27432" marB="27432" anchor="ctr">
+                    <a:solidFill>
+                      <a:srgbClr val="F2F2F2"/>
+                    </a:solidFill>
+                  </a:tcPr>
+                </a:tc>
+                <a:tc>
+                  <a:txBody>
+                    <a:bodyPr/>
+                    <a:lstStyle/>
+                    <a:p>
+                      <a:pPr algn="r"/>
+                      <a:r>
+                        <a:rPr sz="1300" b="0">
+                          <a:solidFill>
+                            <a:srgbClr val="3C3C3B"/>
+                          </a:solidFill>
+                          <a:latin typeface="Aptos"/>
+                        </a:rPr>
+                        <a:t>(2.7)</a:t>
+                      </a:r>
+                    </a:p>
+                  </a:txBody>
+                  <a:tcPr marL="73152" marR="73152" marT="27432" marB="27432" anchor="ctr">
+                    <a:noFill/>
+                  </a:tcPr>
+                </a:tc>
+                <a:tc>
+                  <a:txBody>
+                    <a:bodyPr/>
+                    <a:lstStyle/>
+                    <a:p>
+                      <a:pPr algn="r"/>
+                      <a:r>
+                        <a:rPr sz="1300" b="0">
+                          <a:solidFill>
+                            <a:srgbClr val="3C3C3B"/>
+                          </a:solidFill>
+                          <a:latin typeface="Aptos"/>
+                        </a:rPr>
+                        <a:t>(2.7)</a:t>
+                      </a:r>
+                    </a:p>
+                  </a:txBody>
+                  <a:tcPr marL="73152" marR="73152" marT="27432" marB="27432" anchor="ctr">
+                    <a:noFill/>
+                  </a:tcPr>
+                </a:tc>
+                <a:tc>
+                  <a:txBody>
+                    <a:bodyPr/>
+                    <a:lstStyle/>
+                    <a:p>
+                      <a:pPr algn="r"/>
+                      <a:r>
+                        <a:rPr sz="1300" b="0">
+                          <a:solidFill>
+                            <a:srgbClr val="3C3C3B"/>
+                          </a:solidFill>
+                          <a:latin typeface="Aptos"/>
+                        </a:rPr>
+                        <a:t>(5.4)</a:t>
+                      </a:r>
+                    </a:p>
+                  </a:txBody>
+                  <a:tcPr marL="73152" marR="73152" marT="27432" marB="27432" anchor="ctr">
+                    <a:noFill/>
+                  </a:tcPr>
+                </a:tc>
+              </a:tr>
+              <a:tr h="329184">
+                <a:tc>
+                  <a:txBody>
+                    <a:bodyPr/>
+                    <a:lstStyle/>
+                    <a:p>
+                      <a:pPr algn="l"/>
+                      <a:r>
                         <a:rPr sz="1300" b="1">
                           <a:solidFill>
                             <a:srgbClr val="3C3C3B"/>
                           </a:solidFill>
                           <a:latin typeface="Aptos"/>
                         </a:rPr>
-                        <a:t>6.5</a:t>
+                        <a:t>FEP net = claims + 70% − devex</a:t>
+                      </a:r>
+                    </a:p>
+                  </a:txBody>
+                  <a:tcPr marL="73152" marR="73152" marT="27432" marB="27432" anchor="ctr">
+                    <a:solidFill>
+                      <a:srgbClr val="F2F2F2"/>
+                    </a:solidFill>
+                  </a:tcPr>
+                </a:tc>
+                <a:tc>
+                  <a:txBody>
+                    <a:bodyPr/>
+                    <a:lstStyle/>
+                    <a:p>
+                      <a:pPr algn="l"/>
+                      <a:r>
+                        <a:rPr sz="1300" b="1">
+                          <a:solidFill>
+                            <a:srgbClr val="919191"/>
+                          </a:solidFill>
+                          <a:latin typeface="Aptos"/>
+                        </a:rPr>
+                        <a:t>€ m</a:t>
+                      </a:r>
+                    </a:p>
+                  </a:txBody>
+                  <a:tcPr marL="73152" marR="73152" marT="27432" marB="27432" anchor="ctr">
+                    <a:solidFill>
+                      <a:srgbClr val="F2F2F2"/>
+                    </a:solidFill>
+                  </a:tcPr>
+                </a:tc>
+                <a:tc>
+                  <a:txBody>
+                    <a:bodyPr/>
+                    <a:lstStyle/>
+                    <a:p>
+                      <a:pPr algn="r"/>
+                      <a:r>
+                        <a:rPr sz="1300" b="1">
+                          <a:solidFill>
+                            <a:srgbClr val="3C3C3B"/>
+                          </a:solidFill>
+                          <a:latin typeface="Aptos"/>
+                        </a:rPr>
+                        <a:t>8.4</a:t>
                       </a:r>
                     </a:p>
                   </a:txBody>
@@ -9981,7 +10776,7 @@
                           </a:solidFill>
                           <a:latin typeface="Aptos"/>
                         </a:rPr>
-                        <a:t>6.7</a:t>
+                        <a:t>8.4</a:t>
                       </a:r>
                     </a:p>
                   </a:txBody>
@@ -9991,8 +10786,31 @@
                     </a:solidFill>
                   </a:tcPr>
                 </a:tc>
+                <a:tc>
+                  <a:txBody>
+                    <a:bodyPr/>
+                    <a:lstStyle/>
+                    <a:p>
+                      <a:pPr algn="r"/>
+                      <a:r>
+                        <a:rPr sz="1300" b="1">
+                          <a:solidFill>
+                            <a:srgbClr val="3C3C3B"/>
+                          </a:solidFill>
+                          <a:latin typeface="Aptos"/>
+                        </a:rPr>
+                        <a:t>16.7</a:t>
+                      </a:r>
+                    </a:p>
+                  </a:txBody>
+                  <a:tcPr marL="73152" marR="73152" marT="27432" marB="27432" anchor="ctr">
+                    <a:solidFill>
+                      <a:srgbClr val="E6F4EC"/>
+                    </a:solidFill>
+                  </a:tcPr>
+                </a:tc>
               </a:tr>
-              <a:tr h="420624">
+              <a:tr h="329184">
                 <a:tc>
                   <a:txBody>
                     <a:bodyPr/>
@@ -10006,7 +10824,7 @@
                           </a:solidFill>
                           <a:latin typeface="Aptos"/>
                         </a:rPr>
-                        <a:t>FEP profit – RtB route, low-premium case (100 k€/MVA)</a:t>
+                        <a:t>A.RES 30%</a:t>
                       </a:r>
                     </a:p>
                   </a:txBody>
@@ -10052,28 +10870,49 @@
                           </a:solidFill>
                           <a:latin typeface="Aptos"/>
                         </a:rPr>
-                        <a:t>3.0</a:t>
-                      </a:r>
-                    </a:p>
-                  </a:txBody>
-                  <a:tcPr marL="73152" marR="73152" marT="27432" marB="27432" anchor="ctr">
-                    <a:noFill/>
-                  </a:tcPr>
-                </a:tc>
-                <a:tc>
-                  <a:txBody>
-                    <a:bodyPr/>
-                    <a:lstStyle/>
-                    <a:p>
-                      <a:pPr algn="r"/>
-                      <a:r>
-                        <a:rPr sz="1300" b="0">
-                          <a:solidFill>
-                            <a:srgbClr val="3C3C3B"/>
-                          </a:solidFill>
-                          <a:latin typeface="Aptos"/>
-                        </a:rPr>
-                        <a:t>3.2</a:t>
+                        <a:t>2.2</a:t>
+                      </a:r>
+                    </a:p>
+                  </a:txBody>
+                  <a:tcPr marL="73152" marR="73152" marT="27432" marB="27432" anchor="ctr">
+                    <a:noFill/>
+                  </a:tcPr>
+                </a:tc>
+                <a:tc>
+                  <a:txBody>
+                    <a:bodyPr/>
+                    <a:lstStyle/>
+                    <a:p>
+                      <a:pPr algn="r"/>
+                      <a:r>
+                        <a:rPr sz="1300" b="0">
+                          <a:solidFill>
+                            <a:srgbClr val="3C3C3B"/>
+                          </a:solidFill>
+                          <a:latin typeface="Aptos"/>
+                        </a:rPr>
+                        <a:t>2.3</a:t>
+                      </a:r>
+                    </a:p>
+                  </a:txBody>
+                  <a:tcPr marL="73152" marR="73152" marT="27432" marB="27432" anchor="ctr">
+                    <a:noFill/>
+                  </a:tcPr>
+                </a:tc>
+                <a:tc>
+                  <a:txBody>
+                    <a:bodyPr/>
+                    <a:lstStyle/>
+                    <a:p>
+                      <a:pPr algn="r"/>
+                      <a:r>
+                        <a:rPr sz="1300" b="0">
+                          <a:solidFill>
+                            <a:srgbClr val="3C3C3B"/>
+                          </a:solidFill>
+                          <a:latin typeface="Aptos"/>
+                        </a:rPr>
+                        <a:t>4.6</a:t>
                       </a:r>
                     </a:p>
                   </a:txBody>
@@ -10082,7 +10921,7 @@
                   </a:tcPr>
                 </a:tc>
               </a:tr>
-              <a:tr h="420624">
+              <a:tr h="329184">
                 <a:tc>
                   <a:txBody>
                     <a:bodyPr/>
@@ -10090,13 +10929,13 @@
                     <a:p>
                       <a:pPr algn="l"/>
                       <a:r>
-                        <a:rPr sz="1300" b="0">
-                          <a:solidFill>
-                            <a:srgbClr val="3C3C3B"/>
-                          </a:solidFill>
-                          <a:latin typeface="Aptos"/>
-                        </a:rPr>
-                        <a:t>Exit split – FEP: claims + 70%</a:t>
+                        <a:rPr sz="1300" b="1">
+                          <a:solidFill>
+                            <a:srgbClr val="3C3C3B"/>
+                          </a:solidFill>
+                          <a:latin typeface="Aptos"/>
+                        </a:rPr>
+                        <a:t>A.RES total = 30% + DSA</a:t>
                       </a:r>
                     </a:p>
                   </a:txBody>
@@ -10113,13 +10952,13 @@
                     <a:p>
                       <a:pPr algn="l"/>
                       <a:r>
-                        <a:rPr sz="1300" b="0">
+                        <a:rPr sz="1300" b="1">
                           <a:solidFill>
                             <a:srgbClr val="919191"/>
                           </a:solidFill>
                           <a:latin typeface="Aptos"/>
                         </a:rPr>
-                        <a:t>€ m (k€/MW)</a:t>
+                        <a:t>€ m</a:t>
                       </a:r>
                     </a:p>
                   </a:txBody>
@@ -10136,43 +10975,70 @@
                     <a:p>
                       <a:pPr algn="r"/>
                       <a:r>
-                        <a:rPr sz="1300" b="0">
-                          <a:solidFill>
-                            <a:srgbClr val="3C3C3B"/>
-                          </a:solidFill>
-                          <a:latin typeface="Aptos"/>
-                        </a:rPr>
-                        <a:t>11.1 (73)</a:t>
-                      </a:r>
-                    </a:p>
-                  </a:txBody>
-                  <a:tcPr marL="73152" marR="73152" marT="27432" marB="27432" anchor="ctr">
-                    <a:noFill/>
-                  </a:tcPr>
-                </a:tc>
-                <a:tc>
-                  <a:txBody>
-                    <a:bodyPr/>
-                    <a:lstStyle/>
-                    <a:p>
-                      <a:pPr algn="r"/>
-                      <a:r>
-                        <a:rPr sz="1300" b="0">
-                          <a:solidFill>
-                            <a:srgbClr val="3C3C3B"/>
-                          </a:solidFill>
-                          <a:latin typeface="Aptos"/>
-                        </a:rPr>
-                        <a:t>11.1 (79)</a:t>
-                      </a:r>
-                    </a:p>
-                  </a:txBody>
-                  <a:tcPr marL="73152" marR="73152" marT="27432" marB="27432" anchor="ctr">
-                    <a:noFill/>
+                        <a:rPr sz="1300" b="1">
+                          <a:solidFill>
+                            <a:srgbClr val="3C3C3B"/>
+                          </a:solidFill>
+                          <a:latin typeface="Aptos"/>
+                        </a:rPr>
+                        <a:t>3.4</a:t>
+                      </a:r>
+                    </a:p>
+                  </a:txBody>
+                  <a:tcPr marL="73152" marR="73152" marT="27432" marB="27432" anchor="ctr">
+                    <a:solidFill>
+                      <a:srgbClr val="E6F4EC"/>
+                    </a:solidFill>
+                  </a:tcPr>
+                </a:tc>
+                <a:tc>
+                  <a:txBody>
+                    <a:bodyPr/>
+                    <a:lstStyle/>
+                    <a:p>
+                      <a:pPr algn="r"/>
+                      <a:r>
+                        <a:rPr sz="1300" b="1">
+                          <a:solidFill>
+                            <a:srgbClr val="3C3C3B"/>
+                          </a:solidFill>
+                          <a:latin typeface="Aptos"/>
+                        </a:rPr>
+                        <a:t>3.4</a:t>
+                      </a:r>
+                    </a:p>
+                  </a:txBody>
+                  <a:tcPr marL="73152" marR="73152" marT="27432" marB="27432" anchor="ctr">
+                    <a:solidFill>
+                      <a:srgbClr val="E6F4EC"/>
+                    </a:solidFill>
+                  </a:tcPr>
+                </a:tc>
+                <a:tc>
+                  <a:txBody>
+                    <a:bodyPr/>
+                    <a:lstStyle/>
+                    <a:p>
+                      <a:pPr algn="r"/>
+                      <a:r>
+                        <a:rPr sz="1300" b="1">
+                          <a:solidFill>
+                            <a:srgbClr val="3C3C3B"/>
+                          </a:solidFill>
+                          <a:latin typeface="Aptos"/>
+                        </a:rPr>
+                        <a:t>6.9</a:t>
+                      </a:r>
+                    </a:p>
+                  </a:txBody>
+                  <a:tcPr marL="73152" marR="73152" marT="27432" marB="27432" anchor="ctr">
+                    <a:solidFill>
+                      <a:srgbClr val="E6F4EC"/>
+                    </a:solidFill>
                   </a:tcPr>
                 </a:tc>
               </a:tr>
-              <a:tr h="420624">
+              <a:tr h="329184">
                 <a:tc>
                   <a:txBody>
                     <a:bodyPr/>
@@ -10186,7 +11052,7 @@
                           </a:solidFill>
                           <a:latin typeface="Aptos"/>
                         </a:rPr>
-                        <a:t>Exit split – A.RES: DSA + 30%</a:t>
+                        <a:t>Guarantee fees, signing and DD, tax</a:t>
                       </a:r>
                     </a:p>
                   </a:txBody>
@@ -10209,7 +11075,7 @@
                           </a:solidFill>
                           <a:latin typeface="Aptos"/>
                         </a:rPr>
-                        <a:t>€ m (k€/MW)</a:t>
+                        <a:t>€ m</a:t>
                       </a:r>
                     </a:p>
                   </a:txBody>
@@ -10232,28 +11098,49 @@
                           </a:solidFill>
                           <a:latin typeface="Aptos"/>
                         </a:rPr>
-                        <a:t>3.4 (23)</a:t>
-                      </a:r>
-                    </a:p>
-                  </a:txBody>
-                  <a:tcPr marL="73152" marR="73152" marT="27432" marB="27432" anchor="ctr">
-                    <a:noFill/>
-                  </a:tcPr>
-                </a:tc>
-                <a:tc>
-                  <a:txBody>
-                    <a:bodyPr/>
-                    <a:lstStyle/>
-                    <a:p>
-                      <a:pPr algn="r"/>
-                      <a:r>
-                        <a:rPr sz="1300" b="0">
-                          <a:solidFill>
-                            <a:srgbClr val="3C3C3B"/>
-                          </a:solidFill>
-                          <a:latin typeface="Aptos"/>
-                        </a:rPr>
-                        <a:t>3.4 (25)</a:t>
+                        <a:t>(1.8)</a:t>
+                      </a:r>
+                    </a:p>
+                  </a:txBody>
+                  <a:tcPr marL="73152" marR="73152" marT="27432" marB="27432" anchor="ctr">
+                    <a:noFill/>
+                  </a:tcPr>
+                </a:tc>
+                <a:tc>
+                  <a:txBody>
+                    <a:bodyPr/>
+                    <a:lstStyle/>
+                    <a:p>
+                      <a:pPr algn="r"/>
+                      <a:r>
+                        <a:rPr sz="1300" b="0">
+                          <a:solidFill>
+                            <a:srgbClr val="3C3C3B"/>
+                          </a:solidFill>
+                          <a:latin typeface="Aptos"/>
+                        </a:rPr>
+                        <a:t>(1.6)</a:t>
+                      </a:r>
+                    </a:p>
+                  </a:txBody>
+                  <a:tcPr marL="73152" marR="73152" marT="27432" marB="27432" anchor="ctr">
+                    <a:noFill/>
+                  </a:tcPr>
+                </a:tc>
+                <a:tc>
+                  <a:txBody>
+                    <a:bodyPr/>
+                    <a:lstStyle/>
+                    <a:p>
+                      <a:pPr algn="r"/>
+                      <a:r>
+                        <a:rPr sz="1300" b="0">
+                          <a:solidFill>
+                            <a:srgbClr val="3C3C3B"/>
+                          </a:solidFill>
+                          <a:latin typeface="Aptos"/>
+                        </a:rPr>
+                        <a:t>(3.4)</a:t>
                       </a:r>
                     </a:p>
                   </a:txBody>
@@ -10262,7 +11149,7 @@
                   </a:tcPr>
                 </a:tc>
               </a:tr>
-              <a:tr h="420624">
+              <a:tr h="329184">
                 <a:tc>
                   <a:txBody>
                     <a:bodyPr/>
@@ -10270,13 +11157,13 @@
                     <a:p>
                       <a:pPr algn="l"/>
                       <a:r>
-                        <a:rPr sz="1300" b="0">
-                          <a:solidFill>
-                            <a:srgbClr val="3C3C3B"/>
-                          </a:solidFill>
-                          <a:latin typeface="Aptos"/>
-                        </a:rPr>
-                        <a:t>Exit split – total</a:t>
+                        <a:rPr sz="1300" b="1">
+                          <a:solidFill>
+                            <a:srgbClr val="3C3C3B"/>
+                          </a:solidFill>
+                          <a:latin typeface="Aptos"/>
+                        </a:rPr>
+                        <a:t>FEP profit – RtB route</a:t>
                       </a:r>
                     </a:p>
                   </a:txBody>
@@ -10293,13 +11180,13 @@
                     <a:p>
                       <a:pPr algn="l"/>
                       <a:r>
-                        <a:rPr sz="1300" b="0">
+                        <a:rPr sz="1300" b="1">
                           <a:solidFill>
                             <a:srgbClr val="919191"/>
                           </a:solidFill>
                           <a:latin typeface="Aptos"/>
                         </a:rPr>
-                        <a:t>€ m (k€/MW)</a:t>
+                        <a:t>€ m</a:t>
                       </a:r>
                     </a:p>
                   </a:txBody>
@@ -10316,39 +11203,66 @@
                     <a:p>
                       <a:pPr algn="r"/>
                       <a:r>
-                        <a:rPr sz="1300" b="0">
-                          <a:solidFill>
-                            <a:srgbClr val="3C3C3B"/>
-                          </a:solidFill>
-                          <a:latin typeface="Aptos"/>
-                        </a:rPr>
-                        <a:t>14.5 (96)</a:t>
-                      </a:r>
-                    </a:p>
-                  </a:txBody>
-                  <a:tcPr marL="73152" marR="73152" marT="27432" marB="27432" anchor="ctr">
-                    <a:noFill/>
-                  </a:tcPr>
-                </a:tc>
-                <a:tc>
-                  <a:txBody>
-                    <a:bodyPr/>
-                    <a:lstStyle/>
-                    <a:p>
-                      <a:pPr algn="r"/>
-                      <a:r>
-                        <a:rPr sz="1300" b="0">
-                          <a:solidFill>
-                            <a:srgbClr val="3C3C3B"/>
-                          </a:solidFill>
-                          <a:latin typeface="Aptos"/>
-                        </a:rPr>
-                        <a:t>14.5 (104)</a:t>
-                      </a:r>
-                    </a:p>
-                  </a:txBody>
-                  <a:tcPr marL="73152" marR="73152" marT="27432" marB="27432" anchor="ctr">
-                    <a:noFill/>
+                        <a:rPr sz="1300" b="1">
+                          <a:solidFill>
+                            <a:srgbClr val="3C3C3B"/>
+                          </a:solidFill>
+                          <a:latin typeface="Aptos"/>
+                        </a:rPr>
+                        <a:t>6.5</a:t>
+                      </a:r>
+                    </a:p>
+                  </a:txBody>
+                  <a:tcPr marL="73152" marR="73152" marT="27432" marB="27432" anchor="ctr">
+                    <a:solidFill>
+                      <a:srgbClr val="E6F4EC"/>
+                    </a:solidFill>
+                  </a:tcPr>
+                </a:tc>
+                <a:tc>
+                  <a:txBody>
+                    <a:bodyPr/>
+                    <a:lstStyle/>
+                    <a:p>
+                      <a:pPr algn="r"/>
+                      <a:r>
+                        <a:rPr sz="1300" b="1">
+                          <a:solidFill>
+                            <a:srgbClr val="3C3C3B"/>
+                          </a:solidFill>
+                          <a:latin typeface="Aptos"/>
+                        </a:rPr>
+                        <a:t>6.7</a:t>
+                      </a:r>
+                    </a:p>
+                  </a:txBody>
+                  <a:tcPr marL="73152" marR="73152" marT="27432" marB="27432" anchor="ctr">
+                    <a:solidFill>
+                      <a:srgbClr val="E6F4EC"/>
+                    </a:solidFill>
+                  </a:tcPr>
+                </a:tc>
+                <a:tc>
+                  <a:txBody>
+                    <a:bodyPr/>
+                    <a:lstStyle/>
+                    <a:p>
+                      <a:pPr algn="r"/>
+                      <a:r>
+                        <a:rPr sz="1300" b="1">
+                          <a:solidFill>
+                            <a:srgbClr val="3C3C3B"/>
+                          </a:solidFill>
+                          <a:latin typeface="Aptos"/>
+                        </a:rPr>
+                        <a:t>13.3</a:t>
+                      </a:r>
+                    </a:p>
+                  </a:txBody>
+                  <a:tcPr marL="73152" marR="73152" marT="27432" marB="27432" anchor="ctr">
+                    <a:solidFill>
+                      <a:srgbClr val="E6F4EC"/>
+                    </a:solidFill>
                   </a:tcPr>
                 </a:tc>
               </a:tr>
@@ -10479,7 +11393,7 @@
                 </a:solidFill>
                 <a:latin typeface="Aptos"/>
               </a:rPr>
-              <a:t>TSO security €1.2m (30‑Dec‑2026) and connection fees €1.4m + €18.8m (08‑Jan‑2029). The buyer reimburses €21.4m at the exit.</a:t>
+              <a:t>TSO security €1.2m (30‑Dec‑2026) and connection fees €1.4m + €18.8m (08‑Jan‑2029). The buyer reimburses deposits, fees and land at the exit (memo line).</a:t>
             </a:r>
           </a:p>
         </p:txBody>
@@ -10513,7 +11427,7 @@
                 </a:solidFill>
                 <a:latin typeface="Aptos"/>
               </a:rPr>
-              <a:t>RtB price 150 k€/MVA × 100 MVA, per the Bora scenarios meeting file (Bora!N5), confirmed 12‑Oct‑2026. Receipts = recoverable principal, land and claims, plus 70% of the distributable. Per-MW figures use installed wind of 151 / 140 MW. The participation fee is not recovered.</a:t>
+              <a:t>RtB price 150 k€/MVA × 100 MVA, per the Bora scenarios meeting file (Bora!N5), confirmed 12‑Oct‑2026. Paid amounts at the RtB exit on 31‑Dec‑2029, in devex-file order. The participation fee is not recovered.</a:t>
             </a:r>
           </a:p>
           <a:p>

</xml_diff>

<commit_message>
Set BORA 2 to the BORA 1 strategy (85 points)
Co-Authored-By: Claude Opus 5.5 <noreply@anthropic.com>
Claude-Session: https://claude.ai/code/session_011Cy4jTfjKbxPfMRQvaZwVT
</commit_message>
<xml_diff>
--- a/projects/bora_bidding/out/Bora_Bid_IC.pptx
+++ b/projects/bora_bidding/out/Bora_Bid_IC.pptx
@@ -5831,7 +5831,7 @@
           <a:lstStyle/>
           <a:p>
             <a:r>
-              <a:t>Submit both bids at 85 / 68.25 points: FEP earns €6.5m / €6.7m at the RtB exit, a 22.2% / 22.9% IRR</a:t>
+              <a:t>Submit both bids at 85 / 85 points: FEP earns €6.5m / €6.5m at the RtB exit, a 22.2% / 22.2% IRR</a:t>
             </a:r>
           </a:p>
         </p:txBody>
@@ -6137,7 +6137,7 @@
                 </a:solidFill>
                 <a:latin typeface="Aptos"/>
               </a:rPr>
-              <a:t>Against the zero bid, the commitments cost €0.8m / €0.7m of RtB profit and 2.4 / 1.9 pp of HTM IRR, and add €23.4m / €19.5m to the all-in commitment.</a:t>
+              <a:t>Against the zero bid, the commitments cost €0.8m / €0.8m of RtB profit and 2.4 / 2.4 pp of HTM IRR, and add €23.4m / €23.4m to the all-in commitment.</a:t>
             </a:r>
           </a:p>
         </p:txBody>
@@ -6386,7 +6386,7 @@
                           </a:solidFill>
                           <a:latin typeface="Aptos"/>
                         </a:rPr>
-                        <a:t>68.25</a:t>
+                        <a:t>85</a:t>
                       </a:r>
                     </a:p>
                   </a:txBody>
@@ -6497,7 +6497,7 @@
                           </a:solidFill>
                           <a:latin typeface="Aptos"/>
                         </a:rPr>
-                        <a:t>6.7</a:t>
+                        <a:t>6.5</a:t>
                       </a:r>
                     </a:p>
                   </a:txBody>
@@ -6608,7 +6608,7 @@
                           </a:solidFill>
                           <a:latin typeface="Aptos"/>
                         </a:rPr>
-                        <a:t>22.9%</a:t>
+                        <a:t>22.2%</a:t>
                       </a:r>
                     </a:p>
                   </a:txBody>
@@ -6719,7 +6719,7 @@
                           </a:solidFill>
                           <a:latin typeface="Aptos"/>
                         </a:rPr>
-                        <a:t>40.5%</a:t>
+                        <a:t>37.8%</a:t>
                       </a:r>
                     </a:p>
                   </a:txBody>
@@ -6830,7 +6830,7 @@
                           </a:solidFill>
                           <a:latin typeface="Aptos"/>
                         </a:rPr>
-                        <a:t>9.9%</a:t>
+                        <a:t>9.5%</a:t>
                       </a:r>
                     </a:p>
                   </a:txBody>
@@ -6945,7 +6945,7 @@
                           </a:solidFill>
                           <a:latin typeface="Aptos"/>
                         </a:rPr>
-                        <a:t>167.3</a:t>
+                        <a:t>171.2</a:t>
                       </a:r>
                     </a:p>
                   </a:txBody>
@@ -7033,7 +7033,7 @@
                 </a:solidFill>
                 <a:latin typeface="Aptos"/>
               </a:rPr>
-              <a:t>municipal 50 k€/MW; community 3.00 / 2.01 €/MWh; overbuild 51% / 40% (not built); BESS 51% / 40% of MVA, 4 h; PB at the 1.0x minimum; partial award, shared connection, EU turbines and transformers.</a:t>
+              <a:t>municipal 50 k€/MW; community 3.00 / 3.00 €/MWh; overbuild 51% / 51% (not built); BESS 51% / 51% of MVA, 4 h; PB at the 1.0x minimum; partial award, shared connection, EU turbines and transformers.</a:t>
             </a:r>
           </a:p>
           <a:p>
@@ -7058,7 +7058,7 @@
                 </a:solidFill>
                 <a:latin typeface="Aptos"/>
               </a:rPr>
-              <a:t>participation fee €0.008m per bid (cash) and bid guarantee €1.4m / €1.2m.</a:t>
+              <a:t>participation fee €0.008m per bid (cash) and bid guarantee €1.4m / €1.4m.</a:t>
             </a:r>
           </a:p>
           <a:p>
@@ -7083,7 +7083,7 @@
                 </a:solidFill>
                 <a:latin typeface="Aptos"/>
               </a:rPr>
-              <a:t>PB guarantee €7.0m / €6.1m by 28‑Dec‑2026, which replaces the bid guarantee; TSO cash security €1.2m per bid by 30‑Dec‑2026.</a:t>
+              <a:t>PB guarantee €7.0m / €7.0m by 28‑Dec‑2026, which replaces the bid guarantee; TSO cash security €1.2m per bid by 30‑Dec‑2026.</a:t>
             </a:r>
           </a:p>
           <a:p>
@@ -7931,28 +7931,28 @@
                           </a:solidFill>
                           <a:latin typeface="Aptos"/>
                         </a:rPr>
-                        <a:t>3.00 / 2.01 €/MWh</a:t>
-                      </a:r>
-                    </a:p>
-                  </a:txBody>
-                  <a:tcPr marL="73152" marR="73152" marT="27432" marB="27432" anchor="ctr">
-                    <a:noFill/>
-                  </a:tcPr>
-                </a:tc>
-                <a:tc>
-                  <a:txBody>
-                    <a:bodyPr/>
-                    <a:lstStyle/>
-                    <a:p>
-                      <a:pPr algn="r"/>
-                      <a:r>
-                        <a:rPr sz="1300" b="0">
-                          <a:solidFill>
-                            <a:srgbClr val="3C3C3B"/>
-                          </a:solidFill>
-                          <a:latin typeface="Aptos"/>
-                        </a:rPr>
-                        <a:t>15 / 0.75</a:t>
+                        <a:t>3.00 / 3.00 €/MWh</a:t>
+                      </a:r>
+                    </a:p>
+                  </a:txBody>
+                  <a:tcPr marL="73152" marR="73152" marT="27432" marB="27432" anchor="ctr">
+                    <a:noFill/>
+                  </a:tcPr>
+                </a:tc>
+                <a:tc>
+                  <a:txBody>
+                    <a:bodyPr/>
+                    <a:lstStyle/>
+                    <a:p>
+                      <a:pPr algn="r"/>
+                      <a:r>
+                        <a:rPr sz="1300" b="0">
+                          <a:solidFill>
+                            <a:srgbClr val="3C3C3B"/>
+                          </a:solidFill>
+                          <a:latin typeface="Aptos"/>
+                        </a:rPr>
+                        <a:t>15 / 15</a:t>
                       </a:r>
                     </a:p>
                   </a:txBody>
@@ -7994,28 +7994,28 @@
                           </a:solidFill>
                           <a:latin typeface="Aptos"/>
                         </a:rPr>
-                        <a:t>−2.6 / −1.7</a:t>
-                      </a:r>
-                    </a:p>
-                  </a:txBody>
-                  <a:tcPr marL="73152" marR="73152" marT="27432" marB="27432" anchor="ctr">
-                    <a:noFill/>
-                  </a:tcPr>
-                </a:tc>
-                <a:tc>
-                  <a:txBody>
-                    <a:bodyPr/>
-                    <a:lstStyle/>
-                    <a:p>
-                      <a:pPr algn="r"/>
-                      <a:r>
-                        <a:rPr sz="1300" b="0">
-                          <a:solidFill>
-                            <a:srgbClr val="3C3C3B"/>
-                          </a:solidFill>
-                          <a:latin typeface="Aptos"/>
-                        </a:rPr>
-                        <a:t>−0.6 / −0.4</a:t>
+                        <a:t>−2.6 / −2.6</a:t>
+                      </a:r>
+                    </a:p>
+                  </a:txBody>
+                  <a:tcPr marL="73152" marR="73152" marT="27432" marB="27432" anchor="ctr">
+                    <a:noFill/>
+                  </a:tcPr>
+                </a:tc>
+                <a:tc>
+                  <a:txBody>
+                    <a:bodyPr/>
+                    <a:lstStyle/>
+                    <a:p>
+                      <a:pPr algn="r"/>
+                      <a:r>
+                        <a:rPr sz="1300" b="0">
+                          <a:solidFill>
+                            <a:srgbClr val="3C3C3B"/>
+                          </a:solidFill>
+                          <a:latin typeface="Aptos"/>
+                        </a:rPr>
+                        <a:t>−0.6 / −0.6</a:t>
                       </a:r>
                     </a:p>
                   </a:txBody>
@@ -8057,7 +8057,7 @@
                           </a:solidFill>
                           <a:latin typeface="Aptos"/>
                         </a:rPr>
-                        <a:t>Operating cost after COD. At the band floor, BORA 2 earns 0.75 points.</a:t>
+                        <a:t>Operating cost after COD. At the band floor, BORA 2 earns 15 points.</a:t>
                       </a:r>
                     </a:p>
                   </a:txBody>
@@ -8103,70 +8103,70 @@
                           </a:solidFill>
                           <a:latin typeface="Aptos"/>
                         </a:rPr>
-                        <a:t>51% / 40%</a:t>
-                      </a:r>
-                    </a:p>
-                  </a:txBody>
-                  <a:tcPr marL="73152" marR="73152" marT="27432" marB="27432" anchor="ctr">
-                    <a:noFill/>
-                  </a:tcPr>
-                </a:tc>
-                <a:tc>
-                  <a:txBody>
-                    <a:bodyPr/>
-                    <a:lstStyle/>
-                    <a:p>
-                      <a:pPr algn="r"/>
-                      <a:r>
-                        <a:rPr sz="1300" b="0">
-                          <a:solidFill>
-                            <a:srgbClr val="3C3C3B"/>
-                          </a:solidFill>
-                          <a:latin typeface="Aptos"/>
-                        </a:rPr>
-                        <a:t>10 / 9</a:t>
-                      </a:r>
-                    </a:p>
-                  </a:txBody>
-                  <a:tcPr marL="73152" marR="73152" marT="27432" marB="27432" anchor="ctr">
-                    <a:noFill/>
-                  </a:tcPr>
-                </a:tc>
-                <a:tc>
-                  <a:txBody>
-                    <a:bodyPr/>
-                    <a:lstStyle/>
-                    <a:p>
-                      <a:pPr algn="r"/>
-                      <a:r>
-                        <a:rPr sz="1300" b="0">
-                          <a:solidFill>
-                            <a:srgbClr val="3C3C3B"/>
-                          </a:solidFill>
-                          <a:latin typeface="Aptos"/>
-                        </a:rPr>
-                        <a:t>(0.5) / (0.4)</a:t>
-                      </a:r>
-                    </a:p>
-                  </a:txBody>
-                  <a:tcPr marL="73152" marR="73152" marT="27432" marB="27432" anchor="ctr">
-                    <a:noFill/>
-                  </a:tcPr>
-                </a:tc>
-                <a:tc>
-                  <a:txBody>
-                    <a:bodyPr/>
-                    <a:lstStyle/>
-                    <a:p>
-                      <a:pPr algn="r"/>
-                      <a:r>
-                        <a:rPr sz="1300" b="0">
-                          <a:solidFill>
-                            <a:srgbClr val="3C3C3B"/>
-                          </a:solidFill>
-                          <a:latin typeface="Aptos"/>
-                        </a:rPr>
-                        <a:t>−1.1 / −0.9</a:t>
+                        <a:t>51% / 51%</a:t>
+                      </a:r>
+                    </a:p>
+                  </a:txBody>
+                  <a:tcPr marL="73152" marR="73152" marT="27432" marB="27432" anchor="ctr">
+                    <a:noFill/>
+                  </a:tcPr>
+                </a:tc>
+                <a:tc>
+                  <a:txBody>
+                    <a:bodyPr/>
+                    <a:lstStyle/>
+                    <a:p>
+                      <a:pPr algn="r"/>
+                      <a:r>
+                        <a:rPr sz="1300" b="0">
+                          <a:solidFill>
+                            <a:srgbClr val="3C3C3B"/>
+                          </a:solidFill>
+                          <a:latin typeface="Aptos"/>
+                        </a:rPr>
+                        <a:t>10 / 10</a:t>
+                      </a:r>
+                    </a:p>
+                  </a:txBody>
+                  <a:tcPr marL="73152" marR="73152" marT="27432" marB="27432" anchor="ctr">
+                    <a:noFill/>
+                  </a:tcPr>
+                </a:tc>
+                <a:tc>
+                  <a:txBody>
+                    <a:bodyPr/>
+                    <a:lstStyle/>
+                    <a:p>
+                      <a:pPr algn="r"/>
+                      <a:r>
+                        <a:rPr sz="1300" b="0">
+                          <a:solidFill>
+                            <a:srgbClr val="3C3C3B"/>
+                          </a:solidFill>
+                          <a:latin typeface="Aptos"/>
+                        </a:rPr>
+                        <a:t>(0.5) / (0.5)</a:t>
+                      </a:r>
+                    </a:p>
+                  </a:txBody>
+                  <a:tcPr marL="73152" marR="73152" marT="27432" marB="27432" anchor="ctr">
+                    <a:noFill/>
+                  </a:tcPr>
+                </a:tc>
+                <a:tc>
+                  <a:txBody>
+                    <a:bodyPr/>
+                    <a:lstStyle/>
+                    <a:p>
+                      <a:pPr algn="r"/>
+                      <a:r>
+                        <a:rPr sz="1300" b="0">
+                          <a:solidFill>
+                            <a:srgbClr val="3C3C3B"/>
+                          </a:solidFill>
+                          <a:latin typeface="Aptos"/>
+                        </a:rPr>
+                        <a:t>−1.1 / −1.1</a:t>
                       </a:r>
                     </a:p>
                   </a:txBody>
@@ -8208,7 +8208,7 @@
                           </a:solidFill>
                           <a:latin typeface="Aptos"/>
                         </a:rPr>
-                        <a:t>+1.4 / +1.1</a:t>
+                        <a:t>+1.4 / +1.4</a:t>
                       </a:r>
                     </a:p>
                   </a:txBody>
@@ -8275,112 +8275,112 @@
                           </a:solidFill>
                           <a:latin typeface="Aptos"/>
                         </a:rPr>
-                        <a:t>51% / 40% of MVA</a:t>
-                      </a:r>
-                    </a:p>
-                  </a:txBody>
-                  <a:tcPr marL="73152" marR="73152" marT="27432" marB="27432" anchor="ctr">
-                    <a:noFill/>
-                  </a:tcPr>
-                </a:tc>
-                <a:tc>
-                  <a:txBody>
-                    <a:bodyPr/>
-                    <a:lstStyle/>
-                    <a:p>
-                      <a:pPr algn="r"/>
-                      <a:r>
-                        <a:rPr sz="1300" b="0">
-                          <a:solidFill>
-                            <a:srgbClr val="3C3C3B"/>
-                          </a:solidFill>
-                          <a:latin typeface="Aptos"/>
-                        </a:rPr>
-                        <a:t>15 / 13.50</a:t>
-                      </a:r>
-                    </a:p>
-                  </a:txBody>
-                  <a:tcPr marL="73152" marR="73152" marT="27432" marB="27432" anchor="ctr">
-                    <a:noFill/>
-                  </a:tcPr>
-                </a:tc>
-                <a:tc>
-                  <a:txBody>
-                    <a:bodyPr/>
-                    <a:lstStyle/>
-                    <a:p>
-                      <a:pPr algn="r"/>
-                      <a:r>
-                        <a:rPr sz="1300" b="0">
-                          <a:solidFill>
-                            <a:srgbClr val="3C3C3B"/>
-                          </a:solidFill>
-                          <a:latin typeface="Aptos"/>
-                        </a:rPr>
-                        <a:t>(0.4) / (0.3)</a:t>
-                      </a:r>
-                    </a:p>
-                  </a:txBody>
-                  <a:tcPr marL="73152" marR="73152" marT="27432" marB="27432" anchor="ctr">
-                    <a:noFill/>
-                  </a:tcPr>
-                </a:tc>
-                <a:tc>
-                  <a:txBody>
-                    <a:bodyPr/>
-                    <a:lstStyle/>
-                    <a:p>
-                      <a:pPr algn="r"/>
-                      <a:r>
-                        <a:rPr sz="1300" b="0">
-                          <a:solidFill>
-                            <a:srgbClr val="3C3C3B"/>
-                          </a:solidFill>
-                          <a:latin typeface="Aptos"/>
-                        </a:rPr>
-                        <a:t>−6.5 / −5.1</a:t>
-                      </a:r>
-                    </a:p>
-                  </a:txBody>
-                  <a:tcPr marL="73152" marR="73152" marT="27432" marB="27432" anchor="ctr">
-                    <a:noFill/>
-                  </a:tcPr>
-                </a:tc>
-                <a:tc>
-                  <a:txBody>
-                    <a:bodyPr/>
-                    <a:lstStyle/>
-                    <a:p>
-                      <a:pPr algn="r"/>
-                      <a:r>
-                        <a:rPr sz="1300" b="0">
-                          <a:solidFill>
-                            <a:srgbClr val="3C3C3B"/>
-                          </a:solidFill>
-                          <a:latin typeface="Aptos"/>
-                        </a:rPr>
-                        <a:t>−1.2 / −1.0</a:t>
-                      </a:r>
-                    </a:p>
-                  </a:txBody>
-                  <a:tcPr marL="73152" marR="73152" marT="27432" marB="27432" anchor="ctr">
-                    <a:noFill/>
-                  </a:tcPr>
-                </a:tc>
-                <a:tc>
-                  <a:txBody>
-                    <a:bodyPr/>
-                    <a:lstStyle/>
-                    <a:p>
-                      <a:pPr algn="r"/>
-                      <a:r>
-                        <a:rPr sz="1300" b="0">
-                          <a:solidFill>
-                            <a:srgbClr val="3C3C3B"/>
-                          </a:solidFill>
-                          <a:latin typeface="Aptos"/>
-                        </a:rPr>
-                        <a:t>+2.8 / +2.2</a:t>
+                        <a:t>51% / 51% of MVA</a:t>
+                      </a:r>
+                    </a:p>
+                  </a:txBody>
+                  <a:tcPr marL="73152" marR="73152" marT="27432" marB="27432" anchor="ctr">
+                    <a:noFill/>
+                  </a:tcPr>
+                </a:tc>
+                <a:tc>
+                  <a:txBody>
+                    <a:bodyPr/>
+                    <a:lstStyle/>
+                    <a:p>
+                      <a:pPr algn="r"/>
+                      <a:r>
+                        <a:rPr sz="1300" b="0">
+                          <a:solidFill>
+                            <a:srgbClr val="3C3C3B"/>
+                          </a:solidFill>
+                          <a:latin typeface="Aptos"/>
+                        </a:rPr>
+                        <a:t>15 / 15</a:t>
+                      </a:r>
+                    </a:p>
+                  </a:txBody>
+                  <a:tcPr marL="73152" marR="73152" marT="27432" marB="27432" anchor="ctr">
+                    <a:noFill/>
+                  </a:tcPr>
+                </a:tc>
+                <a:tc>
+                  <a:txBody>
+                    <a:bodyPr/>
+                    <a:lstStyle/>
+                    <a:p>
+                      <a:pPr algn="r"/>
+                      <a:r>
+                        <a:rPr sz="1300" b="0">
+                          <a:solidFill>
+                            <a:srgbClr val="3C3C3B"/>
+                          </a:solidFill>
+                          <a:latin typeface="Aptos"/>
+                        </a:rPr>
+                        <a:t>(0.4) / (0.4)</a:t>
+                      </a:r>
+                    </a:p>
+                  </a:txBody>
+                  <a:tcPr marL="73152" marR="73152" marT="27432" marB="27432" anchor="ctr">
+                    <a:noFill/>
+                  </a:tcPr>
+                </a:tc>
+                <a:tc>
+                  <a:txBody>
+                    <a:bodyPr/>
+                    <a:lstStyle/>
+                    <a:p>
+                      <a:pPr algn="r"/>
+                      <a:r>
+                        <a:rPr sz="1300" b="0">
+                          <a:solidFill>
+                            <a:srgbClr val="3C3C3B"/>
+                          </a:solidFill>
+                          <a:latin typeface="Aptos"/>
+                        </a:rPr>
+                        <a:t>−6.5 / −6.5</a:t>
+                      </a:r>
+                    </a:p>
+                  </a:txBody>
+                  <a:tcPr marL="73152" marR="73152" marT="27432" marB="27432" anchor="ctr">
+                    <a:noFill/>
+                  </a:tcPr>
+                </a:tc>
+                <a:tc>
+                  <a:txBody>
+                    <a:bodyPr/>
+                    <a:lstStyle/>
+                    <a:p>
+                      <a:pPr algn="r"/>
+                      <a:r>
+                        <a:rPr sz="1300" b="0">
+                          <a:solidFill>
+                            <a:srgbClr val="3C3C3B"/>
+                          </a:solidFill>
+                          <a:latin typeface="Aptos"/>
+                        </a:rPr>
+                        <a:t>−1.2 / −1.2</a:t>
+                      </a:r>
+                    </a:p>
+                  </a:txBody>
+                  <a:tcPr marL="73152" marR="73152" marT="27432" marB="27432" anchor="ctr">
+                    <a:noFill/>
+                  </a:tcPr>
+                </a:tc>
+                <a:tc>
+                  <a:txBody>
+                    <a:bodyPr/>
+                    <a:lstStyle/>
+                    <a:p>
+                      <a:pPr algn="r"/>
+                      <a:r>
+                        <a:rPr sz="1300" b="0">
+                          <a:solidFill>
+                            <a:srgbClr val="3C3C3B"/>
+                          </a:solidFill>
+                          <a:latin typeface="Aptos"/>
+                        </a:rPr>
+                        <a:t>+2.8 / +2.8</a:t>
                       </a:r>
                     </a:p>
                   </a:txBody>
@@ -8573,7 +8573,7 @@
                           </a:solidFill>
                           <a:latin typeface="Aptos"/>
                         </a:rPr>
-                        <a:t>Not raised: 2.0x adds 5 points for one more PB of €7.0m / €6.1m of guarantee.</a:t>
+                        <a:t>Not raised: 2.0x adds 5 points for one more PB of €7.0m / €7.0m of guarantee.</a:t>
                       </a:r>
                     </a:p>
                   </a:txBody>
@@ -8805,7 +8805,7 @@
                           </a:solidFill>
                           <a:latin typeface="Aptos"/>
                         </a:rPr>
-                        <a:t>85 / 68.25</a:t>
+                        <a:t>85 / 85</a:t>
                       </a:r>
                     </a:p>
                   </a:txBody>
@@ -8828,7 +8828,7 @@
                           </a:solidFill>
                           <a:latin typeface="Aptos"/>
                         </a:rPr>
-                        <a:t>(0.8) / (0.7)</a:t>
+                        <a:t>(0.8) / (0.8)</a:t>
                       </a:r>
                     </a:p>
                   </a:txBody>
@@ -8851,7 +8851,7 @@
                           </a:solidFill>
                           <a:latin typeface="Aptos"/>
                         </a:rPr>
-                        <a:t>−11.7 / −9.1</a:t>
+                        <a:t>−11.7 / −11.7</a:t>
                       </a:r>
                     </a:p>
                   </a:txBody>
@@ -8874,7 +8874,7 @@
                           </a:solidFill>
                           <a:latin typeface="Aptos"/>
                         </a:rPr>
-                        <a:t>−2.4 / −1.9</a:t>
+                        <a:t>−2.4 / −2.4</a:t>
                       </a:r>
                     </a:p>
                   </a:txBody>
@@ -9019,7 +9019,7 @@
           <a:lstStyle/>
           <a:p>
             <a:r>
-              <a:t>At the RtB exit FEP recovers its cash and earns €6.5m / €6.7m, a 1.25x / 1.26x MOIC</a:t>
+              <a:t>At the RtB exit FEP recovers its cash and earns €6.5m / €6.5m, a 1.25x / 1.25x MOIC</a:t>
             </a:r>
           </a:p>
         </p:txBody>
@@ -9325,7 +9325,7 @@
                 </a:solidFill>
                 <a:latin typeface="Aptos"/>
               </a:rPr>
-              <a:t>Of the €15.0m exit premium per bid, FEP nets €8.4m / €8.4m and A.RES €3.4m / €3.4m; at a 100 k€/MVA premium FEP's RtB profit falls to €3.0m / €3.2m.</a:t>
+              <a:t>Of the €15.0m exit premium per bid, FEP nets €8.4m / €8.4m and A.RES €3.4m / €3.4m; at a 100 k€/MVA premium FEP's RtB profit falls to €3.0m / €3.0m.</a:t>
             </a:r>
           </a:p>
         </p:txBody>
@@ -10108,28 +10108,28 @@
                           </a:solidFill>
                           <a:latin typeface="Aptos"/>
                         </a:rPr>
-                        <a:t>(1.0)</a:t>
-                      </a:r>
-                    </a:p>
-                  </a:txBody>
-                  <a:tcPr marL="73152" marR="73152" marT="27432" marB="27432" anchor="ctr">
-                    <a:noFill/>
-                  </a:tcPr>
-                </a:tc>
-                <a:tc>
-                  <a:txBody>
-                    <a:bodyPr/>
-                    <a:lstStyle/>
-                    <a:p>
-                      <a:pPr algn="r"/>
-                      <a:r>
-                        <a:rPr sz="1300" b="0">
-                          <a:solidFill>
-                            <a:srgbClr val="3C3C3B"/>
-                          </a:solidFill>
-                          <a:latin typeface="Aptos"/>
-                        </a:rPr>
-                        <a:t>(2.1)</a:t>
+                        <a:t>(1.1)</a:t>
+                      </a:r>
+                    </a:p>
+                  </a:txBody>
+                  <a:tcPr marL="73152" marR="73152" marT="27432" marB="27432" anchor="ctr">
+                    <a:noFill/>
+                  </a:tcPr>
+                </a:tc>
+                <a:tc>
+                  <a:txBody>
+                    <a:bodyPr/>
+                    <a:lstStyle/>
+                    <a:p>
+                      <a:pPr algn="r"/>
+                      <a:r>
+                        <a:rPr sz="1300" b="0">
+                          <a:solidFill>
+                            <a:srgbClr val="3C3C3B"/>
+                          </a:solidFill>
+                          <a:latin typeface="Aptos"/>
+                        </a:rPr>
+                        <a:t>(2.2)</a:t>
                       </a:r>
                     </a:p>
                   </a:txBody>
@@ -10219,28 +10219,28 @@
                           </a:solidFill>
                           <a:latin typeface="Aptos"/>
                         </a:rPr>
-                        <a:t>(5.7)</a:t>
-                      </a:r>
-                    </a:p>
-                  </a:txBody>
-                  <a:tcPr marL="73152" marR="73152" marT="27432" marB="27432" anchor="ctr">
-                    <a:noFill/>
-                  </a:tcPr>
-                </a:tc>
-                <a:tc>
-                  <a:txBody>
-                    <a:bodyPr/>
-                    <a:lstStyle/>
-                    <a:p>
-                      <a:pPr algn="r"/>
-                      <a:r>
-                        <a:rPr sz="1300" b="0">
-                          <a:solidFill>
-                            <a:srgbClr val="3C3C3B"/>
-                          </a:solidFill>
-                          <a:latin typeface="Aptos"/>
-                        </a:rPr>
-                        <a:t>(11.5)</a:t>
+                        <a:t>(5.8)</a:t>
+                      </a:r>
+                    </a:p>
+                  </a:txBody>
+                  <a:tcPr marL="73152" marR="73152" marT="27432" marB="27432" anchor="ctr">
+                    <a:noFill/>
+                  </a:tcPr>
+                </a:tc>
+                <a:tc>
+                  <a:txBody>
+                    <a:bodyPr/>
+                    <a:lstStyle/>
+                    <a:p>
+                      <a:pPr algn="r"/>
+                      <a:r>
+                        <a:rPr sz="1300" b="0">
+                          <a:solidFill>
+                            <a:srgbClr val="3C3C3B"/>
+                          </a:solidFill>
+                          <a:latin typeface="Aptos"/>
+                        </a:rPr>
+                        <a:t>(11.6)</a:t>
                       </a:r>
                     </a:p>
                   </a:txBody>
@@ -10330,28 +10330,28 @@
                           </a:solidFill>
                           <a:latin typeface="Aptos"/>
                         </a:rPr>
-                        <a:t>(1.1)</a:t>
-                      </a:r>
-                    </a:p>
-                  </a:txBody>
-                  <a:tcPr marL="73152" marR="73152" marT="27432" marB="27432" anchor="ctr">
-                    <a:noFill/>
-                  </a:tcPr>
-                </a:tc>
-                <a:tc>
-                  <a:txBody>
-                    <a:bodyPr/>
-                    <a:lstStyle/>
-                    <a:p>
-                      <a:pPr algn="r"/>
-                      <a:r>
-                        <a:rPr sz="1300" b="0">
-                          <a:solidFill>
-                            <a:srgbClr val="3C3C3B"/>
-                          </a:solidFill>
-                          <a:latin typeface="Aptos"/>
-                        </a:rPr>
-                        <a:t>(2.3)</a:t>
+                        <a:t>(1.2)</a:t>
+                      </a:r>
+                    </a:p>
+                  </a:txBody>
+                  <a:tcPr marL="73152" marR="73152" marT="27432" marB="27432" anchor="ctr">
+                    <a:noFill/>
+                  </a:tcPr>
+                </a:tc>
+                <a:tc>
+                  <a:txBody>
+                    <a:bodyPr/>
+                    <a:lstStyle/>
+                    <a:p>
+                      <a:pPr algn="r"/>
+                      <a:r>
+                        <a:rPr sz="1300" b="0">
+                          <a:solidFill>
+                            <a:srgbClr val="3C3C3B"/>
+                          </a:solidFill>
+                          <a:latin typeface="Aptos"/>
+                        </a:rPr>
+                        <a:t>(2.4)</a:t>
                       </a:r>
                     </a:p>
                   </a:txBody>
@@ -10441,28 +10441,28 @@
                           </a:solidFill>
                           <a:latin typeface="Aptos"/>
                         </a:rPr>
-                        <a:t>7.7</a:t>
-                      </a:r>
-                    </a:p>
-                  </a:txBody>
-                  <a:tcPr marL="73152" marR="73152" marT="27432" marB="27432" anchor="ctr">
-                    <a:noFill/>
-                  </a:tcPr>
-                </a:tc>
-                <a:tc>
-                  <a:txBody>
-                    <a:bodyPr/>
-                    <a:lstStyle/>
-                    <a:p>
-                      <a:pPr algn="r"/>
-                      <a:r>
-                        <a:rPr sz="1300" b="0">
-                          <a:solidFill>
-                            <a:srgbClr val="3C3C3B"/>
-                          </a:solidFill>
-                          <a:latin typeface="Aptos"/>
-                        </a:rPr>
-                        <a:t>15.2</a:t>
+                        <a:t>7.5</a:t>
+                      </a:r>
+                    </a:p>
+                  </a:txBody>
+                  <a:tcPr marL="73152" marR="73152" marT="27432" marB="27432" anchor="ctr">
+                    <a:noFill/>
+                  </a:tcPr>
+                </a:tc>
+                <a:tc>
+                  <a:txBody>
+                    <a:bodyPr/>
+                    <a:lstStyle/>
+                    <a:p>
+                      <a:pPr algn="r"/>
+                      <a:r>
+                        <a:rPr sz="1300" b="0">
+                          <a:solidFill>
+                            <a:srgbClr val="3C3C3B"/>
+                          </a:solidFill>
+                          <a:latin typeface="Aptos"/>
+                        </a:rPr>
+                        <a:t>15.0</a:t>
                       </a:r>
                     </a:p>
                   </a:txBody>
@@ -10552,28 +10552,28 @@
                           </a:solidFill>
                           <a:latin typeface="Aptos"/>
                         </a:rPr>
-                        <a:t>5.4</a:t>
-                      </a:r>
-                    </a:p>
-                  </a:txBody>
-                  <a:tcPr marL="73152" marR="73152" marT="27432" marB="27432" anchor="ctr">
-                    <a:noFill/>
-                  </a:tcPr>
-                </a:tc>
-                <a:tc>
-                  <a:txBody>
-                    <a:bodyPr/>
-                    <a:lstStyle/>
-                    <a:p>
-                      <a:pPr algn="r"/>
-                      <a:r>
-                        <a:rPr sz="1300" b="0">
-                          <a:solidFill>
-                            <a:srgbClr val="3C3C3B"/>
-                          </a:solidFill>
-                          <a:latin typeface="Aptos"/>
-                        </a:rPr>
-                        <a:t>10.7</a:t>
+                        <a:t>5.2</a:t>
+                      </a:r>
+                    </a:p>
+                  </a:txBody>
+                  <a:tcPr marL="73152" marR="73152" marT="27432" marB="27432" anchor="ctr">
+                    <a:noFill/>
+                  </a:tcPr>
+                </a:tc>
+                <a:tc>
+                  <a:txBody>
+                    <a:bodyPr/>
+                    <a:lstStyle/>
+                    <a:p>
+                      <a:pPr algn="r"/>
+                      <a:r>
+                        <a:rPr sz="1300" b="0">
+                          <a:solidFill>
+                            <a:srgbClr val="3C3C3B"/>
+                          </a:solidFill>
+                          <a:latin typeface="Aptos"/>
+                        </a:rPr>
+                        <a:t>10.5</a:t>
                       </a:r>
                     </a:p>
                   </a:txBody>
@@ -10891,28 +10891,28 @@
                           </a:solidFill>
                           <a:latin typeface="Aptos"/>
                         </a:rPr>
-                        <a:t>2.3</a:t>
-                      </a:r>
-                    </a:p>
-                  </a:txBody>
-                  <a:tcPr marL="73152" marR="73152" marT="27432" marB="27432" anchor="ctr">
-                    <a:noFill/>
-                  </a:tcPr>
-                </a:tc>
-                <a:tc>
-                  <a:txBody>
-                    <a:bodyPr/>
-                    <a:lstStyle/>
-                    <a:p>
-                      <a:pPr algn="r"/>
-                      <a:r>
-                        <a:rPr sz="1300" b="0">
-                          <a:solidFill>
-                            <a:srgbClr val="3C3C3B"/>
-                          </a:solidFill>
-                          <a:latin typeface="Aptos"/>
-                        </a:rPr>
-                        <a:t>4.6</a:t>
+                        <a:t>2.2</a:t>
+                      </a:r>
+                    </a:p>
+                  </a:txBody>
+                  <a:tcPr marL="73152" marR="73152" marT="27432" marB="27432" anchor="ctr">
+                    <a:noFill/>
+                  </a:tcPr>
+                </a:tc>
+                <a:tc>
+                  <a:txBody>
+                    <a:bodyPr/>
+                    <a:lstStyle/>
+                    <a:p>
+                      <a:pPr algn="r"/>
+                      <a:r>
+                        <a:rPr sz="1300" b="0">
+                          <a:solidFill>
+                            <a:srgbClr val="3C3C3B"/>
+                          </a:solidFill>
+                          <a:latin typeface="Aptos"/>
+                        </a:rPr>
+                        <a:t>4.5</a:t>
                       </a:r>
                     </a:p>
                   </a:txBody>
@@ -11119,28 +11119,28 @@
                           </a:solidFill>
                           <a:latin typeface="Aptos"/>
                         </a:rPr>
-                        <a:t>(1.6)</a:t>
-                      </a:r>
-                    </a:p>
-                  </a:txBody>
-                  <a:tcPr marL="73152" marR="73152" marT="27432" marB="27432" anchor="ctr">
-                    <a:noFill/>
-                  </a:tcPr>
-                </a:tc>
-                <a:tc>
-                  <a:txBody>
-                    <a:bodyPr/>
-                    <a:lstStyle/>
-                    <a:p>
-                      <a:pPr algn="r"/>
-                      <a:r>
-                        <a:rPr sz="1300" b="0">
-                          <a:solidFill>
-                            <a:srgbClr val="3C3C3B"/>
-                          </a:solidFill>
-                          <a:latin typeface="Aptos"/>
-                        </a:rPr>
-                        <a:t>(3.4)</a:t>
+                        <a:t>(1.8)</a:t>
+                      </a:r>
+                    </a:p>
+                  </a:txBody>
+                  <a:tcPr marL="73152" marR="73152" marT="27432" marB="27432" anchor="ctr">
+                    <a:noFill/>
+                  </a:tcPr>
+                </a:tc>
+                <a:tc>
+                  <a:txBody>
+                    <a:bodyPr/>
+                    <a:lstStyle/>
+                    <a:p>
+                      <a:pPr algn="r"/>
+                      <a:r>
+                        <a:rPr sz="1300" b="0">
+                          <a:solidFill>
+                            <a:srgbClr val="3C3C3B"/>
+                          </a:solidFill>
+                          <a:latin typeface="Aptos"/>
+                        </a:rPr>
+                        <a:t>(3.6)</a:t>
                       </a:r>
                     </a:p>
                   </a:txBody>
@@ -11232,7 +11232,7 @@
                           </a:solidFill>
                           <a:latin typeface="Aptos"/>
                         </a:rPr>
-                        <a:t>6.7</a:t>
+                        <a:t>6.5</a:t>
                       </a:r>
                     </a:p>
                   </a:txBody>
@@ -11255,7 +11255,7 @@
                           </a:solidFill>
                           <a:latin typeface="Aptos"/>
                         </a:rPr>
-                        <a:t>13.3</a:t>
+                        <a:t>13.1</a:t>
                       </a:r>
                     </a:p>
                   </a:txBody>
@@ -11343,7 +11343,7 @@
                 </a:solidFill>
                 <a:latin typeface="Aptos"/>
               </a:rPr>
-              <a:t>€1.4m / €1.2m, 30‑Oct‑2026 to 28‑Dec‑2026.</a:t>
+              <a:t>€1.4m / €1.4m, 30‑Oct‑2026 to 28‑Dec‑2026.</a:t>
             </a:r>
           </a:p>
           <a:p>
@@ -11368,7 +11368,7 @@
                 </a:solidFill>
                 <a:latin typeface="Aptos"/>
               </a:rPr>
-              <a:t>€7.0m / €6.1m from 28‑Dec‑2026; the buyer replaces it at the exit.</a:t>
+              <a:t>€7.0m / €7.0m from 28‑Dec‑2026; the buyer replaces it at the exit.</a:t>
             </a:r>
           </a:p>
           <a:p>
@@ -11482,7 +11482,7 @@
           <a:lstStyle/>
           <a:p>
             <a:r>
-              <a:t>All-in cost of 1,642 / 1,612 k€ per built MW against a 2,450 k€/MW COD price; HTM NPV €13.4m / €17.2m at 8.0%</a:t>
+              <a:t>All-in cost of 1,642 / 1,642 k€ per built MW against a 2,450 k€/MW COD price; HTM NPV €13.4m / €13.4m at 8.0%</a:t>
             </a:r>
           </a:p>
         </p:txBody>
@@ -11788,7 +11788,7 @@
                 </a:solidFill>
                 <a:latin typeface="Aptos"/>
               </a:rPr>
-              <a:t>The commitments reduce HTM NPV by €18.1m / €14.2m against the zero bid; construction is €150.9m / €148.3m of the all-in commitment.</a:t>
+              <a:t>The commitments reduce HTM NPV by €18.1m / €18.1m against the zero bid; construction is €150.9m / €150.9m of the all-in commitment.</a:t>
             </a:r>
           </a:p>
         </p:txBody>
@@ -12085,7 +12085,7 @@
                           </a:solidFill>
                           <a:latin typeface="Aptos"/>
                         </a:rPr>
-                        <a:t>33.6</a:t>
+                        <a:t>30.8</a:t>
                       </a:r>
                     </a:p>
                   </a:txBody>
@@ -12127,7 +12127,7 @@
                           </a:solidFill>
                           <a:latin typeface="Aptos"/>
                         </a:rPr>
-                        <a:t>(11.0)</a:t>
+                        <a:t>(13.9)</a:t>
                       </a:r>
                     </a:p>
                   </a:txBody>
@@ -12242,7 +12242,7 @@
                           </a:solidFill>
                           <a:latin typeface="Aptos"/>
                         </a:rPr>
-                        <a:t>17.2</a:t>
+                        <a:t>13.4</a:t>
                       </a:r>
                     </a:p>
                   </a:txBody>
@@ -12288,7 +12288,7 @@
                           </a:solidFill>
                           <a:latin typeface="Aptos"/>
                         </a:rPr>
-                        <a:t>(14.2)</a:t>
+                        <a:t>(18.1)</a:t>
                       </a:r>
                     </a:p>
                   </a:txBody>
@@ -12401,7 +12401,7 @@
                           </a:solidFill>
                           <a:latin typeface="Aptos"/>
                         </a:rPr>
-                        <a:t>1,612</a:t>
+                        <a:t>1,642</a:t>
                       </a:r>
                     </a:p>
                   </a:txBody>
@@ -12707,7 +12707,7 @@
                           </a:solidFill>
                           <a:latin typeface="Aptos"/>
                         </a:rPr>
-                        <a:t>7.3</a:t>
+                        <a:t>8.2</a:t>
                       </a:r>
                     </a:p>
                   </a:txBody>
@@ -13013,7 +13013,7 @@
                           </a:solidFill>
                           <a:latin typeface="Aptos"/>
                         </a:rPr>
-                        <a:t>148.3</a:t>
+                        <a:t>150.9</a:t>
                       </a:r>
                     </a:p>
                   </a:txBody>
@@ -13166,7 +13166,7 @@
                           </a:solidFill>
                           <a:latin typeface="Aptos"/>
                         </a:rPr>
-                        <a:t>8.2</a:t>
+                        <a:t>8.5</a:t>
                       </a:r>
                     </a:p>
                   </a:txBody>
@@ -13319,7 +13319,7 @@
                           </a:solidFill>
                           <a:latin typeface="Aptos"/>
                         </a:rPr>
-                        <a:t>1.1</a:t>
+                        <a:t>1.4</a:t>
                       </a:r>
                     </a:p>
                   </a:txBody>
@@ -13431,7 +13431,7 @@
                 </a:solidFill>
                 <a:latin typeface="Aptos"/>
               </a:rPr>
-              <a:t>FEP proceeds of €124.4m / €127.2m on a €245.0m price, a 1.78x / 1.85x MOIC.</a:t>
+              <a:t>FEP proceeds of €124.4m / €124.4m on a €245.0m price, a 1.78x / 1.78x MOIC.</a:t>
             </a:r>
           </a:p>
           <a:p>
@@ -13456,7 +13456,7 @@
                 </a:solidFill>
                 <a:latin typeface="Aptos"/>
               </a:rPr>
-              <a:t>4.89x / 5.13x MOIC; minimum DSCR 1.33x / 1.37x.</a:t>
+              <a:t>4.89x / 4.89x MOIC; minimum DSCR 1.33x / 1.33x.</a:t>
             </a:r>
           </a:p>
         </p:txBody>
@@ -13545,7 +13545,7 @@
           <a:lstStyle/>
           <a:p>
             <a:r>
-              <a:t>Unbuilt overbuild: €1.4m / €1.1m of PB and 33.8 / 28.6 MVA of connection right lost pro rata; a full call is unresolved</a:t>
+              <a:t>Unbuilt overbuild: €1.4m / €1.4m of PB and 33.8 / 33.8 MVA of connection right lost pro rata; a full call is unresolved</a:t>
             </a:r>
           </a:p>
         </p:txBody>
@@ -13987,7 +13987,7 @@
                           </a:solidFill>
                           <a:latin typeface="Aptos"/>
                         </a:rPr>
-                        <a:t>€1.4m / €1.1m, the PB on the extra MW.</a:t>
+                        <a:t>€1.4m / €1.4m, the PB on the extra MW.</a:t>
                       </a:r>
                     </a:p>
                   </a:txBody>
@@ -14054,7 +14054,7 @@
                           </a:solidFill>
                           <a:latin typeface="Aptos"/>
                         </a:rPr>
-                        <a:t>€7.0m / €6.1m: COD IRR 35.8% / 38.7%, HTM IRR 9.1% / 9.5%.</a:t>
+                        <a:t>€7.0m / €7.0m: COD IRR 35.8% / 35.8%, HTM IRR 9.1% / 9.1%.</a:t>
                       </a:r>
                     </a:p>
                   </a:txBody>
@@ -14188,7 +14188,7 @@
                           </a:solidFill>
                           <a:latin typeface="Aptos"/>
                         </a:rPr>
-                        <a:t>33.8 / 28.6 MVA, in the pro-rata reading only (GYIK Q72: a full call keeps the right). Not reflected in generation or price.</a:t>
+                        <a:t>33.8 / 33.8 MVA, in the pro-rata reading only (GYIK Q72: a full call keeps the right). Not reflected in generation or price.</a:t>
                       </a:r>
                     </a:p>
                   </a:txBody>
@@ -14322,7 +14322,7 @@
                           </a:solidFill>
                           <a:latin typeface="Aptos"/>
                         </a:rPr>
-                        <a:t>Points 80.50 / 63.75, returns unchanged. BESS costs −6.5 / −5.1 pp of COD IRR with no BESS revenue.</a:t>
+                        <a:t>Points 80.50 / 80.50, returns unchanged. BESS costs −6.5 / −6.5 pp of COD IRR with no BESS revenue.</a:t>
                       </a:r>
                     </a:p>
                   </a:txBody>
@@ -14429,7 +14429,7 @@
                 </a:solidFill>
                 <a:latin typeface="Aptos"/>
               </a:rPr>
-              <a:t>The grid connection stays at 100 MVA. Building the overbuild lifts the all-in cost to COD from €164.2m / €161.2m to €217.9m / €203.3m. In that case COD IRR is 54.4% / 53.8% and HTM IRR is 11.5% / 11.6%. The build decision passes to the buyer at RtB.</a:t>
+              <a:t>The grid connection stays at 100 MVA. Building the overbuild lifts the all-in cost to COD from €164.2m / €164.2m to €217.9m / €217.9m. In that case COD IRR is 54.4% / 54.4% and HTM IRR is 11.5% / 11.5%. The build decision passes to the buyer at RtB.</a:t>
             </a:r>
           </a:p>
         </p:txBody>

</xml_diff>

<commit_message>
Rebuild the IC deck for one strategy across both bids
Co-Authored-By: Claude Opus 5.5 <noreply@anthropic.com>
Claude-Session: https://claude.ai/code/session_011Cy4jTfjKbxPfMRQvaZwVT
</commit_message>
<xml_diff>
--- a/projects/bora_bidding/out/Bora_Bid_IC.pptx
+++ b/projects/bora_bidding/out/Bora_Bid_IC.pptx
@@ -5831,7 +5831,7 @@
           <a:lstStyle/>
           <a:p>
             <a:r>
-              <a:t>Submit both bids at 85 / 85 points: FEP earns €6.5m / €6.5m at the RtB exit, a 22.2% / 22.2% IRR</a:t>
+              <a:t>Submit both bids with the same commitments at 85 points each: FEP earns €13.1m at the RtB exit, a 22.2% IRR</a:t>
             </a:r>
           </a:p>
         </p:txBody>
@@ -6137,7 +6137,7 @@
                 </a:solidFill>
                 <a:latin typeface="Aptos"/>
               </a:rPr>
-              <a:t>Against the zero bid, the commitments cost €0.8m / €0.8m of RtB profit and 2.4 / 2.4 pp of HTM IRR, and add €23.4m / €23.4m to the all-in commitment.</a:t>
+              <a:t>Against the zero bid, the commitments cost €0.8m of RtB profit and 2.4 pp of HTM IRR per bid, and add €23.4m per bid to the all-in commitment.</a:t>
             </a:r>
           </a:p>
         </p:txBody>
@@ -6227,7 +6227,7 @@
                           </a:solidFill>
                           <a:latin typeface="Aptos"/>
                         </a:rPr>
-                        <a:t>Zero bid</a:t>
+                        <a:t>Zero bid, per bid</a:t>
                       </a:r>
                     </a:p>
                   </a:txBody>
@@ -6250,7 +6250,7 @@
                           </a:solidFill>
                           <a:latin typeface="Aptos"/>
                         </a:rPr>
-                        <a:t>BORA 1</a:t>
+                        <a:t>Per bid</a:t>
                       </a:r>
                     </a:p>
                   </a:txBody>
@@ -6273,7 +6273,7 @@
                           </a:solidFill>
                           <a:latin typeface="Aptos"/>
                         </a:rPr>
-                        <a:t>BORA 2</a:t>
+                        <a:t>Both bids</a:t>
                       </a:r>
                     </a:p>
                   </a:txBody>
@@ -6386,7 +6386,7 @@
                           </a:solidFill>
                           <a:latin typeface="Aptos"/>
                         </a:rPr>
-                        <a:t>85</a:t>
+                        <a:t>–</a:t>
                       </a:r>
                     </a:p>
                   </a:txBody>
@@ -6497,7 +6497,7 @@
                           </a:solidFill>
                           <a:latin typeface="Aptos"/>
                         </a:rPr>
-                        <a:t>6.5</a:t>
+                        <a:t>13.1</a:t>
                       </a:r>
                     </a:p>
                   </a:txBody>
@@ -6608,7 +6608,7 @@
                           </a:solidFill>
                           <a:latin typeface="Aptos"/>
                         </a:rPr>
-                        <a:t>22.2%</a:t>
+                        <a:t>–</a:t>
                       </a:r>
                     </a:p>
                   </a:txBody>
@@ -6719,7 +6719,7 @@
                           </a:solidFill>
                           <a:latin typeface="Aptos"/>
                         </a:rPr>
-                        <a:t>37.8%</a:t>
+                        <a:t>–</a:t>
                       </a:r>
                     </a:p>
                   </a:txBody>
@@ -6830,7 +6830,7 @@
                           </a:solidFill>
                           <a:latin typeface="Aptos"/>
                         </a:rPr>
-                        <a:t>9.5%</a:t>
+                        <a:t>–</a:t>
                       </a:r>
                     </a:p>
                   </a:txBody>
@@ -6945,7 +6945,7 @@
                           </a:solidFill>
                           <a:latin typeface="Aptos"/>
                         </a:rPr>
-                        <a:t>171.2</a:t>
+                        <a:t>342.4</a:t>
                       </a:r>
                     </a:p>
                   </a:txBody>
@@ -6969,7 +6969,7 @@
         <p:spPr>
           <a:xfrm>
             <a:off x="13990320" y="2240280"/>
-            <a:ext cx="4224528" cy="4297680"/>
+            <a:ext cx="4224528" cy="3749039"/>
           </a:xfrm>
           <a:prstGeom prst="rect">
             <a:avLst/>
@@ -7024,7 +7024,7 @@
                 </a:solidFill>
                 <a:latin typeface="Aptos"/>
               </a:rPr>
-              <a:t>Submit both bids by 30‑Oct‑2026: </a:t>
+              <a:t>Submit BORA 1 and BORA 2 by 30‑Oct‑2026, each with: </a:t>
             </a:r>
             <a:r>
               <a:rPr sz="1300" b="0">
@@ -7033,7 +7033,7 @@
                 </a:solidFill>
                 <a:latin typeface="Aptos"/>
               </a:rPr>
-              <a:t>municipal 50 k€/MW; community 3.00 / 3.00 €/MWh; overbuild 51% / 51% (not built); BESS 51% / 51% of MVA, 4 h; PB at the 1.0x minimum; partial award, shared connection, EU turbines and transformers.</a:t>
+              <a:t>municipal 50 k€/MW; community 3.00 €/MWh; overbuild 51% (not built); BESS 51% of MVA, 4 h; PB at the 1.0x minimum; partial award, shared connection, EU turbines and transformers.</a:t>
             </a:r>
           </a:p>
           <a:p>
@@ -7049,7 +7049,7 @@
                 </a:solidFill>
                 <a:latin typeface="Aptos"/>
               </a:rPr>
-              <a:t>Day one, at submission: </a:t>
+              <a:t>Day one, at submission (both bids): </a:t>
             </a:r>
             <a:r>
               <a:rPr sz="1300" b="0">
@@ -7058,7 +7058,7 @@
                 </a:solidFill>
                 <a:latin typeface="Aptos"/>
               </a:rPr>
-              <a:t>participation fee €0.008m per bid (cash) and bid guarantee €1.4m / €1.4m.</a:t>
+              <a:t>participation fees €0.016m in cash and bid guarantees of €2.8m.</a:t>
             </a:r>
           </a:p>
           <a:p>
@@ -7074,7 +7074,7 @@
                 </a:solidFill>
                 <a:latin typeface="Aptos"/>
               </a:rPr>
-              <a:t>After award (13‑Dec‑2026): </a:t>
+              <a:t>After award (13‑Dec‑2026), both bids: </a:t>
             </a:r>
             <a:r>
               <a:rPr sz="1300" b="0">
@@ -7083,32 +7083,7 @@
                 </a:solidFill>
                 <a:latin typeface="Aptos"/>
               </a:rPr>
-              <a:t>PB guarantee €7.0m / €7.0m by 28‑Dec‑2026, which replaces the bid guarantee; TSO cash security €1.2m per bid by 30‑Dec‑2026.</a:t>
-            </a:r>
-          </a:p>
-          <a:p>
-            <a:pPr algn="l">
-              <a:spcBef>
-                <a:spcPts val="800"/>
-              </a:spcBef>
-            </a:pPr>
-            <a:r>
-              <a:rPr sz="1300" b="1">
-                <a:solidFill>
-                  <a:srgbClr val="3C3C3B"/>
-                </a:solidFill>
-                <a:latin typeface="Aptos"/>
-              </a:rPr>
-              <a:t>Before submission: </a:t>
-            </a:r>
-            <a:r>
-              <a:rPr sz="1300" b="0">
-                <a:solidFill>
-                  <a:srgbClr val="3C3C3B"/>
-                </a:solidFill>
-                <a:latin typeface="Aptos"/>
-              </a:rPr>
-              <a:t>legal confirmation that the two bids sit within the 100 MVA group cap per node.</a:t>
+              <a:t>PB guarantees of €14.0m by 28‑Dec‑2026, replacing the bid guarantees; TSO cash security of €2.5m by 30‑Dec‑2026.</a:t>
             </a:r>
           </a:p>
         </p:txBody>
@@ -7142,7 +7117,7 @@
                 </a:solidFill>
                 <a:latin typeface="Aptos"/>
               </a:rPr>
-              <a:t>Post-tax, FEP share, EU turbine, base case (overbuild not built, BESS built, PB lost pro rata to the shortfall); RtB exit 31‑Dec‑2029. Zero bid = every commitment at its zero level.</a:t>
+              <a:t>Post-tax, FEP share, EU turbine, base case (overbuild not built, BESS built, PB lost pro rata to the shortfall); RtB exit 31‑Dec‑2029. Zero bid = every commitment at its zero level. The two bids are identical, so IRRs are the same per bid and for both.</a:t>
             </a:r>
           </a:p>
           <a:p>
@@ -7197,7 +7172,7 @@
           <a:lstStyle/>
           <a:p>
             <a:r>
-              <a:t>Municipal buys 20 points for 0.4 pp of HTM IRR; BESS (1.2 pp) and community (0.6 pp) carry the return cost on BORA 1</a:t>
+              <a:t>Municipal buys 20 points for 0.4 pp of HTM IRR; BESS (1.2 pp) and community (0.6 pp) carry the return cost</a:t>
             </a:r>
           </a:p>
         </p:txBody>
@@ -7503,7 +7478,7 @@
                 </a:solidFill>
                 <a:latin typeface="Aptos"/>
               </a:rPr>
-              <a:t>Each commitment is measured alone against the zero bid; the PB stays at the 1.0x minimum because 2.0x adds 5 points for one more PB of guarantee.</a:t>
+              <a:t>Each commitment is measured alone against the zero bid, per bid; the PB stays at the minimum because 2.0x adds 5 points for one more PB of guarantee.</a:t>
             </a:r>
           </a:p>
         </p:txBody>
@@ -7518,7 +7493,7 @@
         </p:nvGraphicFramePr>
         <p:xfrm>
           <a:off x="4498848" y="2240280"/>
-          <a:ext cx="13716000" cy="4764024"/>
+          <a:ext cx="13716000" cy="4507992"/>
         </p:xfrm>
         <a:graphic>
           <a:graphicData uri="http://schemas.openxmlformats.org/drawingml/2006/table">
@@ -7527,14 +7502,14 @@
                 <a:tableStyleId>{5C22544A-7EE6-4342-B048-85BDC9FD1C3A}</a:tableStyleId>
               </a:tblPr>
               <a:tblGrid>
-                <a:gridCol w="2834640"/>
-                <a:gridCol w="1783080"/>
-                <a:gridCol w="1097280"/>
+                <a:gridCol w="2926080"/>
+                <a:gridCol w="1371600"/>
                 <a:gridCol w="1188720"/>
-                <a:gridCol w="1097280"/>
-                <a:gridCol w="1097280"/>
-                <a:gridCol w="1417320"/>
-                <a:gridCol w="3200400"/>
+                <a:gridCol w="1188720"/>
+                <a:gridCol w="1143000"/>
+                <a:gridCol w="1143000"/>
+                <a:gridCol w="1600200"/>
+                <a:gridCol w="3154680"/>
               </a:tblGrid>
               <a:tr h="539496">
                 <a:tc>
@@ -7550,7 +7525,7 @@
                           </a:solidFill>
                           <a:latin typeface="Aptos"/>
                         </a:rPr>
-                        <a:t>Commitment (B1 / B2)</a:t>
+                        <a:t>Commitment (per bid)</a:t>
                       </a:r>
                     </a:p>
                   </a:txBody>
@@ -7722,7 +7697,7 @@
                   </a:tcPr>
                 </a:tc>
               </a:tr>
-              <a:tr h="603504">
+              <a:tr h="566928">
                 <a:tc>
                   <a:txBody>
                     <a:bodyPr/>
@@ -7759,7 +7734,7 @@
                           </a:solidFill>
                           <a:latin typeface="Aptos"/>
                         </a:rPr>
-                        <a:t>50 / 50 k€/MW</a:t>
+                        <a:t>50 k€/MW</a:t>
                       </a:r>
                     </a:p>
                   </a:txBody>
@@ -7780,7 +7755,7 @@
                           </a:solidFill>
                           <a:latin typeface="Aptos"/>
                         </a:rPr>
-                        <a:t>20 / 20</a:t>
+                        <a:t>20</a:t>
                       </a:r>
                     </a:p>
                   </a:txBody>
@@ -7801,7 +7776,7 @@
                           </a:solidFill>
                           <a:latin typeface="Aptos"/>
                         </a:rPr>
-                        <a:t>0.0 / 0.0</a:t>
+                        <a:t>0.0</a:t>
                       </a:r>
                     </a:p>
                   </a:txBody>
@@ -7822,7 +7797,7 @@
                           </a:solidFill>
                           <a:latin typeface="Aptos"/>
                         </a:rPr>
-                        <a:t>−1.2 / −1.2</a:t>
+                        <a:t>−1.2</a:t>
                       </a:r>
                     </a:p>
                   </a:txBody>
@@ -7843,7 +7818,7 @@
                           </a:solidFill>
                           <a:latin typeface="Aptos"/>
                         </a:rPr>
-                        <a:t>−0.4 / −0.4</a:t>
+                        <a:t>−0.4</a:t>
                       </a:r>
                     </a:p>
                   </a:txBody>
@@ -7864,7 +7839,7 @@
                           </a:solidFill>
                           <a:latin typeface="Aptos"/>
                         </a:rPr>
-                        <a:t>0.0 / 0.0</a:t>
+                        <a:t>0.0</a:t>
                       </a:r>
                     </a:p>
                   </a:txBody>
@@ -7894,7 +7869,7 @@
                   </a:tcPr>
                 </a:tc>
               </a:tr>
-              <a:tr h="603504">
+              <a:tr h="566928">
                 <a:tc>
                   <a:txBody>
                     <a:bodyPr/>
@@ -7931,7 +7906,7 @@
                           </a:solidFill>
                           <a:latin typeface="Aptos"/>
                         </a:rPr>
-                        <a:t>3.00 / 3.00 €/MWh</a:t>
+                        <a:t>3.00 €/MWh</a:t>
                       </a:r>
                     </a:p>
                   </a:txBody>
@@ -7952,7 +7927,7 @@
                           </a:solidFill>
                           <a:latin typeface="Aptos"/>
                         </a:rPr>
-                        <a:t>15 / 15</a:t>
+                        <a:t>15</a:t>
                       </a:r>
                     </a:p>
                   </a:txBody>
@@ -7973,7 +7948,7 @@
                           </a:solidFill>
                           <a:latin typeface="Aptos"/>
                         </a:rPr>
-                        <a:t>0.0 / 0.0</a:t>
+                        <a:t>0.0</a:t>
                       </a:r>
                     </a:p>
                   </a:txBody>
@@ -7994,7 +7969,7 @@
                           </a:solidFill>
                           <a:latin typeface="Aptos"/>
                         </a:rPr>
-                        <a:t>−2.6 / −2.6</a:t>
+                        <a:t>−2.6</a:t>
                       </a:r>
                     </a:p>
                   </a:txBody>
@@ -8015,7 +7990,7 @@
                           </a:solidFill>
                           <a:latin typeface="Aptos"/>
                         </a:rPr>
-                        <a:t>−0.6 / −0.6</a:t>
+                        <a:t>−0.6</a:t>
                       </a:r>
                     </a:p>
                   </a:txBody>
@@ -8036,7 +8011,7 @@
                           </a:solidFill>
                           <a:latin typeface="Aptos"/>
                         </a:rPr>
-                        <a:t>0.0 / 0.0</a:t>
+                        <a:t>0.0</a:t>
                       </a:r>
                     </a:p>
                   </a:txBody>
@@ -8057,7 +8032,7 @@
                           </a:solidFill>
                           <a:latin typeface="Aptos"/>
                         </a:rPr>
-                        <a:t>Operating cost after COD. At the band floor, BORA 2 earns 15 points.</a:t>
+                        <a:t>Operating cost after COD.</a:t>
                       </a:r>
                     </a:p>
                   </a:txBody>
@@ -8066,7 +8041,7 @@
                   </a:tcPr>
                 </a:tc>
               </a:tr>
-              <a:tr h="603504">
+              <a:tr h="566928">
                 <a:tc>
                   <a:txBody>
                     <a:bodyPr/>
@@ -8103,7 +8078,7 @@
                           </a:solidFill>
                           <a:latin typeface="Aptos"/>
                         </a:rPr>
-                        <a:t>51% / 51%</a:t>
+                        <a:t>51%</a:t>
                       </a:r>
                     </a:p>
                   </a:txBody>
@@ -8124,7 +8099,7 @@
                           </a:solidFill>
                           <a:latin typeface="Aptos"/>
                         </a:rPr>
-                        <a:t>10 / 10</a:t>
+                        <a:t>10</a:t>
                       </a:r>
                     </a:p>
                   </a:txBody>
@@ -8145,7 +8120,7 @@
                           </a:solidFill>
                           <a:latin typeface="Aptos"/>
                         </a:rPr>
-                        <a:t>(0.5) / (0.5)</a:t>
+                        <a:t>(0.5)</a:t>
                       </a:r>
                     </a:p>
                   </a:txBody>
@@ -8166,7 +8141,7 @@
                           </a:solidFill>
                           <a:latin typeface="Aptos"/>
                         </a:rPr>
-                        <a:t>−1.1 / −1.1</a:t>
+                        <a:t>−1.1</a:t>
                       </a:r>
                     </a:p>
                   </a:txBody>
@@ -8187,7 +8162,7 @@
                           </a:solidFill>
                           <a:latin typeface="Aptos"/>
                         </a:rPr>
-                        <a:t>−0.2 / −0.2</a:t>
+                        <a:t>−0.2</a:t>
                       </a:r>
                     </a:p>
                   </a:txBody>
@@ -8208,7 +8183,7 @@
                           </a:solidFill>
                           <a:latin typeface="Aptos"/>
                         </a:rPr>
-                        <a:t>+1.4 / +1.4</a:t>
+                        <a:t>+1.4</a:t>
                       </a:r>
                     </a:p>
                   </a:txBody>
@@ -8238,7 +8213,7 @@
                   </a:tcPr>
                 </a:tc>
               </a:tr>
-              <a:tr h="603504">
+              <a:tr h="566928">
                 <a:tc>
                   <a:txBody>
                     <a:bodyPr/>
@@ -8275,7 +8250,7 @@
                           </a:solidFill>
                           <a:latin typeface="Aptos"/>
                         </a:rPr>
-                        <a:t>51% / 51% of MVA</a:t>
+                        <a:t>51% of MVA</a:t>
                       </a:r>
                     </a:p>
                   </a:txBody>
@@ -8296,7 +8271,7 @@
                           </a:solidFill>
                           <a:latin typeface="Aptos"/>
                         </a:rPr>
-                        <a:t>15 / 15</a:t>
+                        <a:t>15</a:t>
                       </a:r>
                     </a:p>
                   </a:txBody>
@@ -8317,7 +8292,7 @@
                           </a:solidFill>
                           <a:latin typeface="Aptos"/>
                         </a:rPr>
-                        <a:t>(0.4) / (0.4)</a:t>
+                        <a:t>(0.4)</a:t>
                       </a:r>
                     </a:p>
                   </a:txBody>
@@ -8338,7 +8313,7 @@
                           </a:solidFill>
                           <a:latin typeface="Aptos"/>
                         </a:rPr>
-                        <a:t>−6.5 / −6.5</a:t>
+                        <a:t>−6.5</a:t>
                       </a:r>
                     </a:p>
                   </a:txBody>
@@ -8359,7 +8334,7 @@
                           </a:solidFill>
                           <a:latin typeface="Aptos"/>
                         </a:rPr>
-                        <a:t>−1.2 / −1.2</a:t>
+                        <a:t>−1.2</a:t>
                       </a:r>
                     </a:p>
                   </a:txBody>
@@ -8380,7 +8355,7 @@
                           </a:solidFill>
                           <a:latin typeface="Aptos"/>
                         </a:rPr>
-                        <a:t>+2.8 / +2.8</a:t>
+                        <a:t>+2.8</a:t>
                       </a:r>
                     </a:p>
                   </a:txBody>
@@ -8410,7 +8385,7 @@
                   </a:tcPr>
                 </a:tc>
               </a:tr>
-              <a:tr h="603504">
+              <a:tr h="566928">
                 <a:tc>
                   <a:txBody>
                     <a:bodyPr/>
@@ -8447,7 +8422,7 @@
                           </a:solidFill>
                           <a:latin typeface="Aptos"/>
                         </a:rPr>
-                        <a:t>1.0x / 1.0x</a:t>
+                        <a:t>1.0x</a:t>
                       </a:r>
                     </a:p>
                   </a:txBody>
@@ -8468,7 +8443,7 @@
                           </a:solidFill>
                           <a:latin typeface="Aptos"/>
                         </a:rPr>
-                        <a:t>0 / 0</a:t>
+                        <a:t>0</a:t>
                       </a:r>
                     </a:p>
                   </a:txBody>
@@ -8573,7 +8548,7 @@
                           </a:solidFill>
                           <a:latin typeface="Aptos"/>
                         </a:rPr>
-                        <a:t>Not raised: 2.0x adds 5 points for one more PB of €7.0m / €7.0m of guarantee.</a:t>
+                        <a:t>Not raised: 2.0x adds 5 points for one more PB of €7.0m of guarantee.</a:t>
                       </a:r>
                     </a:p>
                   </a:txBody>
@@ -8582,7 +8557,7 @@
                   </a:tcPr>
                 </a:tc>
               </a:tr>
-              <a:tr h="603504">
+              <a:tr h="566928">
                 <a:tc>
                   <a:txBody>
                     <a:bodyPr/>
@@ -8640,7 +8615,7 @@
                           </a:solidFill>
                           <a:latin typeface="Aptos"/>
                         </a:rPr>
-                        <a:t>5 / 5 / 12 / 3 each bid</a:t>
+                        <a:t>5 / 5 / 12 / 3</a:t>
                       </a:r>
                     </a:p>
                   </a:txBody>
@@ -8754,7 +8729,7 @@
                   </a:tcPr>
                 </a:tc>
               </a:tr>
-              <a:tr h="603504">
+              <a:tr h="566928">
                 <a:tc>
                   <a:txBody>
                     <a:bodyPr/>
@@ -8805,7 +8780,7 @@
                           </a:solidFill>
                           <a:latin typeface="Aptos"/>
                         </a:rPr>
-                        <a:t>85 / 85</a:t>
+                        <a:t>85</a:t>
                       </a:r>
                     </a:p>
                   </a:txBody>
@@ -8828,7 +8803,7 @@
                           </a:solidFill>
                           <a:latin typeface="Aptos"/>
                         </a:rPr>
-                        <a:t>(0.8) / (0.8)</a:t>
+                        <a:t>(0.8)</a:t>
                       </a:r>
                     </a:p>
                   </a:txBody>
@@ -8851,7 +8826,7 @@
                           </a:solidFill>
                           <a:latin typeface="Aptos"/>
                         </a:rPr>
-                        <a:t>−11.7 / −11.7</a:t>
+                        <a:t>−11.7</a:t>
                       </a:r>
                     </a:p>
                   </a:txBody>
@@ -8874,7 +8849,7 @@
                           </a:solidFill>
                           <a:latin typeface="Aptos"/>
                         </a:rPr>
-                        <a:t>−2.4 / −2.4</a:t>
+                        <a:t>−2.4</a:t>
                       </a:r>
                     </a:p>
                   </a:txBody>
@@ -9019,7 +8994,7 @@
           <a:lstStyle/>
           <a:p>
             <a:r>
-              <a:t>At the RtB exit FEP recovers its cash and earns €6.5m / €6.5m, a 1.25x / 1.25x MOIC</a:t>
+              <a:t>At the RtB exit FEP earns €13.1m on both bids, a 1.25x MOIC; its interest claims are paid ahead of the 70/30 split</a:t>
             </a:r>
           </a:p>
         </p:txBody>
@@ -9325,7 +9300,7 @@
                 </a:solidFill>
                 <a:latin typeface="Aptos"/>
               </a:rPr>
-              <a:t>Of the €15.0m exit premium per bid, FEP nets €8.4m / €8.4m and A.RES €3.4m / €3.4m; at a 100 k€/MVA premium FEP's RtB profit falls to €3.0m / €3.0m.</a:t>
+              <a:t>FEP keeps 55 k€ and A.RES 23 k€ per installed wind MW; at a 100 k€/MVA RtB price, FEP's profit falls to €6.1m for both bids.</a:t>
             </a:r>
           </a:p>
         </p:txBody>
@@ -9340,7 +9315,7 @@
         </p:nvGraphicFramePr>
         <p:xfrm>
           <a:off x="4498848" y="2240280"/>
-          <a:ext cx="9125712" cy="5806440"/>
+          <a:ext cx="9125712" cy="4325112"/>
         </p:xfrm>
         <a:graphic>
           <a:graphicData uri="http://schemas.openxmlformats.org/drawingml/2006/table">
@@ -9349,11 +9324,10 @@
                 <a:tableStyleId>{5C22544A-7EE6-4342-B048-85BDC9FD1C3A}</a:tableStyleId>
               </a:tblPr>
               <a:tblGrid>
-                <a:gridCol w="4279392"/>
-                <a:gridCol w="731520"/>
-                <a:gridCol w="1371600"/>
-                <a:gridCol w="1371600"/>
-                <a:gridCol w="1371600"/>
+                <a:gridCol w="5102352"/>
+                <a:gridCol w="822960"/>
+                <a:gridCol w="1600200"/>
+                <a:gridCol w="1600200"/>
               </a:tblGrid>
               <a:tr h="539496">
                 <a:tc>
@@ -9369,7 +9343,7 @@
                           </a:solidFill>
                           <a:latin typeface="Aptos"/>
                         </a:rPr>
-                        <a:t>RtB exit waterfall (paid)</a:t>
+                        <a:t>Waterfall at the exit, 31‑Dec‑2029</a:t>
                       </a:r>
                     </a:p>
                   </a:txBody>
@@ -9415,7 +9389,7 @@
                           </a:solidFill>
                           <a:latin typeface="Aptos"/>
                         </a:rPr>
-                        <a:t>BORA 1</a:t>
+                        <a:t>Per bid</a:t>
                       </a:r>
                     </a:p>
                   </a:txBody>
@@ -9438,7 +9412,7 @@
                           </a:solidFill>
                           <a:latin typeface="Aptos"/>
                         </a:rPr>
-                        <a:t>BORA 2</a:t>
+                        <a:t>Both bids</a:t>
                       </a:r>
                     </a:p>
                   </a:txBody>
@@ -9448,31 +9422,8 @@
                     </a:solidFill>
                   </a:tcPr>
                 </a:tc>
-                <a:tc>
-                  <a:txBody>
-                    <a:bodyPr/>
-                    <a:lstStyle/>
-                    <a:p>
-                      <a:pPr algn="r"/>
-                      <a:r>
-                        <a:rPr sz="1300" b="1">
-                          <a:solidFill>
-                            <a:srgbClr val="FFFFFF"/>
-                          </a:solidFill>
-                          <a:latin typeface="Aptos"/>
-                        </a:rPr>
-                        <a:t>Total</a:t>
-                      </a:r>
-                    </a:p>
-                  </a:txBody>
-                  <a:tcPr marL="73152" marR="73152" marT="27432" marB="27432" anchor="ctr">
-                    <a:solidFill>
-                      <a:srgbClr val="00A651"/>
-                    </a:solidFill>
-                  </a:tcPr>
-                </a:tc>
               </a:tr>
-              <a:tr h="329184">
+              <a:tr h="420624">
                 <a:tc>
                   <a:txBody>
                     <a:bodyPr/>
@@ -9486,7 +9437,7 @@
                           </a:solidFill>
                           <a:latin typeface="Aptos"/>
                         </a:rPr>
-                        <a:t>Memo: buyer reimbursement (deposits, fees, land)</a:t>
+                        <a:t>RtB price</a:t>
                       </a:r>
                     </a:p>
                   </a:txBody>
@@ -9532,7 +9483,7 @@
                           </a:solidFill>
                           <a:latin typeface="Aptos"/>
                         </a:rPr>
-                        <a:t>21.8</a:t>
+                        <a:t>15.0</a:t>
                       </a:r>
                     </a:p>
                   </a:txBody>
@@ -9553,7 +9504,7 @@
                           </a:solidFill>
                           <a:latin typeface="Aptos"/>
                         </a:rPr>
-                        <a:t>21.8</a:t>
+                        <a:t>30.0</a:t>
                       </a:r>
                     </a:p>
                   </a:txBody>
@@ -9561,29 +9512,8 @@
                     <a:noFill/>
                   </a:tcPr>
                 </a:tc>
-                <a:tc>
-                  <a:txBody>
-                    <a:bodyPr/>
-                    <a:lstStyle/>
-                    <a:p>
-                      <a:pPr algn="r"/>
-                      <a:r>
-                        <a:rPr sz="1300" b="0">
-                          <a:solidFill>
-                            <a:srgbClr val="3C3C3B"/>
-                          </a:solidFill>
-                          <a:latin typeface="Aptos"/>
-                        </a:rPr>
-                        <a:t>43.7</a:t>
-                      </a:r>
-                    </a:p>
-                  </a:txBody>
-                  <a:tcPr marL="73152" marR="73152" marT="27432" marB="27432" anchor="ctr">
-                    <a:noFill/>
-                  </a:tcPr>
-                </a:tc>
               </a:tr>
-              <a:tr h="329184">
+              <a:tr h="420624">
                 <a:tc>
                   <a:txBody>
                     <a:bodyPr/>
@@ -9597,7 +9527,7 @@
                           </a:solidFill>
                           <a:latin typeface="Aptos"/>
                         </a:rPr>
-                        <a:t>Exit premium (RtB price)</a:t>
+                        <a:t>Less sale costs</a:t>
                       </a:r>
                     </a:p>
                   </a:txBody>
@@ -9643,7 +9573,7 @@
                           </a:solidFill>
                           <a:latin typeface="Aptos"/>
                         </a:rPr>
-                        <a:t>15.0</a:t>
+                        <a:t>(0.5)</a:t>
                       </a:r>
                     </a:p>
                   </a:txBody>
@@ -9664,7 +9594,7 @@
                           </a:solidFill>
                           <a:latin typeface="Aptos"/>
                         </a:rPr>
-                        <a:t>15.0</a:t>
+                        <a:t>(1.0)</a:t>
                       </a:r>
                     </a:p>
                   </a:txBody>
@@ -9672,29 +9602,8 @@
                     <a:noFill/>
                   </a:tcPr>
                 </a:tc>
-                <a:tc>
-                  <a:txBody>
-                    <a:bodyPr/>
-                    <a:lstStyle/>
-                    <a:p>
-                      <a:pPr algn="r"/>
-                      <a:r>
-                        <a:rPr sz="1300" b="0">
-                          <a:solidFill>
-                            <a:srgbClr val="3C3C3B"/>
-                          </a:solidFill>
-                          <a:latin typeface="Aptos"/>
-                        </a:rPr>
-                        <a:t>30.0</a:t>
-                      </a:r>
-                    </a:p>
-                  </a:txBody>
-                  <a:tcPr marL="73152" marR="73152" marT="27432" marB="27432" anchor="ctr">
-                    <a:noFill/>
-                  </a:tcPr>
-                </a:tc>
               </a:tr>
-              <a:tr h="329184">
+              <a:tr h="420624">
                 <a:tc>
                   <a:txBody>
                     <a:bodyPr/>
@@ -9708,7 +9617,7 @@
                           </a:solidFill>
                           <a:latin typeface="Aptos"/>
                         </a:rPr>
-                        <a:t>Less sale costs</a:t>
+                        <a:t>Less FEP interest claims (12% deposits, 20% / 2x devex, 6% guarantees)</a:t>
                       </a:r>
                     </a:p>
                   </a:txBody>
@@ -9754,7 +9663,7 @@
                           </a:solidFill>
                           <a:latin typeface="Aptos"/>
                         </a:rPr>
-                        <a:t>(0.5)</a:t>
+                        <a:t>(5.8)</a:t>
                       </a:r>
                     </a:p>
                   </a:txBody>
@@ -9775,7 +9684,7 @@
                           </a:solidFill>
                           <a:latin typeface="Aptos"/>
                         </a:rPr>
-                        <a:t>(0.5)</a:t>
+                        <a:t>(11.6)</a:t>
                       </a:r>
                     </a:p>
                   </a:txBody>
@@ -9783,29 +9692,8 @@
                     <a:noFill/>
                   </a:tcPr>
                 </a:tc>
-                <a:tc>
-                  <a:txBody>
-                    <a:bodyPr/>
-                    <a:lstStyle/>
-                    <a:p>
-                      <a:pPr algn="r"/>
-                      <a:r>
-                        <a:rPr sz="1300" b="0">
-                          <a:solidFill>
-                            <a:srgbClr val="3C3C3B"/>
-                          </a:solidFill>
-                          <a:latin typeface="Aptos"/>
-                        </a:rPr>
-                        <a:t>(1.0)</a:t>
-                      </a:r>
-                    </a:p>
-                  </a:txBody>
-                  <a:tcPr marL="73152" marR="73152" marT="27432" marB="27432" anchor="ctr">
-                    <a:noFill/>
-                  </a:tcPr>
-                </a:tc>
               </a:tr>
-              <a:tr h="329184">
+              <a:tr h="420624">
                 <a:tc>
                   <a:txBody>
                     <a:bodyPr/>
@@ -9819,7 +9707,7 @@
                           </a:solidFill>
                           <a:latin typeface="Aptos"/>
                         </a:rPr>
-                        <a:t>Less FEP claim 12% on deposits and connection fees</a:t>
+                        <a:t>Less DSA</a:t>
                       </a:r>
                     </a:p>
                   </a:txBody>
@@ -9865,7 +9753,7 @@
                           </a:solidFill>
                           <a:latin typeface="Aptos"/>
                         </a:rPr>
-                        <a:t>(1.6)</a:t>
+                        <a:t>(1.2)</a:t>
                       </a:r>
                     </a:p>
                   </a:txBody>
@@ -9886,7 +9774,7 @@
                           </a:solidFill>
                           <a:latin typeface="Aptos"/>
                         </a:rPr>
-                        <a:t>(1.6)</a:t>
+                        <a:t>(2.4)</a:t>
                       </a:r>
                     </a:p>
                   </a:txBody>
@@ -9894,29 +9782,8 @@
                     <a:noFill/>
                   </a:tcPr>
                 </a:tc>
-                <a:tc>
-                  <a:txBody>
-                    <a:bodyPr/>
-                    <a:lstStyle/>
-                    <a:p>
-                      <a:pPr algn="r"/>
-                      <a:r>
-                        <a:rPr sz="1300" b="0">
-                          <a:solidFill>
-                            <a:srgbClr val="3C3C3B"/>
-                          </a:solidFill>
-                          <a:latin typeface="Aptos"/>
-                        </a:rPr>
-                        <a:t>(3.1)</a:t>
-                      </a:r>
-                    </a:p>
-                  </a:txBody>
-                  <a:tcPr marL="73152" marR="73152" marT="27432" marB="27432" anchor="ctr">
-                    <a:noFill/>
-                  </a:tcPr>
-                </a:tc>
               </a:tr>
-              <a:tr h="329184">
+              <a:tr h="420624">
                 <a:tc>
                   <a:txBody>
                     <a:bodyPr/>
@@ -9930,7 +9797,7 @@
                           </a:solidFill>
                           <a:latin typeface="Aptos"/>
                         </a:rPr>
-                        <a:t>Less FEP claim 20% / 2× on devex and land</a:t>
+                        <a:t>Distributable</a:t>
                       </a:r>
                     </a:p>
                   </a:txBody>
@@ -9976,7 +9843,7 @@
                           </a:solidFill>
                           <a:latin typeface="Aptos"/>
                         </a:rPr>
-                        <a:t>(3.1)</a:t>
+                        <a:t>7.5</a:t>
                       </a:r>
                     </a:p>
                   </a:txBody>
@@ -9997,7 +9864,7 @@
                           </a:solidFill>
                           <a:latin typeface="Aptos"/>
                         </a:rPr>
-                        <a:t>(3.1)</a:t>
+                        <a:t>15.0</a:t>
                       </a:r>
                     </a:p>
                   </a:txBody>
@@ -10005,29 +9872,8 @@
                     <a:noFill/>
                   </a:tcPr>
                 </a:tc>
-                <a:tc>
-                  <a:txBody>
-                    <a:bodyPr/>
-                    <a:lstStyle/>
-                    <a:p>
-                      <a:pPr algn="r"/>
-                      <a:r>
-                        <a:rPr sz="1300" b="0">
-                          <a:solidFill>
-                            <a:srgbClr val="3C3C3B"/>
-                          </a:solidFill>
-                          <a:latin typeface="Aptos"/>
-                        </a:rPr>
-                        <a:t>(6.2)</a:t>
-                      </a:r>
-                    </a:p>
-                  </a:txBody>
-                  <a:tcPr marL="73152" marR="73152" marT="27432" marB="27432" anchor="ctr">
-                    <a:noFill/>
-                  </a:tcPr>
-                </a:tc>
               </a:tr>
-              <a:tr h="329184">
+              <a:tr h="420624">
                 <a:tc>
                   <a:txBody>
                     <a:bodyPr/>
@@ -10041,7 +9887,7 @@
                           </a:solidFill>
                           <a:latin typeface="Aptos"/>
                         </a:rPr>
-                        <a:t>Less FEP claim 6% on guarantees</a:t>
+                        <a:t>FEP net: interest claims + 70%, less FEP-borne devex</a:t>
                       </a:r>
                     </a:p>
                   </a:txBody>
@@ -10087,7 +9933,7 @@
                           </a:solidFill>
                           <a:latin typeface="Aptos"/>
                         </a:rPr>
-                        <a:t>(1.1)</a:t>
+                        <a:t>8.4</a:t>
                       </a:r>
                     </a:p>
                   </a:txBody>
@@ -10108,7 +9954,7 @@
                           </a:solidFill>
                           <a:latin typeface="Aptos"/>
                         </a:rPr>
-                        <a:t>(1.1)</a:t>
+                        <a:t>16.7</a:t>
                       </a:r>
                     </a:p>
                   </a:txBody>
@@ -10116,29 +9962,8 @@
                     <a:noFill/>
                   </a:tcPr>
                 </a:tc>
-                <a:tc>
-                  <a:txBody>
-                    <a:bodyPr/>
-                    <a:lstStyle/>
-                    <a:p>
-                      <a:pPr algn="r"/>
-                      <a:r>
-                        <a:rPr sz="1300" b="0">
-                          <a:solidFill>
-                            <a:srgbClr val="3C3C3B"/>
-                          </a:solidFill>
-                          <a:latin typeface="Aptos"/>
-                        </a:rPr>
-                        <a:t>(2.2)</a:t>
-                      </a:r>
-                    </a:p>
-                  </a:txBody>
-                  <a:tcPr marL="73152" marR="73152" marT="27432" marB="27432" anchor="ctr">
-                    <a:noFill/>
-                  </a:tcPr>
-                </a:tc>
               </a:tr>
-              <a:tr h="329184">
+              <a:tr h="420624">
                 <a:tc>
                   <a:txBody>
                     <a:bodyPr/>
@@ -10152,7 +9977,7 @@
                           </a:solidFill>
                           <a:latin typeface="Aptos"/>
                         </a:rPr>
-                        <a:t>Less FEP interest claims, total</a:t>
+                        <a:t>A.RES: 30% + DSA</a:t>
                       </a:r>
                     </a:p>
                   </a:txBody>
@@ -10198,7 +10023,7 @@
                           </a:solidFill>
                           <a:latin typeface="Aptos"/>
                         </a:rPr>
-                        <a:t>(5.8)</a:t>
+                        <a:t>3.4</a:t>
                       </a:r>
                     </a:p>
                   </a:txBody>
@@ -10219,7 +10044,7 @@
                           </a:solidFill>
                           <a:latin typeface="Aptos"/>
                         </a:rPr>
-                        <a:t>(5.8)</a:t>
+                        <a:t>6.9</a:t>
                       </a:r>
                     </a:p>
                   </a:txBody>
@@ -10227,29 +10052,8 @@
                     <a:noFill/>
                   </a:tcPr>
                 </a:tc>
-                <a:tc>
-                  <a:txBody>
-                    <a:bodyPr/>
-                    <a:lstStyle/>
-                    <a:p>
-                      <a:pPr algn="r"/>
-                      <a:r>
-                        <a:rPr sz="1300" b="0">
-                          <a:solidFill>
-                            <a:srgbClr val="3C3C3B"/>
-                          </a:solidFill>
-                          <a:latin typeface="Aptos"/>
-                        </a:rPr>
-                        <a:t>(11.6)</a:t>
-                      </a:r>
-                    </a:p>
-                  </a:txBody>
-                  <a:tcPr marL="73152" marR="73152" marT="27432" marB="27432" anchor="ctr">
-                    <a:noFill/>
-                  </a:tcPr>
-                </a:tc>
               </a:tr>
-              <a:tr h="329184">
+              <a:tr h="420624">
                 <a:tc>
                   <a:txBody>
                     <a:bodyPr/>
@@ -10263,7 +10067,7 @@
                           </a:solidFill>
                           <a:latin typeface="Aptos"/>
                         </a:rPr>
-                        <a:t>Less DSA</a:t>
+                        <a:t>Less guarantee fees, signing and DD, tax</a:t>
                       </a:r>
                     </a:p>
                   </a:txBody>
@@ -10309,7 +10113,7 @@
                           </a:solidFill>
                           <a:latin typeface="Aptos"/>
                         </a:rPr>
-                        <a:t>(1.2)</a:t>
+                        <a:t>(1.8)</a:t>
                       </a:r>
                     </a:p>
                   </a:txBody>
@@ -10330,7 +10134,7 @@
                           </a:solidFill>
                           <a:latin typeface="Aptos"/>
                         </a:rPr>
-                        <a:t>(1.2)</a:t>
+                        <a:t>(3.6)</a:t>
                       </a:r>
                     </a:p>
                   </a:txBody>
@@ -10338,29 +10142,8 @@
                     <a:noFill/>
                   </a:tcPr>
                 </a:tc>
-                <a:tc>
-                  <a:txBody>
-                    <a:bodyPr/>
-                    <a:lstStyle/>
-                    <a:p>
-                      <a:pPr algn="r"/>
-                      <a:r>
-                        <a:rPr sz="1300" b="0">
-                          <a:solidFill>
-                            <a:srgbClr val="3C3C3B"/>
-                          </a:solidFill>
-                          <a:latin typeface="Aptos"/>
-                        </a:rPr>
-                        <a:t>(2.4)</a:t>
-                      </a:r>
-                    </a:p>
-                  </a:txBody>
-                  <a:tcPr marL="73152" marR="73152" marT="27432" marB="27432" anchor="ctr">
-                    <a:noFill/>
-                  </a:tcPr>
-                </a:tc>
               </a:tr>
-              <a:tr h="329184">
+              <a:tr h="420624">
                 <a:tc>
                   <a:txBody>
                     <a:bodyPr/>
@@ -10368,13 +10151,13 @@
                     <a:p>
                       <a:pPr algn="l"/>
                       <a:r>
-                        <a:rPr sz="1300" b="0">
-                          <a:solidFill>
-                            <a:srgbClr val="3C3C3B"/>
-                          </a:solidFill>
-                          <a:latin typeface="Aptos"/>
-                        </a:rPr>
-                        <a:t>Distributable</a:t>
+                        <a:rPr sz="1300" b="1">
+                          <a:solidFill>
+                            <a:srgbClr val="3C3C3B"/>
+                          </a:solidFill>
+                          <a:latin typeface="Aptos"/>
+                        </a:rPr>
+                        <a:t>FEP profit – RtB route</a:t>
                       </a:r>
                     </a:p>
                   </a:txBody>
@@ -10391,7 +10174,7 @@
                     <a:p>
                       <a:pPr algn="l"/>
                       <a:r>
-                        <a:rPr sz="1300" b="0">
+                        <a:rPr sz="1300" b="1">
                           <a:solidFill>
                             <a:srgbClr val="919191"/>
                           </a:solidFill>
@@ -10404,818 +10187,6 @@
                   <a:tcPr marL="73152" marR="73152" marT="27432" marB="27432" anchor="ctr">
                     <a:solidFill>
                       <a:srgbClr val="F2F2F2"/>
-                    </a:solidFill>
-                  </a:tcPr>
-                </a:tc>
-                <a:tc>
-                  <a:txBody>
-                    <a:bodyPr/>
-                    <a:lstStyle/>
-                    <a:p>
-                      <a:pPr algn="r"/>
-                      <a:r>
-                        <a:rPr sz="1300" b="0">
-                          <a:solidFill>
-                            <a:srgbClr val="3C3C3B"/>
-                          </a:solidFill>
-                          <a:latin typeface="Aptos"/>
-                        </a:rPr>
-                        <a:t>7.5</a:t>
-                      </a:r>
-                    </a:p>
-                  </a:txBody>
-                  <a:tcPr marL="73152" marR="73152" marT="27432" marB="27432" anchor="ctr">
-                    <a:noFill/>
-                  </a:tcPr>
-                </a:tc>
-                <a:tc>
-                  <a:txBody>
-                    <a:bodyPr/>
-                    <a:lstStyle/>
-                    <a:p>
-                      <a:pPr algn="r"/>
-                      <a:r>
-                        <a:rPr sz="1300" b="0">
-                          <a:solidFill>
-                            <a:srgbClr val="3C3C3B"/>
-                          </a:solidFill>
-                          <a:latin typeface="Aptos"/>
-                        </a:rPr>
-                        <a:t>7.5</a:t>
-                      </a:r>
-                    </a:p>
-                  </a:txBody>
-                  <a:tcPr marL="73152" marR="73152" marT="27432" marB="27432" anchor="ctr">
-                    <a:noFill/>
-                  </a:tcPr>
-                </a:tc>
-                <a:tc>
-                  <a:txBody>
-                    <a:bodyPr/>
-                    <a:lstStyle/>
-                    <a:p>
-                      <a:pPr algn="r"/>
-                      <a:r>
-                        <a:rPr sz="1300" b="0">
-                          <a:solidFill>
-                            <a:srgbClr val="3C3C3B"/>
-                          </a:solidFill>
-                          <a:latin typeface="Aptos"/>
-                        </a:rPr>
-                        <a:t>15.0</a:t>
-                      </a:r>
-                    </a:p>
-                  </a:txBody>
-                  <a:tcPr marL="73152" marR="73152" marT="27432" marB="27432" anchor="ctr">
-                    <a:noFill/>
-                  </a:tcPr>
-                </a:tc>
-              </a:tr>
-              <a:tr h="329184">
-                <a:tc>
-                  <a:txBody>
-                    <a:bodyPr/>
-                    <a:lstStyle/>
-                    <a:p>
-                      <a:pPr algn="l"/>
-                      <a:r>
-                        <a:rPr sz="1300" b="0">
-                          <a:solidFill>
-                            <a:srgbClr val="3C3C3B"/>
-                          </a:solidFill>
-                          <a:latin typeface="Aptos"/>
-                        </a:rPr>
-                        <a:t>FEP 70%</a:t>
-                      </a:r>
-                    </a:p>
-                  </a:txBody>
-                  <a:tcPr marL="73152" marR="73152" marT="27432" marB="27432" anchor="ctr">
-                    <a:solidFill>
-                      <a:srgbClr val="F2F2F2"/>
-                    </a:solidFill>
-                  </a:tcPr>
-                </a:tc>
-                <a:tc>
-                  <a:txBody>
-                    <a:bodyPr/>
-                    <a:lstStyle/>
-                    <a:p>
-                      <a:pPr algn="l"/>
-                      <a:r>
-                        <a:rPr sz="1300" b="0">
-                          <a:solidFill>
-                            <a:srgbClr val="919191"/>
-                          </a:solidFill>
-                          <a:latin typeface="Aptos"/>
-                        </a:rPr>
-                        <a:t>€ m</a:t>
-                      </a:r>
-                    </a:p>
-                  </a:txBody>
-                  <a:tcPr marL="73152" marR="73152" marT="27432" marB="27432" anchor="ctr">
-                    <a:solidFill>
-                      <a:srgbClr val="F2F2F2"/>
-                    </a:solidFill>
-                  </a:tcPr>
-                </a:tc>
-                <a:tc>
-                  <a:txBody>
-                    <a:bodyPr/>
-                    <a:lstStyle/>
-                    <a:p>
-                      <a:pPr algn="r"/>
-                      <a:r>
-                        <a:rPr sz="1300" b="0">
-                          <a:solidFill>
-                            <a:srgbClr val="3C3C3B"/>
-                          </a:solidFill>
-                          <a:latin typeface="Aptos"/>
-                        </a:rPr>
-                        <a:t>5.2</a:t>
-                      </a:r>
-                    </a:p>
-                  </a:txBody>
-                  <a:tcPr marL="73152" marR="73152" marT="27432" marB="27432" anchor="ctr">
-                    <a:noFill/>
-                  </a:tcPr>
-                </a:tc>
-                <a:tc>
-                  <a:txBody>
-                    <a:bodyPr/>
-                    <a:lstStyle/>
-                    <a:p>
-                      <a:pPr algn="r"/>
-                      <a:r>
-                        <a:rPr sz="1300" b="0">
-                          <a:solidFill>
-                            <a:srgbClr val="3C3C3B"/>
-                          </a:solidFill>
-                          <a:latin typeface="Aptos"/>
-                        </a:rPr>
-                        <a:t>5.2</a:t>
-                      </a:r>
-                    </a:p>
-                  </a:txBody>
-                  <a:tcPr marL="73152" marR="73152" marT="27432" marB="27432" anchor="ctr">
-                    <a:noFill/>
-                  </a:tcPr>
-                </a:tc>
-                <a:tc>
-                  <a:txBody>
-                    <a:bodyPr/>
-                    <a:lstStyle/>
-                    <a:p>
-                      <a:pPr algn="r"/>
-                      <a:r>
-                        <a:rPr sz="1300" b="0">
-                          <a:solidFill>
-                            <a:srgbClr val="3C3C3B"/>
-                          </a:solidFill>
-                          <a:latin typeface="Aptos"/>
-                        </a:rPr>
-                        <a:t>10.5</a:t>
-                      </a:r>
-                    </a:p>
-                  </a:txBody>
-                  <a:tcPr marL="73152" marR="73152" marT="27432" marB="27432" anchor="ctr">
-                    <a:noFill/>
-                  </a:tcPr>
-                </a:tc>
-              </a:tr>
-              <a:tr h="329184">
-                <a:tc>
-                  <a:txBody>
-                    <a:bodyPr/>
-                    <a:lstStyle/>
-                    <a:p>
-                      <a:pPr algn="l"/>
-                      <a:r>
-                        <a:rPr sz="1300" b="0">
-                          <a:solidFill>
-                            <a:srgbClr val="3C3C3B"/>
-                          </a:solidFill>
-                          <a:latin typeface="Aptos"/>
-                        </a:rPr>
-                        <a:t>FEP-borne devex principal</a:t>
-                      </a:r>
-                    </a:p>
-                  </a:txBody>
-                  <a:tcPr marL="73152" marR="73152" marT="27432" marB="27432" anchor="ctr">
-                    <a:solidFill>
-                      <a:srgbClr val="F2F2F2"/>
-                    </a:solidFill>
-                  </a:tcPr>
-                </a:tc>
-                <a:tc>
-                  <a:txBody>
-                    <a:bodyPr/>
-                    <a:lstStyle/>
-                    <a:p>
-                      <a:pPr algn="l"/>
-                      <a:r>
-                        <a:rPr sz="1300" b="0">
-                          <a:solidFill>
-                            <a:srgbClr val="919191"/>
-                          </a:solidFill>
-                          <a:latin typeface="Aptos"/>
-                        </a:rPr>
-                        <a:t>€ m</a:t>
-                      </a:r>
-                    </a:p>
-                  </a:txBody>
-                  <a:tcPr marL="73152" marR="73152" marT="27432" marB="27432" anchor="ctr">
-                    <a:solidFill>
-                      <a:srgbClr val="F2F2F2"/>
-                    </a:solidFill>
-                  </a:tcPr>
-                </a:tc>
-                <a:tc>
-                  <a:txBody>
-                    <a:bodyPr/>
-                    <a:lstStyle/>
-                    <a:p>
-                      <a:pPr algn="r"/>
-                      <a:r>
-                        <a:rPr sz="1300" b="0">
-                          <a:solidFill>
-                            <a:srgbClr val="3C3C3B"/>
-                          </a:solidFill>
-                          <a:latin typeface="Aptos"/>
-                        </a:rPr>
-                        <a:t>(2.7)</a:t>
-                      </a:r>
-                    </a:p>
-                  </a:txBody>
-                  <a:tcPr marL="73152" marR="73152" marT="27432" marB="27432" anchor="ctr">
-                    <a:noFill/>
-                  </a:tcPr>
-                </a:tc>
-                <a:tc>
-                  <a:txBody>
-                    <a:bodyPr/>
-                    <a:lstStyle/>
-                    <a:p>
-                      <a:pPr algn="r"/>
-                      <a:r>
-                        <a:rPr sz="1300" b="0">
-                          <a:solidFill>
-                            <a:srgbClr val="3C3C3B"/>
-                          </a:solidFill>
-                          <a:latin typeface="Aptos"/>
-                        </a:rPr>
-                        <a:t>(2.7)</a:t>
-                      </a:r>
-                    </a:p>
-                  </a:txBody>
-                  <a:tcPr marL="73152" marR="73152" marT="27432" marB="27432" anchor="ctr">
-                    <a:noFill/>
-                  </a:tcPr>
-                </a:tc>
-                <a:tc>
-                  <a:txBody>
-                    <a:bodyPr/>
-                    <a:lstStyle/>
-                    <a:p>
-                      <a:pPr algn="r"/>
-                      <a:r>
-                        <a:rPr sz="1300" b="0">
-                          <a:solidFill>
-                            <a:srgbClr val="3C3C3B"/>
-                          </a:solidFill>
-                          <a:latin typeface="Aptos"/>
-                        </a:rPr>
-                        <a:t>(5.4)</a:t>
-                      </a:r>
-                    </a:p>
-                  </a:txBody>
-                  <a:tcPr marL="73152" marR="73152" marT="27432" marB="27432" anchor="ctr">
-                    <a:noFill/>
-                  </a:tcPr>
-                </a:tc>
-              </a:tr>
-              <a:tr h="329184">
-                <a:tc>
-                  <a:txBody>
-                    <a:bodyPr/>
-                    <a:lstStyle/>
-                    <a:p>
-                      <a:pPr algn="l"/>
-                      <a:r>
-                        <a:rPr sz="1300" b="1">
-                          <a:solidFill>
-                            <a:srgbClr val="3C3C3B"/>
-                          </a:solidFill>
-                          <a:latin typeface="Aptos"/>
-                        </a:rPr>
-                        <a:t>FEP net = claims + 70% − devex</a:t>
-                      </a:r>
-                    </a:p>
-                  </a:txBody>
-                  <a:tcPr marL="73152" marR="73152" marT="27432" marB="27432" anchor="ctr">
-                    <a:solidFill>
-                      <a:srgbClr val="F2F2F2"/>
-                    </a:solidFill>
-                  </a:tcPr>
-                </a:tc>
-                <a:tc>
-                  <a:txBody>
-                    <a:bodyPr/>
-                    <a:lstStyle/>
-                    <a:p>
-                      <a:pPr algn="l"/>
-                      <a:r>
-                        <a:rPr sz="1300" b="1">
-                          <a:solidFill>
-                            <a:srgbClr val="919191"/>
-                          </a:solidFill>
-                          <a:latin typeface="Aptos"/>
-                        </a:rPr>
-                        <a:t>€ m</a:t>
-                      </a:r>
-                    </a:p>
-                  </a:txBody>
-                  <a:tcPr marL="73152" marR="73152" marT="27432" marB="27432" anchor="ctr">
-                    <a:solidFill>
-                      <a:srgbClr val="F2F2F2"/>
-                    </a:solidFill>
-                  </a:tcPr>
-                </a:tc>
-                <a:tc>
-                  <a:txBody>
-                    <a:bodyPr/>
-                    <a:lstStyle/>
-                    <a:p>
-                      <a:pPr algn="r"/>
-                      <a:r>
-                        <a:rPr sz="1300" b="1">
-                          <a:solidFill>
-                            <a:srgbClr val="3C3C3B"/>
-                          </a:solidFill>
-                          <a:latin typeface="Aptos"/>
-                        </a:rPr>
-                        <a:t>8.4</a:t>
-                      </a:r>
-                    </a:p>
-                  </a:txBody>
-                  <a:tcPr marL="73152" marR="73152" marT="27432" marB="27432" anchor="ctr">
-                    <a:solidFill>
-                      <a:srgbClr val="E6F4EC"/>
-                    </a:solidFill>
-                  </a:tcPr>
-                </a:tc>
-                <a:tc>
-                  <a:txBody>
-                    <a:bodyPr/>
-                    <a:lstStyle/>
-                    <a:p>
-                      <a:pPr algn="r"/>
-                      <a:r>
-                        <a:rPr sz="1300" b="1">
-                          <a:solidFill>
-                            <a:srgbClr val="3C3C3B"/>
-                          </a:solidFill>
-                          <a:latin typeface="Aptos"/>
-                        </a:rPr>
-                        <a:t>8.4</a:t>
-                      </a:r>
-                    </a:p>
-                  </a:txBody>
-                  <a:tcPr marL="73152" marR="73152" marT="27432" marB="27432" anchor="ctr">
-                    <a:solidFill>
-                      <a:srgbClr val="E6F4EC"/>
-                    </a:solidFill>
-                  </a:tcPr>
-                </a:tc>
-                <a:tc>
-                  <a:txBody>
-                    <a:bodyPr/>
-                    <a:lstStyle/>
-                    <a:p>
-                      <a:pPr algn="r"/>
-                      <a:r>
-                        <a:rPr sz="1300" b="1">
-                          <a:solidFill>
-                            <a:srgbClr val="3C3C3B"/>
-                          </a:solidFill>
-                          <a:latin typeface="Aptos"/>
-                        </a:rPr>
-                        <a:t>16.7</a:t>
-                      </a:r>
-                    </a:p>
-                  </a:txBody>
-                  <a:tcPr marL="73152" marR="73152" marT="27432" marB="27432" anchor="ctr">
-                    <a:solidFill>
-                      <a:srgbClr val="E6F4EC"/>
-                    </a:solidFill>
-                  </a:tcPr>
-                </a:tc>
-              </a:tr>
-              <a:tr h="329184">
-                <a:tc>
-                  <a:txBody>
-                    <a:bodyPr/>
-                    <a:lstStyle/>
-                    <a:p>
-                      <a:pPr algn="l"/>
-                      <a:r>
-                        <a:rPr sz="1300" b="0">
-                          <a:solidFill>
-                            <a:srgbClr val="3C3C3B"/>
-                          </a:solidFill>
-                          <a:latin typeface="Aptos"/>
-                        </a:rPr>
-                        <a:t>A.RES 30%</a:t>
-                      </a:r>
-                    </a:p>
-                  </a:txBody>
-                  <a:tcPr marL="73152" marR="73152" marT="27432" marB="27432" anchor="ctr">
-                    <a:solidFill>
-                      <a:srgbClr val="F2F2F2"/>
-                    </a:solidFill>
-                  </a:tcPr>
-                </a:tc>
-                <a:tc>
-                  <a:txBody>
-                    <a:bodyPr/>
-                    <a:lstStyle/>
-                    <a:p>
-                      <a:pPr algn="l"/>
-                      <a:r>
-                        <a:rPr sz="1300" b="0">
-                          <a:solidFill>
-                            <a:srgbClr val="919191"/>
-                          </a:solidFill>
-                          <a:latin typeface="Aptos"/>
-                        </a:rPr>
-                        <a:t>€ m</a:t>
-                      </a:r>
-                    </a:p>
-                  </a:txBody>
-                  <a:tcPr marL="73152" marR="73152" marT="27432" marB="27432" anchor="ctr">
-                    <a:solidFill>
-                      <a:srgbClr val="F2F2F2"/>
-                    </a:solidFill>
-                  </a:tcPr>
-                </a:tc>
-                <a:tc>
-                  <a:txBody>
-                    <a:bodyPr/>
-                    <a:lstStyle/>
-                    <a:p>
-                      <a:pPr algn="r"/>
-                      <a:r>
-                        <a:rPr sz="1300" b="0">
-                          <a:solidFill>
-                            <a:srgbClr val="3C3C3B"/>
-                          </a:solidFill>
-                          <a:latin typeface="Aptos"/>
-                        </a:rPr>
-                        <a:t>2.2</a:t>
-                      </a:r>
-                    </a:p>
-                  </a:txBody>
-                  <a:tcPr marL="73152" marR="73152" marT="27432" marB="27432" anchor="ctr">
-                    <a:noFill/>
-                  </a:tcPr>
-                </a:tc>
-                <a:tc>
-                  <a:txBody>
-                    <a:bodyPr/>
-                    <a:lstStyle/>
-                    <a:p>
-                      <a:pPr algn="r"/>
-                      <a:r>
-                        <a:rPr sz="1300" b="0">
-                          <a:solidFill>
-                            <a:srgbClr val="3C3C3B"/>
-                          </a:solidFill>
-                          <a:latin typeface="Aptos"/>
-                        </a:rPr>
-                        <a:t>2.2</a:t>
-                      </a:r>
-                    </a:p>
-                  </a:txBody>
-                  <a:tcPr marL="73152" marR="73152" marT="27432" marB="27432" anchor="ctr">
-                    <a:noFill/>
-                  </a:tcPr>
-                </a:tc>
-                <a:tc>
-                  <a:txBody>
-                    <a:bodyPr/>
-                    <a:lstStyle/>
-                    <a:p>
-                      <a:pPr algn="r"/>
-                      <a:r>
-                        <a:rPr sz="1300" b="0">
-                          <a:solidFill>
-                            <a:srgbClr val="3C3C3B"/>
-                          </a:solidFill>
-                          <a:latin typeface="Aptos"/>
-                        </a:rPr>
-                        <a:t>4.5</a:t>
-                      </a:r>
-                    </a:p>
-                  </a:txBody>
-                  <a:tcPr marL="73152" marR="73152" marT="27432" marB="27432" anchor="ctr">
-                    <a:noFill/>
-                  </a:tcPr>
-                </a:tc>
-              </a:tr>
-              <a:tr h="329184">
-                <a:tc>
-                  <a:txBody>
-                    <a:bodyPr/>
-                    <a:lstStyle/>
-                    <a:p>
-                      <a:pPr algn="l"/>
-                      <a:r>
-                        <a:rPr sz="1300" b="1">
-                          <a:solidFill>
-                            <a:srgbClr val="3C3C3B"/>
-                          </a:solidFill>
-                          <a:latin typeface="Aptos"/>
-                        </a:rPr>
-                        <a:t>A.RES total = 30% + DSA</a:t>
-                      </a:r>
-                    </a:p>
-                  </a:txBody>
-                  <a:tcPr marL="73152" marR="73152" marT="27432" marB="27432" anchor="ctr">
-                    <a:solidFill>
-                      <a:srgbClr val="F2F2F2"/>
-                    </a:solidFill>
-                  </a:tcPr>
-                </a:tc>
-                <a:tc>
-                  <a:txBody>
-                    <a:bodyPr/>
-                    <a:lstStyle/>
-                    <a:p>
-                      <a:pPr algn="l"/>
-                      <a:r>
-                        <a:rPr sz="1300" b="1">
-                          <a:solidFill>
-                            <a:srgbClr val="919191"/>
-                          </a:solidFill>
-                          <a:latin typeface="Aptos"/>
-                        </a:rPr>
-                        <a:t>€ m</a:t>
-                      </a:r>
-                    </a:p>
-                  </a:txBody>
-                  <a:tcPr marL="73152" marR="73152" marT="27432" marB="27432" anchor="ctr">
-                    <a:solidFill>
-                      <a:srgbClr val="F2F2F2"/>
-                    </a:solidFill>
-                  </a:tcPr>
-                </a:tc>
-                <a:tc>
-                  <a:txBody>
-                    <a:bodyPr/>
-                    <a:lstStyle/>
-                    <a:p>
-                      <a:pPr algn="r"/>
-                      <a:r>
-                        <a:rPr sz="1300" b="1">
-                          <a:solidFill>
-                            <a:srgbClr val="3C3C3B"/>
-                          </a:solidFill>
-                          <a:latin typeface="Aptos"/>
-                        </a:rPr>
-                        <a:t>3.4</a:t>
-                      </a:r>
-                    </a:p>
-                  </a:txBody>
-                  <a:tcPr marL="73152" marR="73152" marT="27432" marB="27432" anchor="ctr">
-                    <a:solidFill>
-                      <a:srgbClr val="E6F4EC"/>
-                    </a:solidFill>
-                  </a:tcPr>
-                </a:tc>
-                <a:tc>
-                  <a:txBody>
-                    <a:bodyPr/>
-                    <a:lstStyle/>
-                    <a:p>
-                      <a:pPr algn="r"/>
-                      <a:r>
-                        <a:rPr sz="1300" b="1">
-                          <a:solidFill>
-                            <a:srgbClr val="3C3C3B"/>
-                          </a:solidFill>
-                          <a:latin typeface="Aptos"/>
-                        </a:rPr>
-                        <a:t>3.4</a:t>
-                      </a:r>
-                    </a:p>
-                  </a:txBody>
-                  <a:tcPr marL="73152" marR="73152" marT="27432" marB="27432" anchor="ctr">
-                    <a:solidFill>
-                      <a:srgbClr val="E6F4EC"/>
-                    </a:solidFill>
-                  </a:tcPr>
-                </a:tc>
-                <a:tc>
-                  <a:txBody>
-                    <a:bodyPr/>
-                    <a:lstStyle/>
-                    <a:p>
-                      <a:pPr algn="r"/>
-                      <a:r>
-                        <a:rPr sz="1300" b="1">
-                          <a:solidFill>
-                            <a:srgbClr val="3C3C3B"/>
-                          </a:solidFill>
-                          <a:latin typeface="Aptos"/>
-                        </a:rPr>
-                        <a:t>6.9</a:t>
-                      </a:r>
-                    </a:p>
-                  </a:txBody>
-                  <a:tcPr marL="73152" marR="73152" marT="27432" marB="27432" anchor="ctr">
-                    <a:solidFill>
-                      <a:srgbClr val="E6F4EC"/>
-                    </a:solidFill>
-                  </a:tcPr>
-                </a:tc>
-              </a:tr>
-              <a:tr h="329184">
-                <a:tc>
-                  <a:txBody>
-                    <a:bodyPr/>
-                    <a:lstStyle/>
-                    <a:p>
-                      <a:pPr algn="l"/>
-                      <a:r>
-                        <a:rPr sz="1300" b="0">
-                          <a:solidFill>
-                            <a:srgbClr val="3C3C3B"/>
-                          </a:solidFill>
-                          <a:latin typeface="Aptos"/>
-                        </a:rPr>
-                        <a:t>Guarantee fees, signing and DD, tax</a:t>
-                      </a:r>
-                    </a:p>
-                  </a:txBody>
-                  <a:tcPr marL="73152" marR="73152" marT="27432" marB="27432" anchor="ctr">
-                    <a:solidFill>
-                      <a:srgbClr val="F2F2F2"/>
-                    </a:solidFill>
-                  </a:tcPr>
-                </a:tc>
-                <a:tc>
-                  <a:txBody>
-                    <a:bodyPr/>
-                    <a:lstStyle/>
-                    <a:p>
-                      <a:pPr algn="l"/>
-                      <a:r>
-                        <a:rPr sz="1300" b="0">
-                          <a:solidFill>
-                            <a:srgbClr val="919191"/>
-                          </a:solidFill>
-                          <a:latin typeface="Aptos"/>
-                        </a:rPr>
-                        <a:t>€ m</a:t>
-                      </a:r>
-                    </a:p>
-                  </a:txBody>
-                  <a:tcPr marL="73152" marR="73152" marT="27432" marB="27432" anchor="ctr">
-                    <a:solidFill>
-                      <a:srgbClr val="F2F2F2"/>
-                    </a:solidFill>
-                  </a:tcPr>
-                </a:tc>
-                <a:tc>
-                  <a:txBody>
-                    <a:bodyPr/>
-                    <a:lstStyle/>
-                    <a:p>
-                      <a:pPr algn="r"/>
-                      <a:r>
-                        <a:rPr sz="1300" b="0">
-                          <a:solidFill>
-                            <a:srgbClr val="3C3C3B"/>
-                          </a:solidFill>
-                          <a:latin typeface="Aptos"/>
-                        </a:rPr>
-                        <a:t>(1.8)</a:t>
-                      </a:r>
-                    </a:p>
-                  </a:txBody>
-                  <a:tcPr marL="73152" marR="73152" marT="27432" marB="27432" anchor="ctr">
-                    <a:noFill/>
-                  </a:tcPr>
-                </a:tc>
-                <a:tc>
-                  <a:txBody>
-                    <a:bodyPr/>
-                    <a:lstStyle/>
-                    <a:p>
-                      <a:pPr algn="r"/>
-                      <a:r>
-                        <a:rPr sz="1300" b="0">
-                          <a:solidFill>
-                            <a:srgbClr val="3C3C3B"/>
-                          </a:solidFill>
-                          <a:latin typeface="Aptos"/>
-                        </a:rPr>
-                        <a:t>(1.8)</a:t>
-                      </a:r>
-                    </a:p>
-                  </a:txBody>
-                  <a:tcPr marL="73152" marR="73152" marT="27432" marB="27432" anchor="ctr">
-                    <a:noFill/>
-                  </a:tcPr>
-                </a:tc>
-                <a:tc>
-                  <a:txBody>
-                    <a:bodyPr/>
-                    <a:lstStyle/>
-                    <a:p>
-                      <a:pPr algn="r"/>
-                      <a:r>
-                        <a:rPr sz="1300" b="0">
-                          <a:solidFill>
-                            <a:srgbClr val="3C3C3B"/>
-                          </a:solidFill>
-                          <a:latin typeface="Aptos"/>
-                        </a:rPr>
-                        <a:t>(3.6)</a:t>
-                      </a:r>
-                    </a:p>
-                  </a:txBody>
-                  <a:tcPr marL="73152" marR="73152" marT="27432" marB="27432" anchor="ctr">
-                    <a:noFill/>
-                  </a:tcPr>
-                </a:tc>
-              </a:tr>
-              <a:tr h="329184">
-                <a:tc>
-                  <a:txBody>
-                    <a:bodyPr/>
-                    <a:lstStyle/>
-                    <a:p>
-                      <a:pPr algn="l"/>
-                      <a:r>
-                        <a:rPr sz="1300" b="1">
-                          <a:solidFill>
-                            <a:srgbClr val="3C3C3B"/>
-                          </a:solidFill>
-                          <a:latin typeface="Aptos"/>
-                        </a:rPr>
-                        <a:t>FEP profit – RtB route</a:t>
-                      </a:r>
-                    </a:p>
-                  </a:txBody>
-                  <a:tcPr marL="73152" marR="73152" marT="27432" marB="27432" anchor="ctr">
-                    <a:solidFill>
-                      <a:srgbClr val="F2F2F2"/>
-                    </a:solidFill>
-                  </a:tcPr>
-                </a:tc>
-                <a:tc>
-                  <a:txBody>
-                    <a:bodyPr/>
-                    <a:lstStyle/>
-                    <a:p>
-                      <a:pPr algn="l"/>
-                      <a:r>
-                        <a:rPr sz="1300" b="1">
-                          <a:solidFill>
-                            <a:srgbClr val="919191"/>
-                          </a:solidFill>
-                          <a:latin typeface="Aptos"/>
-                        </a:rPr>
-                        <a:t>€ m</a:t>
-                      </a:r>
-                    </a:p>
-                  </a:txBody>
-                  <a:tcPr marL="73152" marR="73152" marT="27432" marB="27432" anchor="ctr">
-                    <a:solidFill>
-                      <a:srgbClr val="F2F2F2"/>
-                    </a:solidFill>
-                  </a:tcPr>
-                </a:tc>
-                <a:tc>
-                  <a:txBody>
-                    <a:bodyPr/>
-                    <a:lstStyle/>
-                    <a:p>
-                      <a:pPr algn="r"/>
-                      <a:r>
-                        <a:rPr sz="1300" b="1">
-                          <a:solidFill>
-                            <a:srgbClr val="3C3C3B"/>
-                          </a:solidFill>
-                          <a:latin typeface="Aptos"/>
-                        </a:rPr>
-                        <a:t>6.5</a:t>
-                      </a:r>
-                    </a:p>
-                  </a:txBody>
-                  <a:tcPr marL="73152" marR="73152" marT="27432" marB="27432" anchor="ctr">
-                    <a:solidFill>
-                      <a:srgbClr val="E6F4EC"/>
                     </a:solidFill>
                   </a:tcPr>
                 </a:tc>
@@ -11279,7 +10250,7 @@
         <p:spPr>
           <a:xfrm>
             <a:off x="13990320" y="2240280"/>
-            <a:ext cx="4224528" cy="2377440"/>
+            <a:ext cx="4224528" cy="2514600"/>
           </a:xfrm>
           <a:prstGeom prst="rect">
             <a:avLst/>
@@ -11318,7 +10289,7 @@
                 </a:solidFill>
                 <a:latin typeface="Aptos"/>
               </a:rPr>
-              <a:t>Securities to the exit</a:t>
+              <a:t>Cash to the exit</a:t>
             </a:r>
           </a:p>
           <a:p>
@@ -11334,7 +10305,7 @@
                 </a:solidFill>
                 <a:latin typeface="Aptos"/>
               </a:rPr>
-              <a:t>Bid guarantee </a:t>
+              <a:t/>
             </a:r>
             <a:r>
               <a:rPr sz="1300" b="0">
@@ -11343,7 +10314,7 @@
                 </a:solidFill>
                 <a:latin typeface="Aptos"/>
               </a:rPr>
-              <a:t>€1.4m / €1.4m, 30‑Oct‑2026 to 28‑Dec‑2026.</a:t>
+              <a:t>FEP funds the deposits, connection fees and land; the buyer reimburses €43.7m for both bids at the exit.</a:t>
             </a:r>
           </a:p>
           <a:p>
@@ -11359,7 +10330,7 @@
                 </a:solidFill>
                 <a:latin typeface="Aptos"/>
               </a:rPr>
-              <a:t>PB guarantee </a:t>
+              <a:t/>
             </a:r>
             <a:r>
               <a:rPr sz="1300" b="0">
@@ -11368,7 +10339,7 @@
                 </a:solidFill>
                 <a:latin typeface="Aptos"/>
               </a:rPr>
-              <a:t>€7.0m / €7.0m from 28‑Dec‑2026; the buyer replaces it at the exit.</a:t>
+              <a:t>The largest outlay is the connection fees, €2.8m direct and €37.6m indirect, paid on 08‑Jan‑2029.</a:t>
             </a:r>
           </a:p>
           <a:p>
@@ -11384,7 +10355,7 @@
                 </a:solidFill>
                 <a:latin typeface="Aptos"/>
               </a:rPr>
-              <a:t>Cash: </a:t>
+              <a:t/>
             </a:r>
             <a:r>
               <a:rPr sz="1300" b="0">
@@ -11393,7 +10364,7 @@
                 </a:solidFill>
                 <a:latin typeface="Aptos"/>
               </a:rPr>
-              <a:t>TSO security €1.2m (30‑Dec‑2026) and connection fees €1.4m + €18.8m (08‑Jan‑2029). The buyer reimburses deposits, fees and land at the exit (memo line).</a:t>
+              <a:t>The buyer replaces the PB guarantee at the exit.</a:t>
             </a:r>
           </a:p>
         </p:txBody>
@@ -11427,7 +10398,7 @@
                 </a:solidFill>
                 <a:latin typeface="Aptos"/>
               </a:rPr>
-              <a:t>RtB price 150 k€/MVA × 100 MVA, per the Bora scenarios meeting file (Bora!N5), confirmed 12‑Oct‑2026. Paid amounts at the RtB exit on 31‑Dec‑2029, in devex-file order. The participation fee is not recovered.</a:t>
+              <a:t>RtB price 150 k€/MVA × 100 MVA per bid, per the Bora scenarios meeting file (Bora!N5), confirmed 12‑Oct‑2026. Per-MW figures use 151 MW of installed wind per bid. The participation fee is not recovered.</a:t>
             </a:r>
           </a:p>
           <a:p>
@@ -11482,7 +10453,7 @@
           <a:lstStyle/>
           <a:p>
             <a:r>
-              <a:t>All-in cost of 1,642 / 1,642 k€ per built MW against a 2,450 k€/MW COD price; HTM NPV €13.4m / €13.4m at 8.0%</a:t>
+              <a:t>All-in cost of 1,642 k€ per built MW against a 2,450 k€/MW COD price; HTM NPV of €26.7m for both bids at 8.0%</a:t>
             </a:r>
           </a:p>
         </p:txBody>
@@ -11788,7 +10759,7 @@
                 </a:solidFill>
                 <a:latin typeface="Aptos"/>
               </a:rPr>
-              <a:t>The commitments reduce HTM NPV by €18.1m / €18.1m against the zero bid; construction is €150.9m / €150.9m of the all-in commitment.</a:t>
+              <a:t>Against the zero bid, the commitments reduce FEP's NPV by €13.9m on a sale at COD and €18.1m held to maturity, per bid.</a:t>
             </a:r>
           </a:p>
         </p:txBody>
@@ -11803,7 +10774,7 @@
         </p:nvGraphicFramePr>
         <p:xfrm>
           <a:off x="4498848" y="2240280"/>
-          <a:ext cx="9070847" cy="4325112"/>
+          <a:ext cx="9125712" cy="4050792"/>
         </p:xfrm>
         <a:graphic>
           <a:graphicData uri="http://schemas.openxmlformats.org/drawingml/2006/table">
@@ -11812,13 +10783,12 @@
                 <a:tableStyleId>{5C22544A-7EE6-4342-B048-85BDC9FD1C3A}</a:tableStyleId>
               </a:tblPr>
               <a:tblGrid>
-                <a:gridCol w="3712463"/>
+                <a:gridCol w="4005072"/>
                 <a:gridCol w="822960"/>
-                <a:gridCol w="914400"/>
-                <a:gridCol w="914400"/>
-                <a:gridCol w="914400"/>
-                <a:gridCol w="896112"/>
-                <a:gridCol w="896112"/>
+                <a:gridCol w="1143000"/>
+                <a:gridCol w="1051560"/>
+                <a:gridCol w="1051560"/>
+                <a:gridCol w="1051560"/>
               </a:tblGrid>
               <a:tr h="539496">
                 <a:tc>
@@ -11880,7 +10850,7 @@
                           </a:solidFill>
                           <a:latin typeface="Aptos"/>
                         </a:rPr>
-                        <a:t>Zero bid</a:t>
+                        <a:t>Zero bid, per bid</a:t>
                       </a:r>
                     </a:p>
                   </a:txBody>
@@ -11903,7 +10873,7 @@
                           </a:solidFill>
                           <a:latin typeface="Aptos"/>
                         </a:rPr>
-                        <a:t>BORA 1</a:t>
+                        <a:t>Per bid</a:t>
                       </a:r>
                     </a:p>
                   </a:txBody>
@@ -11926,7 +10896,7 @@
                           </a:solidFill>
                           <a:latin typeface="Aptos"/>
                         </a:rPr>
-                        <a:t>BORA 2</a:t>
+                        <a:t>Δ per bid</a:t>
                       </a:r>
                     </a:p>
                   </a:txBody>
@@ -11949,7 +10919,7 @@
                           </a:solidFill>
                           <a:latin typeface="Aptos"/>
                         </a:rPr>
-                        <a:t>Δ B1</a:t>
+                        <a:t>Both bids</a:t>
                       </a:r>
                     </a:p>
                   </a:txBody>
@@ -11959,31 +10929,8 @@
                     </a:solidFill>
                   </a:tcPr>
                 </a:tc>
-                <a:tc>
-                  <a:txBody>
-                    <a:bodyPr/>
-                    <a:lstStyle/>
-                    <a:p>
-                      <a:pPr algn="r"/>
-                      <a:r>
-                        <a:rPr sz="1300" b="1">
-                          <a:solidFill>
-                            <a:srgbClr val="FFFFFF"/>
-                          </a:solidFill>
-                          <a:latin typeface="Aptos"/>
-                        </a:rPr>
-                        <a:t>Δ B2</a:t>
-                      </a:r>
-                    </a:p>
-                  </a:txBody>
-                  <a:tcPr marL="73152" marR="73152" marT="27432" marB="27432" anchor="ctr">
-                    <a:solidFill>
-                      <a:srgbClr val="00A651"/>
-                    </a:solidFill>
-                  </a:tcPr>
-                </a:tc>
               </a:tr>
-              <a:tr h="420624">
+              <a:tr h="438912">
                 <a:tc>
                   <a:txBody>
                     <a:bodyPr/>
@@ -12085,7 +11032,7 @@
                           </a:solidFill>
                           <a:latin typeface="Aptos"/>
                         </a:rPr>
-                        <a:t>30.8</a:t>
+                        <a:t>(13.9)</a:t>
                       </a:r>
                     </a:p>
                   </a:txBody>
@@ -12106,7 +11053,7 @@
                           </a:solidFill>
                           <a:latin typeface="Aptos"/>
                         </a:rPr>
-                        <a:t>(13.9)</a:t>
+                        <a:t>61.5</a:t>
                       </a:r>
                     </a:p>
                   </a:txBody>
@@ -12114,29 +11061,8 @@
                     <a:noFill/>
                   </a:tcPr>
                 </a:tc>
-                <a:tc>
-                  <a:txBody>
-                    <a:bodyPr/>
-                    <a:lstStyle/>
-                    <a:p>
-                      <a:pPr algn="r"/>
-                      <a:r>
-                        <a:rPr sz="1300" b="0">
-                          <a:solidFill>
-                            <a:srgbClr val="3C3C3B"/>
-                          </a:solidFill>
-                          <a:latin typeface="Aptos"/>
-                        </a:rPr>
-                        <a:t>(13.9)</a:t>
-                      </a:r>
-                    </a:p>
-                  </a:txBody>
-                  <a:tcPr marL="73152" marR="73152" marT="27432" marB="27432" anchor="ctr">
-                    <a:noFill/>
-                  </a:tcPr>
-                </a:tc>
               </a:tr>
-              <a:tr h="420624">
+              <a:tr h="438912">
                 <a:tc>
                   <a:txBody>
                     <a:bodyPr/>
@@ -12242,7 +11168,7 @@
                           </a:solidFill>
                           <a:latin typeface="Aptos"/>
                         </a:rPr>
-                        <a:t>13.4</a:t>
+                        <a:t>(18.1)</a:t>
                       </a:r>
                     </a:p>
                   </a:txBody>
@@ -12265,7 +11191,7 @@
                           </a:solidFill>
                           <a:latin typeface="Aptos"/>
                         </a:rPr>
-                        <a:t>(18.1)</a:t>
+                        <a:t>26.7</a:t>
                       </a:r>
                     </a:p>
                   </a:txBody>
@@ -12275,31 +11201,8 @@
                     </a:solidFill>
                   </a:tcPr>
                 </a:tc>
-                <a:tc>
-                  <a:txBody>
-                    <a:bodyPr/>
-                    <a:lstStyle/>
-                    <a:p>
-                      <a:pPr algn="r"/>
-                      <a:r>
-                        <a:rPr sz="1300" b="1">
-                          <a:solidFill>
-                            <a:srgbClr val="3C3C3B"/>
-                          </a:solidFill>
-                          <a:latin typeface="Aptos"/>
-                        </a:rPr>
-                        <a:t>(18.1)</a:t>
-                      </a:r>
-                    </a:p>
-                  </a:txBody>
-                  <a:tcPr marL="73152" marR="73152" marT="27432" marB="27432" anchor="ctr">
-                    <a:solidFill>
-                      <a:srgbClr val="E6F4EC"/>
-                    </a:solidFill>
-                  </a:tcPr>
-                </a:tc>
               </a:tr>
-              <a:tr h="420624">
+              <a:tr h="438912">
                 <a:tc>
                   <a:txBody>
                     <a:bodyPr/>
@@ -12401,7 +11304,7 @@
                           </a:solidFill>
                           <a:latin typeface="Aptos"/>
                         </a:rPr>
-                        <a:t>1,642</a:t>
+                        <a:t>–</a:t>
                       </a:r>
                     </a:p>
                   </a:txBody>
@@ -12430,29 +11333,8 @@
                     <a:noFill/>
                   </a:tcPr>
                 </a:tc>
-                <a:tc>
-                  <a:txBody>
-                    <a:bodyPr/>
-                    <a:lstStyle/>
-                    <a:p>
-                      <a:pPr algn="r"/>
-                      <a:r>
-                        <a:rPr sz="1300" b="0">
-                          <a:solidFill>
-                            <a:srgbClr val="3C3C3B"/>
-                          </a:solidFill>
-                          <a:latin typeface="Aptos"/>
-                        </a:rPr>
-                        <a:t>–</a:t>
-                      </a:r>
-                    </a:p>
-                  </a:txBody>
-                  <a:tcPr marL="73152" marR="73152" marT="27432" marB="27432" anchor="ctr">
-                    <a:noFill/>
-                  </a:tcPr>
-                </a:tc>
               </a:tr>
-              <a:tr h="420624">
+              <a:tr h="438912">
                 <a:tc>
                   <a:txBody>
                     <a:bodyPr/>
@@ -12554,7 +11436,7 @@
                           </a:solidFill>
                           <a:latin typeface="Aptos"/>
                         </a:rPr>
-                        <a:t>2,450</a:t>
+                        <a:t>–</a:t>
                       </a:r>
                     </a:p>
                   </a:txBody>
@@ -12583,29 +11465,8 @@
                     <a:noFill/>
                   </a:tcPr>
                 </a:tc>
-                <a:tc>
-                  <a:txBody>
-                    <a:bodyPr/>
-                    <a:lstStyle/>
-                    <a:p>
-                      <a:pPr algn="r"/>
-                      <a:r>
-                        <a:rPr sz="1300" b="0">
-                          <a:solidFill>
-                            <a:srgbClr val="3C3C3B"/>
-                          </a:solidFill>
-                          <a:latin typeface="Aptos"/>
-                        </a:rPr>
-                        <a:t>–</a:t>
-                      </a:r>
-                    </a:p>
-                  </a:txBody>
-                  <a:tcPr marL="73152" marR="73152" marT="27432" marB="27432" anchor="ctr">
-                    <a:noFill/>
-                  </a:tcPr>
-                </a:tc>
               </a:tr>
-              <a:tr h="420624">
+              <a:tr h="438912">
                 <a:tc>
                   <a:txBody>
                     <a:bodyPr/>
@@ -12707,7 +11568,7 @@
                           </a:solidFill>
                           <a:latin typeface="Aptos"/>
                         </a:rPr>
-                        <a:t>8.2</a:t>
+                        <a:t>–</a:t>
                       </a:r>
                     </a:p>
                   </a:txBody>
@@ -12728,7 +11589,7 @@
                           </a:solidFill>
                           <a:latin typeface="Aptos"/>
                         </a:rPr>
-                        <a:t>–</a:t>
+                        <a:t>16.5</a:t>
                       </a:r>
                     </a:p>
                   </a:txBody>
@@ -12736,29 +11597,8 @@
                     <a:noFill/>
                   </a:tcPr>
                 </a:tc>
-                <a:tc>
-                  <a:txBody>
-                    <a:bodyPr/>
-                    <a:lstStyle/>
-                    <a:p>
-                      <a:pPr algn="r"/>
-                      <a:r>
-                        <a:rPr sz="1300" b="0">
-                          <a:solidFill>
-                            <a:srgbClr val="3C3C3B"/>
-                          </a:solidFill>
-                          <a:latin typeface="Aptos"/>
-                        </a:rPr>
-                        <a:t>–</a:t>
-                      </a:r>
-                    </a:p>
-                  </a:txBody>
-                  <a:tcPr marL="73152" marR="73152" marT="27432" marB="27432" anchor="ctr">
-                    <a:noFill/>
-                  </a:tcPr>
-                </a:tc>
               </a:tr>
-              <a:tr h="420624">
+              <a:tr h="438912">
                 <a:tc>
                   <a:txBody>
                     <a:bodyPr/>
@@ -12860,7 +11700,7 @@
                           </a:solidFill>
                           <a:latin typeface="Aptos"/>
                         </a:rPr>
-                        <a:t>3.5</a:t>
+                        <a:t>–</a:t>
                       </a:r>
                     </a:p>
                   </a:txBody>
@@ -12881,7 +11721,7 @@
                           </a:solidFill>
                           <a:latin typeface="Aptos"/>
                         </a:rPr>
-                        <a:t>–</a:t>
+                        <a:t>7.0</a:t>
                       </a:r>
                     </a:p>
                   </a:txBody>
@@ -12889,29 +11729,8 @@
                     <a:noFill/>
                   </a:tcPr>
                 </a:tc>
-                <a:tc>
-                  <a:txBody>
-                    <a:bodyPr/>
-                    <a:lstStyle/>
-                    <a:p>
-                      <a:pPr algn="r"/>
-                      <a:r>
-                        <a:rPr sz="1300" b="0">
-                          <a:solidFill>
-                            <a:srgbClr val="3C3C3B"/>
-                          </a:solidFill>
-                          <a:latin typeface="Aptos"/>
-                        </a:rPr>
-                        <a:t>–</a:t>
-                      </a:r>
-                    </a:p>
-                  </a:txBody>
-                  <a:tcPr marL="73152" marR="73152" marT="27432" marB="27432" anchor="ctr">
-                    <a:noFill/>
-                  </a:tcPr>
-                </a:tc>
               </a:tr>
-              <a:tr h="420624">
+              <a:tr h="438912">
                 <a:tc>
                   <a:txBody>
                     <a:bodyPr/>
@@ -13013,7 +11832,7 @@
                           </a:solidFill>
                           <a:latin typeface="Aptos"/>
                         </a:rPr>
-                        <a:t>150.9</a:t>
+                        <a:t>–</a:t>
                       </a:r>
                     </a:p>
                   </a:txBody>
@@ -13034,7 +11853,7 @@
                           </a:solidFill>
                           <a:latin typeface="Aptos"/>
                         </a:rPr>
-                        <a:t>–</a:t>
+                        <a:t>301.8</a:t>
                       </a:r>
                     </a:p>
                   </a:txBody>
@@ -13042,29 +11861,8 @@
                     <a:noFill/>
                   </a:tcPr>
                 </a:tc>
-                <a:tc>
-                  <a:txBody>
-                    <a:bodyPr/>
-                    <a:lstStyle/>
-                    <a:p>
-                      <a:pPr algn="r"/>
-                      <a:r>
-                        <a:rPr sz="1300" b="0">
-                          <a:solidFill>
-                            <a:srgbClr val="3C3C3B"/>
-                          </a:solidFill>
-                          <a:latin typeface="Aptos"/>
-                        </a:rPr>
-                        <a:t>–</a:t>
-                      </a:r>
-                    </a:p>
-                  </a:txBody>
-                  <a:tcPr marL="73152" marR="73152" marT="27432" marB="27432" anchor="ctr">
-                    <a:noFill/>
-                  </a:tcPr>
-                </a:tc>
               </a:tr>
-              <a:tr h="420624">
+              <a:tr h="438912">
                 <a:tc>
                   <a:txBody>
                     <a:bodyPr/>
@@ -13166,7 +11964,7 @@
                           </a:solidFill>
                           <a:latin typeface="Aptos"/>
                         </a:rPr>
-                        <a:t>8.5</a:t>
+                        <a:t>–</a:t>
                       </a:r>
                     </a:p>
                   </a:txBody>
@@ -13187,181 +11985,7 @@
                           </a:solidFill>
                           <a:latin typeface="Aptos"/>
                         </a:rPr>
-                        <a:t>–</a:t>
-                      </a:r>
-                    </a:p>
-                  </a:txBody>
-                  <a:tcPr marL="73152" marR="73152" marT="27432" marB="27432" anchor="ctr">
-                    <a:noFill/>
-                  </a:tcPr>
-                </a:tc>
-                <a:tc>
-                  <a:txBody>
-                    <a:bodyPr/>
-                    <a:lstStyle/>
-                    <a:p>
-                      <a:pPr algn="r"/>
-                      <a:r>
-                        <a:rPr sz="1300" b="0">
-                          <a:solidFill>
-                            <a:srgbClr val="3C3C3B"/>
-                          </a:solidFill>
-                          <a:latin typeface="Aptos"/>
-                        </a:rPr>
-                        <a:t>–</a:t>
-                      </a:r>
-                    </a:p>
-                  </a:txBody>
-                  <a:tcPr marL="73152" marR="73152" marT="27432" marB="27432" anchor="ctr">
-                    <a:noFill/>
-                  </a:tcPr>
-                </a:tc>
-              </a:tr>
-              <a:tr h="420624">
-                <a:tc>
-                  <a:txBody>
-                    <a:bodyPr/>
-                    <a:lstStyle/>
-                    <a:p>
-                      <a:pPr algn="l"/>
-                      <a:r>
-                        <a:rPr sz="1300" b="0">
-                          <a:solidFill>
-                            <a:srgbClr val="3C3C3B"/>
-                          </a:solidFill>
-                          <a:latin typeface="Aptos"/>
-                        </a:rPr>
-                        <a:t>Memo, not in the commitment: PB lost pro rata, overbuild not built</a:t>
-                      </a:r>
-                    </a:p>
-                  </a:txBody>
-                  <a:tcPr marL="73152" marR="73152" marT="27432" marB="27432" anchor="ctr">
-                    <a:solidFill>
-                      <a:srgbClr val="F2F2F2"/>
-                    </a:solidFill>
-                  </a:tcPr>
-                </a:tc>
-                <a:tc>
-                  <a:txBody>
-                    <a:bodyPr/>
-                    <a:lstStyle/>
-                    <a:p>
-                      <a:pPr algn="l"/>
-                      <a:r>
-                        <a:rPr sz="1300" b="0">
-                          <a:solidFill>
-                            <a:srgbClr val="919191"/>
-                          </a:solidFill>
-                          <a:latin typeface="Aptos"/>
-                        </a:rPr>
-                        <a:t>€ m</a:t>
-                      </a:r>
-                    </a:p>
-                  </a:txBody>
-                  <a:tcPr marL="73152" marR="73152" marT="27432" marB="27432" anchor="ctr">
-                    <a:solidFill>
-                      <a:srgbClr val="F2F2F2"/>
-                    </a:solidFill>
-                  </a:tcPr>
-                </a:tc>
-                <a:tc>
-                  <a:txBody>
-                    <a:bodyPr/>
-                    <a:lstStyle/>
-                    <a:p>
-                      <a:pPr algn="r"/>
-                      <a:r>
-                        <a:rPr sz="1300" b="0">
-                          <a:solidFill>
-                            <a:srgbClr val="3C3C3B"/>
-                          </a:solidFill>
-                          <a:latin typeface="Aptos"/>
-                        </a:rPr>
-                        <a:t>–</a:t>
-                      </a:r>
-                    </a:p>
-                  </a:txBody>
-                  <a:tcPr marL="73152" marR="73152" marT="27432" marB="27432" anchor="ctr">
-                    <a:noFill/>
-                  </a:tcPr>
-                </a:tc>
-                <a:tc>
-                  <a:txBody>
-                    <a:bodyPr/>
-                    <a:lstStyle/>
-                    <a:p>
-                      <a:pPr algn="r"/>
-                      <a:r>
-                        <a:rPr sz="1300" b="0">
-                          <a:solidFill>
-                            <a:srgbClr val="3C3C3B"/>
-                          </a:solidFill>
-                          <a:latin typeface="Aptos"/>
-                        </a:rPr>
-                        <a:t>1.4</a:t>
-                      </a:r>
-                    </a:p>
-                  </a:txBody>
-                  <a:tcPr marL="73152" marR="73152" marT="27432" marB="27432" anchor="ctr">
-                    <a:noFill/>
-                  </a:tcPr>
-                </a:tc>
-                <a:tc>
-                  <a:txBody>
-                    <a:bodyPr/>
-                    <a:lstStyle/>
-                    <a:p>
-                      <a:pPr algn="r"/>
-                      <a:r>
-                        <a:rPr sz="1300" b="0">
-                          <a:solidFill>
-                            <a:srgbClr val="3C3C3B"/>
-                          </a:solidFill>
-                          <a:latin typeface="Aptos"/>
-                        </a:rPr>
-                        <a:t>1.4</a:t>
-                      </a:r>
-                    </a:p>
-                  </a:txBody>
-                  <a:tcPr marL="73152" marR="73152" marT="27432" marB="27432" anchor="ctr">
-                    <a:noFill/>
-                  </a:tcPr>
-                </a:tc>
-                <a:tc>
-                  <a:txBody>
-                    <a:bodyPr/>
-                    <a:lstStyle/>
-                    <a:p>
-                      <a:pPr algn="r"/>
-                      <a:r>
-                        <a:rPr sz="1300" b="0">
-                          <a:solidFill>
-                            <a:srgbClr val="3C3C3B"/>
-                          </a:solidFill>
-                          <a:latin typeface="Aptos"/>
-                        </a:rPr>
-                        <a:t>–</a:t>
-                      </a:r>
-                    </a:p>
-                  </a:txBody>
-                  <a:tcPr marL="73152" marR="73152" marT="27432" marB="27432" anchor="ctr">
-                    <a:noFill/>
-                  </a:tcPr>
-                </a:tc>
-                <a:tc>
-                  <a:txBody>
-                    <a:bodyPr/>
-                    <a:lstStyle/>
-                    <a:p>
-                      <a:pPr algn="r"/>
-                      <a:r>
-                        <a:rPr sz="1300" b="0">
-                          <a:solidFill>
-                            <a:srgbClr val="3C3C3B"/>
-                          </a:solidFill>
-                          <a:latin typeface="Aptos"/>
-                        </a:rPr>
-                        <a:t>–</a:t>
+                        <a:t>17.1</a:t>
                       </a:r>
                     </a:p>
                   </a:txBody>
@@ -13383,7 +12007,7 @@
         <p:spPr>
           <a:xfrm>
             <a:off x="13990320" y="2240280"/>
-            <a:ext cx="4224528" cy="1600200"/>
+            <a:ext cx="4224528" cy="1737360"/>
           </a:xfrm>
           <a:prstGeom prst="rect">
             <a:avLst/>
@@ -13416,6 +12040,22 @@
           <a:p>
             <a:pPr algn="l"/>
             <a:r>
+              <a:rPr sz="1600" b="1">
+                <a:solidFill>
+                  <a:srgbClr val="00563C"/>
+                </a:solidFill>
+                <a:latin typeface="Aptos"/>
+              </a:rPr>
+              <a:t>Per bid</a:t>
+            </a:r>
+          </a:p>
+          <a:p>
+            <a:pPr algn="l">
+              <a:spcBef>
+                <a:spcPts val="800"/>
+              </a:spcBef>
+            </a:pPr>
+            <a:r>
               <a:rPr sz="1300" b="1">
                 <a:solidFill>
                   <a:srgbClr val="3C3C3B"/>
@@ -13431,7 +12071,7 @@
                 </a:solidFill>
                 <a:latin typeface="Aptos"/>
               </a:rPr>
-              <a:t>FEP proceeds of €124.4m / €124.4m on a €245.0m price, a 1.78x / 1.78x MOIC.</a:t>
+              <a:t>FEP proceeds of €124.4m on a €245.0m price, a 1.78x MOIC.</a:t>
             </a:r>
           </a:p>
           <a:p>
@@ -13456,7 +12096,7 @@
                 </a:solidFill>
                 <a:latin typeface="Aptos"/>
               </a:rPr>
-              <a:t>4.89x / 4.89x MOIC; minimum DSCR 1.33x / 1.33x.</a:t>
+              <a:t>4.89x MOIC; minimum DSCR 1.33x.</a:t>
             </a:r>
           </a:p>
         </p:txBody>
@@ -13490,7 +12130,7 @@
                 </a:solidFill>
                 <a:latin typeface="Aptos"/>
               </a:rPr>
-              <a:t>NPV at 8.0%. COD 30‑Sep‑2031, 100 MW built; PPA 90 €/MWh; gearing 60.0%. HTM includes the buy-out of the developer at the RtB exit date. The four breakdown lines sum to the all-in commitment on slide 2.</a:t>
+              <a:t>NPV at 8.0%. COD 30‑Sep‑2031, 100 MW built per bid; PPA 90 €/MWh; gearing 60.0%. HTM includes the buy-out of the developer at the RtB exit date. The four breakdown lines sum to the all-in commitment on slide 2.</a:t>
             </a:r>
           </a:p>
           <a:p>
@@ -13545,7 +12185,7 @@
           <a:lstStyle/>
           <a:p>
             <a:r>
-              <a:t>Unbuilt overbuild: €1.4m / €1.4m of PB and 33.8 / 33.8 MVA of connection right lost pro rata; a full call is unresolved</a:t>
+              <a:t>Unbuilt overbuild: both bids lose €2.8m of PB and 67.5 MVA of connection right pro rata; a full call is unresolved</a:t>
             </a:r>
           </a:p>
         </p:txBody>
@@ -13916,7 +12556,7 @@
                           </a:solidFill>
                           <a:latin typeface="Aptos"/>
                         </a:rPr>
-                        <a:t>Exposure (B1 / B2)</a:t>
+                        <a:t>Exposure (per bid)</a:t>
                       </a:r>
                     </a:p>
                   </a:txBody>
@@ -13987,7 +12627,7 @@
                           </a:solidFill>
                           <a:latin typeface="Aptos"/>
                         </a:rPr>
-                        <a:t>€1.4m / €1.4m, the PB on the extra MW.</a:t>
+                        <a:t>€1.4m, the PB on the extra MW.</a:t>
                       </a:r>
                     </a:p>
                   </a:txBody>
@@ -14054,7 +12694,7 @@
                           </a:solidFill>
                           <a:latin typeface="Aptos"/>
                         </a:rPr>
-                        <a:t>€7.0m / €7.0m: COD IRR 35.8% / 35.8%, HTM IRR 9.1% / 9.1%.</a:t>
+                        <a:t>The whole PB: COD IRR 35.8%, HTM IRR 9.1%.</a:t>
                       </a:r>
                     </a:p>
                   </a:txBody>
@@ -14188,7 +12828,7 @@
                           </a:solidFill>
                           <a:latin typeface="Aptos"/>
                         </a:rPr>
-                        <a:t>33.8 / 33.8 MVA, in the pro-rata reading only (GYIK Q72: a full call keeps the right). Not reflected in generation or price.</a:t>
+                        <a:t>33.8 MVA, in the pro-rata reading only (GYIK Q72: a full call keeps the right). Not reflected in generation or price.</a:t>
                       </a:r>
                     </a:p>
                   </a:txBody>
@@ -14232,7 +12872,7 @@
                           </a:solidFill>
                           <a:latin typeface="Aptos"/>
                         </a:rPr>
-                        <a:t>100 MVA group cap per node (Kiírás V.7; GYIK Q52)</a:t>
+                        <a:t>ÖSZ-4 scored on installed wind (GYIK Q20)</a:t>
                       </a:r>
                     </a:p>
                   </a:txBody>
@@ -14255,7 +12895,7 @@
                           </a:solidFill>
                           <a:latin typeface="Aptos"/>
                         </a:rPr>
-                        <a:t>Both bids are invalid if FEP, A.RES and the SPVs count as one company group.</a:t>
+                        <a:t>Points fall to 80.50; returns unchanged.</a:t>
                       </a:r>
                     </a:p>
                   </a:txBody>
@@ -14276,7 +12916,7 @@
                           </a:solidFill>
                           <a:latin typeface="Aptos"/>
                         </a:rPr>
-                        <a:t>Legal confirmation before submission.</a:t>
+                        <a:t>Ranking risk only; the commitment is the same.</a:t>
                       </a:r>
                     </a:p>
                   </a:txBody>
@@ -14299,7 +12939,7 @@
                           </a:solidFill>
                           <a:latin typeface="Aptos"/>
                         </a:rPr>
-                        <a:t>ÖSZ-4 scored on installed wind (GYIK Q20); BESS valued at cost only</a:t>
+                        <a:t>BESS valued at cost only</a:t>
                       </a:r>
                     </a:p>
                   </a:txBody>
@@ -14322,7 +12962,7 @@
                           </a:solidFill>
                           <a:latin typeface="Aptos"/>
                         </a:rPr>
-                        <a:t>Points 80.50 / 80.50, returns unchanged. BESS costs −6.5 / −6.5 pp of COD IRR with no BESS revenue.</a:t>
+                        <a:t>Its return cost (slide 3) excludes any BESS revenue or sale value.</a:t>
                       </a:r>
                     </a:p>
                   </a:txBody>
@@ -14343,7 +12983,7 @@
                           </a:solidFill>
                           <a:latin typeface="Aptos"/>
                         </a:rPr>
-                        <a:t>Ranking risk only. Any BESS revenue is upside.</a:t>
+                        <a:t>Conservative: any BESS revenue is upside.</a:t>
                       </a:r>
                     </a:p>
                   </a:txBody>
@@ -14429,7 +13069,7 @@
                 </a:solidFill>
                 <a:latin typeface="Aptos"/>
               </a:rPr>
-              <a:t>The grid connection stays at 100 MVA. Building the overbuild lifts the all-in cost to COD from €164.2m / €164.2m to €217.9m / €217.9m. In that case COD IRR is 54.4% / 54.4% and HTM IRR is 11.5% / 11.5%. The build decision passes to the buyer at RtB.</a:t>
+              <a:t>The grid connection stays at 100 MVA. Building the overbuild lifts the all-in cost to COD from €164.2m to €217.9m per bid. In that case COD IRR is 54.4% and HTM IRR is 11.5%. The build decision passes to the buyer at RtB.</a:t>
             </a:r>
           </a:p>
         </p:txBody>

</xml_diff>

<commit_message>
Add the Funding and capex slide; bind the deck by name
Co-Authored-By: Claude Opus 5.5 <noreply@anthropic.com>
Claude-Session: https://claude.ai/code/session_011Cy4jTfjKbxPfMRQvaZwVT
</commit_message>
<xml_diff>
--- a/projects/bora_bidding/out/Bora_Bid_IC.pptx
+++ b/projects/bora_bidding/out/Bora_Bid_IC.pptx
@@ -18,6 +18,7 @@
     <p:sldId id="260" r:id="rId10"/>
     <p:sldId id="261" r:id="rId9"/>
     <p:sldId id="262" r:id="rId8"/>
+    <p:sldId id="263" r:id="rId7"/>
   </p:sldIdLst>
   <p:sldSz cx="20105688" cy="11310938"/>
   <p:notesSz cx="6858000" cy="9144000"/>
@@ -5893,7 +5894,7 @@
         </p:nvGraphicFramePr>
         <p:xfrm>
           <a:off x="0" y="0"/>
-          <a:ext cx="3767328" cy="3886200"/>
+          <a:ext cx="3767328" cy="4663440"/>
         </p:xfrm>
         <a:graphic>
           <a:graphicData uri="http://schemas.openxmlformats.org/drawingml/2006/table">
@@ -6004,6 +6005,44 @@
                           <a:latin typeface="Aptos"/>
                         </a:rPr>
                         <a:t>Economics – RtB exit</a:t>
+                      </a:r>
+                    </a:p>
+                  </a:txBody>
+                  <a:tcPr marL="180000" anchor="ctr">
+                    <a:lnL>
+                      <a:noFill/>
+                    </a:lnL>
+                    <a:lnR>
+                      <a:noFill/>
+                    </a:lnR>
+                    <a:lnT w="6350">
+                      <a:solidFill>
+                        <a:srgbClr val="3C3C3B"/>
+                      </a:solidFill>
+                    </a:lnT>
+                    <a:lnB w="6350">
+                      <a:solidFill>
+                        <a:srgbClr val="3C3C3B"/>
+                      </a:solidFill>
+                    </a:lnB>
+                    <a:noFill/>
+                  </a:tcPr>
+                </a:tc>
+              </a:tr>
+              <a:tr h="777240">
+                <a:tc>
+                  <a:txBody>
+                    <a:bodyPr/>
+                    <a:lstStyle/>
+                    <a:p>
+                      <a:r>
+                        <a:rPr sz="1800" b="0">
+                          <a:solidFill>
+                            <a:srgbClr val="3C3C3B"/>
+                          </a:solidFill>
+                          <a:latin typeface="Aptos"/>
+                        </a:rPr>
+                        <a:t>Funding and capex</a:t>
                       </a:r>
                     </a:p>
                   </a:txBody>
@@ -7234,7 +7273,7 @@
         </p:nvGraphicFramePr>
         <p:xfrm>
           <a:off x="0" y="0"/>
-          <a:ext cx="3767328" cy="3886200"/>
+          <a:ext cx="3767328" cy="4663440"/>
         </p:xfrm>
         <a:graphic>
           <a:graphicData uri="http://schemas.openxmlformats.org/drawingml/2006/table">
@@ -7345,6 +7384,44 @@
                           <a:latin typeface="Aptos"/>
                         </a:rPr>
                         <a:t>Economics – RtB exit</a:t>
+                      </a:r>
+                    </a:p>
+                  </a:txBody>
+                  <a:tcPr marL="180000" anchor="ctr">
+                    <a:lnL>
+                      <a:noFill/>
+                    </a:lnL>
+                    <a:lnR>
+                      <a:noFill/>
+                    </a:lnR>
+                    <a:lnT w="6350">
+                      <a:solidFill>
+                        <a:srgbClr val="3C3C3B"/>
+                      </a:solidFill>
+                    </a:lnT>
+                    <a:lnB w="6350">
+                      <a:solidFill>
+                        <a:srgbClr val="3C3C3B"/>
+                      </a:solidFill>
+                    </a:lnB>
+                    <a:noFill/>
+                  </a:tcPr>
+                </a:tc>
+              </a:tr>
+              <a:tr h="777240">
+                <a:tc>
+                  <a:txBody>
+                    <a:bodyPr/>
+                    <a:lstStyle/>
+                    <a:p>
+                      <a:r>
+                        <a:rPr sz="1800" b="0">
+                          <a:solidFill>
+                            <a:srgbClr val="3C3C3B"/>
+                          </a:solidFill>
+                          <a:latin typeface="Aptos"/>
+                        </a:rPr>
+                        <a:t>Funding and capex</a:t>
                       </a:r>
                     </a:p>
                   </a:txBody>
@@ -9056,7 +9133,7 @@
         </p:nvGraphicFramePr>
         <p:xfrm>
           <a:off x="0" y="0"/>
-          <a:ext cx="3767328" cy="3886200"/>
+          <a:ext cx="3767328" cy="4663440"/>
         </p:xfrm>
         <a:graphic>
           <a:graphicData uri="http://schemas.openxmlformats.org/drawingml/2006/table">
@@ -9188,6 +9265,44 @@
                       </a:gsLst>
                       <a:lin scaled="0" ang="0"/>
                     </a:gradFill>
+                  </a:tcPr>
+                </a:tc>
+              </a:tr>
+              <a:tr h="777240">
+                <a:tc>
+                  <a:txBody>
+                    <a:bodyPr/>
+                    <a:lstStyle/>
+                    <a:p>
+                      <a:r>
+                        <a:rPr sz="1800" b="0">
+                          <a:solidFill>
+                            <a:srgbClr val="3C3C3B"/>
+                          </a:solidFill>
+                          <a:latin typeface="Aptos"/>
+                        </a:rPr>
+                        <a:t>Funding and capex</a:t>
+                      </a:r>
+                    </a:p>
+                  </a:txBody>
+                  <a:tcPr marL="180000" anchor="ctr">
+                    <a:lnL>
+                      <a:noFill/>
+                    </a:lnL>
+                    <a:lnR>
+                      <a:noFill/>
+                    </a:lnR>
+                    <a:lnT w="6350">
+                      <a:solidFill>
+                        <a:srgbClr val="3C3C3B"/>
+                      </a:solidFill>
+                    </a:lnT>
+                    <a:lnB w="6350">
+                      <a:solidFill>
+                        <a:srgbClr val="3C3C3B"/>
+                      </a:solidFill>
+                    </a:lnB>
+                    <a:noFill/>
                   </a:tcPr>
                 </a:tc>
               </a:tr>
@@ -10453,7 +10568,7 @@
           <a:lstStyle/>
           <a:p>
             <a:r>
-              <a:t>All-in cost of 1,642 k€ per built MW against a 2,450 k€/MW COD price; HTM NPV of €26.7m for both bids at 8.0%</a:t>
+              <a:t>Both bids need €140.0m of cash equity to COD and up to €14.0m of guarantees; all-in cost is 1,642 k€ per built MW</a:t>
             </a:r>
           </a:p>
         </p:txBody>
@@ -10515,7 +10630,7 @@
         </p:nvGraphicFramePr>
         <p:xfrm>
           <a:off x="0" y="0"/>
-          <a:ext cx="3767328" cy="3886200"/>
+          <a:ext cx="3767328" cy="4663440"/>
         </p:xfrm>
         <a:graphic>
           <a:graphicData uri="http://schemas.openxmlformats.org/drawingml/2006/table">
@@ -10616,6 +10731,3188 @@
                           <a:latin typeface="Aptos"/>
                         </a:rPr>
                         <a:t>Economics – RtB exit</a:t>
+                      </a:r>
+                    </a:p>
+                  </a:txBody>
+                  <a:tcPr marL="180000" anchor="ctr">
+                    <a:lnL>
+                      <a:noFill/>
+                    </a:lnL>
+                    <a:lnR>
+                      <a:noFill/>
+                    </a:lnR>
+                    <a:lnT w="6350">
+                      <a:solidFill>
+                        <a:srgbClr val="3C3C3B"/>
+                      </a:solidFill>
+                    </a:lnT>
+                    <a:lnB w="6350">
+                      <a:solidFill>
+                        <a:srgbClr val="3C3C3B"/>
+                      </a:solidFill>
+                    </a:lnB>
+                    <a:noFill/>
+                  </a:tcPr>
+                </a:tc>
+              </a:tr>
+              <a:tr h="777240">
+                <a:tc>
+                  <a:txBody>
+                    <a:bodyPr/>
+                    <a:lstStyle/>
+                    <a:p>
+                      <a:r>
+                        <a:rPr sz="1800" b="1">
+                          <a:solidFill>
+                            <a:srgbClr val="FFFFFF"/>
+                          </a:solidFill>
+                          <a:latin typeface="Aptos"/>
+                        </a:rPr>
+                        <a:t>Funding and capex</a:t>
+                      </a:r>
+                    </a:p>
+                  </a:txBody>
+                  <a:tcPr marL="180000" anchor="ctr">
+                    <a:lnL>
+                      <a:noFill/>
+                    </a:lnL>
+                    <a:lnR>
+                      <a:noFill/>
+                    </a:lnR>
+                    <a:lnT w="6350">
+                      <a:solidFill>
+                        <a:srgbClr val="3C3C3B"/>
+                      </a:solidFill>
+                    </a:lnT>
+                    <a:lnB w="6350">
+                      <a:solidFill>
+                        <a:srgbClr val="3C3C3B"/>
+                      </a:solidFill>
+                    </a:lnB>
+                    <a:gradFill rotWithShape="1">
+                      <a:gsLst>
+                        <a:gs pos="0">
+                          <a:srgbClr val="00A651"/>
+                        </a:gs>
+                        <a:gs pos="100000">
+                          <a:srgbClr val="00563C"/>
+                        </a:gs>
+                      </a:gsLst>
+                      <a:lin scaled="0" ang="0"/>
+                    </a:gradFill>
+                  </a:tcPr>
+                </a:tc>
+              </a:tr>
+              <a:tr h="777240">
+                <a:tc>
+                  <a:txBody>
+                    <a:bodyPr/>
+                    <a:lstStyle/>
+                    <a:p>
+                      <a:r>
+                        <a:rPr sz="1800" b="0">
+                          <a:solidFill>
+                            <a:srgbClr val="3C3C3B"/>
+                          </a:solidFill>
+                          <a:latin typeface="Aptos"/>
+                        </a:rPr>
+                        <a:t>Economics – COD and HTM</a:t>
+                      </a:r>
+                    </a:p>
+                  </a:txBody>
+                  <a:tcPr marL="180000" anchor="ctr">
+                    <a:lnL>
+                      <a:noFill/>
+                    </a:lnL>
+                    <a:lnR>
+                      <a:noFill/>
+                    </a:lnR>
+                    <a:lnT w="6350">
+                      <a:solidFill>
+                        <a:srgbClr val="3C3C3B"/>
+                      </a:solidFill>
+                    </a:lnT>
+                    <a:lnB w="6350">
+                      <a:solidFill>
+                        <a:srgbClr val="3C3C3B"/>
+                      </a:solidFill>
+                    </a:lnB>
+                    <a:noFill/>
+                  </a:tcPr>
+                </a:tc>
+              </a:tr>
+              <a:tr h="777240">
+                <a:tc>
+                  <a:txBody>
+                    <a:bodyPr/>
+                    <a:lstStyle/>
+                    <a:p>
+                      <a:r>
+                        <a:rPr sz="1800" b="0">
+                          <a:solidFill>
+                            <a:srgbClr val="3C3C3B"/>
+                          </a:solidFill>
+                          <a:latin typeface="Aptos"/>
+                        </a:rPr>
+                        <a:t>Risks and mitigants</a:t>
+                      </a:r>
+                    </a:p>
+                  </a:txBody>
+                  <a:tcPr marL="180000" anchor="ctr">
+                    <a:lnL>
+                      <a:noFill/>
+                    </a:lnL>
+                    <a:lnR>
+                      <a:noFill/>
+                    </a:lnR>
+                    <a:lnT w="6350">
+                      <a:solidFill>
+                        <a:srgbClr val="3C3C3B"/>
+                      </a:solidFill>
+                    </a:lnT>
+                    <a:lnB w="6350">
+                      <a:solidFill>
+                        <a:srgbClr val="3C3C3B"/>
+                      </a:solidFill>
+                    </a:lnB>
+                    <a:noFill/>
+                  </a:tcPr>
+                </a:tc>
+              </a:tr>
+            </a:tbl>
+          </a:graphicData>
+        </a:graphic>
+      </p:graphicFrame>
+      <p:sp>
+        <p:nvSpPr>
+          <p:cNvPr id="4" name="Subtitle"/>
+          <p:cNvSpPr txBox="1"/>
+          <p:nvPr/>
+        </p:nvSpPr>
+        <p:spPr>
+          <a:xfrm>
+            <a:off x="4498848" y="1371600"/>
+            <a:ext cx="13716000" cy="685800"/>
+          </a:xfrm>
+          <a:prstGeom prst="rect">
+            <a:avLst/>
+          </a:prstGeom>
+          <a:noFill/>
+        </p:spPr>
+        <p:txBody>
+          <a:bodyPr wrap="square">
+            <a:spAutoFit/>
+          </a:bodyPr>
+          <a:lstStyle/>
+          <a:p>
+            <a:r>
+              <a:rPr sz="1800" b="1">
+                <a:solidFill>
+                  <a:srgbClr val="3C3C3B"/>
+                </a:solidFill>
+                <a:latin typeface="Aptos"/>
+              </a:rPr>
+              <a:t>€49.9m of the cash is spent by the RtB exit on 31‑Dec‑2029; on the build route, construction equity of €71.1m follows from NTP to COD.</a:t>
+            </a:r>
+          </a:p>
+        </p:txBody>
+      </p:sp>
+      <p:graphicFrame>
+        <p:nvGraphicFramePr>
+          <p:cNvPr id="5" name="Funding"/>
+          <p:cNvGraphicFramePr>
+            <a:graphicFrameLocks noGrp="1"/>
+          </p:cNvGraphicFramePr>
+          <p:nvPr/>
+        </p:nvGraphicFramePr>
+        <p:xfrm>
+          <a:off x="4498848" y="2240280"/>
+          <a:ext cx="8732520" cy="5148072"/>
+        </p:xfrm>
+        <a:graphic>
+          <a:graphicData uri="http://schemas.openxmlformats.org/drawingml/2006/table">
+            <a:tbl>
+              <a:tblPr>
+                <a:tableStyleId>{5C22544A-7EE6-4342-B048-85BDC9FD1C3A}</a:tableStyleId>
+              </a:tblPr>
+              <a:tblGrid>
+                <a:gridCol w="1280160"/>
+                <a:gridCol w="3703320"/>
+                <a:gridCol w="1051560"/>
+                <a:gridCol w="1325880"/>
+                <a:gridCol w="1371600"/>
+              </a:tblGrid>
+              <a:tr h="539496">
+                <a:tc>
+                  <a:txBody>
+                    <a:bodyPr/>
+                    <a:lstStyle/>
+                    <a:p>
+                      <a:pPr algn="l"/>
+                      <a:r>
+                        <a:rPr sz="1300" b="1">
+                          <a:solidFill>
+                            <a:srgbClr val="FFFFFF"/>
+                          </a:solidFill>
+                          <a:latin typeface="Aptos"/>
+                        </a:rPr>
+                        <a:t>Date</a:t>
+                      </a:r>
+                    </a:p>
+                  </a:txBody>
+                  <a:tcPr marL="73152" marR="73152" marT="27432" marB="27432" anchor="ctr">
+                    <a:solidFill>
+                      <a:srgbClr val="00A651"/>
+                    </a:solidFill>
+                  </a:tcPr>
+                </a:tc>
+                <a:tc>
+                  <a:txBody>
+                    <a:bodyPr/>
+                    <a:lstStyle/>
+                    <a:p>
+                      <a:pPr algn="l"/>
+                      <a:r>
+                        <a:rPr sz="1300" b="1">
+                          <a:solidFill>
+                            <a:srgbClr val="FFFFFF"/>
+                          </a:solidFill>
+                          <a:latin typeface="Aptos"/>
+                        </a:rPr>
+                        <a:t>Funding need – both bids</a:t>
+                      </a:r>
+                    </a:p>
+                  </a:txBody>
+                  <a:tcPr marL="73152" marR="73152" marT="27432" marB="27432" anchor="ctr">
+                    <a:solidFill>
+                      <a:srgbClr val="00A651"/>
+                    </a:solidFill>
+                  </a:tcPr>
+                </a:tc>
+                <a:tc>
+                  <a:txBody>
+                    <a:bodyPr/>
+                    <a:lstStyle/>
+                    <a:p>
+                      <a:pPr algn="r"/>
+                      <a:r>
+                        <a:rPr sz="1300" b="1">
+                          <a:solidFill>
+                            <a:srgbClr val="FFFFFF"/>
+                          </a:solidFill>
+                          <a:latin typeface="Aptos"/>
+                        </a:rPr>
+                        <a:t>Cash € m</a:t>
+                      </a:r>
+                    </a:p>
+                  </a:txBody>
+                  <a:tcPr marL="73152" marR="73152" marT="27432" marB="27432" anchor="ctr">
+                    <a:solidFill>
+                      <a:srgbClr val="00A651"/>
+                    </a:solidFill>
+                  </a:tcPr>
+                </a:tc>
+                <a:tc>
+                  <a:txBody>
+                    <a:bodyPr/>
+                    <a:lstStyle/>
+                    <a:p>
+                      <a:pPr algn="r"/>
+                      <a:r>
+                        <a:rPr sz="1300" b="1">
+                          <a:solidFill>
+                            <a:srgbClr val="FFFFFF"/>
+                          </a:solidFill>
+                          <a:latin typeface="Aptos"/>
+                        </a:rPr>
+                        <a:t>Guarantee € m</a:t>
+                      </a:r>
+                    </a:p>
+                  </a:txBody>
+                  <a:tcPr marL="73152" marR="73152" marT="27432" marB="27432" anchor="ctr">
+                    <a:solidFill>
+                      <a:srgbClr val="00A651"/>
+                    </a:solidFill>
+                  </a:tcPr>
+                </a:tc>
+                <a:tc>
+                  <a:txBody>
+                    <a:bodyPr/>
+                    <a:lstStyle/>
+                    <a:p>
+                      <a:pPr algn="r"/>
+                      <a:r>
+                        <a:rPr sz="1300" b="1">
+                          <a:solidFill>
+                            <a:srgbClr val="FFFFFF"/>
+                          </a:solidFill>
+                          <a:latin typeface="Aptos"/>
+                        </a:rPr>
+                        <a:t>Cumulative cash € m</a:t>
+                      </a:r>
+                    </a:p>
+                  </a:txBody>
+                  <a:tcPr marL="73152" marR="73152" marT="27432" marB="27432" anchor="ctr">
+                    <a:solidFill>
+                      <a:srgbClr val="00A651"/>
+                    </a:solidFill>
+                  </a:tcPr>
+                </a:tc>
+              </a:tr>
+              <a:tr h="329184">
+                <a:tc>
+                  <a:txBody>
+                    <a:bodyPr/>
+                    <a:lstStyle/>
+                    <a:p>
+                      <a:pPr algn="l"/>
+                      <a:r>
+                        <a:rPr sz="1300" b="0">
+                          <a:solidFill>
+                            <a:srgbClr val="3C3C3B"/>
+                          </a:solidFill>
+                          <a:latin typeface="Aptos"/>
+                        </a:rPr>
+                        <a:t>31‑Jul‑2026</a:t>
+                      </a:r>
+                    </a:p>
+                  </a:txBody>
+                  <a:tcPr marL="73152" marR="73152" marT="27432" marB="27432" anchor="ctr">
+                    <a:solidFill>
+                      <a:srgbClr val="F2F2F2"/>
+                    </a:solidFill>
+                  </a:tcPr>
+                </a:tc>
+                <a:tc>
+                  <a:txBody>
+                    <a:bodyPr/>
+                    <a:lstStyle/>
+                    <a:p>
+                      <a:pPr algn="l"/>
+                      <a:r>
+                        <a:rPr sz="1300" b="0">
+                          <a:solidFill>
+                            <a:srgbClr val="3C3C3B"/>
+                          </a:solidFill>
+                          <a:latin typeface="Aptos"/>
+                        </a:rPr>
+                        <a:t>Signing fee and DD</a:t>
+                      </a:r>
+                    </a:p>
+                  </a:txBody>
+                  <a:tcPr marL="73152" marR="73152" marT="27432" marB="27432" anchor="ctr">
+                    <a:noFill/>
+                  </a:tcPr>
+                </a:tc>
+                <a:tc>
+                  <a:txBody>
+                    <a:bodyPr/>
+                    <a:lstStyle/>
+                    <a:p>
+                      <a:pPr algn="r"/>
+                      <a:r>
+                        <a:rPr sz="1300" b="0">
+                          <a:solidFill>
+                            <a:srgbClr val="3C3C3B"/>
+                          </a:solidFill>
+                          <a:latin typeface="Aptos"/>
+                        </a:rPr>
+                        <a:t>0.8</a:t>
+                      </a:r>
+                    </a:p>
+                  </a:txBody>
+                  <a:tcPr marL="73152" marR="73152" marT="27432" marB="27432" anchor="ctr">
+                    <a:noFill/>
+                  </a:tcPr>
+                </a:tc>
+                <a:tc>
+                  <a:txBody>
+                    <a:bodyPr/>
+                    <a:lstStyle/>
+                    <a:p>
+                      <a:pPr algn="r"/>
+                      <a:r>
+                        <a:rPr sz="1300" b="0">
+                          <a:solidFill>
+                            <a:srgbClr val="3C3C3B"/>
+                          </a:solidFill>
+                          <a:latin typeface="Aptos"/>
+                        </a:rPr>
+                        <a:t>–</a:t>
+                      </a:r>
+                    </a:p>
+                  </a:txBody>
+                  <a:tcPr marL="73152" marR="73152" marT="27432" marB="27432" anchor="ctr">
+                    <a:noFill/>
+                  </a:tcPr>
+                </a:tc>
+                <a:tc>
+                  <a:txBody>
+                    <a:bodyPr/>
+                    <a:lstStyle/>
+                    <a:p>
+                      <a:pPr algn="r"/>
+                      <a:r>
+                        <a:rPr sz="1300" b="0">
+                          <a:solidFill>
+                            <a:srgbClr val="3C3C3B"/>
+                          </a:solidFill>
+                          <a:latin typeface="Aptos"/>
+                        </a:rPr>
+                        <a:t>0.8</a:t>
+                      </a:r>
+                    </a:p>
+                  </a:txBody>
+                  <a:tcPr marL="73152" marR="73152" marT="27432" marB="27432" anchor="ctr">
+                    <a:noFill/>
+                  </a:tcPr>
+                </a:tc>
+              </a:tr>
+              <a:tr h="329184">
+                <a:tc>
+                  <a:txBody>
+                    <a:bodyPr/>
+                    <a:lstStyle/>
+                    <a:p>
+                      <a:pPr algn="l"/>
+                      <a:r>
+                        <a:rPr sz="1300" b="0">
+                          <a:solidFill>
+                            <a:srgbClr val="3C3C3B"/>
+                          </a:solidFill>
+                          <a:latin typeface="Aptos"/>
+                        </a:rPr>
+                        <a:t>30‑Oct‑2026</a:t>
+                      </a:r>
+                    </a:p>
+                  </a:txBody>
+                  <a:tcPr marL="73152" marR="73152" marT="27432" marB="27432" anchor="ctr">
+                    <a:solidFill>
+                      <a:srgbClr val="F2F2F2"/>
+                    </a:solidFill>
+                  </a:tcPr>
+                </a:tc>
+                <a:tc>
+                  <a:txBody>
+                    <a:bodyPr/>
+                    <a:lstStyle/>
+                    <a:p>
+                      <a:pPr algn="l"/>
+                      <a:r>
+                        <a:rPr sz="1300" b="0">
+                          <a:solidFill>
+                            <a:srgbClr val="3C3C3B"/>
+                          </a:solidFill>
+                          <a:latin typeface="Aptos"/>
+                        </a:rPr>
+                        <a:t>Bid: participation fee (cash), bid guarantee</a:t>
+                      </a:r>
+                    </a:p>
+                  </a:txBody>
+                  <a:tcPr marL="73152" marR="73152" marT="27432" marB="27432" anchor="ctr">
+                    <a:noFill/>
+                  </a:tcPr>
+                </a:tc>
+                <a:tc>
+                  <a:txBody>
+                    <a:bodyPr/>
+                    <a:lstStyle/>
+                    <a:p>
+                      <a:pPr algn="r"/>
+                      <a:r>
+                        <a:rPr sz="1300" b="0">
+                          <a:solidFill>
+                            <a:srgbClr val="3C3C3B"/>
+                          </a:solidFill>
+                          <a:latin typeface="Aptos"/>
+                        </a:rPr>
+                        <a:t>0.02</a:t>
+                      </a:r>
+                    </a:p>
+                  </a:txBody>
+                  <a:tcPr marL="73152" marR="73152" marT="27432" marB="27432" anchor="ctr">
+                    <a:noFill/>
+                  </a:tcPr>
+                </a:tc>
+                <a:tc>
+                  <a:txBody>
+                    <a:bodyPr/>
+                    <a:lstStyle/>
+                    <a:p>
+                      <a:pPr algn="r"/>
+                      <a:r>
+                        <a:rPr sz="1300" b="0">
+                          <a:solidFill>
+                            <a:srgbClr val="3C3C3B"/>
+                          </a:solidFill>
+                          <a:latin typeface="Aptos"/>
+                        </a:rPr>
+                        <a:t>2.8</a:t>
+                      </a:r>
+                    </a:p>
+                  </a:txBody>
+                  <a:tcPr marL="73152" marR="73152" marT="27432" marB="27432" anchor="ctr">
+                    <a:noFill/>
+                  </a:tcPr>
+                </a:tc>
+                <a:tc>
+                  <a:txBody>
+                    <a:bodyPr/>
+                    <a:lstStyle/>
+                    <a:p>
+                      <a:pPr algn="r"/>
+                      <a:r>
+                        <a:rPr sz="1300" b="0">
+                          <a:solidFill>
+                            <a:srgbClr val="3C3C3B"/>
+                          </a:solidFill>
+                          <a:latin typeface="Aptos"/>
+                        </a:rPr>
+                        <a:t>0.8</a:t>
+                      </a:r>
+                    </a:p>
+                  </a:txBody>
+                  <a:tcPr marL="73152" marR="73152" marT="27432" marB="27432" anchor="ctr">
+                    <a:noFill/>
+                  </a:tcPr>
+                </a:tc>
+              </a:tr>
+              <a:tr h="329184">
+                <a:tc>
+                  <a:txBody>
+                    <a:bodyPr/>
+                    <a:lstStyle/>
+                    <a:p>
+                      <a:pPr algn="l"/>
+                      <a:r>
+                        <a:rPr sz="1300" b="0">
+                          <a:solidFill>
+                            <a:srgbClr val="3C3C3B"/>
+                          </a:solidFill>
+                          <a:latin typeface="Aptos"/>
+                        </a:rPr>
+                        <a:t>28‑Dec‑2026</a:t>
+                      </a:r>
+                    </a:p>
+                  </a:txBody>
+                  <a:tcPr marL="73152" marR="73152" marT="27432" marB="27432" anchor="ctr">
+                    <a:solidFill>
+                      <a:srgbClr val="F2F2F2"/>
+                    </a:solidFill>
+                  </a:tcPr>
+                </a:tc>
+                <a:tc>
+                  <a:txBody>
+                    <a:bodyPr/>
+                    <a:lstStyle/>
+                    <a:p>
+                      <a:pPr algn="l"/>
+                      <a:r>
+                        <a:rPr sz="1300" b="0">
+                          <a:solidFill>
+                            <a:srgbClr val="3C3C3B"/>
+                          </a:solidFill>
+                          <a:latin typeface="Aptos"/>
+                        </a:rPr>
+                        <a:t>Award: performance guarantee (bid guarantee released)</a:t>
+                      </a:r>
+                    </a:p>
+                  </a:txBody>
+                  <a:tcPr marL="73152" marR="73152" marT="27432" marB="27432" anchor="ctr">
+                    <a:noFill/>
+                  </a:tcPr>
+                </a:tc>
+                <a:tc>
+                  <a:txBody>
+                    <a:bodyPr/>
+                    <a:lstStyle/>
+                    <a:p>
+                      <a:pPr algn="r"/>
+                      <a:r>
+                        <a:rPr sz="1300" b="0">
+                          <a:solidFill>
+                            <a:srgbClr val="3C3C3B"/>
+                          </a:solidFill>
+                          <a:latin typeface="Aptos"/>
+                        </a:rPr>
+                        <a:t>–</a:t>
+                      </a:r>
+                    </a:p>
+                  </a:txBody>
+                  <a:tcPr marL="73152" marR="73152" marT="27432" marB="27432" anchor="ctr">
+                    <a:noFill/>
+                  </a:tcPr>
+                </a:tc>
+                <a:tc>
+                  <a:txBody>
+                    <a:bodyPr/>
+                    <a:lstStyle/>
+                    <a:p>
+                      <a:pPr algn="r"/>
+                      <a:r>
+                        <a:rPr sz="1300" b="0">
+                          <a:solidFill>
+                            <a:srgbClr val="3C3C3B"/>
+                          </a:solidFill>
+                          <a:latin typeface="Aptos"/>
+                        </a:rPr>
+                        <a:t>14.0</a:t>
+                      </a:r>
+                    </a:p>
+                  </a:txBody>
+                  <a:tcPr marL="73152" marR="73152" marT="27432" marB="27432" anchor="ctr">
+                    <a:noFill/>
+                  </a:tcPr>
+                </a:tc>
+                <a:tc>
+                  <a:txBody>
+                    <a:bodyPr/>
+                    <a:lstStyle/>
+                    <a:p>
+                      <a:pPr algn="r"/>
+                      <a:r>
+                        <a:rPr sz="1300" b="0">
+                          <a:solidFill>
+                            <a:srgbClr val="3C3C3B"/>
+                          </a:solidFill>
+                          <a:latin typeface="Aptos"/>
+                        </a:rPr>
+                        <a:t>0.8</a:t>
+                      </a:r>
+                    </a:p>
+                  </a:txBody>
+                  <a:tcPr marL="73152" marR="73152" marT="27432" marB="27432" anchor="ctr">
+                    <a:noFill/>
+                  </a:tcPr>
+                </a:tc>
+              </a:tr>
+              <a:tr h="329184">
+                <a:tc>
+                  <a:txBody>
+                    <a:bodyPr/>
+                    <a:lstStyle/>
+                    <a:p>
+                      <a:pPr algn="l"/>
+                      <a:r>
+                        <a:rPr sz="1300" b="0">
+                          <a:solidFill>
+                            <a:srgbClr val="3C3C3B"/>
+                          </a:solidFill>
+                          <a:latin typeface="Aptos"/>
+                        </a:rPr>
+                        <a:t>30‑Dec‑2026</a:t>
+                      </a:r>
+                    </a:p>
+                  </a:txBody>
+                  <a:tcPr marL="73152" marR="73152" marT="27432" marB="27432" anchor="ctr">
+                    <a:solidFill>
+                      <a:srgbClr val="F2F2F2"/>
+                    </a:solidFill>
+                  </a:tcPr>
+                </a:tc>
+                <a:tc>
+                  <a:txBody>
+                    <a:bodyPr/>
+                    <a:lstStyle/>
+                    <a:p>
+                      <a:pPr algn="l"/>
+                      <a:r>
+                        <a:rPr sz="1300" b="0">
+                          <a:solidFill>
+                            <a:srgbClr val="3C3C3B"/>
+                          </a:solidFill>
+                          <a:latin typeface="Aptos"/>
+                        </a:rPr>
+                        <a:t>Connection request: TSO security</a:t>
+                      </a:r>
+                    </a:p>
+                  </a:txBody>
+                  <a:tcPr marL="73152" marR="73152" marT="27432" marB="27432" anchor="ctr">
+                    <a:noFill/>
+                  </a:tcPr>
+                </a:tc>
+                <a:tc>
+                  <a:txBody>
+                    <a:bodyPr/>
+                    <a:lstStyle/>
+                    <a:p>
+                      <a:pPr algn="r"/>
+                      <a:r>
+                        <a:rPr sz="1300" b="0">
+                          <a:solidFill>
+                            <a:srgbClr val="3C3C3B"/>
+                          </a:solidFill>
+                          <a:latin typeface="Aptos"/>
+                        </a:rPr>
+                        <a:t>2.5</a:t>
+                      </a:r>
+                    </a:p>
+                  </a:txBody>
+                  <a:tcPr marL="73152" marR="73152" marT="27432" marB="27432" anchor="ctr">
+                    <a:noFill/>
+                  </a:tcPr>
+                </a:tc>
+                <a:tc>
+                  <a:txBody>
+                    <a:bodyPr/>
+                    <a:lstStyle/>
+                    <a:p>
+                      <a:pPr algn="r"/>
+                      <a:r>
+                        <a:rPr sz="1300" b="0">
+                          <a:solidFill>
+                            <a:srgbClr val="3C3C3B"/>
+                          </a:solidFill>
+                          <a:latin typeface="Aptos"/>
+                        </a:rPr>
+                        <a:t>–</a:t>
+                      </a:r>
+                    </a:p>
+                  </a:txBody>
+                  <a:tcPr marL="73152" marR="73152" marT="27432" marB="27432" anchor="ctr">
+                    <a:noFill/>
+                  </a:tcPr>
+                </a:tc>
+                <a:tc>
+                  <a:txBody>
+                    <a:bodyPr/>
+                    <a:lstStyle/>
+                    <a:p>
+                      <a:pPr algn="r"/>
+                      <a:r>
+                        <a:rPr sz="1300" b="0">
+                          <a:solidFill>
+                            <a:srgbClr val="3C3C3B"/>
+                          </a:solidFill>
+                          <a:latin typeface="Aptos"/>
+                        </a:rPr>
+                        <a:t>3.3</a:t>
+                      </a:r>
+                    </a:p>
+                  </a:txBody>
+                  <a:tcPr marL="73152" marR="73152" marT="27432" marB="27432" anchor="ctr">
+                    <a:noFill/>
+                  </a:tcPr>
+                </a:tc>
+              </a:tr>
+              <a:tr h="329184">
+                <a:tc>
+                  <a:txBody>
+                    <a:bodyPr/>
+                    <a:lstStyle/>
+                    <a:p>
+                      <a:pPr algn="l"/>
+                      <a:r>
+                        <a:rPr sz="1300" b="0">
+                          <a:solidFill>
+                            <a:srgbClr val="3C3C3B"/>
+                          </a:solidFill>
+                          <a:latin typeface="Aptos"/>
+                        </a:rPr>
+                        <a:t>31‑Dec‑2026</a:t>
+                      </a:r>
+                    </a:p>
+                  </a:txBody>
+                  <a:tcPr marL="73152" marR="73152" marT="27432" marB="27432" anchor="ctr">
+                    <a:solidFill>
+                      <a:srgbClr val="F2F2F2"/>
+                    </a:solidFill>
+                  </a:tcPr>
+                </a:tc>
+                <a:tc>
+                  <a:txBody>
+                    <a:bodyPr/>
+                    <a:lstStyle/>
+                    <a:p>
+                      <a:pPr algn="l"/>
+                      <a:r>
+                        <a:rPr sz="1300" b="0">
+                          <a:solidFill>
+                            <a:srgbClr val="3C3C3B"/>
+                          </a:solidFill>
+                          <a:latin typeface="Aptos"/>
+                        </a:rPr>
+                        <a:t>Devex, land and contingency 2026</a:t>
+                      </a:r>
+                    </a:p>
+                  </a:txBody>
+                  <a:tcPr marL="73152" marR="73152" marT="27432" marB="27432" anchor="ctr">
+                    <a:noFill/>
+                  </a:tcPr>
+                </a:tc>
+                <a:tc>
+                  <a:txBody>
+                    <a:bodyPr/>
+                    <a:lstStyle/>
+                    <a:p>
+                      <a:pPr algn="r"/>
+                      <a:r>
+                        <a:rPr sz="1300" b="0">
+                          <a:solidFill>
+                            <a:srgbClr val="3C3C3B"/>
+                          </a:solidFill>
+                          <a:latin typeface="Aptos"/>
+                        </a:rPr>
+                        <a:t>0.4</a:t>
+                      </a:r>
+                    </a:p>
+                  </a:txBody>
+                  <a:tcPr marL="73152" marR="73152" marT="27432" marB="27432" anchor="ctr">
+                    <a:noFill/>
+                  </a:tcPr>
+                </a:tc>
+                <a:tc>
+                  <a:txBody>
+                    <a:bodyPr/>
+                    <a:lstStyle/>
+                    <a:p>
+                      <a:pPr algn="r"/>
+                      <a:r>
+                        <a:rPr sz="1300" b="0">
+                          <a:solidFill>
+                            <a:srgbClr val="3C3C3B"/>
+                          </a:solidFill>
+                          <a:latin typeface="Aptos"/>
+                        </a:rPr>
+                        <a:t>–</a:t>
+                      </a:r>
+                    </a:p>
+                  </a:txBody>
+                  <a:tcPr marL="73152" marR="73152" marT="27432" marB="27432" anchor="ctr">
+                    <a:noFill/>
+                  </a:tcPr>
+                </a:tc>
+                <a:tc>
+                  <a:txBody>
+                    <a:bodyPr/>
+                    <a:lstStyle/>
+                    <a:p>
+                      <a:pPr algn="r"/>
+                      <a:r>
+                        <a:rPr sz="1300" b="0">
+                          <a:solidFill>
+                            <a:srgbClr val="3C3C3B"/>
+                          </a:solidFill>
+                          <a:latin typeface="Aptos"/>
+                        </a:rPr>
+                        <a:t>3.6</a:t>
+                      </a:r>
+                    </a:p>
+                  </a:txBody>
+                  <a:tcPr marL="73152" marR="73152" marT="27432" marB="27432" anchor="ctr">
+                    <a:noFill/>
+                  </a:tcPr>
+                </a:tc>
+              </a:tr>
+              <a:tr h="329184">
+                <a:tc>
+                  <a:txBody>
+                    <a:bodyPr/>
+                    <a:lstStyle/>
+                    <a:p>
+                      <a:pPr algn="l"/>
+                      <a:r>
+                        <a:rPr sz="1300" b="0">
+                          <a:solidFill>
+                            <a:srgbClr val="3C3C3B"/>
+                          </a:solidFill>
+                          <a:latin typeface="Aptos"/>
+                        </a:rPr>
+                        <a:t>31‑Dec‑2027</a:t>
+                      </a:r>
+                    </a:p>
+                  </a:txBody>
+                  <a:tcPr marL="73152" marR="73152" marT="27432" marB="27432" anchor="ctr">
+                    <a:solidFill>
+                      <a:srgbClr val="F2F2F2"/>
+                    </a:solidFill>
+                  </a:tcPr>
+                </a:tc>
+                <a:tc>
+                  <a:txBody>
+                    <a:bodyPr/>
+                    <a:lstStyle/>
+                    <a:p>
+                      <a:pPr algn="l"/>
+                      <a:r>
+                        <a:rPr sz="1300" b="0">
+                          <a:solidFill>
+                            <a:srgbClr val="3C3C3B"/>
+                          </a:solidFill>
+                          <a:latin typeface="Aptos"/>
+                        </a:rPr>
+                        <a:t>Devex, land and contingency 2027</a:t>
+                      </a:r>
+                    </a:p>
+                  </a:txBody>
+                  <a:tcPr marL="73152" marR="73152" marT="27432" marB="27432" anchor="ctr">
+                    <a:noFill/>
+                  </a:tcPr>
+                </a:tc>
+                <a:tc>
+                  <a:txBody>
+                    <a:bodyPr/>
+                    <a:lstStyle/>
+                    <a:p>
+                      <a:pPr algn="r"/>
+                      <a:r>
+                        <a:rPr sz="1300" b="0">
+                          <a:solidFill>
+                            <a:srgbClr val="3C3C3B"/>
+                          </a:solidFill>
+                          <a:latin typeface="Aptos"/>
+                        </a:rPr>
+                        <a:t>1.7</a:t>
+                      </a:r>
+                    </a:p>
+                  </a:txBody>
+                  <a:tcPr marL="73152" marR="73152" marT="27432" marB="27432" anchor="ctr">
+                    <a:noFill/>
+                  </a:tcPr>
+                </a:tc>
+                <a:tc>
+                  <a:txBody>
+                    <a:bodyPr/>
+                    <a:lstStyle/>
+                    <a:p>
+                      <a:pPr algn="r"/>
+                      <a:r>
+                        <a:rPr sz="1300" b="0">
+                          <a:solidFill>
+                            <a:srgbClr val="3C3C3B"/>
+                          </a:solidFill>
+                          <a:latin typeface="Aptos"/>
+                        </a:rPr>
+                        <a:t>–</a:t>
+                      </a:r>
+                    </a:p>
+                  </a:txBody>
+                  <a:tcPr marL="73152" marR="73152" marT="27432" marB="27432" anchor="ctr">
+                    <a:noFill/>
+                  </a:tcPr>
+                </a:tc>
+                <a:tc>
+                  <a:txBody>
+                    <a:bodyPr/>
+                    <a:lstStyle/>
+                    <a:p>
+                      <a:pPr algn="r"/>
+                      <a:r>
+                        <a:rPr sz="1300" b="0">
+                          <a:solidFill>
+                            <a:srgbClr val="3C3C3B"/>
+                          </a:solidFill>
+                          <a:latin typeface="Aptos"/>
+                        </a:rPr>
+                        <a:t>5.4</a:t>
+                      </a:r>
+                    </a:p>
+                  </a:txBody>
+                  <a:tcPr marL="73152" marR="73152" marT="27432" marB="27432" anchor="ctr">
+                    <a:noFill/>
+                  </a:tcPr>
+                </a:tc>
+              </a:tr>
+              <a:tr h="329184">
+                <a:tc>
+                  <a:txBody>
+                    <a:bodyPr/>
+                    <a:lstStyle/>
+                    <a:p>
+                      <a:pPr algn="l"/>
+                      <a:r>
+                        <a:rPr sz="1300" b="0">
+                          <a:solidFill>
+                            <a:srgbClr val="3C3C3B"/>
+                          </a:solidFill>
+                          <a:latin typeface="Aptos"/>
+                        </a:rPr>
+                        <a:t>31‑Dec‑2028</a:t>
+                      </a:r>
+                    </a:p>
+                  </a:txBody>
+                  <a:tcPr marL="73152" marR="73152" marT="27432" marB="27432" anchor="ctr">
+                    <a:solidFill>
+                      <a:srgbClr val="F2F2F2"/>
+                    </a:solidFill>
+                  </a:tcPr>
+                </a:tc>
+                <a:tc>
+                  <a:txBody>
+                    <a:bodyPr/>
+                    <a:lstStyle/>
+                    <a:p>
+                      <a:pPr algn="l"/>
+                      <a:r>
+                        <a:rPr sz="1300" b="0">
+                          <a:solidFill>
+                            <a:srgbClr val="3C3C3B"/>
+                          </a:solidFill>
+                          <a:latin typeface="Aptos"/>
+                        </a:rPr>
+                        <a:t>Devex, land and contingency 2028</a:t>
+                      </a:r>
+                    </a:p>
+                  </a:txBody>
+                  <a:tcPr marL="73152" marR="73152" marT="27432" marB="27432" anchor="ctr">
+                    <a:noFill/>
+                  </a:tcPr>
+                </a:tc>
+                <a:tc>
+                  <a:txBody>
+                    <a:bodyPr/>
+                    <a:lstStyle/>
+                    <a:p>
+                      <a:pPr algn="r"/>
+                      <a:r>
+                        <a:rPr sz="1300" b="0">
+                          <a:solidFill>
+                            <a:srgbClr val="3C3C3B"/>
+                          </a:solidFill>
+                          <a:latin typeface="Aptos"/>
+                        </a:rPr>
+                        <a:t>3.6</a:t>
+                      </a:r>
+                    </a:p>
+                  </a:txBody>
+                  <a:tcPr marL="73152" marR="73152" marT="27432" marB="27432" anchor="ctr">
+                    <a:noFill/>
+                  </a:tcPr>
+                </a:tc>
+                <a:tc>
+                  <a:txBody>
+                    <a:bodyPr/>
+                    <a:lstStyle/>
+                    <a:p>
+                      <a:pPr algn="r"/>
+                      <a:r>
+                        <a:rPr sz="1300" b="0">
+                          <a:solidFill>
+                            <a:srgbClr val="3C3C3B"/>
+                          </a:solidFill>
+                          <a:latin typeface="Aptos"/>
+                        </a:rPr>
+                        <a:t>–</a:t>
+                      </a:r>
+                    </a:p>
+                  </a:txBody>
+                  <a:tcPr marL="73152" marR="73152" marT="27432" marB="27432" anchor="ctr">
+                    <a:noFill/>
+                  </a:tcPr>
+                </a:tc>
+                <a:tc>
+                  <a:txBody>
+                    <a:bodyPr/>
+                    <a:lstStyle/>
+                    <a:p>
+                      <a:pPr algn="r"/>
+                      <a:r>
+                        <a:rPr sz="1300" b="0">
+                          <a:solidFill>
+                            <a:srgbClr val="3C3C3B"/>
+                          </a:solidFill>
+                          <a:latin typeface="Aptos"/>
+                        </a:rPr>
+                        <a:t>8.9</a:t>
+                      </a:r>
+                    </a:p>
+                  </a:txBody>
+                  <a:tcPr marL="73152" marR="73152" marT="27432" marB="27432" anchor="ctr">
+                    <a:noFill/>
+                  </a:tcPr>
+                </a:tc>
+              </a:tr>
+              <a:tr h="329184">
+                <a:tc>
+                  <a:txBody>
+                    <a:bodyPr/>
+                    <a:lstStyle/>
+                    <a:p>
+                      <a:pPr algn="l"/>
+                      <a:r>
+                        <a:rPr sz="1300" b="0">
+                          <a:solidFill>
+                            <a:srgbClr val="3C3C3B"/>
+                          </a:solidFill>
+                          <a:latin typeface="Aptos"/>
+                        </a:rPr>
+                        <a:t>08‑Jan‑2029</a:t>
+                      </a:r>
+                    </a:p>
+                  </a:txBody>
+                  <a:tcPr marL="73152" marR="73152" marT="27432" marB="27432" anchor="ctr">
+                    <a:solidFill>
+                      <a:srgbClr val="F2F2F2"/>
+                    </a:solidFill>
+                  </a:tcPr>
+                </a:tc>
+                <a:tc>
+                  <a:txBody>
+                    <a:bodyPr/>
+                    <a:lstStyle/>
+                    <a:p>
+                      <a:pPr algn="l"/>
+                      <a:r>
+                        <a:rPr sz="1300" b="0">
+                          <a:solidFill>
+                            <a:srgbClr val="3C3C3B"/>
+                          </a:solidFill>
+                          <a:latin typeface="Aptos"/>
+                        </a:rPr>
+                        <a:t>HCSSZ: connection fees</a:t>
+                      </a:r>
+                    </a:p>
+                  </a:txBody>
+                  <a:tcPr marL="73152" marR="73152" marT="27432" marB="27432" anchor="ctr">
+                    <a:noFill/>
+                  </a:tcPr>
+                </a:tc>
+                <a:tc>
+                  <a:txBody>
+                    <a:bodyPr/>
+                    <a:lstStyle/>
+                    <a:p>
+                      <a:pPr algn="r"/>
+                      <a:r>
+                        <a:rPr sz="1300" b="0">
+                          <a:solidFill>
+                            <a:srgbClr val="3C3C3B"/>
+                          </a:solidFill>
+                          <a:latin typeface="Aptos"/>
+                        </a:rPr>
+                        <a:t>40.4</a:t>
+                      </a:r>
+                    </a:p>
+                  </a:txBody>
+                  <a:tcPr marL="73152" marR="73152" marT="27432" marB="27432" anchor="ctr">
+                    <a:noFill/>
+                  </a:tcPr>
+                </a:tc>
+                <a:tc>
+                  <a:txBody>
+                    <a:bodyPr/>
+                    <a:lstStyle/>
+                    <a:p>
+                      <a:pPr algn="r"/>
+                      <a:r>
+                        <a:rPr sz="1300" b="0">
+                          <a:solidFill>
+                            <a:srgbClr val="3C3C3B"/>
+                          </a:solidFill>
+                          <a:latin typeface="Aptos"/>
+                        </a:rPr>
+                        <a:t>–</a:t>
+                      </a:r>
+                    </a:p>
+                  </a:txBody>
+                  <a:tcPr marL="73152" marR="73152" marT="27432" marB="27432" anchor="ctr">
+                    <a:noFill/>
+                  </a:tcPr>
+                </a:tc>
+                <a:tc>
+                  <a:txBody>
+                    <a:bodyPr/>
+                    <a:lstStyle/>
+                    <a:p>
+                      <a:pPr algn="r"/>
+                      <a:r>
+                        <a:rPr sz="1300" b="0">
+                          <a:solidFill>
+                            <a:srgbClr val="3C3C3B"/>
+                          </a:solidFill>
+                          <a:latin typeface="Aptos"/>
+                        </a:rPr>
+                        <a:t>49.3</a:t>
+                      </a:r>
+                    </a:p>
+                  </a:txBody>
+                  <a:tcPr marL="73152" marR="73152" marT="27432" marB="27432" anchor="ctr">
+                    <a:noFill/>
+                  </a:tcPr>
+                </a:tc>
+              </a:tr>
+              <a:tr h="329184">
+                <a:tc>
+                  <a:txBody>
+                    <a:bodyPr/>
+                    <a:lstStyle/>
+                    <a:p>
+                      <a:pPr algn="l"/>
+                      <a:r>
+                        <a:rPr sz="1300" b="0">
+                          <a:solidFill>
+                            <a:srgbClr val="3C3C3B"/>
+                          </a:solidFill>
+                          <a:latin typeface="Aptos"/>
+                        </a:rPr>
+                        <a:t>31‑Dec‑2029</a:t>
+                      </a:r>
+                    </a:p>
+                  </a:txBody>
+                  <a:tcPr marL="73152" marR="73152" marT="27432" marB="27432" anchor="ctr">
+                    <a:solidFill>
+                      <a:srgbClr val="F2F2F2"/>
+                    </a:solidFill>
+                  </a:tcPr>
+                </a:tc>
+                <a:tc>
+                  <a:txBody>
+                    <a:bodyPr/>
+                    <a:lstStyle/>
+                    <a:p>
+                      <a:pPr algn="l"/>
+                      <a:r>
+                        <a:rPr sz="1300" b="0">
+                          <a:solidFill>
+                            <a:srgbClr val="3C3C3B"/>
+                          </a:solidFill>
+                          <a:latin typeface="Aptos"/>
+                        </a:rPr>
+                        <a:t>Devex, land and contingency 2029</a:t>
+                      </a:r>
+                    </a:p>
+                  </a:txBody>
+                  <a:tcPr marL="73152" marR="73152" marT="27432" marB="27432" anchor="ctr">
+                    <a:noFill/>
+                  </a:tcPr>
+                </a:tc>
+                <a:tc>
+                  <a:txBody>
+                    <a:bodyPr/>
+                    <a:lstStyle/>
+                    <a:p>
+                      <a:pPr algn="r"/>
+                      <a:r>
+                        <a:rPr sz="1300" b="0">
+                          <a:solidFill>
+                            <a:srgbClr val="3C3C3B"/>
+                          </a:solidFill>
+                          <a:latin typeface="Aptos"/>
+                        </a:rPr>
+                        <a:t>0.6</a:t>
+                      </a:r>
+                    </a:p>
+                  </a:txBody>
+                  <a:tcPr marL="73152" marR="73152" marT="27432" marB="27432" anchor="ctr">
+                    <a:noFill/>
+                  </a:tcPr>
+                </a:tc>
+                <a:tc>
+                  <a:txBody>
+                    <a:bodyPr/>
+                    <a:lstStyle/>
+                    <a:p>
+                      <a:pPr algn="r"/>
+                      <a:r>
+                        <a:rPr sz="1300" b="0">
+                          <a:solidFill>
+                            <a:srgbClr val="3C3C3B"/>
+                          </a:solidFill>
+                          <a:latin typeface="Aptos"/>
+                        </a:rPr>
+                        <a:t>–</a:t>
+                      </a:r>
+                    </a:p>
+                  </a:txBody>
+                  <a:tcPr marL="73152" marR="73152" marT="27432" marB="27432" anchor="ctr">
+                    <a:noFill/>
+                  </a:tcPr>
+                </a:tc>
+                <a:tc>
+                  <a:txBody>
+                    <a:bodyPr/>
+                    <a:lstStyle/>
+                    <a:p>
+                      <a:pPr algn="r"/>
+                      <a:r>
+                        <a:rPr sz="1300" b="0">
+                          <a:solidFill>
+                            <a:srgbClr val="3C3C3B"/>
+                          </a:solidFill>
+                          <a:latin typeface="Aptos"/>
+                        </a:rPr>
+                        <a:t>49.9</a:t>
+                      </a:r>
+                    </a:p>
+                  </a:txBody>
+                  <a:tcPr marL="73152" marR="73152" marT="27432" marB="27432" anchor="ctr">
+                    <a:noFill/>
+                  </a:tcPr>
+                </a:tc>
+              </a:tr>
+              <a:tr h="329184">
+                <a:tc>
+                  <a:txBody>
+                    <a:bodyPr/>
+                    <a:lstStyle/>
+                    <a:p>
+                      <a:pPr algn="l"/>
+                      <a:r>
+                        <a:rPr sz="1300" b="0">
+                          <a:solidFill>
+                            <a:srgbClr val="3C3C3B"/>
+                          </a:solidFill>
+                          <a:latin typeface="Aptos"/>
+                        </a:rPr>
+                        <a:t>30‑Sep‑2031</a:t>
+                      </a:r>
+                    </a:p>
+                  </a:txBody>
+                  <a:tcPr marL="73152" marR="73152" marT="27432" marB="27432" anchor="ctr">
+                    <a:solidFill>
+                      <a:srgbClr val="F2F2F2"/>
+                    </a:solidFill>
+                  </a:tcPr>
+                </a:tc>
+                <a:tc>
+                  <a:txBody>
+                    <a:bodyPr/>
+                    <a:lstStyle/>
+                    <a:p>
+                      <a:pPr algn="l"/>
+                      <a:r>
+                        <a:rPr sz="1300" b="0">
+                          <a:solidFill>
+                            <a:srgbClr val="3C3C3B"/>
+                          </a:solidFill>
+                          <a:latin typeface="Aptos"/>
+                        </a:rPr>
+                        <a:t>NTP → COD: construction equity (capex, lease less debt)</a:t>
+                      </a:r>
+                    </a:p>
+                  </a:txBody>
+                  <a:tcPr marL="73152" marR="73152" marT="27432" marB="27432" anchor="ctr">
+                    <a:noFill/>
+                  </a:tcPr>
+                </a:tc>
+                <a:tc>
+                  <a:txBody>
+                    <a:bodyPr/>
+                    <a:lstStyle/>
+                    <a:p>
+                      <a:pPr algn="r"/>
+                      <a:r>
+                        <a:rPr sz="1300" b="0">
+                          <a:solidFill>
+                            <a:srgbClr val="3C3C3B"/>
+                          </a:solidFill>
+                          <a:latin typeface="Aptos"/>
+                        </a:rPr>
+                        <a:t>71.1</a:t>
+                      </a:r>
+                    </a:p>
+                  </a:txBody>
+                  <a:tcPr marL="73152" marR="73152" marT="27432" marB="27432" anchor="ctr">
+                    <a:noFill/>
+                  </a:tcPr>
+                </a:tc>
+                <a:tc>
+                  <a:txBody>
+                    <a:bodyPr/>
+                    <a:lstStyle/>
+                    <a:p>
+                      <a:pPr algn="r"/>
+                      <a:r>
+                        <a:rPr sz="1300" b="0">
+                          <a:solidFill>
+                            <a:srgbClr val="3C3C3B"/>
+                          </a:solidFill>
+                          <a:latin typeface="Aptos"/>
+                        </a:rPr>
+                        <a:t>–</a:t>
+                      </a:r>
+                    </a:p>
+                  </a:txBody>
+                  <a:tcPr marL="73152" marR="73152" marT="27432" marB="27432" anchor="ctr">
+                    <a:noFill/>
+                  </a:tcPr>
+                </a:tc>
+                <a:tc>
+                  <a:txBody>
+                    <a:bodyPr/>
+                    <a:lstStyle/>
+                    <a:p>
+                      <a:pPr algn="r"/>
+                      <a:r>
+                        <a:rPr sz="1300" b="0">
+                          <a:solidFill>
+                            <a:srgbClr val="3C3C3B"/>
+                          </a:solidFill>
+                          <a:latin typeface="Aptos"/>
+                        </a:rPr>
+                        <a:t>121.0</a:t>
+                      </a:r>
+                    </a:p>
+                  </a:txBody>
+                  <a:tcPr marL="73152" marR="73152" marT="27432" marB="27432" anchor="ctr">
+                    <a:noFill/>
+                  </a:tcPr>
+                </a:tc>
+              </a:tr>
+              <a:tr h="329184">
+                <a:tc>
+                  <a:txBody>
+                    <a:bodyPr/>
+                    <a:lstStyle/>
+                    <a:p>
+                      <a:pPr algn="l"/>
+                      <a:r>
+                        <a:rPr sz="1300" b="0">
+                          <a:solidFill>
+                            <a:srgbClr val="3C3C3B"/>
+                          </a:solidFill>
+                          <a:latin typeface="Aptos"/>
+                        </a:rPr>
+                        <a:t>30‑Sep‑2031</a:t>
+                      </a:r>
+                    </a:p>
+                  </a:txBody>
+                  <a:tcPr marL="73152" marR="73152" marT="27432" marB="27432" anchor="ctr">
+                    <a:solidFill>
+                      <a:srgbClr val="F2F2F2"/>
+                    </a:solidFill>
+                  </a:tcPr>
+                </a:tc>
+                <a:tc>
+                  <a:txBody>
+                    <a:bodyPr/>
+                    <a:lstStyle/>
+                    <a:p>
+                      <a:pPr algn="l"/>
+                      <a:r>
+                        <a:rPr sz="1300" b="0">
+                          <a:solidFill>
+                            <a:srgbClr val="3C3C3B"/>
+                          </a:solidFill>
+                          <a:latin typeface="Aptos"/>
+                        </a:rPr>
+                        <a:t>NTP → COD: debt fees (IDC is debt-funded)</a:t>
+                      </a:r>
+                    </a:p>
+                  </a:txBody>
+                  <a:tcPr marL="73152" marR="73152" marT="27432" marB="27432" anchor="ctr">
+                    <a:noFill/>
+                  </a:tcPr>
+                </a:tc>
+                <a:tc>
+                  <a:txBody>
+                    <a:bodyPr/>
+                    <a:lstStyle/>
+                    <a:p>
+                      <a:pPr algn="r"/>
+                      <a:r>
+                        <a:rPr sz="1300" b="0">
+                          <a:solidFill>
+                            <a:srgbClr val="3C3C3B"/>
+                          </a:solidFill>
+                          <a:latin typeface="Aptos"/>
+                        </a:rPr>
+                        <a:t>5.0</a:t>
+                      </a:r>
+                    </a:p>
+                  </a:txBody>
+                  <a:tcPr marL="73152" marR="73152" marT="27432" marB="27432" anchor="ctr">
+                    <a:noFill/>
+                  </a:tcPr>
+                </a:tc>
+                <a:tc>
+                  <a:txBody>
+                    <a:bodyPr/>
+                    <a:lstStyle/>
+                    <a:p>
+                      <a:pPr algn="r"/>
+                      <a:r>
+                        <a:rPr sz="1300" b="0">
+                          <a:solidFill>
+                            <a:srgbClr val="3C3C3B"/>
+                          </a:solidFill>
+                          <a:latin typeface="Aptos"/>
+                        </a:rPr>
+                        <a:t>–</a:t>
+                      </a:r>
+                    </a:p>
+                  </a:txBody>
+                  <a:tcPr marL="73152" marR="73152" marT="27432" marB="27432" anchor="ctr">
+                    <a:noFill/>
+                  </a:tcPr>
+                </a:tc>
+                <a:tc>
+                  <a:txBody>
+                    <a:bodyPr/>
+                    <a:lstStyle/>
+                    <a:p>
+                      <a:pPr algn="r"/>
+                      <a:r>
+                        <a:rPr sz="1300" b="0">
+                          <a:solidFill>
+                            <a:srgbClr val="3C3C3B"/>
+                          </a:solidFill>
+                          <a:latin typeface="Aptos"/>
+                        </a:rPr>
+                        <a:t>126.0</a:t>
+                      </a:r>
+                    </a:p>
+                  </a:txBody>
+                  <a:tcPr marL="73152" marR="73152" marT="27432" marB="27432" anchor="ctr">
+                    <a:noFill/>
+                  </a:tcPr>
+                </a:tc>
+              </a:tr>
+              <a:tr h="329184">
+                <a:tc>
+                  <a:txBody>
+                    <a:bodyPr/>
+                    <a:lstStyle/>
+                    <a:p>
+                      <a:pPr algn="l"/>
+                      <a:r>
+                        <a:rPr sz="1300" b="0">
+                          <a:solidFill>
+                            <a:srgbClr val="3C3C3B"/>
+                          </a:solidFill>
+                          <a:latin typeface="Aptos"/>
+                        </a:rPr>
+                        <a:t>30‑Sep‑2031</a:t>
+                      </a:r>
+                    </a:p>
+                  </a:txBody>
+                  <a:tcPr marL="73152" marR="73152" marT="27432" marB="27432" anchor="ctr">
+                    <a:solidFill>
+                      <a:srgbClr val="F2F2F2"/>
+                    </a:solidFill>
+                  </a:tcPr>
+                </a:tc>
+                <a:tc>
+                  <a:txBody>
+                    <a:bodyPr/>
+                    <a:lstStyle/>
+                    <a:p>
+                      <a:pPr algn="l"/>
+                      <a:r>
+                        <a:rPr sz="1300" b="0">
+                          <a:solidFill>
+                            <a:srgbClr val="3C3C3B"/>
+                          </a:solidFill>
+                          <a:latin typeface="Aptos"/>
+                        </a:rPr>
+                        <a:t>Guarantee fees to COD</a:t>
+                      </a:r>
+                    </a:p>
+                  </a:txBody>
+                  <a:tcPr marL="73152" marR="73152" marT="27432" marB="27432" anchor="ctr">
+                    <a:noFill/>
+                  </a:tcPr>
+                </a:tc>
+                <a:tc>
+                  <a:txBody>
+                    <a:bodyPr/>
+                    <a:lstStyle/>
+                    <a:p>
+                      <a:pPr algn="r"/>
+                      <a:r>
+                        <a:rPr sz="1300" b="0">
+                          <a:solidFill>
+                            <a:srgbClr val="3C3C3B"/>
+                          </a:solidFill>
+                          <a:latin typeface="Aptos"/>
+                        </a:rPr>
+                        <a:t>4.0</a:t>
+                      </a:r>
+                    </a:p>
+                  </a:txBody>
+                  <a:tcPr marL="73152" marR="73152" marT="27432" marB="27432" anchor="ctr">
+                    <a:noFill/>
+                  </a:tcPr>
+                </a:tc>
+                <a:tc>
+                  <a:txBody>
+                    <a:bodyPr/>
+                    <a:lstStyle/>
+                    <a:p>
+                      <a:pPr algn="r"/>
+                      <a:r>
+                        <a:rPr sz="1300" b="0">
+                          <a:solidFill>
+                            <a:srgbClr val="3C3C3B"/>
+                          </a:solidFill>
+                          <a:latin typeface="Aptos"/>
+                        </a:rPr>
+                        <a:t>–</a:t>
+                      </a:r>
+                    </a:p>
+                  </a:txBody>
+                  <a:tcPr marL="73152" marR="73152" marT="27432" marB="27432" anchor="ctr">
+                    <a:noFill/>
+                  </a:tcPr>
+                </a:tc>
+                <a:tc>
+                  <a:txBody>
+                    <a:bodyPr/>
+                    <a:lstStyle/>
+                    <a:p>
+                      <a:pPr algn="r"/>
+                      <a:r>
+                        <a:rPr sz="1300" b="0">
+                          <a:solidFill>
+                            <a:srgbClr val="3C3C3B"/>
+                          </a:solidFill>
+                          <a:latin typeface="Aptos"/>
+                        </a:rPr>
+                        <a:t>130.0</a:t>
+                      </a:r>
+                    </a:p>
+                  </a:txBody>
+                  <a:tcPr marL="73152" marR="73152" marT="27432" marB="27432" anchor="ctr">
+                    <a:noFill/>
+                  </a:tcPr>
+                </a:tc>
+              </a:tr>
+              <a:tr h="329184">
+                <a:tc>
+                  <a:txBody>
+                    <a:bodyPr/>
+                    <a:lstStyle/>
+                    <a:p>
+                      <a:pPr algn="l"/>
+                      <a:r>
+                        <a:rPr sz="1300" b="0">
+                          <a:solidFill>
+                            <a:srgbClr val="3C3C3B"/>
+                          </a:solidFill>
+                          <a:latin typeface="Aptos"/>
+                        </a:rPr>
+                        <a:t>30‑Sep‑2031</a:t>
+                      </a:r>
+                    </a:p>
+                  </a:txBody>
+                  <a:tcPr marL="73152" marR="73152" marT="27432" marB="27432" anchor="ctr">
+                    <a:solidFill>
+                      <a:srgbClr val="F2F2F2"/>
+                    </a:solidFill>
+                  </a:tcPr>
+                </a:tc>
+                <a:tc>
+                  <a:txBody>
+                    <a:bodyPr/>
+                    <a:lstStyle/>
+                    <a:p>
+                      <a:pPr algn="l"/>
+                      <a:r>
+                        <a:rPr sz="1300" b="0">
+                          <a:solidFill>
+                            <a:srgbClr val="3C3C3B"/>
+                          </a:solidFill>
+                          <a:latin typeface="Aptos"/>
+                        </a:rPr>
+                        <a:t>COD: municipal one-off</a:t>
+                      </a:r>
+                    </a:p>
+                  </a:txBody>
+                  <a:tcPr marL="73152" marR="73152" marT="27432" marB="27432" anchor="ctr">
+                    <a:noFill/>
+                  </a:tcPr>
+                </a:tc>
+                <a:tc>
+                  <a:txBody>
+                    <a:bodyPr/>
+                    <a:lstStyle/>
+                    <a:p>
+                      <a:pPr algn="r"/>
+                      <a:r>
+                        <a:rPr sz="1300" b="0">
+                          <a:solidFill>
+                            <a:srgbClr val="3C3C3B"/>
+                          </a:solidFill>
+                          <a:latin typeface="Aptos"/>
+                        </a:rPr>
+                        <a:t>10.0</a:t>
+                      </a:r>
+                    </a:p>
+                  </a:txBody>
+                  <a:tcPr marL="73152" marR="73152" marT="27432" marB="27432" anchor="ctr">
+                    <a:noFill/>
+                  </a:tcPr>
+                </a:tc>
+                <a:tc>
+                  <a:txBody>
+                    <a:bodyPr/>
+                    <a:lstStyle/>
+                    <a:p>
+                      <a:pPr algn="r"/>
+                      <a:r>
+                        <a:rPr sz="1300" b="0">
+                          <a:solidFill>
+                            <a:srgbClr val="3C3C3B"/>
+                          </a:solidFill>
+                          <a:latin typeface="Aptos"/>
+                        </a:rPr>
+                        <a:t>–</a:t>
+                      </a:r>
+                    </a:p>
+                  </a:txBody>
+                  <a:tcPr marL="73152" marR="73152" marT="27432" marB="27432" anchor="ctr">
+                    <a:noFill/>
+                  </a:tcPr>
+                </a:tc>
+                <a:tc>
+                  <a:txBody>
+                    <a:bodyPr/>
+                    <a:lstStyle/>
+                    <a:p>
+                      <a:pPr algn="r"/>
+                      <a:r>
+                        <a:rPr sz="1300" b="0">
+                          <a:solidFill>
+                            <a:srgbClr val="3C3C3B"/>
+                          </a:solidFill>
+                          <a:latin typeface="Aptos"/>
+                        </a:rPr>
+                        <a:t>140.0</a:t>
+                      </a:r>
+                    </a:p>
+                  </a:txBody>
+                  <a:tcPr marL="73152" marR="73152" marT="27432" marB="27432" anchor="ctr">
+                    <a:noFill/>
+                  </a:tcPr>
+                </a:tc>
+              </a:tr>
+              <a:tr h="329184">
+                <a:tc>
+                  <a:txBody>
+                    <a:bodyPr/>
+                    <a:lstStyle/>
+                    <a:p>
+                      <a:pPr algn="l"/>
+                    </a:p>
+                  </a:txBody>
+                  <a:tcPr marL="73152" marR="73152" marT="27432" marB="27432" anchor="ctr">
+                    <a:solidFill>
+                      <a:srgbClr val="F2F2F2"/>
+                    </a:solidFill>
+                  </a:tcPr>
+                </a:tc>
+                <a:tc>
+                  <a:txBody>
+                    <a:bodyPr/>
+                    <a:lstStyle/>
+                    <a:p>
+                      <a:pPr algn="l"/>
+                      <a:r>
+                        <a:rPr sz="1300" b="1">
+                          <a:solidFill>
+                            <a:srgbClr val="3C3C3B"/>
+                          </a:solidFill>
+                          <a:latin typeface="Aptos"/>
+                        </a:rPr>
+                        <a:t>Total cash equity to COD; peak guarantee</a:t>
+                      </a:r>
+                    </a:p>
+                  </a:txBody>
+                  <a:tcPr marL="73152" marR="73152" marT="27432" marB="27432" anchor="ctr">
+                    <a:solidFill>
+                      <a:srgbClr val="E6F4EC"/>
+                    </a:solidFill>
+                  </a:tcPr>
+                </a:tc>
+                <a:tc>
+                  <a:txBody>
+                    <a:bodyPr/>
+                    <a:lstStyle/>
+                    <a:p>
+                      <a:pPr algn="r"/>
+                      <a:r>
+                        <a:rPr sz="1300" b="1">
+                          <a:solidFill>
+                            <a:srgbClr val="3C3C3B"/>
+                          </a:solidFill>
+                          <a:latin typeface="Aptos"/>
+                        </a:rPr>
+                        <a:t>140.0</a:t>
+                      </a:r>
+                    </a:p>
+                  </a:txBody>
+                  <a:tcPr marL="73152" marR="73152" marT="27432" marB="27432" anchor="ctr">
+                    <a:solidFill>
+                      <a:srgbClr val="E6F4EC"/>
+                    </a:solidFill>
+                  </a:tcPr>
+                </a:tc>
+                <a:tc>
+                  <a:txBody>
+                    <a:bodyPr/>
+                    <a:lstStyle/>
+                    <a:p>
+                      <a:pPr algn="r"/>
+                      <a:r>
+                        <a:rPr sz="1300" b="1">
+                          <a:solidFill>
+                            <a:srgbClr val="3C3C3B"/>
+                          </a:solidFill>
+                          <a:latin typeface="Aptos"/>
+                        </a:rPr>
+                        <a:t>14.0</a:t>
+                      </a:r>
+                    </a:p>
+                  </a:txBody>
+                  <a:tcPr marL="73152" marR="73152" marT="27432" marB="27432" anchor="ctr">
+                    <a:solidFill>
+                      <a:srgbClr val="E6F4EC"/>
+                    </a:solidFill>
+                  </a:tcPr>
+                </a:tc>
+                <a:tc>
+                  <a:txBody>
+                    <a:bodyPr/>
+                    <a:lstStyle/>
+                    <a:p>
+                      <a:pPr algn="r"/>
+                      <a:r>
+                        <a:rPr sz="1300" b="1">
+                          <a:solidFill>
+                            <a:srgbClr val="3C3C3B"/>
+                          </a:solidFill>
+                          <a:latin typeface="Aptos"/>
+                        </a:rPr>
+                        <a:t>–</a:t>
+                      </a:r>
+                    </a:p>
+                  </a:txBody>
+                  <a:tcPr marL="73152" marR="73152" marT="27432" marB="27432" anchor="ctr">
+                    <a:solidFill>
+                      <a:srgbClr val="E6F4EC"/>
+                    </a:solidFill>
+                  </a:tcPr>
+                </a:tc>
+              </a:tr>
+            </a:tbl>
+          </a:graphicData>
+        </a:graphic>
+      </p:graphicFrame>
+      <p:graphicFrame>
+        <p:nvGraphicFramePr>
+          <p:cNvPr id="6" name="Capex"/>
+          <p:cNvGraphicFramePr>
+            <a:graphicFrameLocks noGrp="1"/>
+          </p:cNvGraphicFramePr>
+          <p:nvPr/>
+        </p:nvGraphicFramePr>
+        <p:xfrm>
+          <a:off x="13551408" y="2240280"/>
+          <a:ext cx="4663440" cy="5148072"/>
+        </p:xfrm>
+        <a:graphic>
+          <a:graphicData uri="http://schemas.openxmlformats.org/drawingml/2006/table">
+            <a:tbl>
+              <a:tblPr>
+                <a:tableStyleId>{5C22544A-7EE6-4342-B048-85BDC9FD1C3A}</a:tableStyleId>
+              </a:tblPr>
+              <a:tblGrid>
+                <a:gridCol w="2651760"/>
+                <a:gridCol w="1005840"/>
+                <a:gridCol w="1005840"/>
+              </a:tblGrid>
+              <a:tr h="539496">
+                <a:tc>
+                  <a:txBody>
+                    <a:bodyPr/>
+                    <a:lstStyle/>
+                    <a:p>
+                      <a:pPr algn="l"/>
+                      <a:r>
+                        <a:rPr sz="1300" b="1">
+                          <a:solidFill>
+                            <a:srgbClr val="FFFFFF"/>
+                          </a:solidFill>
+                          <a:latin typeface="Aptos"/>
+                        </a:rPr>
+                        <a:t>Capex to COD – both bids, 200 MW</a:t>
+                      </a:r>
+                    </a:p>
+                  </a:txBody>
+                  <a:tcPr marL="73152" marR="73152" marT="27432" marB="27432" anchor="ctr">
+                    <a:solidFill>
+                      <a:srgbClr val="00A651"/>
+                    </a:solidFill>
+                  </a:tcPr>
+                </a:tc>
+                <a:tc>
+                  <a:txBody>
+                    <a:bodyPr/>
+                    <a:lstStyle/>
+                    <a:p>
+                      <a:pPr algn="r"/>
+                      <a:r>
+                        <a:rPr sz="1300" b="1">
+                          <a:solidFill>
+                            <a:srgbClr val="FFFFFF"/>
+                          </a:solidFill>
+                          <a:latin typeface="Aptos"/>
+                        </a:rPr>
+                        <a:t>€ m</a:t>
+                      </a:r>
+                    </a:p>
+                  </a:txBody>
+                  <a:tcPr marL="73152" marR="73152" marT="27432" marB="27432" anchor="ctr">
+                    <a:solidFill>
+                      <a:srgbClr val="00A651"/>
+                    </a:solidFill>
+                  </a:tcPr>
+                </a:tc>
+                <a:tc>
+                  <a:txBody>
+                    <a:bodyPr/>
+                    <a:lstStyle/>
+                    <a:p>
+                      <a:pPr algn="r"/>
+                      <a:r>
+                        <a:rPr sz="1300" b="1">
+                          <a:solidFill>
+                            <a:srgbClr val="FFFFFF"/>
+                          </a:solidFill>
+                          <a:latin typeface="Aptos"/>
+                        </a:rPr>
+                        <a:t>k€/MW</a:t>
+                      </a:r>
+                    </a:p>
+                  </a:txBody>
+                  <a:tcPr marL="73152" marR="73152" marT="27432" marB="27432" anchor="ctr">
+                    <a:solidFill>
+                      <a:srgbClr val="00A651"/>
+                    </a:solidFill>
+                  </a:tcPr>
+                </a:tc>
+              </a:tr>
+              <a:tr h="329184">
+                <a:tc>
+                  <a:txBody>
+                    <a:bodyPr/>
+                    <a:lstStyle/>
+                    <a:p>
+                      <a:pPr algn="l"/>
+                      <a:r>
+                        <a:rPr sz="1300" b="0">
+                          <a:solidFill>
+                            <a:srgbClr val="3C3C3B"/>
+                          </a:solidFill>
+                          <a:latin typeface="Aptos"/>
+                        </a:rPr>
+                        <a:t>Turbines</a:t>
+                      </a:r>
+                    </a:p>
+                  </a:txBody>
+                  <a:tcPr marL="73152" marR="73152" marT="27432" marB="27432" anchor="ctr">
+                    <a:solidFill>
+                      <a:srgbClr val="F2F2F2"/>
+                    </a:solidFill>
+                  </a:tcPr>
+                </a:tc>
+                <a:tc>
+                  <a:txBody>
+                    <a:bodyPr/>
+                    <a:lstStyle/>
+                    <a:p>
+                      <a:pPr algn="r"/>
+                      <a:r>
+                        <a:rPr sz="1300" b="0">
+                          <a:solidFill>
+                            <a:srgbClr val="3C3C3B"/>
+                          </a:solidFill>
+                          <a:latin typeface="Aptos"/>
+                        </a:rPr>
+                        <a:t>120.0</a:t>
+                      </a:r>
+                    </a:p>
+                  </a:txBody>
+                  <a:tcPr marL="73152" marR="73152" marT="27432" marB="27432" anchor="ctr">
+                    <a:noFill/>
+                  </a:tcPr>
+                </a:tc>
+                <a:tc>
+                  <a:txBody>
+                    <a:bodyPr/>
+                    <a:lstStyle/>
+                    <a:p>
+                      <a:pPr algn="r"/>
+                      <a:r>
+                        <a:rPr sz="1300" b="0">
+                          <a:solidFill>
+                            <a:srgbClr val="3C3C3B"/>
+                          </a:solidFill>
+                          <a:latin typeface="Aptos"/>
+                        </a:rPr>
+                        <a:t>600</a:t>
+                      </a:r>
+                    </a:p>
+                  </a:txBody>
+                  <a:tcPr marL="73152" marR="73152" marT="27432" marB="27432" anchor="ctr">
+                    <a:noFill/>
+                  </a:tcPr>
+                </a:tc>
+              </a:tr>
+              <a:tr h="329184">
+                <a:tc>
+                  <a:txBody>
+                    <a:bodyPr/>
+                    <a:lstStyle/>
+                    <a:p>
+                      <a:pPr algn="l"/>
+                      <a:r>
+                        <a:rPr sz="1300" b="0">
+                          <a:solidFill>
+                            <a:srgbClr val="3C3C3B"/>
+                          </a:solidFill>
+                          <a:latin typeface="Aptos"/>
+                        </a:rPr>
+                        <a:t>Installation</a:t>
+                      </a:r>
+                    </a:p>
+                  </a:txBody>
+                  <a:tcPr marL="73152" marR="73152" marT="27432" marB="27432" anchor="ctr">
+                    <a:solidFill>
+                      <a:srgbClr val="F2F2F2"/>
+                    </a:solidFill>
+                  </a:tcPr>
+                </a:tc>
+                <a:tc>
+                  <a:txBody>
+                    <a:bodyPr/>
+                    <a:lstStyle/>
+                    <a:p>
+                      <a:pPr algn="r"/>
+                      <a:r>
+                        <a:rPr sz="1300" b="0">
+                          <a:solidFill>
+                            <a:srgbClr val="3C3C3B"/>
+                          </a:solidFill>
+                          <a:latin typeface="Aptos"/>
+                        </a:rPr>
+                        <a:t>16.0</a:t>
+                      </a:r>
+                    </a:p>
+                  </a:txBody>
+                  <a:tcPr marL="73152" marR="73152" marT="27432" marB="27432" anchor="ctr">
+                    <a:noFill/>
+                  </a:tcPr>
+                </a:tc>
+                <a:tc>
+                  <a:txBody>
+                    <a:bodyPr/>
+                    <a:lstStyle/>
+                    <a:p>
+                      <a:pPr algn="r"/>
+                      <a:r>
+                        <a:rPr sz="1300" b="0">
+                          <a:solidFill>
+                            <a:srgbClr val="3C3C3B"/>
+                          </a:solidFill>
+                          <a:latin typeface="Aptos"/>
+                        </a:rPr>
+                        <a:t>80</a:t>
+                      </a:r>
+                    </a:p>
+                  </a:txBody>
+                  <a:tcPr marL="73152" marR="73152" marT="27432" marB="27432" anchor="ctr">
+                    <a:noFill/>
+                  </a:tcPr>
+                </a:tc>
+              </a:tr>
+              <a:tr h="329184">
+                <a:tc>
+                  <a:txBody>
+                    <a:bodyPr/>
+                    <a:lstStyle/>
+                    <a:p>
+                      <a:pPr algn="l"/>
+                      <a:r>
+                        <a:rPr sz="1300" b="0">
+                          <a:solidFill>
+                            <a:srgbClr val="3C3C3B"/>
+                          </a:solidFill>
+                          <a:latin typeface="Aptos"/>
+                        </a:rPr>
+                        <a:t>Foundations</a:t>
+                      </a:r>
+                    </a:p>
+                  </a:txBody>
+                  <a:tcPr marL="73152" marR="73152" marT="27432" marB="27432" anchor="ctr">
+                    <a:solidFill>
+                      <a:srgbClr val="F2F2F2"/>
+                    </a:solidFill>
+                  </a:tcPr>
+                </a:tc>
+                <a:tc>
+                  <a:txBody>
+                    <a:bodyPr/>
+                    <a:lstStyle/>
+                    <a:p>
+                      <a:pPr algn="r"/>
+                      <a:r>
+                        <a:rPr sz="1300" b="0">
+                          <a:solidFill>
+                            <a:srgbClr val="3C3C3B"/>
+                          </a:solidFill>
+                          <a:latin typeface="Aptos"/>
+                        </a:rPr>
+                        <a:t>18.0</a:t>
+                      </a:r>
+                    </a:p>
+                  </a:txBody>
+                  <a:tcPr marL="73152" marR="73152" marT="27432" marB="27432" anchor="ctr">
+                    <a:noFill/>
+                  </a:tcPr>
+                </a:tc>
+                <a:tc>
+                  <a:txBody>
+                    <a:bodyPr/>
+                    <a:lstStyle/>
+                    <a:p>
+                      <a:pPr algn="r"/>
+                      <a:r>
+                        <a:rPr sz="1300" b="0">
+                          <a:solidFill>
+                            <a:srgbClr val="3C3C3B"/>
+                          </a:solidFill>
+                          <a:latin typeface="Aptos"/>
+                        </a:rPr>
+                        <a:t>90</a:t>
+                      </a:r>
+                    </a:p>
+                  </a:txBody>
+                  <a:tcPr marL="73152" marR="73152" marT="27432" marB="27432" anchor="ctr">
+                    <a:noFill/>
+                  </a:tcPr>
+                </a:tc>
+              </a:tr>
+              <a:tr h="329184">
+                <a:tc>
+                  <a:txBody>
+                    <a:bodyPr/>
+                    <a:lstStyle/>
+                    <a:p>
+                      <a:pPr algn="l"/>
+                      <a:r>
+                        <a:rPr sz="1300" b="0">
+                          <a:solidFill>
+                            <a:srgbClr val="3C3C3B"/>
+                          </a:solidFill>
+                          <a:latin typeface="Aptos"/>
+                        </a:rPr>
+                        <a:t>Balance of plant</a:t>
+                      </a:r>
+                    </a:p>
+                  </a:txBody>
+                  <a:tcPr marL="73152" marR="73152" marT="27432" marB="27432" anchor="ctr">
+                    <a:solidFill>
+                      <a:srgbClr val="F2F2F2"/>
+                    </a:solidFill>
+                  </a:tcPr>
+                </a:tc>
+                <a:tc>
+                  <a:txBody>
+                    <a:bodyPr/>
+                    <a:lstStyle/>
+                    <a:p>
+                      <a:pPr algn="r"/>
+                      <a:r>
+                        <a:rPr sz="1300" b="0">
+                          <a:solidFill>
+                            <a:srgbClr val="3C3C3B"/>
+                          </a:solidFill>
+                          <a:latin typeface="Aptos"/>
+                        </a:rPr>
+                        <a:t>26.0</a:t>
+                      </a:r>
+                    </a:p>
+                  </a:txBody>
+                  <a:tcPr marL="73152" marR="73152" marT="27432" marB="27432" anchor="ctr">
+                    <a:noFill/>
+                  </a:tcPr>
+                </a:tc>
+                <a:tc>
+                  <a:txBody>
+                    <a:bodyPr/>
+                    <a:lstStyle/>
+                    <a:p>
+                      <a:pPr algn="r"/>
+                      <a:r>
+                        <a:rPr sz="1300" b="0">
+                          <a:solidFill>
+                            <a:srgbClr val="3C3C3B"/>
+                          </a:solidFill>
+                          <a:latin typeface="Aptos"/>
+                        </a:rPr>
+                        <a:t>130</a:t>
+                      </a:r>
+                    </a:p>
+                  </a:txBody>
+                  <a:tcPr marL="73152" marR="73152" marT="27432" marB="27432" anchor="ctr">
+                    <a:noFill/>
+                  </a:tcPr>
+                </a:tc>
+              </a:tr>
+              <a:tr h="329184">
+                <a:tc>
+                  <a:txBody>
+                    <a:bodyPr/>
+                    <a:lstStyle/>
+                    <a:p>
+                      <a:pPr algn="l"/>
+                      <a:r>
+                        <a:rPr sz="1300" b="0">
+                          <a:solidFill>
+                            <a:srgbClr val="3C3C3B"/>
+                          </a:solidFill>
+                          <a:latin typeface="Aptos"/>
+                        </a:rPr>
+                        <a:t>Owner's costs</a:t>
+                      </a:r>
+                    </a:p>
+                  </a:txBody>
+                  <a:tcPr marL="73152" marR="73152" marT="27432" marB="27432" anchor="ctr">
+                    <a:solidFill>
+                      <a:srgbClr val="F2F2F2"/>
+                    </a:solidFill>
+                  </a:tcPr>
+                </a:tc>
+                <a:tc>
+                  <a:txBody>
+                    <a:bodyPr/>
+                    <a:lstStyle/>
+                    <a:p>
+                      <a:pPr algn="r"/>
+                      <a:r>
+                        <a:rPr sz="1300" b="0">
+                          <a:solidFill>
+                            <a:srgbClr val="3C3C3B"/>
+                          </a:solidFill>
+                          <a:latin typeface="Aptos"/>
+                        </a:rPr>
+                        <a:t>8.0</a:t>
+                      </a:r>
+                    </a:p>
+                  </a:txBody>
+                  <a:tcPr marL="73152" marR="73152" marT="27432" marB="27432" anchor="ctr">
+                    <a:noFill/>
+                  </a:tcPr>
+                </a:tc>
+                <a:tc>
+                  <a:txBody>
+                    <a:bodyPr/>
+                    <a:lstStyle/>
+                    <a:p>
+                      <a:pPr algn="r"/>
+                      <a:r>
+                        <a:rPr sz="1300" b="0">
+                          <a:solidFill>
+                            <a:srgbClr val="3C3C3B"/>
+                          </a:solidFill>
+                          <a:latin typeface="Aptos"/>
+                        </a:rPr>
+                        <a:t>40</a:t>
+                      </a:r>
+                    </a:p>
+                  </a:txBody>
+                  <a:tcPr marL="73152" marR="73152" marT="27432" marB="27432" anchor="ctr">
+                    <a:noFill/>
+                  </a:tcPr>
+                </a:tc>
+              </a:tr>
+              <a:tr h="329184">
+                <a:tc>
+                  <a:txBody>
+                    <a:bodyPr/>
+                    <a:lstStyle/>
+                    <a:p>
+                      <a:pPr algn="l"/>
+                      <a:r>
+                        <a:rPr sz="1300" b="0">
+                          <a:solidFill>
+                            <a:srgbClr val="3C3C3B"/>
+                          </a:solidFill>
+                          <a:latin typeface="Aptos"/>
+                        </a:rPr>
+                        <a:t>Land, easements, pre-COD lease</a:t>
+                      </a:r>
+                    </a:p>
+                  </a:txBody>
+                  <a:tcPr marL="73152" marR="73152" marT="27432" marB="27432" anchor="ctr">
+                    <a:solidFill>
+                      <a:srgbClr val="F2F2F2"/>
+                    </a:solidFill>
+                  </a:tcPr>
+                </a:tc>
+                <a:tc>
+                  <a:txBody>
+                    <a:bodyPr/>
+                    <a:lstStyle/>
+                    <a:p>
+                      <a:pPr algn="r"/>
+                      <a:r>
+                        <a:rPr sz="1300" b="0">
+                          <a:solidFill>
+                            <a:srgbClr val="3C3C3B"/>
+                          </a:solidFill>
+                          <a:latin typeface="Aptos"/>
+                        </a:rPr>
+                        <a:t>4.2</a:t>
+                      </a:r>
+                    </a:p>
+                  </a:txBody>
+                  <a:tcPr marL="73152" marR="73152" marT="27432" marB="27432" anchor="ctr">
+                    <a:noFill/>
+                  </a:tcPr>
+                </a:tc>
+                <a:tc>
+                  <a:txBody>
+                    <a:bodyPr/>
+                    <a:lstStyle/>
+                    <a:p>
+                      <a:pPr algn="r"/>
+                      <a:r>
+                        <a:rPr sz="1300" b="0">
+                          <a:solidFill>
+                            <a:srgbClr val="3C3C3B"/>
+                          </a:solidFill>
+                          <a:latin typeface="Aptos"/>
+                        </a:rPr>
+                        <a:t>21</a:t>
+                      </a:r>
+                    </a:p>
+                  </a:txBody>
+                  <a:tcPr marL="73152" marR="73152" marT="27432" marB="27432" anchor="ctr">
+                    <a:noFill/>
+                  </a:tcPr>
+                </a:tc>
+              </a:tr>
+              <a:tr h="329184">
+                <a:tc>
+                  <a:txBody>
+                    <a:bodyPr/>
+                    <a:lstStyle/>
+                    <a:p>
+                      <a:pPr algn="l"/>
+                      <a:r>
+                        <a:rPr sz="1300" b="0">
+                          <a:solidFill>
+                            <a:srgbClr val="3C3C3B"/>
+                          </a:solidFill>
+                          <a:latin typeface="Aptos"/>
+                        </a:rPr>
+                        <a:t>Contingency</a:t>
+                      </a:r>
+                    </a:p>
+                  </a:txBody>
+                  <a:tcPr marL="73152" marR="73152" marT="27432" marB="27432" anchor="ctr">
+                    <a:solidFill>
+                      <a:srgbClr val="F2F2F2"/>
+                    </a:solidFill>
+                  </a:tcPr>
+                </a:tc>
+                <a:tc>
+                  <a:txBody>
+                    <a:bodyPr/>
+                    <a:lstStyle/>
+                    <a:p>
+                      <a:pPr algn="r"/>
+                      <a:r>
+                        <a:rPr sz="1300" b="0">
+                          <a:solidFill>
+                            <a:srgbClr val="3C3C3B"/>
+                          </a:solidFill>
+                          <a:latin typeface="Aptos"/>
+                        </a:rPr>
+                        <a:t>10.8</a:t>
+                      </a:r>
+                    </a:p>
+                  </a:txBody>
+                  <a:tcPr marL="73152" marR="73152" marT="27432" marB="27432" anchor="ctr">
+                    <a:noFill/>
+                  </a:tcPr>
+                </a:tc>
+                <a:tc>
+                  <a:txBody>
+                    <a:bodyPr/>
+                    <a:lstStyle/>
+                    <a:p>
+                      <a:pPr algn="r"/>
+                      <a:r>
+                        <a:rPr sz="1300" b="0">
+                          <a:solidFill>
+                            <a:srgbClr val="3C3C3B"/>
+                          </a:solidFill>
+                          <a:latin typeface="Aptos"/>
+                        </a:rPr>
+                        <a:t>54</a:t>
+                      </a:r>
+                    </a:p>
+                  </a:txBody>
+                  <a:tcPr marL="73152" marR="73152" marT="27432" marB="27432" anchor="ctr">
+                    <a:noFill/>
+                  </a:tcPr>
+                </a:tc>
+              </a:tr>
+              <a:tr h="329184">
+                <a:tc>
+                  <a:txBody>
+                    <a:bodyPr/>
+                    <a:lstStyle/>
+                    <a:p>
+                      <a:pPr algn="l"/>
+                      <a:r>
+                        <a:rPr sz="1300" b="0">
+                          <a:solidFill>
+                            <a:srgbClr val="3C3C3B"/>
+                          </a:solidFill>
+                          <a:latin typeface="Aptos"/>
+                        </a:rPr>
+                        <a:t>Substation and 132 kV bay</a:t>
+                      </a:r>
+                    </a:p>
+                  </a:txBody>
+                  <a:tcPr marL="73152" marR="73152" marT="27432" marB="27432" anchor="ctr">
+                    <a:solidFill>
+                      <a:srgbClr val="F2F2F2"/>
+                    </a:solidFill>
+                  </a:tcPr>
+                </a:tc>
+                <a:tc>
+                  <a:txBody>
+                    <a:bodyPr/>
+                    <a:lstStyle/>
+                    <a:p>
+                      <a:pPr algn="r"/>
+                      <a:r>
+                        <a:rPr sz="1300" b="0">
+                          <a:solidFill>
+                            <a:srgbClr val="3C3C3B"/>
+                          </a:solidFill>
+                          <a:latin typeface="Aptos"/>
+                        </a:rPr>
+                        <a:t>24.0</a:t>
+                      </a:r>
+                    </a:p>
+                  </a:txBody>
+                  <a:tcPr marL="73152" marR="73152" marT="27432" marB="27432" anchor="ctr">
+                    <a:noFill/>
+                  </a:tcPr>
+                </a:tc>
+                <a:tc>
+                  <a:txBody>
+                    <a:bodyPr/>
+                    <a:lstStyle/>
+                    <a:p>
+                      <a:pPr algn="r"/>
+                      <a:r>
+                        <a:rPr sz="1300" b="0">
+                          <a:solidFill>
+                            <a:srgbClr val="3C3C3B"/>
+                          </a:solidFill>
+                          <a:latin typeface="Aptos"/>
+                        </a:rPr>
+                        <a:t>120</a:t>
+                      </a:r>
+                    </a:p>
+                  </a:txBody>
+                  <a:tcPr marL="73152" marR="73152" marT="27432" marB="27432" anchor="ctr">
+                    <a:noFill/>
+                  </a:tcPr>
+                </a:tc>
+              </a:tr>
+              <a:tr h="329184">
+                <a:tc>
+                  <a:txBody>
+                    <a:bodyPr/>
+                    <a:lstStyle/>
+                    <a:p>
+                      <a:pPr algn="l"/>
+                      <a:r>
+                        <a:rPr sz="1300" b="0">
+                          <a:solidFill>
+                            <a:srgbClr val="3C3C3B"/>
+                          </a:solidFill>
+                          <a:latin typeface="Aptos"/>
+                        </a:rPr>
+                        <a:t>BESS</a:t>
+                      </a:r>
+                    </a:p>
+                  </a:txBody>
+                  <a:tcPr marL="73152" marR="73152" marT="27432" marB="27432" anchor="ctr">
+                    <a:solidFill>
+                      <a:srgbClr val="F2F2F2"/>
+                    </a:solidFill>
+                  </a:tcPr>
+                </a:tc>
+                <a:tc>
+                  <a:txBody>
+                    <a:bodyPr/>
+                    <a:lstStyle/>
+                    <a:p>
+                      <a:pPr algn="r"/>
+                      <a:r>
+                        <a:rPr sz="1300" b="0">
+                          <a:solidFill>
+                            <a:srgbClr val="3C3C3B"/>
+                          </a:solidFill>
+                          <a:latin typeface="Aptos"/>
+                        </a:rPr>
+                        <a:t>24.5</a:t>
+                      </a:r>
+                    </a:p>
+                  </a:txBody>
+                  <a:tcPr marL="73152" marR="73152" marT="27432" marB="27432" anchor="ctr">
+                    <a:noFill/>
+                  </a:tcPr>
+                </a:tc>
+                <a:tc>
+                  <a:txBody>
+                    <a:bodyPr/>
+                    <a:lstStyle/>
+                    <a:p>
+                      <a:pPr algn="r"/>
+                      <a:r>
+                        <a:rPr sz="1300" b="0">
+                          <a:solidFill>
+                            <a:srgbClr val="3C3C3B"/>
+                          </a:solidFill>
+                          <a:latin typeface="Aptos"/>
+                        </a:rPr>
+                        <a:t>122</a:t>
+                      </a:r>
+                    </a:p>
+                  </a:txBody>
+                  <a:tcPr marL="73152" marR="73152" marT="27432" marB="27432" anchor="ctr">
+                    <a:noFill/>
+                  </a:tcPr>
+                </a:tc>
+              </a:tr>
+              <a:tr h="329184">
+                <a:tc>
+                  <a:txBody>
+                    <a:bodyPr/>
+                    <a:lstStyle/>
+                    <a:p>
+                      <a:pPr algn="l"/>
+                      <a:r>
+                        <a:rPr sz="1300" b="0">
+                          <a:solidFill>
+                            <a:srgbClr val="3C3C3B"/>
+                          </a:solidFill>
+                          <a:latin typeface="Aptos"/>
+                        </a:rPr>
+                        <a:t>Connection fees</a:t>
+                      </a:r>
+                    </a:p>
+                  </a:txBody>
+                  <a:tcPr marL="73152" marR="73152" marT="27432" marB="27432" anchor="ctr">
+                    <a:solidFill>
+                      <a:srgbClr val="F2F2F2"/>
+                    </a:solidFill>
+                  </a:tcPr>
+                </a:tc>
+                <a:tc>
+                  <a:txBody>
+                    <a:bodyPr/>
+                    <a:lstStyle/>
+                    <a:p>
+                      <a:pPr algn="r"/>
+                      <a:r>
+                        <a:rPr sz="1300" b="0">
+                          <a:solidFill>
+                            <a:srgbClr val="3C3C3B"/>
+                          </a:solidFill>
+                          <a:latin typeface="Aptos"/>
+                        </a:rPr>
+                        <a:t>40.4</a:t>
+                      </a:r>
+                    </a:p>
+                  </a:txBody>
+                  <a:tcPr marL="73152" marR="73152" marT="27432" marB="27432" anchor="ctr">
+                    <a:noFill/>
+                  </a:tcPr>
+                </a:tc>
+                <a:tc>
+                  <a:txBody>
+                    <a:bodyPr/>
+                    <a:lstStyle/>
+                    <a:p>
+                      <a:pPr algn="r"/>
+                      <a:r>
+                        <a:rPr sz="1300" b="0">
+                          <a:solidFill>
+                            <a:srgbClr val="3C3C3B"/>
+                          </a:solidFill>
+                          <a:latin typeface="Aptos"/>
+                        </a:rPr>
+                        <a:t>202</a:t>
+                      </a:r>
+                    </a:p>
+                  </a:txBody>
+                  <a:tcPr marL="73152" marR="73152" marT="27432" marB="27432" anchor="ctr">
+                    <a:noFill/>
+                  </a:tcPr>
+                </a:tc>
+              </a:tr>
+              <a:tr h="329184">
+                <a:tc>
+                  <a:txBody>
+                    <a:bodyPr/>
+                    <a:lstStyle/>
+                    <a:p>
+                      <a:pPr algn="l"/>
+                      <a:r>
+                        <a:rPr sz="1300" b="0">
+                          <a:solidFill>
+                            <a:srgbClr val="3C3C3B"/>
+                          </a:solidFill>
+                          <a:latin typeface="Aptos"/>
+                        </a:rPr>
+                        <a:t>Municipal one-off</a:t>
+                      </a:r>
+                    </a:p>
+                  </a:txBody>
+                  <a:tcPr marL="73152" marR="73152" marT="27432" marB="27432" anchor="ctr">
+                    <a:solidFill>
+                      <a:srgbClr val="F2F2F2"/>
+                    </a:solidFill>
+                  </a:tcPr>
+                </a:tc>
+                <a:tc>
+                  <a:txBody>
+                    <a:bodyPr/>
+                    <a:lstStyle/>
+                    <a:p>
+                      <a:pPr algn="r"/>
+                      <a:r>
+                        <a:rPr sz="1300" b="0">
+                          <a:solidFill>
+                            <a:srgbClr val="3C3C3B"/>
+                          </a:solidFill>
+                          <a:latin typeface="Aptos"/>
+                        </a:rPr>
+                        <a:t>10.0</a:t>
+                      </a:r>
+                    </a:p>
+                  </a:txBody>
+                  <a:tcPr marL="73152" marR="73152" marT="27432" marB="27432" anchor="ctr">
+                    <a:noFill/>
+                  </a:tcPr>
+                </a:tc>
+                <a:tc>
+                  <a:txBody>
+                    <a:bodyPr/>
+                    <a:lstStyle/>
+                    <a:p>
+                      <a:pPr algn="r"/>
+                      <a:r>
+                        <a:rPr sz="1300" b="0">
+                          <a:solidFill>
+                            <a:srgbClr val="3C3C3B"/>
+                          </a:solidFill>
+                          <a:latin typeface="Aptos"/>
+                        </a:rPr>
+                        <a:t>50</a:t>
+                      </a:r>
+                    </a:p>
+                  </a:txBody>
+                  <a:tcPr marL="73152" marR="73152" marT="27432" marB="27432" anchor="ctr">
+                    <a:noFill/>
+                  </a:tcPr>
+                </a:tc>
+              </a:tr>
+              <a:tr h="329184">
+                <a:tc>
+                  <a:txBody>
+                    <a:bodyPr/>
+                    <a:lstStyle/>
+                    <a:p>
+                      <a:pPr algn="l"/>
+                      <a:r>
+                        <a:rPr sz="1300" b="0">
+                          <a:solidFill>
+                            <a:srgbClr val="3C3C3B"/>
+                          </a:solidFill>
+                          <a:latin typeface="Aptos"/>
+                        </a:rPr>
+                        <a:t>Development: devex, land, signing, securities</a:t>
+                      </a:r>
+                    </a:p>
+                  </a:txBody>
+                  <a:tcPr marL="73152" marR="73152" marT="27432" marB="27432" anchor="ctr">
+                    <a:solidFill>
+                      <a:srgbClr val="F2F2F2"/>
+                    </a:solidFill>
+                  </a:tcPr>
+                </a:tc>
+                <a:tc>
+                  <a:txBody>
+                    <a:bodyPr/>
+                    <a:lstStyle/>
+                    <a:p>
+                      <a:pPr algn="r"/>
+                      <a:r>
+                        <a:rPr sz="1300" b="0">
+                          <a:solidFill>
+                            <a:srgbClr val="3C3C3B"/>
+                          </a:solidFill>
+                          <a:latin typeface="Aptos"/>
+                        </a:rPr>
+                        <a:t>9.5</a:t>
+                      </a:r>
+                    </a:p>
+                  </a:txBody>
+                  <a:tcPr marL="73152" marR="73152" marT="27432" marB="27432" anchor="ctr">
+                    <a:noFill/>
+                  </a:tcPr>
+                </a:tc>
+                <a:tc>
+                  <a:txBody>
+                    <a:bodyPr/>
+                    <a:lstStyle/>
+                    <a:p>
+                      <a:pPr algn="r"/>
+                      <a:r>
+                        <a:rPr sz="1300" b="0">
+                          <a:solidFill>
+                            <a:srgbClr val="3C3C3B"/>
+                          </a:solidFill>
+                          <a:latin typeface="Aptos"/>
+                        </a:rPr>
+                        <a:t>48</a:t>
+                      </a:r>
+                    </a:p>
+                  </a:txBody>
+                  <a:tcPr marL="73152" marR="73152" marT="27432" marB="27432" anchor="ctr">
+                    <a:noFill/>
+                  </a:tcPr>
+                </a:tc>
+              </a:tr>
+              <a:tr h="329184">
+                <a:tc>
+                  <a:txBody>
+                    <a:bodyPr/>
+                    <a:lstStyle/>
+                    <a:p>
+                      <a:pPr algn="l"/>
+                      <a:r>
+                        <a:rPr sz="1300" b="0">
+                          <a:solidFill>
+                            <a:srgbClr val="3C3C3B"/>
+                          </a:solidFill>
+                          <a:latin typeface="Aptos"/>
+                        </a:rPr>
+                        <a:t>Financing: IDC, debt fees, guarantee fees</a:t>
+                      </a:r>
+                    </a:p>
+                  </a:txBody>
+                  <a:tcPr marL="73152" marR="73152" marT="27432" marB="27432" anchor="ctr">
+                    <a:solidFill>
+                      <a:srgbClr val="F2F2F2"/>
+                    </a:solidFill>
+                  </a:tcPr>
+                </a:tc>
+                <a:tc>
+                  <a:txBody>
+                    <a:bodyPr/>
+                    <a:lstStyle/>
+                    <a:p>
+                      <a:pPr algn="r"/>
+                      <a:r>
+                        <a:rPr sz="1300" b="0">
+                          <a:solidFill>
+                            <a:srgbClr val="3C3C3B"/>
+                          </a:solidFill>
+                          <a:latin typeface="Aptos"/>
+                        </a:rPr>
+                        <a:t>17.1</a:t>
+                      </a:r>
+                    </a:p>
+                  </a:txBody>
+                  <a:tcPr marL="73152" marR="73152" marT="27432" marB="27432" anchor="ctr">
+                    <a:noFill/>
+                  </a:tcPr>
+                </a:tc>
+                <a:tc>
+                  <a:txBody>
+                    <a:bodyPr/>
+                    <a:lstStyle/>
+                    <a:p>
+                      <a:pPr algn="r"/>
+                      <a:r>
+                        <a:rPr sz="1300" b="0">
+                          <a:solidFill>
+                            <a:srgbClr val="3C3C3B"/>
+                          </a:solidFill>
+                          <a:latin typeface="Aptos"/>
+                        </a:rPr>
+                        <a:t>85</a:t>
+                      </a:r>
+                    </a:p>
+                  </a:txBody>
+                  <a:tcPr marL="73152" marR="73152" marT="27432" marB="27432" anchor="ctr">
+                    <a:noFill/>
+                  </a:tcPr>
+                </a:tc>
+              </a:tr>
+              <a:tr h="329184">
+                <a:tc>
+                  <a:txBody>
+                    <a:bodyPr/>
+                    <a:lstStyle/>
+                    <a:p>
+                      <a:pPr algn="l"/>
+                      <a:r>
+                        <a:rPr sz="1300" b="1">
+                          <a:solidFill>
+                            <a:srgbClr val="3C3C3B"/>
+                          </a:solidFill>
+                          <a:latin typeface="Aptos"/>
+                        </a:rPr>
+                        <a:t>All-in cost to COD</a:t>
+                      </a:r>
+                    </a:p>
+                  </a:txBody>
+                  <a:tcPr marL="73152" marR="73152" marT="27432" marB="27432" anchor="ctr">
+                    <a:solidFill>
+                      <a:srgbClr val="F2F2F2"/>
+                    </a:solidFill>
+                  </a:tcPr>
+                </a:tc>
+                <a:tc>
+                  <a:txBody>
+                    <a:bodyPr/>
+                    <a:lstStyle/>
+                    <a:p>
+                      <a:pPr algn="r"/>
+                      <a:r>
+                        <a:rPr sz="1300" b="1">
+                          <a:solidFill>
+                            <a:srgbClr val="3C3C3B"/>
+                          </a:solidFill>
+                          <a:latin typeface="Aptos"/>
+                        </a:rPr>
+                        <a:t>328.4</a:t>
+                      </a:r>
+                    </a:p>
+                  </a:txBody>
+                  <a:tcPr marL="73152" marR="73152" marT="27432" marB="27432" anchor="ctr">
+                    <a:solidFill>
+                      <a:srgbClr val="E6F4EC"/>
+                    </a:solidFill>
+                  </a:tcPr>
+                </a:tc>
+                <a:tc>
+                  <a:txBody>
+                    <a:bodyPr/>
+                    <a:lstStyle/>
+                    <a:p>
+                      <a:pPr algn="r"/>
+                      <a:r>
+                        <a:rPr sz="1300" b="1">
+                          <a:solidFill>
+                            <a:srgbClr val="3C3C3B"/>
+                          </a:solidFill>
+                          <a:latin typeface="Aptos"/>
+                        </a:rPr>
+                        <a:t>1,642</a:t>
+                      </a:r>
+                    </a:p>
+                  </a:txBody>
+                  <a:tcPr marL="73152" marR="73152" marT="27432" marB="27432" anchor="ctr">
+                    <a:solidFill>
+                      <a:srgbClr val="E6F4EC"/>
+                    </a:solidFill>
+                  </a:tcPr>
+                </a:tc>
+              </a:tr>
+            </a:tbl>
+          </a:graphicData>
+        </a:graphic>
+      </p:graphicFrame>
+      <p:sp>
+        <p:nvSpPr>
+          <p:cNvPr id="7" name="Footnote"/>
+          <p:cNvSpPr txBox="1"/>
+          <p:nvPr/>
+        </p:nvSpPr>
+        <p:spPr>
+          <a:xfrm>
+            <a:off x="4498848" y="9646920"/>
+            <a:ext cx="13167360" cy="640080"/>
+          </a:xfrm>
+          <a:prstGeom prst="rect">
+            <a:avLst/>
+          </a:prstGeom>
+          <a:noFill/>
+        </p:spPr>
+        <p:txBody>
+          <a:bodyPr wrap="square">
+            <a:spAutoFit/>
+          </a:bodyPr>
+          <a:lstStyle/>
+          <a:p>
+            <a:r>
+              <a:rPr sz="1100" b="0">
+                <a:solidFill>
+                  <a:srgbClr val="919191"/>
+                </a:solidFill>
+                <a:latin typeface="Aptos"/>
+              </a:rPr>
+              <a:t>Both bids together, base case, build route. Cash = FEP equity; guarantees = bank guarantees outstanding (peak shown), not cash. IDC is debt-funded. k€/MW on 200 MW built.</a:t>
+            </a:r>
+          </a:p>
+          <a:p>
+            <a:r>
+              <a:rPr sz="1100" b="0">
+                <a:solidFill>
+                  <a:srgbClr val="919191"/>
+                </a:solidFill>
+                <a:latin typeface="Aptos"/>
+              </a:rPr>
+              <a:t>Source: Bora_Bid_Model.xlsm, 12 Oct 2026.</a:t>
+            </a:r>
+          </a:p>
+        </p:txBody>
+      </p:sp>
+    </p:spTree>
+  </p:cSld>
+  <p:clrMapOvr>
+    <a:masterClrMapping/>
+  </p:clrMapOvr>
+</p:sld>
+</file>
+
+<file path=ppt/slides/slide6.xml><?xml version="1.0" encoding="utf-8"?>
+<p:sld xmlns:a="http://schemas.openxmlformats.org/drawingml/2006/main" xmlns:p="http://schemas.openxmlformats.org/presentationml/2006/main" xmlns:r="http://schemas.openxmlformats.org/officeDocument/2006/relationships">
+  <p:cSld>
+    <p:spTree>
+      <p:nvGrpSpPr>
+        <p:cNvPr id="1" name=""/>
+        <p:cNvGrpSpPr/>
+        <p:nvPr/>
+      </p:nvGrpSpPr>
+      <p:grpSpPr/>
+      <p:sp>
+        <p:nvSpPr>
+          <p:cNvPr id="2" name="Title 1"/>
+          <p:cNvSpPr>
+            <a:spLocks noGrp="1"/>
+          </p:cNvSpPr>
+          <p:nvPr>
+            <p:ph type="title"/>
+          </p:nvPr>
+        </p:nvSpPr>
+        <p:spPr>
+          <a:xfrm>
+            <a:off x="4498848" y="182880"/>
+            <a:ext cx="12710160" cy="1097280"/>
+          </a:xfrm>
+        </p:spPr>
+        <p:txBody>
+          <a:bodyPr wrap="square"/>
+          <a:lstStyle/>
+          <a:p>
+            <a:r>
+              <a:t>Both bids clear the 8.0% discount rate: HTM IRR 9.5% and NPV €26.7m for both bids; a sale at COD returns 37.8%</a:t>
+            </a:r>
+          </a:p>
+        </p:txBody>
+      </p:sp>
+      <p:sp>
+        <p:nvSpPr>
+          <p:cNvPr id="2" name="Slide Number Placeholder 1">
+            <a:extLst>
+              <a:ext uri="{FF2B5EF4-FFF2-40B4-BE49-F238E27FC236}">
+                <a16:creationId xmlns:a16="http://schemas.microsoft.com/office/drawing/2014/main" id="{88576B7A-1C0F-D2A3-8BE9-18F63D64C454}"/>
+              </a:ext>
+            </a:extLst>
+          </p:cNvPr>
+          <p:cNvSpPr>
+            <a:spLocks noGrp="1"/>
+          </p:cNvSpPr>
+          <p:nvPr>
+            <p:ph type="sldNum" sz="quarter" idx="4"/>
+          </p:nvPr>
+        </p:nvSpPr>
+        <p:spPr>
+          <a:xfrm>
+            <a:off x="14200188" y="10483850"/>
+            <a:ext cx="4522787" cy="601663"/>
+          </a:xfrm>
+          <a:prstGeom prst="rect">
+            <a:avLst/>
+          </a:prstGeom>
+        </p:spPr>
+        <p:txBody>
+          <a:bodyPr vert="horz" lIns="91440" tIns="45720" rIns="91440" bIns="45720" rtlCol="0" anchor="ctr"/>
+          <a:lstStyle>
+            <a:lvl1pPr algn="r">
+              <a:defRPr sz="1200">
+                <a:solidFill>
+                  <a:schemeClr val="tx1">
+                    <a:tint val="82000"/>
+                  </a:schemeClr>
+                </a:solidFill>
+              </a:defRPr>
+            </a:lvl1pPr>
+          </a:lstStyle>
+          <a:p>
+            <a:fld id="{52EEA166-2877-4493-9FAA-8D6952A82FC3}" type="slidenum">
+              <a:rPr lang="en-GB" smtClean="0"/>
+              <a:t>‹#›</a:t>
+            </a:fld>
+            <a:endParaRPr lang="en-GB"/>
+          </a:p>
+        </p:txBody>
+      </p:sp>
+      <p:graphicFrame>
+        <p:nvGraphicFramePr>
+          <p:cNvPr id="3" name="Navigator"/>
+          <p:cNvGraphicFramePr>
+            <a:graphicFrameLocks noGrp="1"/>
+          </p:cNvGraphicFramePr>
+          <p:nvPr/>
+        </p:nvGraphicFramePr>
+        <p:xfrm>
+          <a:off x="0" y="0"/>
+          <a:ext cx="3767328" cy="4663440"/>
+        </p:xfrm>
+        <a:graphic>
+          <a:graphicData uri="http://schemas.openxmlformats.org/drawingml/2006/table">
+            <a:tbl>
+              <a:tblPr>
+                <a:tableStyleId>{5C22544A-7EE6-4342-B048-85BDC9FD1C3A}</a:tableStyleId>
+              </a:tblPr>
+              <a:tblGrid>
+                <a:gridCol w="3767328"/>
+              </a:tblGrid>
+              <a:tr h="777240">
+                <a:tc>
+                  <a:txBody>
+                    <a:bodyPr/>
+                    <a:lstStyle/>
+                    <a:p>
+                      <a:r>
+                        <a:rPr sz="1800" b="0">
+                          <a:solidFill>
+                            <a:srgbClr val="3C3C3B"/>
+                          </a:solidFill>
+                          <a:latin typeface="Aptos"/>
+                        </a:rPr>
+                        <a:t>Executive summary</a:t>
+                      </a:r>
+                    </a:p>
+                  </a:txBody>
+                  <a:tcPr marL="180000" anchor="ctr">
+                    <a:lnL>
+                      <a:noFill/>
+                    </a:lnL>
+                    <a:lnR>
+                      <a:noFill/>
+                    </a:lnR>
+                    <a:lnT w="6350">
+                      <a:solidFill>
+                        <a:srgbClr val="3C3C3B"/>
+                      </a:solidFill>
+                    </a:lnT>
+                    <a:lnB w="6350">
+                      <a:solidFill>
+                        <a:srgbClr val="3C3C3B"/>
+                      </a:solidFill>
+                    </a:lnB>
+                    <a:noFill/>
+                  </a:tcPr>
+                </a:tc>
+              </a:tr>
+              <a:tr h="777240">
+                <a:tc>
+                  <a:txBody>
+                    <a:bodyPr/>
+                    <a:lstStyle/>
+                    <a:p>
+                      <a:r>
+                        <a:rPr sz="1800" b="0">
+                          <a:solidFill>
+                            <a:srgbClr val="3C3C3B"/>
+                          </a:solidFill>
+                          <a:latin typeface="Aptos"/>
+                        </a:rPr>
+                        <a:t>Commitments</a:t>
+                      </a:r>
+                    </a:p>
+                  </a:txBody>
+                  <a:tcPr marL="180000" anchor="ctr">
+                    <a:lnL>
+                      <a:noFill/>
+                    </a:lnL>
+                    <a:lnR>
+                      <a:noFill/>
+                    </a:lnR>
+                    <a:lnT w="6350">
+                      <a:solidFill>
+                        <a:srgbClr val="3C3C3B"/>
+                      </a:solidFill>
+                    </a:lnT>
+                    <a:lnB w="6350">
+                      <a:solidFill>
+                        <a:srgbClr val="3C3C3B"/>
+                      </a:solidFill>
+                    </a:lnB>
+                    <a:noFill/>
+                  </a:tcPr>
+                </a:tc>
+              </a:tr>
+              <a:tr h="777240">
+                <a:tc>
+                  <a:txBody>
+                    <a:bodyPr/>
+                    <a:lstStyle/>
+                    <a:p>
+                      <a:r>
+                        <a:rPr sz="1800" b="0">
+                          <a:solidFill>
+                            <a:srgbClr val="3C3C3B"/>
+                          </a:solidFill>
+                          <a:latin typeface="Aptos"/>
+                        </a:rPr>
+                        <a:t>Economics – RtB exit</a:t>
+                      </a:r>
+                    </a:p>
+                  </a:txBody>
+                  <a:tcPr marL="180000" anchor="ctr">
+                    <a:lnL>
+                      <a:noFill/>
+                    </a:lnL>
+                    <a:lnR>
+                      <a:noFill/>
+                    </a:lnR>
+                    <a:lnT w="6350">
+                      <a:solidFill>
+                        <a:srgbClr val="3C3C3B"/>
+                      </a:solidFill>
+                    </a:lnT>
+                    <a:lnB w="6350">
+                      <a:solidFill>
+                        <a:srgbClr val="3C3C3B"/>
+                      </a:solidFill>
+                    </a:lnB>
+                    <a:noFill/>
+                  </a:tcPr>
+                </a:tc>
+              </a:tr>
+              <a:tr h="777240">
+                <a:tc>
+                  <a:txBody>
+                    <a:bodyPr/>
+                    <a:lstStyle/>
+                    <a:p>
+                      <a:r>
+                        <a:rPr sz="1800" b="0">
+                          <a:solidFill>
+                            <a:srgbClr val="3C3C3B"/>
+                          </a:solidFill>
+                          <a:latin typeface="Aptos"/>
+                        </a:rPr>
+                        <a:t>Funding and capex</a:t>
                       </a:r>
                     </a:p>
                   </a:txBody>
@@ -10774,7 +14071,7 @@
         </p:nvGraphicFramePr>
         <p:xfrm>
           <a:off x="4498848" y="2240280"/>
-          <a:ext cx="9125712" cy="4050792"/>
+          <a:ext cx="9125712" cy="2368296"/>
         </p:xfrm>
         <a:graphic>
           <a:graphicData uri="http://schemas.openxmlformats.org/drawingml/2006/table">
@@ -10930,7 +14227,7 @@
                   </a:tcPr>
                 </a:tc>
               </a:tr>
-              <a:tr h="438912">
+              <a:tr h="457200">
                 <a:tc>
                   <a:txBody>
                     <a:bodyPr/>
@@ -10944,7 +14241,7 @@
                           </a:solidFill>
                           <a:latin typeface="Aptos"/>
                         </a:rPr>
-                        <a:t>FEP NPV – sale at COD</a:t>
+                        <a:t>FEP IRR – sale at COD</a:t>
                       </a:r>
                     </a:p>
                   </a:txBody>
@@ -10967,7 +14264,7 @@
                           </a:solidFill>
                           <a:latin typeface="Aptos"/>
                         </a:rPr>
-                        <a:t>€ m</a:t>
+                        <a:t>% / pp</a:t>
                       </a:r>
                     </a:p>
                   </a:txBody>
@@ -10990,70 +14287,70 @@
                           </a:solidFill>
                           <a:latin typeface="Aptos"/>
                         </a:rPr>
-                        <a:t>44.6</a:t>
-                      </a:r>
-                    </a:p>
-                  </a:txBody>
-                  <a:tcPr marL="73152" marR="73152" marT="27432" marB="27432" anchor="ctr">
-                    <a:noFill/>
-                  </a:tcPr>
-                </a:tc>
-                <a:tc>
-                  <a:txBody>
-                    <a:bodyPr/>
-                    <a:lstStyle/>
-                    <a:p>
-                      <a:pPr algn="r"/>
-                      <a:r>
-                        <a:rPr sz="1300" b="0">
-                          <a:solidFill>
-                            <a:srgbClr val="3C3C3B"/>
-                          </a:solidFill>
-                          <a:latin typeface="Aptos"/>
-                        </a:rPr>
-                        <a:t>30.8</a:t>
-                      </a:r>
-                    </a:p>
-                  </a:txBody>
-                  <a:tcPr marL="73152" marR="73152" marT="27432" marB="27432" anchor="ctr">
-                    <a:noFill/>
-                  </a:tcPr>
-                </a:tc>
-                <a:tc>
-                  <a:txBody>
-                    <a:bodyPr/>
-                    <a:lstStyle/>
-                    <a:p>
-                      <a:pPr algn="r"/>
-                      <a:r>
-                        <a:rPr sz="1300" b="0">
-                          <a:solidFill>
-                            <a:srgbClr val="3C3C3B"/>
-                          </a:solidFill>
-                          <a:latin typeface="Aptos"/>
-                        </a:rPr>
-                        <a:t>(13.9)</a:t>
-                      </a:r>
-                    </a:p>
-                  </a:txBody>
-                  <a:tcPr marL="73152" marR="73152" marT="27432" marB="27432" anchor="ctr">
-                    <a:noFill/>
-                  </a:tcPr>
-                </a:tc>
-                <a:tc>
-                  <a:txBody>
-                    <a:bodyPr/>
-                    <a:lstStyle/>
-                    <a:p>
-                      <a:pPr algn="r"/>
-                      <a:r>
-                        <a:rPr sz="1300" b="0">
-                          <a:solidFill>
-                            <a:srgbClr val="3C3C3B"/>
-                          </a:solidFill>
-                          <a:latin typeface="Aptos"/>
-                        </a:rPr>
-                        <a:t>61.5</a:t>
+                        <a:t>49.6%</a:t>
+                      </a:r>
+                    </a:p>
+                  </a:txBody>
+                  <a:tcPr marL="73152" marR="73152" marT="27432" marB="27432" anchor="ctr">
+                    <a:noFill/>
+                  </a:tcPr>
+                </a:tc>
+                <a:tc>
+                  <a:txBody>
+                    <a:bodyPr/>
+                    <a:lstStyle/>
+                    <a:p>
+                      <a:pPr algn="r"/>
+                      <a:r>
+                        <a:rPr sz="1300" b="0">
+                          <a:solidFill>
+                            <a:srgbClr val="3C3C3B"/>
+                          </a:solidFill>
+                          <a:latin typeface="Aptos"/>
+                        </a:rPr>
+                        <a:t>37.8%</a:t>
+                      </a:r>
+                    </a:p>
+                  </a:txBody>
+                  <a:tcPr marL="73152" marR="73152" marT="27432" marB="27432" anchor="ctr">
+                    <a:noFill/>
+                  </a:tcPr>
+                </a:tc>
+                <a:tc>
+                  <a:txBody>
+                    <a:bodyPr/>
+                    <a:lstStyle/>
+                    <a:p>
+                      <a:pPr algn="r"/>
+                      <a:r>
+                        <a:rPr sz="1300" b="0">
+                          <a:solidFill>
+                            <a:srgbClr val="3C3C3B"/>
+                          </a:solidFill>
+                          <a:latin typeface="Aptos"/>
+                        </a:rPr>
+                        <a:t>−11.7</a:t>
+                      </a:r>
+                    </a:p>
+                  </a:txBody>
+                  <a:tcPr marL="73152" marR="73152" marT="27432" marB="27432" anchor="ctr">
+                    <a:noFill/>
+                  </a:tcPr>
+                </a:tc>
+                <a:tc>
+                  <a:txBody>
+                    <a:bodyPr/>
+                    <a:lstStyle/>
+                    <a:p>
+                      <a:pPr algn="r"/>
+                      <a:r>
+                        <a:rPr sz="1300" b="0">
+                          <a:solidFill>
+                            <a:srgbClr val="3C3C3B"/>
+                          </a:solidFill>
+                          <a:latin typeface="Aptos"/>
+                        </a:rPr>
+                        <a:t>–</a:t>
                       </a:r>
                     </a:p>
                   </a:txBody>
@@ -11062,7 +14359,7 @@
                   </a:tcPr>
                 </a:tc>
               </a:tr>
-              <a:tr h="438912">
+              <a:tr h="457200">
                 <a:tc>
                   <a:txBody>
                     <a:bodyPr/>
@@ -11070,13 +14367,13 @@
                     <a:p>
                       <a:pPr algn="l"/>
                       <a:r>
-                        <a:rPr sz="1300" b="1">
-                          <a:solidFill>
-                            <a:srgbClr val="3C3C3B"/>
-                          </a:solidFill>
-                          <a:latin typeface="Aptos"/>
-                        </a:rPr>
-                        <a:t>FEP NPV – hold to maturity</a:t>
+                        <a:rPr sz="1300" b="0">
+                          <a:solidFill>
+                            <a:srgbClr val="3C3C3B"/>
+                          </a:solidFill>
+                          <a:latin typeface="Aptos"/>
+                        </a:rPr>
+                        <a:t>FEP NPV – sale at COD</a:t>
                       </a:r>
                     </a:p>
                   </a:txBody>
@@ -11093,7 +14390,7 @@
                     <a:p>
                       <a:pPr algn="l"/>
                       <a:r>
-                        <a:rPr sz="1300" b="1">
+                        <a:rPr sz="1300" b="0">
                           <a:solidFill>
                             <a:srgbClr val="919191"/>
                           </a:solidFill>
@@ -11116,6 +14413,270 @@
                     <a:p>
                       <a:pPr algn="r"/>
                       <a:r>
+                        <a:rPr sz="1300" b="0">
+                          <a:solidFill>
+                            <a:srgbClr val="3C3C3B"/>
+                          </a:solidFill>
+                          <a:latin typeface="Aptos"/>
+                        </a:rPr>
+                        <a:t>44.6</a:t>
+                      </a:r>
+                    </a:p>
+                  </a:txBody>
+                  <a:tcPr marL="73152" marR="73152" marT="27432" marB="27432" anchor="ctr">
+                    <a:noFill/>
+                  </a:tcPr>
+                </a:tc>
+                <a:tc>
+                  <a:txBody>
+                    <a:bodyPr/>
+                    <a:lstStyle/>
+                    <a:p>
+                      <a:pPr algn="r"/>
+                      <a:r>
+                        <a:rPr sz="1300" b="0">
+                          <a:solidFill>
+                            <a:srgbClr val="3C3C3B"/>
+                          </a:solidFill>
+                          <a:latin typeface="Aptos"/>
+                        </a:rPr>
+                        <a:t>30.8</a:t>
+                      </a:r>
+                    </a:p>
+                  </a:txBody>
+                  <a:tcPr marL="73152" marR="73152" marT="27432" marB="27432" anchor="ctr">
+                    <a:noFill/>
+                  </a:tcPr>
+                </a:tc>
+                <a:tc>
+                  <a:txBody>
+                    <a:bodyPr/>
+                    <a:lstStyle/>
+                    <a:p>
+                      <a:pPr algn="r"/>
+                      <a:r>
+                        <a:rPr sz="1300" b="0">
+                          <a:solidFill>
+                            <a:srgbClr val="3C3C3B"/>
+                          </a:solidFill>
+                          <a:latin typeface="Aptos"/>
+                        </a:rPr>
+                        <a:t>(13.9)</a:t>
+                      </a:r>
+                    </a:p>
+                  </a:txBody>
+                  <a:tcPr marL="73152" marR="73152" marT="27432" marB="27432" anchor="ctr">
+                    <a:noFill/>
+                  </a:tcPr>
+                </a:tc>
+                <a:tc>
+                  <a:txBody>
+                    <a:bodyPr/>
+                    <a:lstStyle/>
+                    <a:p>
+                      <a:pPr algn="r"/>
+                      <a:r>
+                        <a:rPr sz="1300" b="0">
+                          <a:solidFill>
+                            <a:srgbClr val="3C3C3B"/>
+                          </a:solidFill>
+                          <a:latin typeface="Aptos"/>
+                        </a:rPr>
+                        <a:t>61.5</a:t>
+                      </a:r>
+                    </a:p>
+                  </a:txBody>
+                  <a:tcPr marL="73152" marR="73152" marT="27432" marB="27432" anchor="ctr">
+                    <a:noFill/>
+                  </a:tcPr>
+                </a:tc>
+              </a:tr>
+              <a:tr h="457200">
+                <a:tc>
+                  <a:txBody>
+                    <a:bodyPr/>
+                    <a:lstStyle/>
+                    <a:p>
+                      <a:pPr algn="l"/>
+                      <a:r>
+                        <a:rPr sz="1300" b="0">
+                          <a:solidFill>
+                            <a:srgbClr val="3C3C3B"/>
+                          </a:solidFill>
+                          <a:latin typeface="Aptos"/>
+                        </a:rPr>
+                        <a:t>FEP IRR – hold to maturity</a:t>
+                      </a:r>
+                    </a:p>
+                  </a:txBody>
+                  <a:tcPr marL="73152" marR="73152" marT="27432" marB="27432" anchor="ctr">
+                    <a:solidFill>
+                      <a:srgbClr val="F2F2F2"/>
+                    </a:solidFill>
+                  </a:tcPr>
+                </a:tc>
+                <a:tc>
+                  <a:txBody>
+                    <a:bodyPr/>
+                    <a:lstStyle/>
+                    <a:p>
+                      <a:pPr algn="l"/>
+                      <a:r>
+                        <a:rPr sz="1300" b="0">
+                          <a:solidFill>
+                            <a:srgbClr val="919191"/>
+                          </a:solidFill>
+                          <a:latin typeface="Aptos"/>
+                        </a:rPr>
+                        <a:t>% / pp</a:t>
+                      </a:r>
+                    </a:p>
+                  </a:txBody>
+                  <a:tcPr marL="73152" marR="73152" marT="27432" marB="27432" anchor="ctr">
+                    <a:solidFill>
+                      <a:srgbClr val="F2F2F2"/>
+                    </a:solidFill>
+                  </a:tcPr>
+                </a:tc>
+                <a:tc>
+                  <a:txBody>
+                    <a:bodyPr/>
+                    <a:lstStyle/>
+                    <a:p>
+                      <a:pPr algn="r"/>
+                      <a:r>
+                        <a:rPr sz="1300" b="0">
+                          <a:solidFill>
+                            <a:srgbClr val="3C3C3B"/>
+                          </a:solidFill>
+                          <a:latin typeface="Aptos"/>
+                        </a:rPr>
+                        <a:t>11.9%</a:t>
+                      </a:r>
+                    </a:p>
+                  </a:txBody>
+                  <a:tcPr marL="73152" marR="73152" marT="27432" marB="27432" anchor="ctr">
+                    <a:noFill/>
+                  </a:tcPr>
+                </a:tc>
+                <a:tc>
+                  <a:txBody>
+                    <a:bodyPr/>
+                    <a:lstStyle/>
+                    <a:p>
+                      <a:pPr algn="r"/>
+                      <a:r>
+                        <a:rPr sz="1300" b="0">
+                          <a:solidFill>
+                            <a:srgbClr val="3C3C3B"/>
+                          </a:solidFill>
+                          <a:latin typeface="Aptos"/>
+                        </a:rPr>
+                        <a:t>9.5%</a:t>
+                      </a:r>
+                    </a:p>
+                  </a:txBody>
+                  <a:tcPr marL="73152" marR="73152" marT="27432" marB="27432" anchor="ctr">
+                    <a:noFill/>
+                  </a:tcPr>
+                </a:tc>
+                <a:tc>
+                  <a:txBody>
+                    <a:bodyPr/>
+                    <a:lstStyle/>
+                    <a:p>
+                      <a:pPr algn="r"/>
+                      <a:r>
+                        <a:rPr sz="1300" b="0">
+                          <a:solidFill>
+                            <a:srgbClr val="3C3C3B"/>
+                          </a:solidFill>
+                          <a:latin typeface="Aptos"/>
+                        </a:rPr>
+                        <a:t>−2.4</a:t>
+                      </a:r>
+                    </a:p>
+                  </a:txBody>
+                  <a:tcPr marL="73152" marR="73152" marT="27432" marB="27432" anchor="ctr">
+                    <a:noFill/>
+                  </a:tcPr>
+                </a:tc>
+                <a:tc>
+                  <a:txBody>
+                    <a:bodyPr/>
+                    <a:lstStyle/>
+                    <a:p>
+                      <a:pPr algn="r"/>
+                      <a:r>
+                        <a:rPr sz="1300" b="0">
+                          <a:solidFill>
+                            <a:srgbClr val="3C3C3B"/>
+                          </a:solidFill>
+                          <a:latin typeface="Aptos"/>
+                        </a:rPr>
+                        <a:t>–</a:t>
+                      </a:r>
+                    </a:p>
+                  </a:txBody>
+                  <a:tcPr marL="73152" marR="73152" marT="27432" marB="27432" anchor="ctr">
+                    <a:noFill/>
+                  </a:tcPr>
+                </a:tc>
+              </a:tr>
+              <a:tr h="457200">
+                <a:tc>
+                  <a:txBody>
+                    <a:bodyPr/>
+                    <a:lstStyle/>
+                    <a:p>
+                      <a:pPr algn="l"/>
+                      <a:r>
+                        <a:rPr sz="1300" b="1">
+                          <a:solidFill>
+                            <a:srgbClr val="3C3C3B"/>
+                          </a:solidFill>
+                          <a:latin typeface="Aptos"/>
+                        </a:rPr>
+                        <a:t>FEP NPV – hold to maturity</a:t>
+                      </a:r>
+                    </a:p>
+                  </a:txBody>
+                  <a:tcPr marL="73152" marR="73152" marT="27432" marB="27432" anchor="ctr">
+                    <a:solidFill>
+                      <a:srgbClr val="F2F2F2"/>
+                    </a:solidFill>
+                  </a:tcPr>
+                </a:tc>
+                <a:tc>
+                  <a:txBody>
+                    <a:bodyPr/>
+                    <a:lstStyle/>
+                    <a:p>
+                      <a:pPr algn="l"/>
+                      <a:r>
+                        <a:rPr sz="1300" b="1">
+                          <a:solidFill>
+                            <a:srgbClr val="919191"/>
+                          </a:solidFill>
+                          <a:latin typeface="Aptos"/>
+                        </a:rPr>
+                        <a:t>€ m</a:t>
+                      </a:r>
+                    </a:p>
+                  </a:txBody>
+                  <a:tcPr marL="73152" marR="73152" marT="27432" marB="27432" anchor="ctr">
+                    <a:solidFill>
+                      <a:srgbClr val="F2F2F2"/>
+                    </a:solidFill>
+                  </a:tcPr>
+                </a:tc>
+                <a:tc>
+                  <a:txBody>
+                    <a:bodyPr/>
+                    <a:lstStyle/>
+                    <a:p>
+                      <a:pPr algn="r"/>
+                      <a:r>
                         <a:rPr sz="1300" b="1">
                           <a:solidFill>
                             <a:srgbClr val="3C3C3B"/>
@@ -11199,798 +14760,6 @@
                     <a:solidFill>
                       <a:srgbClr val="E6F4EC"/>
                     </a:solidFill>
-                  </a:tcPr>
-                </a:tc>
-              </a:tr>
-              <a:tr h="438912">
-                <a:tc>
-                  <a:txBody>
-                    <a:bodyPr/>
-                    <a:lstStyle/>
-                    <a:p>
-                      <a:pPr algn="l"/>
-                      <a:r>
-                        <a:rPr sz="1300" b="0">
-                          <a:solidFill>
-                            <a:srgbClr val="3C3C3B"/>
-                          </a:solidFill>
-                          <a:latin typeface="Aptos"/>
-                        </a:rPr>
-                        <a:t>All-in cost to COD per built MW</a:t>
-                      </a:r>
-                    </a:p>
-                  </a:txBody>
-                  <a:tcPr marL="73152" marR="73152" marT="27432" marB="27432" anchor="ctr">
-                    <a:solidFill>
-                      <a:srgbClr val="F2F2F2"/>
-                    </a:solidFill>
-                  </a:tcPr>
-                </a:tc>
-                <a:tc>
-                  <a:txBody>
-                    <a:bodyPr/>
-                    <a:lstStyle/>
-                    <a:p>
-                      <a:pPr algn="l"/>
-                      <a:r>
-                        <a:rPr sz="1300" b="0">
-                          <a:solidFill>
-                            <a:srgbClr val="919191"/>
-                          </a:solidFill>
-                          <a:latin typeface="Aptos"/>
-                        </a:rPr>
-                        <a:t>k€/MW</a:t>
-                      </a:r>
-                    </a:p>
-                  </a:txBody>
-                  <a:tcPr marL="73152" marR="73152" marT="27432" marB="27432" anchor="ctr">
-                    <a:solidFill>
-                      <a:srgbClr val="F2F2F2"/>
-                    </a:solidFill>
-                  </a:tcPr>
-                </a:tc>
-                <a:tc>
-                  <a:txBody>
-                    <a:bodyPr/>
-                    <a:lstStyle/>
-                    <a:p>
-                      <a:pPr algn="r"/>
-                      <a:r>
-                        <a:rPr sz="1300" b="0">
-                          <a:solidFill>
-                            <a:srgbClr val="3C3C3B"/>
-                          </a:solidFill>
-                          <a:latin typeface="Aptos"/>
-                        </a:rPr>
-                        <a:t>–</a:t>
-                      </a:r>
-                    </a:p>
-                  </a:txBody>
-                  <a:tcPr marL="73152" marR="73152" marT="27432" marB="27432" anchor="ctr">
-                    <a:noFill/>
-                  </a:tcPr>
-                </a:tc>
-                <a:tc>
-                  <a:txBody>
-                    <a:bodyPr/>
-                    <a:lstStyle/>
-                    <a:p>
-                      <a:pPr algn="r"/>
-                      <a:r>
-                        <a:rPr sz="1300" b="0">
-                          <a:solidFill>
-                            <a:srgbClr val="3C3C3B"/>
-                          </a:solidFill>
-                          <a:latin typeface="Aptos"/>
-                        </a:rPr>
-                        <a:t>1,642</a:t>
-                      </a:r>
-                    </a:p>
-                  </a:txBody>
-                  <a:tcPr marL="73152" marR="73152" marT="27432" marB="27432" anchor="ctr">
-                    <a:noFill/>
-                  </a:tcPr>
-                </a:tc>
-                <a:tc>
-                  <a:txBody>
-                    <a:bodyPr/>
-                    <a:lstStyle/>
-                    <a:p>
-                      <a:pPr algn="r"/>
-                      <a:r>
-                        <a:rPr sz="1300" b="0">
-                          <a:solidFill>
-                            <a:srgbClr val="3C3C3B"/>
-                          </a:solidFill>
-                          <a:latin typeface="Aptos"/>
-                        </a:rPr>
-                        <a:t>–</a:t>
-                      </a:r>
-                    </a:p>
-                  </a:txBody>
-                  <a:tcPr marL="73152" marR="73152" marT="27432" marB="27432" anchor="ctr">
-                    <a:noFill/>
-                  </a:tcPr>
-                </a:tc>
-                <a:tc>
-                  <a:txBody>
-                    <a:bodyPr/>
-                    <a:lstStyle/>
-                    <a:p>
-                      <a:pPr algn="r"/>
-                      <a:r>
-                        <a:rPr sz="1300" b="0">
-                          <a:solidFill>
-                            <a:srgbClr val="3C3C3B"/>
-                          </a:solidFill>
-                          <a:latin typeface="Aptos"/>
-                        </a:rPr>
-                        <a:t>–</a:t>
-                      </a:r>
-                    </a:p>
-                  </a:txBody>
-                  <a:tcPr marL="73152" marR="73152" marT="27432" marB="27432" anchor="ctr">
-                    <a:noFill/>
-                  </a:tcPr>
-                </a:tc>
-              </a:tr>
-              <a:tr h="438912">
-                <a:tc>
-                  <a:txBody>
-                    <a:bodyPr/>
-                    <a:lstStyle/>
-                    <a:p>
-                      <a:pPr algn="l"/>
-                      <a:r>
-                        <a:rPr sz="1300" b="0">
-                          <a:solidFill>
-                            <a:srgbClr val="3C3C3B"/>
-                          </a:solidFill>
-                          <a:latin typeface="Aptos"/>
-                        </a:rPr>
-                        <a:t>COD sale price per built MW</a:t>
-                      </a:r>
-                    </a:p>
-                  </a:txBody>
-                  <a:tcPr marL="73152" marR="73152" marT="27432" marB="27432" anchor="ctr">
-                    <a:solidFill>
-                      <a:srgbClr val="F2F2F2"/>
-                    </a:solidFill>
-                  </a:tcPr>
-                </a:tc>
-                <a:tc>
-                  <a:txBody>
-                    <a:bodyPr/>
-                    <a:lstStyle/>
-                    <a:p>
-                      <a:pPr algn="l"/>
-                      <a:r>
-                        <a:rPr sz="1300" b="0">
-                          <a:solidFill>
-                            <a:srgbClr val="919191"/>
-                          </a:solidFill>
-                          <a:latin typeface="Aptos"/>
-                        </a:rPr>
-                        <a:t>k€/MW</a:t>
-                      </a:r>
-                    </a:p>
-                  </a:txBody>
-                  <a:tcPr marL="73152" marR="73152" marT="27432" marB="27432" anchor="ctr">
-                    <a:solidFill>
-                      <a:srgbClr val="F2F2F2"/>
-                    </a:solidFill>
-                  </a:tcPr>
-                </a:tc>
-                <a:tc>
-                  <a:txBody>
-                    <a:bodyPr/>
-                    <a:lstStyle/>
-                    <a:p>
-                      <a:pPr algn="r"/>
-                      <a:r>
-                        <a:rPr sz="1300" b="0">
-                          <a:solidFill>
-                            <a:srgbClr val="3C3C3B"/>
-                          </a:solidFill>
-                          <a:latin typeface="Aptos"/>
-                        </a:rPr>
-                        <a:t>–</a:t>
-                      </a:r>
-                    </a:p>
-                  </a:txBody>
-                  <a:tcPr marL="73152" marR="73152" marT="27432" marB="27432" anchor="ctr">
-                    <a:noFill/>
-                  </a:tcPr>
-                </a:tc>
-                <a:tc>
-                  <a:txBody>
-                    <a:bodyPr/>
-                    <a:lstStyle/>
-                    <a:p>
-                      <a:pPr algn="r"/>
-                      <a:r>
-                        <a:rPr sz="1300" b="0">
-                          <a:solidFill>
-                            <a:srgbClr val="3C3C3B"/>
-                          </a:solidFill>
-                          <a:latin typeface="Aptos"/>
-                        </a:rPr>
-                        <a:t>2,450</a:t>
-                      </a:r>
-                    </a:p>
-                  </a:txBody>
-                  <a:tcPr marL="73152" marR="73152" marT="27432" marB="27432" anchor="ctr">
-                    <a:noFill/>
-                  </a:tcPr>
-                </a:tc>
-                <a:tc>
-                  <a:txBody>
-                    <a:bodyPr/>
-                    <a:lstStyle/>
-                    <a:p>
-                      <a:pPr algn="r"/>
-                      <a:r>
-                        <a:rPr sz="1300" b="0">
-                          <a:solidFill>
-                            <a:srgbClr val="3C3C3B"/>
-                          </a:solidFill>
-                          <a:latin typeface="Aptos"/>
-                        </a:rPr>
-                        <a:t>–</a:t>
-                      </a:r>
-                    </a:p>
-                  </a:txBody>
-                  <a:tcPr marL="73152" marR="73152" marT="27432" marB="27432" anchor="ctr">
-                    <a:noFill/>
-                  </a:tcPr>
-                </a:tc>
-                <a:tc>
-                  <a:txBody>
-                    <a:bodyPr/>
-                    <a:lstStyle/>
-                    <a:p>
-                      <a:pPr algn="r"/>
-                      <a:r>
-                        <a:rPr sz="1300" b="0">
-                          <a:solidFill>
-                            <a:srgbClr val="3C3C3B"/>
-                          </a:solidFill>
-                          <a:latin typeface="Aptos"/>
-                        </a:rPr>
-                        <a:t>–</a:t>
-                      </a:r>
-                    </a:p>
-                  </a:txBody>
-                  <a:tcPr marL="73152" marR="73152" marT="27432" marB="27432" anchor="ctr">
-                    <a:noFill/>
-                  </a:tcPr>
-                </a:tc>
-              </a:tr>
-              <a:tr h="438912">
-                <a:tc>
-                  <a:txBody>
-                    <a:bodyPr/>
-                    <a:lstStyle/>
-                    <a:p>
-                      <a:pPr algn="l"/>
-                      <a:r>
-                        <a:rPr sz="1300" b="0">
-                          <a:solidFill>
-                            <a:srgbClr val="3C3C3B"/>
-                          </a:solidFill>
-                          <a:latin typeface="Aptos"/>
-                        </a:rPr>
-                        <a:t>Securities: cash posted and guarantees</a:t>
-                      </a:r>
-                    </a:p>
-                  </a:txBody>
-                  <a:tcPr marL="73152" marR="73152" marT="27432" marB="27432" anchor="ctr">
-                    <a:solidFill>
-                      <a:srgbClr val="F2F2F2"/>
-                    </a:solidFill>
-                  </a:tcPr>
-                </a:tc>
-                <a:tc>
-                  <a:txBody>
-                    <a:bodyPr/>
-                    <a:lstStyle/>
-                    <a:p>
-                      <a:pPr algn="l"/>
-                      <a:r>
-                        <a:rPr sz="1300" b="0">
-                          <a:solidFill>
-                            <a:srgbClr val="919191"/>
-                          </a:solidFill>
-                          <a:latin typeface="Aptos"/>
-                        </a:rPr>
-                        <a:t>€ m</a:t>
-                      </a:r>
-                    </a:p>
-                  </a:txBody>
-                  <a:tcPr marL="73152" marR="73152" marT="27432" marB="27432" anchor="ctr">
-                    <a:solidFill>
-                      <a:srgbClr val="F2F2F2"/>
-                    </a:solidFill>
-                  </a:tcPr>
-                </a:tc>
-                <a:tc>
-                  <a:txBody>
-                    <a:bodyPr/>
-                    <a:lstStyle/>
-                    <a:p>
-                      <a:pPr algn="r"/>
-                      <a:r>
-                        <a:rPr sz="1300" b="0">
-                          <a:solidFill>
-                            <a:srgbClr val="3C3C3B"/>
-                          </a:solidFill>
-                          <a:latin typeface="Aptos"/>
-                        </a:rPr>
-                        <a:t>–</a:t>
-                      </a:r>
-                    </a:p>
-                  </a:txBody>
-                  <a:tcPr marL="73152" marR="73152" marT="27432" marB="27432" anchor="ctr">
-                    <a:noFill/>
-                  </a:tcPr>
-                </a:tc>
-                <a:tc>
-                  <a:txBody>
-                    <a:bodyPr/>
-                    <a:lstStyle/>
-                    <a:p>
-                      <a:pPr algn="r"/>
-                      <a:r>
-                        <a:rPr sz="1300" b="0">
-                          <a:solidFill>
-                            <a:srgbClr val="3C3C3B"/>
-                          </a:solidFill>
-                          <a:latin typeface="Aptos"/>
-                        </a:rPr>
-                        <a:t>8.2</a:t>
-                      </a:r>
-                    </a:p>
-                  </a:txBody>
-                  <a:tcPr marL="73152" marR="73152" marT="27432" marB="27432" anchor="ctr">
-                    <a:noFill/>
-                  </a:tcPr>
-                </a:tc>
-                <a:tc>
-                  <a:txBody>
-                    <a:bodyPr/>
-                    <a:lstStyle/>
-                    <a:p>
-                      <a:pPr algn="r"/>
-                      <a:r>
-                        <a:rPr sz="1300" b="0">
-                          <a:solidFill>
-                            <a:srgbClr val="3C3C3B"/>
-                          </a:solidFill>
-                          <a:latin typeface="Aptos"/>
-                        </a:rPr>
-                        <a:t>–</a:t>
-                      </a:r>
-                    </a:p>
-                  </a:txBody>
-                  <a:tcPr marL="73152" marR="73152" marT="27432" marB="27432" anchor="ctr">
-                    <a:noFill/>
-                  </a:tcPr>
-                </a:tc>
-                <a:tc>
-                  <a:txBody>
-                    <a:bodyPr/>
-                    <a:lstStyle/>
-                    <a:p>
-                      <a:pPr algn="r"/>
-                      <a:r>
-                        <a:rPr sz="1300" b="0">
-                          <a:solidFill>
-                            <a:srgbClr val="3C3C3B"/>
-                          </a:solidFill>
-                          <a:latin typeface="Aptos"/>
-                        </a:rPr>
-                        <a:t>16.5</a:t>
-                      </a:r>
-                    </a:p>
-                  </a:txBody>
-                  <a:tcPr marL="73152" marR="73152" marT="27432" marB="27432" anchor="ctr">
-                    <a:noFill/>
-                  </a:tcPr>
-                </a:tc>
-              </a:tr>
-              <a:tr h="438912">
-                <a:tc>
-                  <a:txBody>
-                    <a:bodyPr/>
-                    <a:lstStyle/>
-                    <a:p>
-                      <a:pPr algn="l"/>
-                      <a:r>
-                        <a:rPr sz="1300" b="0">
-                          <a:solidFill>
-                            <a:srgbClr val="3C3C3B"/>
-                          </a:solidFill>
-                          <a:latin typeface="Aptos"/>
-                        </a:rPr>
-                        <a:t>Devex, land, signing and DD</a:t>
-                      </a:r>
-                    </a:p>
-                  </a:txBody>
-                  <a:tcPr marL="73152" marR="73152" marT="27432" marB="27432" anchor="ctr">
-                    <a:solidFill>
-                      <a:srgbClr val="F2F2F2"/>
-                    </a:solidFill>
-                  </a:tcPr>
-                </a:tc>
-                <a:tc>
-                  <a:txBody>
-                    <a:bodyPr/>
-                    <a:lstStyle/>
-                    <a:p>
-                      <a:pPr algn="l"/>
-                      <a:r>
-                        <a:rPr sz="1300" b="0">
-                          <a:solidFill>
-                            <a:srgbClr val="919191"/>
-                          </a:solidFill>
-                          <a:latin typeface="Aptos"/>
-                        </a:rPr>
-                        <a:t>€ m</a:t>
-                      </a:r>
-                    </a:p>
-                  </a:txBody>
-                  <a:tcPr marL="73152" marR="73152" marT="27432" marB="27432" anchor="ctr">
-                    <a:solidFill>
-                      <a:srgbClr val="F2F2F2"/>
-                    </a:solidFill>
-                  </a:tcPr>
-                </a:tc>
-                <a:tc>
-                  <a:txBody>
-                    <a:bodyPr/>
-                    <a:lstStyle/>
-                    <a:p>
-                      <a:pPr algn="r"/>
-                      <a:r>
-                        <a:rPr sz="1300" b="0">
-                          <a:solidFill>
-                            <a:srgbClr val="3C3C3B"/>
-                          </a:solidFill>
-                          <a:latin typeface="Aptos"/>
-                        </a:rPr>
-                        <a:t>–</a:t>
-                      </a:r>
-                    </a:p>
-                  </a:txBody>
-                  <a:tcPr marL="73152" marR="73152" marT="27432" marB="27432" anchor="ctr">
-                    <a:noFill/>
-                  </a:tcPr>
-                </a:tc>
-                <a:tc>
-                  <a:txBody>
-                    <a:bodyPr/>
-                    <a:lstStyle/>
-                    <a:p>
-                      <a:pPr algn="r"/>
-                      <a:r>
-                        <a:rPr sz="1300" b="0">
-                          <a:solidFill>
-                            <a:srgbClr val="3C3C3B"/>
-                          </a:solidFill>
-                          <a:latin typeface="Aptos"/>
-                        </a:rPr>
-                        <a:t>3.5</a:t>
-                      </a:r>
-                    </a:p>
-                  </a:txBody>
-                  <a:tcPr marL="73152" marR="73152" marT="27432" marB="27432" anchor="ctr">
-                    <a:noFill/>
-                  </a:tcPr>
-                </a:tc>
-                <a:tc>
-                  <a:txBody>
-                    <a:bodyPr/>
-                    <a:lstStyle/>
-                    <a:p>
-                      <a:pPr algn="r"/>
-                      <a:r>
-                        <a:rPr sz="1300" b="0">
-                          <a:solidFill>
-                            <a:srgbClr val="3C3C3B"/>
-                          </a:solidFill>
-                          <a:latin typeface="Aptos"/>
-                        </a:rPr>
-                        <a:t>–</a:t>
-                      </a:r>
-                    </a:p>
-                  </a:txBody>
-                  <a:tcPr marL="73152" marR="73152" marT="27432" marB="27432" anchor="ctr">
-                    <a:noFill/>
-                  </a:tcPr>
-                </a:tc>
-                <a:tc>
-                  <a:txBody>
-                    <a:bodyPr/>
-                    <a:lstStyle/>
-                    <a:p>
-                      <a:pPr algn="r"/>
-                      <a:r>
-                        <a:rPr sz="1300" b="0">
-                          <a:solidFill>
-                            <a:srgbClr val="3C3C3B"/>
-                          </a:solidFill>
-                          <a:latin typeface="Aptos"/>
-                        </a:rPr>
-                        <a:t>7.0</a:t>
-                      </a:r>
-                    </a:p>
-                  </a:txBody>
-                  <a:tcPr marL="73152" marR="73152" marT="27432" marB="27432" anchor="ctr">
-                    <a:noFill/>
-                  </a:tcPr>
-                </a:tc>
-              </a:tr>
-              <a:tr h="438912">
-                <a:tc>
-                  <a:txBody>
-                    <a:bodyPr/>
-                    <a:lstStyle/>
-                    <a:p>
-                      <a:pPr algn="l"/>
-                      <a:r>
-                        <a:rPr sz="1300" b="0">
-                          <a:solidFill>
-                            <a:srgbClr val="3C3C3B"/>
-                          </a:solidFill>
-                          <a:latin typeface="Aptos"/>
-                        </a:rPr>
-                        <a:t>Construction capex incl. connection fees, municipal and pre-COD lease</a:t>
-                      </a:r>
-                    </a:p>
-                  </a:txBody>
-                  <a:tcPr marL="73152" marR="73152" marT="27432" marB="27432" anchor="ctr">
-                    <a:solidFill>
-                      <a:srgbClr val="F2F2F2"/>
-                    </a:solidFill>
-                  </a:tcPr>
-                </a:tc>
-                <a:tc>
-                  <a:txBody>
-                    <a:bodyPr/>
-                    <a:lstStyle/>
-                    <a:p>
-                      <a:pPr algn="l"/>
-                      <a:r>
-                        <a:rPr sz="1300" b="0">
-                          <a:solidFill>
-                            <a:srgbClr val="919191"/>
-                          </a:solidFill>
-                          <a:latin typeface="Aptos"/>
-                        </a:rPr>
-                        <a:t>€ m</a:t>
-                      </a:r>
-                    </a:p>
-                  </a:txBody>
-                  <a:tcPr marL="73152" marR="73152" marT="27432" marB="27432" anchor="ctr">
-                    <a:solidFill>
-                      <a:srgbClr val="F2F2F2"/>
-                    </a:solidFill>
-                  </a:tcPr>
-                </a:tc>
-                <a:tc>
-                  <a:txBody>
-                    <a:bodyPr/>
-                    <a:lstStyle/>
-                    <a:p>
-                      <a:pPr algn="r"/>
-                      <a:r>
-                        <a:rPr sz="1300" b="0">
-                          <a:solidFill>
-                            <a:srgbClr val="3C3C3B"/>
-                          </a:solidFill>
-                          <a:latin typeface="Aptos"/>
-                        </a:rPr>
-                        <a:t>–</a:t>
-                      </a:r>
-                    </a:p>
-                  </a:txBody>
-                  <a:tcPr marL="73152" marR="73152" marT="27432" marB="27432" anchor="ctr">
-                    <a:noFill/>
-                  </a:tcPr>
-                </a:tc>
-                <a:tc>
-                  <a:txBody>
-                    <a:bodyPr/>
-                    <a:lstStyle/>
-                    <a:p>
-                      <a:pPr algn="r"/>
-                      <a:r>
-                        <a:rPr sz="1300" b="0">
-                          <a:solidFill>
-                            <a:srgbClr val="3C3C3B"/>
-                          </a:solidFill>
-                          <a:latin typeface="Aptos"/>
-                        </a:rPr>
-                        <a:t>150.9</a:t>
-                      </a:r>
-                    </a:p>
-                  </a:txBody>
-                  <a:tcPr marL="73152" marR="73152" marT="27432" marB="27432" anchor="ctr">
-                    <a:noFill/>
-                  </a:tcPr>
-                </a:tc>
-                <a:tc>
-                  <a:txBody>
-                    <a:bodyPr/>
-                    <a:lstStyle/>
-                    <a:p>
-                      <a:pPr algn="r"/>
-                      <a:r>
-                        <a:rPr sz="1300" b="0">
-                          <a:solidFill>
-                            <a:srgbClr val="3C3C3B"/>
-                          </a:solidFill>
-                          <a:latin typeface="Aptos"/>
-                        </a:rPr>
-                        <a:t>–</a:t>
-                      </a:r>
-                    </a:p>
-                  </a:txBody>
-                  <a:tcPr marL="73152" marR="73152" marT="27432" marB="27432" anchor="ctr">
-                    <a:noFill/>
-                  </a:tcPr>
-                </a:tc>
-                <a:tc>
-                  <a:txBody>
-                    <a:bodyPr/>
-                    <a:lstStyle/>
-                    <a:p>
-                      <a:pPr algn="r"/>
-                      <a:r>
-                        <a:rPr sz="1300" b="0">
-                          <a:solidFill>
-                            <a:srgbClr val="3C3C3B"/>
-                          </a:solidFill>
-                          <a:latin typeface="Aptos"/>
-                        </a:rPr>
-                        <a:t>301.8</a:t>
-                      </a:r>
-                    </a:p>
-                  </a:txBody>
-                  <a:tcPr marL="73152" marR="73152" marT="27432" marB="27432" anchor="ctr">
-                    <a:noFill/>
-                  </a:tcPr>
-                </a:tc>
-              </a:tr>
-              <a:tr h="438912">
-                <a:tc>
-                  <a:txBody>
-                    <a:bodyPr/>
-                    <a:lstStyle/>
-                    <a:p>
-                      <a:pPr algn="l"/>
-                      <a:r>
-                        <a:rPr sz="1300" b="0">
-                          <a:solidFill>
-                            <a:srgbClr val="3C3C3B"/>
-                          </a:solidFill>
-                          <a:latin typeface="Aptos"/>
-                        </a:rPr>
-                        <a:t>Financing: IDC, debt fees, guarantee fees</a:t>
-                      </a:r>
-                    </a:p>
-                  </a:txBody>
-                  <a:tcPr marL="73152" marR="73152" marT="27432" marB="27432" anchor="ctr">
-                    <a:solidFill>
-                      <a:srgbClr val="F2F2F2"/>
-                    </a:solidFill>
-                  </a:tcPr>
-                </a:tc>
-                <a:tc>
-                  <a:txBody>
-                    <a:bodyPr/>
-                    <a:lstStyle/>
-                    <a:p>
-                      <a:pPr algn="l"/>
-                      <a:r>
-                        <a:rPr sz="1300" b="0">
-                          <a:solidFill>
-                            <a:srgbClr val="919191"/>
-                          </a:solidFill>
-                          <a:latin typeface="Aptos"/>
-                        </a:rPr>
-                        <a:t>€ m</a:t>
-                      </a:r>
-                    </a:p>
-                  </a:txBody>
-                  <a:tcPr marL="73152" marR="73152" marT="27432" marB="27432" anchor="ctr">
-                    <a:solidFill>
-                      <a:srgbClr val="F2F2F2"/>
-                    </a:solidFill>
-                  </a:tcPr>
-                </a:tc>
-                <a:tc>
-                  <a:txBody>
-                    <a:bodyPr/>
-                    <a:lstStyle/>
-                    <a:p>
-                      <a:pPr algn="r"/>
-                      <a:r>
-                        <a:rPr sz="1300" b="0">
-                          <a:solidFill>
-                            <a:srgbClr val="3C3C3B"/>
-                          </a:solidFill>
-                          <a:latin typeface="Aptos"/>
-                        </a:rPr>
-                        <a:t>–</a:t>
-                      </a:r>
-                    </a:p>
-                  </a:txBody>
-                  <a:tcPr marL="73152" marR="73152" marT="27432" marB="27432" anchor="ctr">
-                    <a:noFill/>
-                  </a:tcPr>
-                </a:tc>
-                <a:tc>
-                  <a:txBody>
-                    <a:bodyPr/>
-                    <a:lstStyle/>
-                    <a:p>
-                      <a:pPr algn="r"/>
-                      <a:r>
-                        <a:rPr sz="1300" b="0">
-                          <a:solidFill>
-                            <a:srgbClr val="3C3C3B"/>
-                          </a:solidFill>
-                          <a:latin typeface="Aptos"/>
-                        </a:rPr>
-                        <a:t>8.5</a:t>
-                      </a:r>
-                    </a:p>
-                  </a:txBody>
-                  <a:tcPr marL="73152" marR="73152" marT="27432" marB="27432" anchor="ctr">
-                    <a:noFill/>
-                  </a:tcPr>
-                </a:tc>
-                <a:tc>
-                  <a:txBody>
-                    <a:bodyPr/>
-                    <a:lstStyle/>
-                    <a:p>
-                      <a:pPr algn="r"/>
-                      <a:r>
-                        <a:rPr sz="1300" b="0">
-                          <a:solidFill>
-                            <a:srgbClr val="3C3C3B"/>
-                          </a:solidFill>
-                          <a:latin typeface="Aptos"/>
-                        </a:rPr>
-                        <a:t>–</a:t>
-                      </a:r>
-                    </a:p>
-                  </a:txBody>
-                  <a:tcPr marL="73152" marR="73152" marT="27432" marB="27432" anchor="ctr">
-                    <a:noFill/>
-                  </a:tcPr>
-                </a:tc>
-                <a:tc>
-                  <a:txBody>
-                    <a:bodyPr/>
-                    <a:lstStyle/>
-                    <a:p>
-                      <a:pPr algn="r"/>
-                      <a:r>
-                        <a:rPr sz="1300" b="0">
-                          <a:solidFill>
-                            <a:srgbClr val="3C3C3B"/>
-                          </a:solidFill>
-                          <a:latin typeface="Aptos"/>
-                        </a:rPr>
-                        <a:t>17.1</a:t>
-                      </a:r>
-                    </a:p>
-                  </a:txBody>
-                  <a:tcPr marL="73152" marR="73152" marT="27432" marB="27432" anchor="ctr">
-                    <a:noFill/>
                   </a:tcPr>
                 </a:tc>
               </a:tr>
@@ -12130,7 +14899,7 @@
                 </a:solidFill>
                 <a:latin typeface="Aptos"/>
               </a:rPr>
-              <a:t>NPV at 8.0%. COD 30‑Sep‑2031, 100 MW built per bid; PPA 90 €/MWh; gearing 60.0%. HTM includes the buy-out of the developer at the RtB exit date. The four breakdown lines sum to the all-in commitment on slide 2.</a:t>
+              <a:t>NPV at 8.0%. COD 30‑Sep‑2031, 100 MW built per bid; PPA 90 €/MWh; gearing 60.0%. HTM includes the buy-out of the developer at the RtB exit date. Funding and capex to COD are on slide 5.</a:t>
             </a:r>
           </a:p>
           <a:p>
@@ -12154,7 +14923,7 @@
 </p:sld>
 </file>
 
-<file path=ppt/slides/slide6.xml><?xml version="1.0" encoding="utf-8"?>
+<file path=ppt/slides/slide7.xml><?xml version="1.0" encoding="utf-8"?>
 <p:sld xmlns:a="http://schemas.openxmlformats.org/drawingml/2006/main" xmlns:p="http://schemas.openxmlformats.org/presentationml/2006/main" xmlns:r="http://schemas.openxmlformats.org/officeDocument/2006/relationships">
   <p:cSld>
     <p:spTree>
@@ -12247,7 +15016,7 @@
         </p:nvGraphicFramePr>
         <p:xfrm>
           <a:off x="0" y="0"/>
-          <a:ext cx="3767328" cy="3886200"/>
+          <a:ext cx="3767328" cy="4663440"/>
         </p:xfrm>
         <a:graphic>
           <a:graphicData uri="http://schemas.openxmlformats.org/drawingml/2006/table">
@@ -12348,6 +15117,44 @@
                           <a:latin typeface="Aptos"/>
                         </a:rPr>
                         <a:t>Economics – RtB exit</a:t>
+                      </a:r>
+                    </a:p>
+                  </a:txBody>
+                  <a:tcPr marL="180000" anchor="ctr">
+                    <a:lnL>
+                      <a:noFill/>
+                    </a:lnL>
+                    <a:lnR>
+                      <a:noFill/>
+                    </a:lnR>
+                    <a:lnT w="6350">
+                      <a:solidFill>
+                        <a:srgbClr val="3C3C3B"/>
+                      </a:solidFill>
+                    </a:lnT>
+                    <a:lnB w="6350">
+                      <a:solidFill>
+                        <a:srgbClr val="3C3C3B"/>
+                      </a:solidFill>
+                    </a:lnB>
+                    <a:noFill/>
+                  </a:tcPr>
+                </a:tc>
+              </a:tr>
+              <a:tr h="777240">
+                <a:tc>
+                  <a:txBody>
+                    <a:bodyPr/>
+                    <a:lstStyle/>
+                    <a:p>
+                      <a:r>
+                        <a:rPr sz="1800" b="0">
+                          <a:solidFill>
+                            <a:srgbClr val="3C3C3B"/>
+                          </a:solidFill>
+                          <a:latin typeface="Aptos"/>
+                        </a:rPr>
+                        <a:t>Funding and capex</a:t>
                       </a:r>
                     </a:p>
                   </a:txBody>

</xml_diff>

<commit_message>
Set BESS capex to 100 k€/MWh on built MWh in the Bora and non-delivery models
Co-Authored-By: Claude Opus 5.5 <noreply@anthropic.com>
Claude-Session: https://claude.ai/code/session_011Cy4jTfjKbxPfMRQvaZwVT
</commit_message>
<xml_diff>
--- a/projects/bora_bidding/out/Bora_Bid_IC.pptx
+++ b/projects/bora_bidding/out/Bora_Bid_IC.pptx
@@ -6176,7 +6176,7 @@
                 </a:solidFill>
                 <a:latin typeface="Aptos"/>
               </a:rPr>
-              <a:t>Against the zero bid, the commitments cost €0.8m of RtB profit and 2.4 pp of HTM IRR per bid, and add €23.4m per bid to the all-in commitment.</a:t>
+              <a:t>Against the zero bid, the commitments cost €0.8m of RtB profit and 3.0 pp of HTM IRR per bid, and add €31.9m per bid to the all-in commitment.</a:t>
             </a:r>
           </a:p>
         </p:txBody>
@@ -6737,7 +6737,7 @@
                           </a:solidFill>
                           <a:latin typeface="Aptos"/>
                         </a:rPr>
-                        <a:t>37.8%</a:t>
+                        <a:t>33.9%</a:t>
                       </a:r>
                     </a:p>
                   </a:txBody>
@@ -6848,7 +6848,7 @@
                           </a:solidFill>
                           <a:latin typeface="Aptos"/>
                         </a:rPr>
-                        <a:t>9.5%</a:t>
+                        <a:t>8.9%</a:t>
                       </a:r>
                     </a:p>
                   </a:txBody>
@@ -6961,7 +6961,7 @@
                           </a:solidFill>
                           <a:latin typeface="Aptos"/>
                         </a:rPr>
-                        <a:t>171.2</a:t>
+                        <a:t>179.7</a:t>
                       </a:r>
                     </a:p>
                   </a:txBody>
@@ -6984,7 +6984,7 @@
                           </a:solidFill>
                           <a:latin typeface="Aptos"/>
                         </a:rPr>
-                        <a:t>342.4</a:t>
+                        <a:t>359.5</a:t>
                       </a:r>
                     </a:p>
                   </a:txBody>
@@ -7211,7 +7211,7 @@
           <a:lstStyle/>
           <a:p>
             <a:r>
-              <a:t>Municipal buys 20 points for 0.4 pp of HTM IRR; BESS (1.2 pp) and community (0.6 pp) carry the return cost</a:t>
+              <a:t>Municipal buys 20 points for 0.4 pp of HTM IRR; BESS (1.9 pp) and community (0.6 pp) carry the return cost</a:t>
             </a:r>
           </a:p>
         </p:txBody>
@@ -8390,28 +8390,28 @@
                           </a:solidFill>
                           <a:latin typeface="Aptos"/>
                         </a:rPr>
-                        <a:t>−6.5</a:t>
-                      </a:r>
-                    </a:p>
-                  </a:txBody>
-                  <a:tcPr marL="73152" marR="73152" marT="27432" marB="27432" anchor="ctr">
-                    <a:noFill/>
-                  </a:tcPr>
-                </a:tc>
-                <a:tc>
-                  <a:txBody>
-                    <a:bodyPr/>
-                    <a:lstStyle/>
-                    <a:p>
-                      <a:pPr algn="r"/>
-                      <a:r>
-                        <a:rPr sz="1300" b="0">
-                          <a:solidFill>
-                            <a:srgbClr val="3C3C3B"/>
-                          </a:solidFill>
-                          <a:latin typeface="Aptos"/>
-                        </a:rPr>
-                        <a:t>−1.2</a:t>
+                        <a:t>−10.2</a:t>
+                      </a:r>
+                    </a:p>
+                  </a:txBody>
+                  <a:tcPr marL="73152" marR="73152" marT="27432" marB="27432" anchor="ctr">
+                    <a:noFill/>
+                  </a:tcPr>
+                </a:tc>
+                <a:tc>
+                  <a:txBody>
+                    <a:bodyPr/>
+                    <a:lstStyle/>
+                    <a:p>
+                      <a:pPr algn="r"/>
+                      <a:r>
+                        <a:rPr sz="1300" b="0">
+                          <a:solidFill>
+                            <a:srgbClr val="3C3C3B"/>
+                          </a:solidFill>
+                          <a:latin typeface="Aptos"/>
+                        </a:rPr>
+                        <a:t>−1.9</a:t>
                       </a:r>
                     </a:p>
                   </a:txBody>
@@ -8903,7 +8903,7 @@
                           </a:solidFill>
                           <a:latin typeface="Aptos"/>
                         </a:rPr>
-                        <a:t>−11.7</a:t>
+                        <a:t>−15.6</a:t>
                       </a:r>
                     </a:p>
                   </a:txBody>
@@ -8926,7 +8926,7 @@
                           </a:solidFill>
                           <a:latin typeface="Aptos"/>
                         </a:rPr>
-                        <a:t>−2.4</a:t>
+                        <a:t>−3.0</a:t>
                       </a:r>
                     </a:p>
                   </a:txBody>
@@ -10568,7 +10568,7 @@
           <a:lstStyle/>
           <a:p>
             <a:r>
-              <a:t>Both bids need €140.0m of cash equity to COD and up to €14.0m of guarantees; all-in cost is 1,642 k€ per built MW</a:t>
+              <a:t>Both bids need €146.8m of cash equity to COD and up to €14.0m of guarantees; all-in cost is 1,727 k€ per built MW</a:t>
             </a:r>
           </a:p>
         </p:txBody>
@@ -10912,7 +10912,7 @@
                 </a:solidFill>
                 <a:latin typeface="Aptos"/>
               </a:rPr>
-              <a:t>€49.9m of the cash is spent by the RtB exit on 31‑Dec‑2029; on the build route, construction equity of €71.1m follows from NTP to COD.</a:t>
+              <a:t>€49.9m of the cash is spent by the RtB exit on 31‑Dec‑2029; on the build route, construction equity of €77.6m follows from NTP to COD.</a:t>
             </a:r>
           </a:p>
         </p:txBody>
@@ -12098,7 +12098,7 @@
                           </a:solidFill>
                           <a:latin typeface="Aptos"/>
                         </a:rPr>
-                        <a:t>71.1</a:t>
+                        <a:t>77.6</a:t>
                       </a:r>
                     </a:p>
                   </a:txBody>
@@ -12140,7 +12140,7 @@
                           </a:solidFill>
                           <a:latin typeface="Aptos"/>
                         </a:rPr>
-                        <a:t>121.0</a:t>
+                        <a:t>127.5</a:t>
                       </a:r>
                     </a:p>
                   </a:txBody>
@@ -12207,7 +12207,7 @@
                           </a:solidFill>
                           <a:latin typeface="Aptos"/>
                         </a:rPr>
-                        <a:t>5.0</a:t>
+                        <a:t>5.3</a:t>
                       </a:r>
                     </a:p>
                   </a:txBody>
@@ -12249,7 +12249,7 @@
                           </a:solidFill>
                           <a:latin typeface="Aptos"/>
                         </a:rPr>
-                        <a:t>126.0</a:t>
+                        <a:t>132.8</a:t>
                       </a:r>
                     </a:p>
                   </a:txBody>
@@ -12358,7 +12358,7 @@
                           </a:solidFill>
                           <a:latin typeface="Aptos"/>
                         </a:rPr>
-                        <a:t>130.0</a:t>
+                        <a:t>136.8</a:t>
                       </a:r>
                     </a:p>
                   </a:txBody>
@@ -12467,7 +12467,7 @@
                           </a:solidFill>
                           <a:latin typeface="Aptos"/>
                         </a:rPr>
-                        <a:t>140.0</a:t>
+                        <a:t>146.8</a:t>
                       </a:r>
                     </a:p>
                   </a:txBody>
@@ -12527,7 +12527,7 @@
                           </a:solidFill>
                           <a:latin typeface="Aptos"/>
                         </a:rPr>
-                        <a:t>140.0</a:t>
+                        <a:t>146.8</a:t>
                       </a:r>
                     </a:p>
                   </a:txBody>
@@ -13255,28 +13255,28 @@
                           </a:solidFill>
                           <a:latin typeface="Aptos"/>
                         </a:rPr>
-                        <a:t>24.5</a:t>
-                      </a:r>
-                    </a:p>
-                  </a:txBody>
-                  <a:tcPr marL="73152" marR="73152" marT="27432" marB="27432" anchor="ctr">
-                    <a:noFill/>
-                  </a:tcPr>
-                </a:tc>
-                <a:tc>
-                  <a:txBody>
-                    <a:bodyPr/>
-                    <a:lstStyle/>
-                    <a:p>
-                      <a:pPr algn="r"/>
-                      <a:r>
-                        <a:rPr sz="1300" b="0">
-                          <a:solidFill>
-                            <a:srgbClr val="3C3C3B"/>
-                          </a:solidFill>
-                          <a:latin typeface="Aptos"/>
-                        </a:rPr>
-                        <a:t>122</a:t>
+                        <a:t>40.8</a:t>
+                      </a:r>
+                    </a:p>
+                  </a:txBody>
+                  <a:tcPr marL="73152" marR="73152" marT="27432" marB="27432" anchor="ctr">
+                    <a:noFill/>
+                  </a:tcPr>
+                </a:tc>
+                <a:tc>
+                  <a:txBody>
+                    <a:bodyPr/>
+                    <a:lstStyle/>
+                    <a:p>
+                      <a:pPr algn="r"/>
+                      <a:r>
+                        <a:rPr sz="1300" b="0">
+                          <a:solidFill>
+                            <a:srgbClr val="3C3C3B"/>
+                          </a:solidFill>
+                          <a:latin typeface="Aptos"/>
+                        </a:rPr>
+                        <a:t>204</a:t>
                       </a:r>
                     </a:p>
                   </a:txBody>
@@ -13523,28 +13523,28 @@
                           </a:solidFill>
                           <a:latin typeface="Aptos"/>
                         </a:rPr>
-                        <a:t>17.1</a:t>
-                      </a:r>
-                    </a:p>
-                  </a:txBody>
-                  <a:tcPr marL="73152" marR="73152" marT="27432" marB="27432" anchor="ctr">
-                    <a:noFill/>
-                  </a:tcPr>
-                </a:tc>
-                <a:tc>
-                  <a:txBody>
-                    <a:bodyPr/>
-                    <a:lstStyle/>
-                    <a:p>
-                      <a:pPr algn="r"/>
-                      <a:r>
-                        <a:rPr sz="1300" b="0">
-                          <a:solidFill>
-                            <a:srgbClr val="3C3C3B"/>
-                          </a:solidFill>
-                          <a:latin typeface="Aptos"/>
-                        </a:rPr>
-                        <a:t>85</a:t>
+                        <a:t>17.8</a:t>
+                      </a:r>
+                    </a:p>
+                  </a:txBody>
+                  <a:tcPr marL="73152" marR="73152" marT="27432" marB="27432" anchor="ctr">
+                    <a:noFill/>
+                  </a:tcPr>
+                </a:tc>
+                <a:tc>
+                  <a:txBody>
+                    <a:bodyPr/>
+                    <a:lstStyle/>
+                    <a:p>
+                      <a:pPr algn="r"/>
+                      <a:r>
+                        <a:rPr sz="1300" b="0">
+                          <a:solidFill>
+                            <a:srgbClr val="3C3C3B"/>
+                          </a:solidFill>
+                          <a:latin typeface="Aptos"/>
+                        </a:rPr>
+                        <a:t>89</a:t>
                       </a:r>
                     </a:p>
                   </a:txBody>
@@ -13590,7 +13590,7 @@
                           </a:solidFill>
                           <a:latin typeface="Aptos"/>
                         </a:rPr>
-                        <a:t>328.4</a:t>
+                        <a:t>345.5</a:t>
                       </a:r>
                     </a:p>
                   </a:txBody>
@@ -13613,7 +13613,7 @@
                           </a:solidFill>
                           <a:latin typeface="Aptos"/>
                         </a:rPr>
-                        <a:t>1,642</a:t>
+                        <a:t>1,727</a:t>
                       </a:r>
                     </a:p>
                   </a:txBody>
@@ -13712,7 +13712,7 @@
           <a:lstStyle/>
           <a:p>
             <a:r>
-              <a:t>Both bids clear the 8.0% discount rate: HTM IRR 9.5% and NPV €26.7m for both bids; a sale at COD returns 37.8%</a:t>
+              <a:t>Both bids clear the 8.0% discount rate: HTM IRR 8.9% and NPV €16.3m for both bids; a sale at COD returns 33.9%</a:t>
             </a:r>
           </a:p>
         </p:txBody>
@@ -14056,7 +14056,7 @@
                 </a:solidFill>
                 <a:latin typeface="Aptos"/>
               </a:rPr>
-              <a:t>Against the zero bid, the commitments reduce FEP's NPV by €13.9m on a sale at COD and €18.1m held to maturity, per bid.</a:t>
+              <a:t>Against the zero bid, the commitments reduce FEP's NPV by €18.1m on a sale at COD and €23.3m held to maturity, per bid.</a:t>
             </a:r>
           </a:p>
         </p:txBody>
@@ -14308,28 +14308,28 @@
                           </a:solidFill>
                           <a:latin typeface="Aptos"/>
                         </a:rPr>
-                        <a:t>37.8%</a:t>
-                      </a:r>
-                    </a:p>
-                  </a:txBody>
-                  <a:tcPr marL="73152" marR="73152" marT="27432" marB="27432" anchor="ctr">
-                    <a:noFill/>
-                  </a:tcPr>
-                </a:tc>
-                <a:tc>
-                  <a:txBody>
-                    <a:bodyPr/>
-                    <a:lstStyle/>
-                    <a:p>
-                      <a:pPr algn="r"/>
-                      <a:r>
-                        <a:rPr sz="1300" b="0">
-                          <a:solidFill>
-                            <a:srgbClr val="3C3C3B"/>
-                          </a:solidFill>
-                          <a:latin typeface="Aptos"/>
-                        </a:rPr>
-                        <a:t>−11.7</a:t>
+                        <a:t>33.9%</a:t>
+                      </a:r>
+                    </a:p>
+                  </a:txBody>
+                  <a:tcPr marL="73152" marR="73152" marT="27432" marB="27432" anchor="ctr">
+                    <a:noFill/>
+                  </a:tcPr>
+                </a:tc>
+                <a:tc>
+                  <a:txBody>
+                    <a:bodyPr/>
+                    <a:lstStyle/>
+                    <a:p>
+                      <a:pPr algn="r"/>
+                      <a:r>
+                        <a:rPr sz="1300" b="0">
+                          <a:solidFill>
+                            <a:srgbClr val="3C3C3B"/>
+                          </a:solidFill>
+                          <a:latin typeface="Aptos"/>
+                        </a:rPr>
+                        <a:t>−15.6</a:t>
                       </a:r>
                     </a:p>
                   </a:txBody>
@@ -14440,49 +14440,49 @@
                           </a:solidFill>
                           <a:latin typeface="Aptos"/>
                         </a:rPr>
-                        <a:t>30.8</a:t>
-                      </a:r>
-                    </a:p>
-                  </a:txBody>
-                  <a:tcPr marL="73152" marR="73152" marT="27432" marB="27432" anchor="ctr">
-                    <a:noFill/>
-                  </a:tcPr>
-                </a:tc>
-                <a:tc>
-                  <a:txBody>
-                    <a:bodyPr/>
-                    <a:lstStyle/>
-                    <a:p>
-                      <a:pPr algn="r"/>
-                      <a:r>
-                        <a:rPr sz="1300" b="0">
-                          <a:solidFill>
-                            <a:srgbClr val="3C3C3B"/>
-                          </a:solidFill>
-                          <a:latin typeface="Aptos"/>
-                        </a:rPr>
-                        <a:t>(13.9)</a:t>
-                      </a:r>
-                    </a:p>
-                  </a:txBody>
-                  <a:tcPr marL="73152" marR="73152" marT="27432" marB="27432" anchor="ctr">
-                    <a:noFill/>
-                  </a:tcPr>
-                </a:tc>
-                <a:tc>
-                  <a:txBody>
-                    <a:bodyPr/>
-                    <a:lstStyle/>
-                    <a:p>
-                      <a:pPr algn="r"/>
-                      <a:r>
-                        <a:rPr sz="1300" b="0">
-                          <a:solidFill>
-                            <a:srgbClr val="3C3C3B"/>
-                          </a:solidFill>
-                          <a:latin typeface="Aptos"/>
-                        </a:rPr>
-                        <a:t>61.5</a:t>
+                        <a:t>26.5</a:t>
+                      </a:r>
+                    </a:p>
+                  </a:txBody>
+                  <a:tcPr marL="73152" marR="73152" marT="27432" marB="27432" anchor="ctr">
+                    <a:noFill/>
+                  </a:tcPr>
+                </a:tc>
+                <a:tc>
+                  <a:txBody>
+                    <a:bodyPr/>
+                    <a:lstStyle/>
+                    <a:p>
+                      <a:pPr algn="r"/>
+                      <a:r>
+                        <a:rPr sz="1300" b="0">
+                          <a:solidFill>
+                            <a:srgbClr val="3C3C3B"/>
+                          </a:solidFill>
+                          <a:latin typeface="Aptos"/>
+                        </a:rPr>
+                        <a:t>(18.1)</a:t>
+                      </a:r>
+                    </a:p>
+                  </a:txBody>
+                  <a:tcPr marL="73152" marR="73152" marT="27432" marB="27432" anchor="ctr">
+                    <a:noFill/>
+                  </a:tcPr>
+                </a:tc>
+                <a:tc>
+                  <a:txBody>
+                    <a:bodyPr/>
+                    <a:lstStyle/>
+                    <a:p>
+                      <a:pPr algn="r"/>
+                      <a:r>
+                        <a:rPr sz="1300" b="0">
+                          <a:solidFill>
+                            <a:srgbClr val="3C3C3B"/>
+                          </a:solidFill>
+                          <a:latin typeface="Aptos"/>
+                        </a:rPr>
+                        <a:t>53.1</a:t>
                       </a:r>
                     </a:p>
                   </a:txBody>
@@ -14572,28 +14572,28 @@
                           </a:solidFill>
                           <a:latin typeface="Aptos"/>
                         </a:rPr>
-                        <a:t>9.5%</a:t>
-                      </a:r>
-                    </a:p>
-                  </a:txBody>
-                  <a:tcPr marL="73152" marR="73152" marT="27432" marB="27432" anchor="ctr">
-                    <a:noFill/>
-                  </a:tcPr>
-                </a:tc>
-                <a:tc>
-                  <a:txBody>
-                    <a:bodyPr/>
-                    <a:lstStyle/>
-                    <a:p>
-                      <a:pPr algn="r"/>
-                      <a:r>
-                        <a:rPr sz="1300" b="0">
-                          <a:solidFill>
-                            <a:srgbClr val="3C3C3B"/>
-                          </a:solidFill>
-                          <a:latin typeface="Aptos"/>
-                        </a:rPr>
-                        <a:t>−2.4</a:t>
+                        <a:t>8.9%</a:t>
+                      </a:r>
+                    </a:p>
+                  </a:txBody>
+                  <a:tcPr marL="73152" marR="73152" marT="27432" marB="27432" anchor="ctr">
+                    <a:noFill/>
+                  </a:tcPr>
+                </a:tc>
+                <a:tc>
+                  <a:txBody>
+                    <a:bodyPr/>
+                    <a:lstStyle/>
+                    <a:p>
+                      <a:pPr algn="r"/>
+                      <a:r>
+                        <a:rPr sz="1300" b="0">
+                          <a:solidFill>
+                            <a:srgbClr val="3C3C3B"/>
+                          </a:solidFill>
+                          <a:latin typeface="Aptos"/>
+                        </a:rPr>
+                        <a:t>−3.0</a:t>
                       </a:r>
                     </a:p>
                   </a:txBody>
@@ -14706,7 +14706,7 @@
                           </a:solidFill>
                           <a:latin typeface="Aptos"/>
                         </a:rPr>
-                        <a:t>13.4</a:t>
+                        <a:t>8.1</a:t>
                       </a:r>
                     </a:p>
                   </a:txBody>
@@ -14729,7 +14729,7 @@
                           </a:solidFill>
                           <a:latin typeface="Aptos"/>
                         </a:rPr>
-                        <a:t>(18.1)</a:t>
+                        <a:t>(23.3)</a:t>
                       </a:r>
                     </a:p>
                   </a:txBody>
@@ -14752,7 +14752,7 @@
                           </a:solidFill>
                           <a:latin typeface="Aptos"/>
                         </a:rPr>
-                        <a:t>26.7</a:t>
+                        <a:t>16.3</a:t>
                       </a:r>
                     </a:p>
                   </a:txBody>
@@ -14840,7 +14840,7 @@
                 </a:solidFill>
                 <a:latin typeface="Aptos"/>
               </a:rPr>
-              <a:t>FEP proceeds of €124.4m on a €245.0m price, a 1.78x MOIC.</a:t>
+              <a:t>FEP proceeds of €121.9m on a €245.0m price, a 1.66x MOIC.</a:t>
             </a:r>
           </a:p>
           <a:p>
@@ -14865,7 +14865,7 @@
                 </a:solidFill>
                 <a:latin typeface="Aptos"/>
               </a:rPr>
-              <a:t>4.89x MOIC; minimum DSCR 1.33x.</a:t>
+              <a:t>4.60x MOIC; minimum DSCR 1.26x.</a:t>
             </a:r>
           </a:p>
         </p:txBody>
@@ -15501,7 +15501,7 @@
                           </a:solidFill>
                           <a:latin typeface="Aptos"/>
                         </a:rPr>
-                        <a:t>The whole PB: COD IRR 35.8%, HTM IRR 9.1%.</a:t>
+                        <a:t>The whole PB: COD IRR 31.8%, HTM IRR 8.5%.</a:t>
                       </a:r>
                     </a:p>
                   </a:txBody>
@@ -15876,7 +15876,7 @@
                 </a:solidFill>
                 <a:latin typeface="Aptos"/>
               </a:rPr>
-              <a:t>The grid connection stays at 100 MVA. Building the overbuild lifts the all-in cost to COD from €164.2m to €217.9m per bid. In that case COD IRR is 54.4% and HTM IRR is 11.5%. The build decision passes to the buyer at RtB.</a:t>
+              <a:t>The grid connection stays at 100 MVA. Building the overbuild lifts the all-in cost to COD from €172.7m to €226.4m per bid. In that case COD IRR is 51.4% and HTM IRR is 10.9%. The build decision passes to the buyer at RtB.</a:t>
             </a:r>
           </a:p>
         </p:txBody>

</xml_diff>

<commit_message>
Add the Nothing delivered slide to the Bora IC deck
Co-Authored-By: Claude Opus 5.5 <noreply@anthropic.com>
Claude-Session: https://claude.ai/code/session_011Cy4jTfjKbxPfMRQvaZwVT
</commit_message>
<xml_diff>
--- a/projects/bora_bidding/out/Bora_Bid_IC.pptx
+++ b/projects/bora_bidding/out/Bora_Bid_IC.pptx
@@ -19,6 +19,7 @@
     <p:sldId id="261" r:id="rId9"/>
     <p:sldId id="262" r:id="rId8"/>
     <p:sldId id="263" r:id="rId7"/>
+    <p:sldId id="264" r:id="rId21"/>
   </p:sldIdLst>
   <p:sldSz cx="20105688" cy="11310938"/>
   <p:notesSz cx="6858000" cy="9144000"/>
@@ -14954,6 +14955,1416 @@
           <a:lstStyle/>
           <a:p>
             <a:r>
+              <a:t>Delivering nothing after award costs the full PB of €7.0m per bid but lifts HTM IRR from 8.9% to 12.1%</a:t>
+            </a:r>
+          </a:p>
+        </p:txBody>
+      </p:sp>
+      <p:sp>
+        <p:nvSpPr>
+          <p:cNvPr id="2" name="Slide Number Placeholder 1">
+            <a:extLst>
+              <a:ext uri="{FF2B5EF4-FFF2-40B4-BE49-F238E27FC236}">
+                <a16:creationId xmlns:a16="http://schemas.microsoft.com/office/drawing/2014/main" id="{88576B7A-1C0F-D2A3-8BE9-18F63D64C454}"/>
+              </a:ext>
+            </a:extLst>
+          </p:cNvPr>
+          <p:cNvSpPr>
+            <a:spLocks noGrp="1"/>
+          </p:cNvSpPr>
+          <p:nvPr>
+            <p:ph type="sldNum" sz="quarter" idx="4"/>
+          </p:nvPr>
+        </p:nvSpPr>
+        <p:spPr>
+          <a:xfrm>
+            <a:off x="14200188" y="10483850"/>
+            <a:ext cx="4522787" cy="601663"/>
+          </a:xfrm>
+          <a:prstGeom prst="rect">
+            <a:avLst/>
+          </a:prstGeom>
+        </p:spPr>
+        <p:txBody>
+          <a:bodyPr vert="horz" lIns="91440" tIns="45720" rIns="91440" bIns="45720" rtlCol="0" anchor="ctr"/>
+          <a:lstStyle>
+            <a:lvl1pPr algn="r">
+              <a:defRPr sz="1200">
+                <a:solidFill>
+                  <a:schemeClr val="tx1">
+                    <a:tint val="82000"/>
+                  </a:schemeClr>
+                </a:solidFill>
+              </a:defRPr>
+            </a:lvl1pPr>
+          </a:lstStyle>
+          <a:p>
+            <a:fld id="{52EEA166-2877-4493-9FAA-8D6952A82FC3}" type="slidenum">
+              <a:rPr lang="en-GB" smtClean="0"/>
+              <a:t>‹#›</a:t>
+            </a:fld>
+            <a:endParaRPr lang="en-GB"/>
+          </a:p>
+        </p:txBody>
+      </p:sp>
+      <p:graphicFrame>
+        <p:nvGraphicFramePr>
+          <p:cNvPr id="3" name="Navigator"/>
+          <p:cNvGraphicFramePr>
+            <a:graphicFrameLocks noGrp="1"/>
+          </p:cNvGraphicFramePr>
+          <p:nvPr/>
+        </p:nvGraphicFramePr>
+        <p:xfrm>
+          <a:off x="0" y="0"/>
+          <a:ext cx="3767328" cy="4663440"/>
+        </p:xfrm>
+        <a:graphic>
+          <a:graphicData uri="http://schemas.openxmlformats.org/drawingml/2006/table">
+            <a:tbl>
+              <a:tblPr>
+                <a:tableStyleId>{5C22544A-7EE6-4342-B048-85BDC9FD1C3A}</a:tableStyleId>
+              </a:tblPr>
+              <a:tblGrid>
+                <a:gridCol w="3767328"/>
+              </a:tblGrid>
+              <a:tr h="777240">
+                <a:tc>
+                  <a:txBody>
+                    <a:bodyPr/>
+                    <a:lstStyle/>
+                    <a:p>
+                      <a:r>
+                        <a:rPr sz="1800" b="0">
+                          <a:solidFill>
+                            <a:srgbClr val="3C3C3B"/>
+                          </a:solidFill>
+                          <a:latin typeface="Aptos"/>
+                        </a:rPr>
+                        <a:t>Executive summary</a:t>
+                      </a:r>
+                    </a:p>
+                  </a:txBody>
+                  <a:tcPr marL="180000" anchor="ctr">
+                    <a:lnL>
+                      <a:noFill/>
+                    </a:lnL>
+                    <a:lnR>
+                      <a:noFill/>
+                    </a:lnR>
+                    <a:lnT w="6350">
+                      <a:solidFill>
+                        <a:srgbClr val="3C3C3B"/>
+                      </a:solidFill>
+                    </a:lnT>
+                    <a:lnB w="6350">
+                      <a:solidFill>
+                        <a:srgbClr val="3C3C3B"/>
+                      </a:solidFill>
+                    </a:lnB>
+                    <a:noFill/>
+                  </a:tcPr>
+                </a:tc>
+              </a:tr>
+              <a:tr h="777240">
+                <a:tc>
+                  <a:txBody>
+                    <a:bodyPr/>
+                    <a:lstStyle/>
+                    <a:p>
+                      <a:r>
+                        <a:rPr sz="1800" b="0">
+                          <a:solidFill>
+                            <a:srgbClr val="3C3C3B"/>
+                          </a:solidFill>
+                          <a:latin typeface="Aptos"/>
+                        </a:rPr>
+                        <a:t>Commitments</a:t>
+                      </a:r>
+                    </a:p>
+                  </a:txBody>
+                  <a:tcPr marL="180000" anchor="ctr">
+                    <a:lnL>
+                      <a:noFill/>
+                    </a:lnL>
+                    <a:lnR>
+                      <a:noFill/>
+                    </a:lnR>
+                    <a:lnT w="6350">
+                      <a:solidFill>
+                        <a:srgbClr val="3C3C3B"/>
+                      </a:solidFill>
+                    </a:lnT>
+                    <a:lnB w="6350">
+                      <a:solidFill>
+                        <a:srgbClr val="3C3C3B"/>
+                      </a:solidFill>
+                    </a:lnB>
+                    <a:noFill/>
+                  </a:tcPr>
+                </a:tc>
+              </a:tr>
+              <a:tr h="777240">
+                <a:tc>
+                  <a:txBody>
+                    <a:bodyPr/>
+                    <a:lstStyle/>
+                    <a:p>
+                      <a:r>
+                        <a:rPr sz="1800" b="0">
+                          <a:solidFill>
+                            <a:srgbClr val="3C3C3B"/>
+                          </a:solidFill>
+                          <a:latin typeface="Aptos"/>
+                        </a:rPr>
+                        <a:t>Economics – RtB exit</a:t>
+                      </a:r>
+                    </a:p>
+                  </a:txBody>
+                  <a:tcPr marL="180000" anchor="ctr">
+                    <a:lnL>
+                      <a:noFill/>
+                    </a:lnL>
+                    <a:lnR>
+                      <a:noFill/>
+                    </a:lnR>
+                    <a:lnT w="6350">
+                      <a:solidFill>
+                        <a:srgbClr val="3C3C3B"/>
+                      </a:solidFill>
+                    </a:lnT>
+                    <a:lnB w="6350">
+                      <a:solidFill>
+                        <a:srgbClr val="3C3C3B"/>
+                      </a:solidFill>
+                    </a:lnB>
+                    <a:noFill/>
+                  </a:tcPr>
+                </a:tc>
+              </a:tr>
+              <a:tr h="777240">
+                <a:tc>
+                  <a:txBody>
+                    <a:bodyPr/>
+                    <a:lstStyle/>
+                    <a:p>
+                      <a:r>
+                        <a:rPr sz="1800" b="0">
+                          <a:solidFill>
+                            <a:srgbClr val="3C3C3B"/>
+                          </a:solidFill>
+                          <a:latin typeface="Aptos"/>
+                        </a:rPr>
+                        <a:t>Funding and capex</a:t>
+                      </a:r>
+                    </a:p>
+                  </a:txBody>
+                  <a:tcPr marL="180000" anchor="ctr">
+                    <a:lnL>
+                      <a:noFill/>
+                    </a:lnL>
+                    <a:lnR>
+                      <a:noFill/>
+                    </a:lnR>
+                    <a:lnT w="6350">
+                      <a:solidFill>
+                        <a:srgbClr val="3C3C3B"/>
+                      </a:solidFill>
+                    </a:lnT>
+                    <a:lnB w="6350">
+                      <a:solidFill>
+                        <a:srgbClr val="3C3C3B"/>
+                      </a:solidFill>
+                    </a:lnB>
+                    <a:noFill/>
+                  </a:tcPr>
+                </a:tc>
+              </a:tr>
+              <a:tr h="777240">
+                <a:tc>
+                  <a:txBody>
+                    <a:bodyPr/>
+                    <a:lstStyle/>
+                    <a:p>
+                      <a:r>
+                        <a:rPr sz="1800" b="0">
+                          <a:solidFill>
+                            <a:srgbClr val="3C3C3B"/>
+                          </a:solidFill>
+                          <a:latin typeface="Aptos"/>
+                        </a:rPr>
+                        <a:t>Economics – COD and HTM</a:t>
+                      </a:r>
+                    </a:p>
+                  </a:txBody>
+                  <a:tcPr marL="180000" anchor="ctr">
+                    <a:lnL>
+                      <a:noFill/>
+                    </a:lnL>
+                    <a:lnR>
+                      <a:noFill/>
+                    </a:lnR>
+                    <a:lnT w="6350">
+                      <a:solidFill>
+                        <a:srgbClr val="3C3C3B"/>
+                      </a:solidFill>
+                    </a:lnT>
+                    <a:lnB w="6350">
+                      <a:solidFill>
+                        <a:srgbClr val="3C3C3B"/>
+                      </a:solidFill>
+                    </a:lnB>
+                    <a:noFill/>
+                  </a:tcPr>
+                </a:tc>
+              </a:tr>
+              <a:tr h="777240">
+                <a:tc>
+                  <a:txBody>
+                    <a:bodyPr/>
+                    <a:lstStyle/>
+                    <a:p>
+                      <a:r>
+                        <a:rPr sz="1800" b="1">
+                          <a:solidFill>
+                            <a:srgbClr val="FFFFFF"/>
+                          </a:solidFill>
+                          <a:latin typeface="Aptos"/>
+                        </a:rPr>
+                        <a:t>Risks and mitigants</a:t>
+                      </a:r>
+                    </a:p>
+                  </a:txBody>
+                  <a:tcPr marL="180000" anchor="ctr">
+                    <a:lnL>
+                      <a:noFill/>
+                    </a:lnL>
+                    <a:lnR>
+                      <a:noFill/>
+                    </a:lnR>
+                    <a:lnT w="6350">
+                      <a:solidFill>
+                        <a:srgbClr val="3C3C3B"/>
+                      </a:solidFill>
+                    </a:lnT>
+                    <a:lnB w="6350">
+                      <a:solidFill>
+                        <a:srgbClr val="3C3C3B"/>
+                      </a:solidFill>
+                    </a:lnB>
+                    <a:gradFill rotWithShape="1">
+                      <a:gsLst>
+                        <a:gs pos="0">
+                          <a:srgbClr val="00A651"/>
+                        </a:gs>
+                        <a:gs pos="100000">
+                          <a:srgbClr val="00563C"/>
+                        </a:gs>
+                      </a:gsLst>
+                      <a:lin scaled="0" ang="0"/>
+                    </a:gradFill>
+                  </a:tcPr>
+                </a:tc>
+              </a:tr>
+            </a:tbl>
+          </a:graphicData>
+        </a:graphic>
+      </p:graphicFrame>
+      <p:sp>
+        <p:nvSpPr>
+          <p:cNvPr id="4" name="Subtitle"/>
+          <p:cNvSpPr txBox="1"/>
+          <p:nvPr/>
+        </p:nvSpPr>
+        <p:spPr>
+          <a:xfrm>
+            <a:off x="4498848" y="1371600"/>
+            <a:ext cx="13716000" cy="685800"/>
+          </a:xfrm>
+          <a:prstGeom prst="rect">
+            <a:avLst/>
+          </a:prstGeom>
+          <a:noFill/>
+        </p:spPr>
+        <p:txBody>
+          <a:bodyPr wrap="square">
+            <a:spAutoFit/>
+          </a:bodyPr>
+          <a:lstStyle/>
+          <a:p>
+            <a:r>
+              <a:rPr sz="1800" b="1">
+                <a:solidFill>
+                  <a:srgbClr val="3C3C3B"/>
+                </a:solidFill>
+                <a:latin typeface="Aptos"/>
+              </a:rPr>
+              <a:t>The BESS, municipal, community and EU-equipment costs fall away (€38.8m less to COD per bid); the price is €14.0m of PB called on both bids and a possible group exclusion.</a:t>
+            </a:r>
+          </a:p>
+        </p:txBody>
+      </p:sp>
+      <p:graphicFrame>
+        <p:nvGraphicFramePr>
+          <p:cNvPr id="5" name="Table"/>
+          <p:cNvGraphicFramePr>
+            <a:graphicFrameLocks noGrp="1"/>
+          </p:cNvGraphicFramePr>
+          <p:nvPr/>
+        </p:nvGraphicFramePr>
+        <p:xfrm>
+          <a:off x="4498848" y="2240280"/>
+          <a:ext cx="9125712" cy="3282696"/>
+        </p:xfrm>
+        <a:graphic>
+          <a:graphicData uri="http://schemas.openxmlformats.org/drawingml/2006/table">
+            <a:tbl>
+              <a:tblPr>
+                <a:tableStyleId>{5C22544A-7EE6-4342-B048-85BDC9FD1C3A}</a:tableStyleId>
+              </a:tblPr>
+              <a:tblGrid>
+                <a:gridCol w="4096512"/>
+                <a:gridCol w="822960"/>
+                <a:gridCol w="1280160"/>
+                <a:gridCol w="1828800"/>
+                <a:gridCol w="1097280"/>
+              </a:tblGrid>
+              <a:tr h="539496">
+                <a:tc>
+                  <a:txBody>
+                    <a:bodyPr/>
+                    <a:lstStyle/>
+                    <a:p>
+                      <a:pPr algn="l"/>
+                      <a:r>
+                        <a:rPr sz="1300" b="1">
+                          <a:solidFill>
+                            <a:srgbClr val="FFFFFF"/>
+                          </a:solidFill>
+                          <a:latin typeface="Aptos"/>
+                        </a:rPr>
+                        <a:t>Per bid</a:t>
+                      </a:r>
+                    </a:p>
+                  </a:txBody>
+                  <a:tcPr marL="73152" marR="73152" marT="27432" marB="27432" anchor="ctr">
+                    <a:solidFill>
+                      <a:srgbClr val="00A651"/>
+                    </a:solidFill>
+                  </a:tcPr>
+                </a:tc>
+                <a:tc>
+                  <a:txBody>
+                    <a:bodyPr/>
+                    <a:lstStyle/>
+                    <a:p>
+                      <a:pPr algn="l"/>
+                      <a:r>
+                        <a:rPr sz="1300" b="1">
+                          <a:solidFill>
+                            <a:srgbClr val="FFFFFF"/>
+                          </a:solidFill>
+                          <a:latin typeface="Aptos"/>
+                        </a:rPr>
+                        <a:t>Unit</a:t>
+                      </a:r>
+                    </a:p>
+                  </a:txBody>
+                  <a:tcPr marL="73152" marR="73152" marT="27432" marB="27432" anchor="ctr">
+                    <a:solidFill>
+                      <a:srgbClr val="00A651"/>
+                    </a:solidFill>
+                  </a:tcPr>
+                </a:tc>
+                <a:tc>
+                  <a:txBody>
+                    <a:bodyPr/>
+                    <a:lstStyle/>
+                    <a:p>
+                      <a:pPr algn="r"/>
+                      <a:r>
+                        <a:rPr sz="1300" b="1">
+                          <a:solidFill>
+                            <a:srgbClr val="FFFFFF"/>
+                          </a:solidFill>
+                          <a:latin typeface="Aptos"/>
+                        </a:rPr>
+                        <a:t>Base</a:t>
+                      </a:r>
+                    </a:p>
+                  </a:txBody>
+                  <a:tcPr marL="73152" marR="73152" marT="27432" marB="27432" anchor="ctr">
+                    <a:solidFill>
+                      <a:srgbClr val="00A651"/>
+                    </a:solidFill>
+                  </a:tcPr>
+                </a:tc>
+                <a:tc>
+                  <a:txBody>
+                    <a:bodyPr/>
+                    <a:lstStyle/>
+                    <a:p>
+                      <a:pPr algn="r"/>
+                      <a:r>
+                        <a:rPr sz="1300" b="1">
+                          <a:solidFill>
+                            <a:srgbClr val="FFFFFF"/>
+                          </a:solidFill>
+                          <a:latin typeface="Aptos"/>
+                        </a:rPr>
+                        <a:t>Nothing delivered</a:t>
+                      </a:r>
+                    </a:p>
+                  </a:txBody>
+                  <a:tcPr marL="73152" marR="73152" marT="27432" marB="27432" anchor="ctr">
+                    <a:solidFill>
+                      <a:srgbClr val="00A651"/>
+                    </a:solidFill>
+                  </a:tcPr>
+                </a:tc>
+                <a:tc>
+                  <a:txBody>
+                    <a:bodyPr/>
+                    <a:lstStyle/>
+                    <a:p>
+                      <a:pPr algn="r"/>
+                      <a:r>
+                        <a:rPr sz="1300" b="1">
+                          <a:solidFill>
+                            <a:srgbClr val="FFFFFF"/>
+                          </a:solidFill>
+                          <a:latin typeface="Aptos"/>
+                        </a:rPr>
+                        <a:t>Δ</a:t>
+                      </a:r>
+                    </a:p>
+                  </a:txBody>
+                  <a:tcPr marL="73152" marR="73152" marT="27432" marB="27432" anchor="ctr">
+                    <a:solidFill>
+                      <a:srgbClr val="00A651"/>
+                    </a:solidFill>
+                  </a:tcPr>
+                </a:tc>
+              </a:tr>
+              <a:tr h="457200">
+                <a:tc>
+                  <a:txBody>
+                    <a:bodyPr/>
+                    <a:lstStyle/>
+                    <a:p>
+                      <a:pPr algn="l"/>
+                      <a:r>
+                        <a:rPr sz="1300" b="0">
+                          <a:solidFill>
+                            <a:srgbClr val="3C3C3B"/>
+                          </a:solidFill>
+                          <a:latin typeface="Aptos"/>
+                        </a:rPr>
+                        <a:t>Points</a:t>
+                      </a:r>
+                    </a:p>
+                  </a:txBody>
+                  <a:tcPr marL="73152" marR="73152" marT="27432" marB="27432" anchor="ctr">
+                    <a:solidFill>
+                      <a:srgbClr val="F2F2F2"/>
+                    </a:solidFill>
+                  </a:tcPr>
+                </a:tc>
+                <a:tc>
+                  <a:txBody>
+                    <a:bodyPr/>
+                    <a:lstStyle/>
+                    <a:p>
+                      <a:pPr algn="l"/>
+                      <a:r>
+                        <a:rPr sz="1300" b="0">
+                          <a:solidFill>
+                            <a:srgbClr val="919191"/>
+                          </a:solidFill>
+                          <a:latin typeface="Aptos"/>
+                        </a:rPr>
+                        <a:t>points</a:t>
+                      </a:r>
+                    </a:p>
+                  </a:txBody>
+                  <a:tcPr marL="73152" marR="73152" marT="27432" marB="27432" anchor="ctr">
+                    <a:solidFill>
+                      <a:srgbClr val="F2F2F2"/>
+                    </a:solidFill>
+                  </a:tcPr>
+                </a:tc>
+                <a:tc>
+                  <a:txBody>
+                    <a:bodyPr/>
+                    <a:lstStyle/>
+                    <a:p>
+                      <a:pPr algn="r"/>
+                      <a:r>
+                        <a:rPr sz="1300" b="0">
+                          <a:solidFill>
+                            <a:srgbClr val="3C3C3B"/>
+                          </a:solidFill>
+                          <a:latin typeface="Aptos"/>
+                        </a:rPr>
+                        <a:t>85</a:t>
+                      </a:r>
+                    </a:p>
+                  </a:txBody>
+                  <a:tcPr marL="73152" marR="73152" marT="27432" marB="27432" anchor="ctr">
+                    <a:noFill/>
+                  </a:tcPr>
+                </a:tc>
+                <a:tc>
+                  <a:txBody>
+                    <a:bodyPr/>
+                    <a:lstStyle/>
+                    <a:p>
+                      <a:pPr algn="r"/>
+                      <a:r>
+                        <a:rPr sz="1300" b="0">
+                          <a:solidFill>
+                            <a:srgbClr val="3C3C3B"/>
+                          </a:solidFill>
+                          <a:latin typeface="Aptos"/>
+                        </a:rPr>
+                        <a:t>85</a:t>
+                      </a:r>
+                    </a:p>
+                  </a:txBody>
+                  <a:tcPr marL="73152" marR="73152" marT="27432" marB="27432" anchor="ctr">
+                    <a:noFill/>
+                  </a:tcPr>
+                </a:tc>
+                <a:tc>
+                  <a:txBody>
+                    <a:bodyPr/>
+                    <a:lstStyle/>
+                    <a:p>
+                      <a:pPr algn="r"/>
+                      <a:r>
+                        <a:rPr sz="1300" b="0">
+                          <a:solidFill>
+                            <a:srgbClr val="3C3C3B"/>
+                          </a:solidFill>
+                          <a:latin typeface="Aptos"/>
+                        </a:rPr>
+                        <a:t>0</a:t>
+                      </a:r>
+                    </a:p>
+                  </a:txBody>
+                  <a:tcPr marL="73152" marR="73152" marT="27432" marB="27432" anchor="ctr">
+                    <a:noFill/>
+                  </a:tcPr>
+                </a:tc>
+              </a:tr>
+              <a:tr h="457200">
+                <a:tc>
+                  <a:txBody>
+                    <a:bodyPr/>
+                    <a:lstStyle/>
+                    <a:p>
+                      <a:pPr algn="l"/>
+                      <a:r>
+                        <a:rPr sz="1300" b="1">
+                          <a:solidFill>
+                            <a:srgbClr val="3C3C3B"/>
+                          </a:solidFill>
+                          <a:latin typeface="Aptos"/>
+                        </a:rPr>
+                        <a:t>PB called (base: pro-rata loss)</a:t>
+                      </a:r>
+                    </a:p>
+                  </a:txBody>
+                  <a:tcPr marL="73152" marR="73152" marT="27432" marB="27432" anchor="ctr">
+                    <a:solidFill>
+                      <a:srgbClr val="F2F2F2"/>
+                    </a:solidFill>
+                  </a:tcPr>
+                </a:tc>
+                <a:tc>
+                  <a:txBody>
+                    <a:bodyPr/>
+                    <a:lstStyle/>
+                    <a:p>
+                      <a:pPr algn="l"/>
+                      <a:r>
+                        <a:rPr sz="1300" b="1">
+                          <a:solidFill>
+                            <a:srgbClr val="919191"/>
+                          </a:solidFill>
+                          <a:latin typeface="Aptos"/>
+                        </a:rPr>
+                        <a:t>€ m</a:t>
+                      </a:r>
+                    </a:p>
+                  </a:txBody>
+                  <a:tcPr marL="73152" marR="73152" marT="27432" marB="27432" anchor="ctr">
+                    <a:solidFill>
+                      <a:srgbClr val="F2F2F2"/>
+                    </a:solidFill>
+                  </a:tcPr>
+                </a:tc>
+                <a:tc>
+                  <a:txBody>
+                    <a:bodyPr/>
+                    <a:lstStyle/>
+                    <a:p>
+                      <a:pPr algn="r"/>
+                      <a:r>
+                        <a:rPr sz="1300" b="1">
+                          <a:solidFill>
+                            <a:srgbClr val="3C3C3B"/>
+                          </a:solidFill>
+                          <a:latin typeface="Aptos"/>
+                        </a:rPr>
+                        <a:t>1.4</a:t>
+                      </a:r>
+                    </a:p>
+                  </a:txBody>
+                  <a:tcPr marL="73152" marR="73152" marT="27432" marB="27432" anchor="ctr">
+                    <a:solidFill>
+                      <a:srgbClr val="E6F4EC"/>
+                    </a:solidFill>
+                  </a:tcPr>
+                </a:tc>
+                <a:tc>
+                  <a:txBody>
+                    <a:bodyPr/>
+                    <a:lstStyle/>
+                    <a:p>
+                      <a:pPr algn="r"/>
+                      <a:r>
+                        <a:rPr sz="1300" b="1">
+                          <a:solidFill>
+                            <a:srgbClr val="3C3C3B"/>
+                          </a:solidFill>
+                          <a:latin typeface="Aptos"/>
+                        </a:rPr>
+                        <a:t>7.0</a:t>
+                      </a:r>
+                    </a:p>
+                  </a:txBody>
+                  <a:tcPr marL="73152" marR="73152" marT="27432" marB="27432" anchor="ctr">
+                    <a:solidFill>
+                      <a:srgbClr val="E6F4EC"/>
+                    </a:solidFill>
+                  </a:tcPr>
+                </a:tc>
+                <a:tc>
+                  <a:txBody>
+                    <a:bodyPr/>
+                    <a:lstStyle/>
+                    <a:p>
+                      <a:pPr algn="r"/>
+                      <a:r>
+                        <a:rPr sz="1300" b="1">
+                          <a:solidFill>
+                            <a:srgbClr val="3C3C3B"/>
+                          </a:solidFill>
+                          <a:latin typeface="Aptos"/>
+                        </a:rPr>
+                        <a:t>+5.6</a:t>
+                      </a:r>
+                    </a:p>
+                  </a:txBody>
+                  <a:tcPr marL="73152" marR="73152" marT="27432" marB="27432" anchor="ctr">
+                    <a:solidFill>
+                      <a:srgbClr val="E6F4EC"/>
+                    </a:solidFill>
+                  </a:tcPr>
+                </a:tc>
+              </a:tr>
+              <a:tr h="457200">
+                <a:tc>
+                  <a:txBody>
+                    <a:bodyPr/>
+                    <a:lstStyle/>
+                    <a:p>
+                      <a:pPr algn="l"/>
+                      <a:r>
+                        <a:rPr sz="1300" b="0">
+                          <a:solidFill>
+                            <a:srgbClr val="3C3C3B"/>
+                          </a:solidFill>
+                          <a:latin typeface="Aptos"/>
+                        </a:rPr>
+                        <a:t>All-in cost to COD</a:t>
+                      </a:r>
+                    </a:p>
+                  </a:txBody>
+                  <a:tcPr marL="73152" marR="73152" marT="27432" marB="27432" anchor="ctr">
+                    <a:solidFill>
+                      <a:srgbClr val="F2F2F2"/>
+                    </a:solidFill>
+                  </a:tcPr>
+                </a:tc>
+                <a:tc>
+                  <a:txBody>
+                    <a:bodyPr/>
+                    <a:lstStyle/>
+                    <a:p>
+                      <a:pPr algn="l"/>
+                      <a:r>
+                        <a:rPr sz="1300" b="0">
+                          <a:solidFill>
+                            <a:srgbClr val="919191"/>
+                          </a:solidFill>
+                          <a:latin typeface="Aptos"/>
+                        </a:rPr>
+                        <a:t>€ m</a:t>
+                      </a:r>
+                    </a:p>
+                  </a:txBody>
+                  <a:tcPr marL="73152" marR="73152" marT="27432" marB="27432" anchor="ctr">
+                    <a:solidFill>
+                      <a:srgbClr val="F2F2F2"/>
+                    </a:solidFill>
+                  </a:tcPr>
+                </a:tc>
+                <a:tc>
+                  <a:txBody>
+                    <a:bodyPr/>
+                    <a:lstStyle/>
+                    <a:p>
+                      <a:pPr algn="r"/>
+                      <a:r>
+                        <a:rPr sz="1300" b="0">
+                          <a:solidFill>
+                            <a:srgbClr val="3C3C3B"/>
+                          </a:solidFill>
+                          <a:latin typeface="Aptos"/>
+                        </a:rPr>
+                        <a:t>172.7</a:t>
+                      </a:r>
+                    </a:p>
+                  </a:txBody>
+                  <a:tcPr marL="73152" marR="73152" marT="27432" marB="27432" anchor="ctr">
+                    <a:noFill/>
+                  </a:tcPr>
+                </a:tc>
+                <a:tc>
+                  <a:txBody>
+                    <a:bodyPr/>
+                    <a:lstStyle/>
+                    <a:p>
+                      <a:pPr algn="r"/>
+                      <a:r>
+                        <a:rPr sz="1300" b="0">
+                          <a:solidFill>
+                            <a:srgbClr val="3C3C3B"/>
+                          </a:solidFill>
+                          <a:latin typeface="Aptos"/>
+                        </a:rPr>
+                        <a:t>134.0</a:t>
+                      </a:r>
+                    </a:p>
+                  </a:txBody>
+                  <a:tcPr marL="73152" marR="73152" marT="27432" marB="27432" anchor="ctr">
+                    <a:noFill/>
+                  </a:tcPr>
+                </a:tc>
+                <a:tc>
+                  <a:txBody>
+                    <a:bodyPr/>
+                    <a:lstStyle/>
+                    <a:p>
+                      <a:pPr algn="r"/>
+                      <a:r>
+                        <a:rPr sz="1300" b="0">
+                          <a:solidFill>
+                            <a:srgbClr val="3C3C3B"/>
+                          </a:solidFill>
+                          <a:latin typeface="Aptos"/>
+                        </a:rPr>
+                        <a:t>(38.8)</a:t>
+                      </a:r>
+                    </a:p>
+                  </a:txBody>
+                  <a:tcPr marL="73152" marR="73152" marT="27432" marB="27432" anchor="ctr">
+                    <a:noFill/>
+                  </a:tcPr>
+                </a:tc>
+              </a:tr>
+              <a:tr h="457200">
+                <a:tc>
+                  <a:txBody>
+                    <a:bodyPr/>
+                    <a:lstStyle/>
+                    <a:p>
+                      <a:pPr algn="l"/>
+                      <a:r>
+                        <a:rPr sz="1300" b="0">
+                          <a:solidFill>
+                            <a:srgbClr val="3C3C3B"/>
+                          </a:solidFill>
+                          <a:latin typeface="Aptos"/>
+                        </a:rPr>
+                        <a:t>FEP IRR – sale at COD</a:t>
+                      </a:r>
+                    </a:p>
+                  </a:txBody>
+                  <a:tcPr marL="73152" marR="73152" marT="27432" marB="27432" anchor="ctr">
+                    <a:solidFill>
+                      <a:srgbClr val="F2F2F2"/>
+                    </a:solidFill>
+                  </a:tcPr>
+                </a:tc>
+                <a:tc>
+                  <a:txBody>
+                    <a:bodyPr/>
+                    <a:lstStyle/>
+                    <a:p>
+                      <a:pPr algn="l"/>
+                      <a:r>
+                        <a:rPr sz="1300" b="0">
+                          <a:solidFill>
+                            <a:srgbClr val="919191"/>
+                          </a:solidFill>
+                          <a:latin typeface="Aptos"/>
+                        </a:rPr>
+                        <a:t>% / pp</a:t>
+                      </a:r>
+                    </a:p>
+                  </a:txBody>
+                  <a:tcPr marL="73152" marR="73152" marT="27432" marB="27432" anchor="ctr">
+                    <a:solidFill>
+                      <a:srgbClr val="F2F2F2"/>
+                    </a:solidFill>
+                  </a:tcPr>
+                </a:tc>
+                <a:tc>
+                  <a:txBody>
+                    <a:bodyPr/>
+                    <a:lstStyle/>
+                    <a:p>
+                      <a:pPr algn="r"/>
+                      <a:r>
+                        <a:rPr sz="1300" b="0">
+                          <a:solidFill>
+                            <a:srgbClr val="3C3C3B"/>
+                          </a:solidFill>
+                          <a:latin typeface="Aptos"/>
+                        </a:rPr>
+                        <a:t>33.9%</a:t>
+                      </a:r>
+                    </a:p>
+                  </a:txBody>
+                  <a:tcPr marL="73152" marR="73152" marT="27432" marB="27432" anchor="ctr">
+                    <a:noFill/>
+                  </a:tcPr>
+                </a:tc>
+                <a:tc>
+                  <a:txBody>
+                    <a:bodyPr/>
+                    <a:lstStyle/>
+                    <a:p>
+                      <a:pPr algn="r"/>
+                      <a:r>
+                        <a:rPr sz="1300" b="0">
+                          <a:solidFill>
+                            <a:srgbClr val="3C3C3B"/>
+                          </a:solidFill>
+                          <a:latin typeface="Aptos"/>
+                        </a:rPr>
+                        <a:t>50.9%</a:t>
+                      </a:r>
+                    </a:p>
+                  </a:txBody>
+                  <a:tcPr marL="73152" marR="73152" marT="27432" marB="27432" anchor="ctr">
+                    <a:noFill/>
+                  </a:tcPr>
+                </a:tc>
+                <a:tc>
+                  <a:txBody>
+                    <a:bodyPr/>
+                    <a:lstStyle/>
+                    <a:p>
+                      <a:pPr algn="r"/>
+                      <a:r>
+                        <a:rPr sz="1300" b="0">
+                          <a:solidFill>
+                            <a:srgbClr val="3C3C3B"/>
+                          </a:solidFill>
+                          <a:latin typeface="Aptos"/>
+                        </a:rPr>
+                        <a:t>+16.9</a:t>
+                      </a:r>
+                    </a:p>
+                  </a:txBody>
+                  <a:tcPr marL="73152" marR="73152" marT="27432" marB="27432" anchor="ctr">
+                    <a:noFill/>
+                  </a:tcPr>
+                </a:tc>
+              </a:tr>
+              <a:tr h="457200">
+                <a:tc>
+                  <a:txBody>
+                    <a:bodyPr/>
+                    <a:lstStyle/>
+                    <a:p>
+                      <a:pPr algn="l"/>
+                      <a:r>
+                        <a:rPr sz="1300" b="1">
+                          <a:solidFill>
+                            <a:srgbClr val="3C3C3B"/>
+                          </a:solidFill>
+                          <a:latin typeface="Aptos"/>
+                        </a:rPr>
+                        <a:t>FEP IRR – hold to maturity</a:t>
+                      </a:r>
+                    </a:p>
+                  </a:txBody>
+                  <a:tcPr marL="73152" marR="73152" marT="27432" marB="27432" anchor="ctr">
+                    <a:solidFill>
+                      <a:srgbClr val="F2F2F2"/>
+                    </a:solidFill>
+                  </a:tcPr>
+                </a:tc>
+                <a:tc>
+                  <a:txBody>
+                    <a:bodyPr/>
+                    <a:lstStyle/>
+                    <a:p>
+                      <a:pPr algn="l"/>
+                      <a:r>
+                        <a:rPr sz="1300" b="1">
+                          <a:solidFill>
+                            <a:srgbClr val="919191"/>
+                          </a:solidFill>
+                          <a:latin typeface="Aptos"/>
+                        </a:rPr>
+                        <a:t>% / pp</a:t>
+                      </a:r>
+                    </a:p>
+                  </a:txBody>
+                  <a:tcPr marL="73152" marR="73152" marT="27432" marB="27432" anchor="ctr">
+                    <a:solidFill>
+                      <a:srgbClr val="F2F2F2"/>
+                    </a:solidFill>
+                  </a:tcPr>
+                </a:tc>
+                <a:tc>
+                  <a:txBody>
+                    <a:bodyPr/>
+                    <a:lstStyle/>
+                    <a:p>
+                      <a:pPr algn="r"/>
+                      <a:r>
+                        <a:rPr sz="1300" b="1">
+                          <a:solidFill>
+                            <a:srgbClr val="3C3C3B"/>
+                          </a:solidFill>
+                          <a:latin typeface="Aptos"/>
+                        </a:rPr>
+                        <a:t>8.9%</a:t>
+                      </a:r>
+                    </a:p>
+                  </a:txBody>
+                  <a:tcPr marL="73152" marR="73152" marT="27432" marB="27432" anchor="ctr">
+                    <a:solidFill>
+                      <a:srgbClr val="E6F4EC"/>
+                    </a:solidFill>
+                  </a:tcPr>
+                </a:tc>
+                <a:tc>
+                  <a:txBody>
+                    <a:bodyPr/>
+                    <a:lstStyle/>
+                    <a:p>
+                      <a:pPr algn="r"/>
+                      <a:r>
+                        <a:rPr sz="1300" b="1">
+                          <a:solidFill>
+                            <a:srgbClr val="3C3C3B"/>
+                          </a:solidFill>
+                          <a:latin typeface="Aptos"/>
+                        </a:rPr>
+                        <a:t>12.1%</a:t>
+                      </a:r>
+                    </a:p>
+                  </a:txBody>
+                  <a:tcPr marL="73152" marR="73152" marT="27432" marB="27432" anchor="ctr">
+                    <a:solidFill>
+                      <a:srgbClr val="E6F4EC"/>
+                    </a:solidFill>
+                  </a:tcPr>
+                </a:tc>
+                <a:tc>
+                  <a:txBody>
+                    <a:bodyPr/>
+                    <a:lstStyle/>
+                    <a:p>
+                      <a:pPr algn="r"/>
+                      <a:r>
+                        <a:rPr sz="1300" b="1">
+                          <a:solidFill>
+                            <a:srgbClr val="3C3C3B"/>
+                          </a:solidFill>
+                          <a:latin typeface="Aptos"/>
+                        </a:rPr>
+                        <a:t>+3.2</a:t>
+                      </a:r>
+                    </a:p>
+                  </a:txBody>
+                  <a:tcPr marL="73152" marR="73152" marT="27432" marB="27432" anchor="ctr">
+                    <a:solidFill>
+                      <a:srgbClr val="E6F4EC"/>
+                    </a:solidFill>
+                  </a:tcPr>
+                </a:tc>
+              </a:tr>
+              <a:tr h="457200">
+                <a:tc>
+                  <a:txBody>
+                    <a:bodyPr/>
+                    <a:lstStyle/>
+                    <a:p>
+                      <a:pPr algn="l"/>
+                      <a:r>
+                        <a:rPr sz="1300" b="0">
+                          <a:solidFill>
+                            <a:srgbClr val="3C3C3B"/>
+                          </a:solidFill>
+                          <a:latin typeface="Aptos"/>
+                        </a:rPr>
+                        <a:t>FEP NPV – hold to maturity at 8.0%</a:t>
+                      </a:r>
+                    </a:p>
+                  </a:txBody>
+                  <a:tcPr marL="73152" marR="73152" marT="27432" marB="27432" anchor="ctr">
+                    <a:solidFill>
+                      <a:srgbClr val="F2F2F2"/>
+                    </a:solidFill>
+                  </a:tcPr>
+                </a:tc>
+                <a:tc>
+                  <a:txBody>
+                    <a:bodyPr/>
+                    <a:lstStyle/>
+                    <a:p>
+                      <a:pPr algn="l"/>
+                      <a:r>
+                        <a:rPr sz="1300" b="0">
+                          <a:solidFill>
+                            <a:srgbClr val="919191"/>
+                          </a:solidFill>
+                          <a:latin typeface="Aptos"/>
+                        </a:rPr>
+                        <a:t>€ m</a:t>
+                      </a:r>
+                    </a:p>
+                  </a:txBody>
+                  <a:tcPr marL="73152" marR="73152" marT="27432" marB="27432" anchor="ctr">
+                    <a:solidFill>
+                      <a:srgbClr val="F2F2F2"/>
+                    </a:solidFill>
+                  </a:tcPr>
+                </a:tc>
+                <a:tc>
+                  <a:txBody>
+                    <a:bodyPr/>
+                    <a:lstStyle/>
+                    <a:p>
+                      <a:pPr algn="r"/>
+                      <a:r>
+                        <a:rPr sz="1300" b="0">
+                          <a:solidFill>
+                            <a:srgbClr val="3C3C3B"/>
+                          </a:solidFill>
+                          <a:latin typeface="Aptos"/>
+                        </a:rPr>
+                        <a:t>8.1</a:t>
+                      </a:r>
+                    </a:p>
+                  </a:txBody>
+                  <a:tcPr marL="73152" marR="73152" marT="27432" marB="27432" anchor="ctr">
+                    <a:noFill/>
+                  </a:tcPr>
+                </a:tc>
+                <a:tc>
+                  <a:txBody>
+                    <a:bodyPr/>
+                    <a:lstStyle/>
+                    <a:p>
+                      <a:pPr algn="r"/>
+                      <a:r>
+                        <a:rPr sz="1300" b="0">
+                          <a:solidFill>
+                            <a:srgbClr val="3C3C3B"/>
+                          </a:solidFill>
+                          <a:latin typeface="Aptos"/>
+                        </a:rPr>
+                        <a:t>33.1</a:t>
+                      </a:r>
+                    </a:p>
+                  </a:txBody>
+                  <a:tcPr marL="73152" marR="73152" marT="27432" marB="27432" anchor="ctr">
+                    <a:noFill/>
+                  </a:tcPr>
+                </a:tc>
+                <a:tc>
+                  <a:txBody>
+                    <a:bodyPr/>
+                    <a:lstStyle/>
+                    <a:p>
+                      <a:pPr algn="r"/>
+                      <a:r>
+                        <a:rPr sz="1300" b="0">
+                          <a:solidFill>
+                            <a:srgbClr val="3C3C3B"/>
+                          </a:solidFill>
+                          <a:latin typeface="Aptos"/>
+                        </a:rPr>
+                        <a:t>+24.9</a:t>
+                      </a:r>
+                    </a:p>
+                  </a:txBody>
+                  <a:tcPr marL="73152" marR="73152" marT="27432" marB="27432" anchor="ctr">
+                    <a:noFill/>
+                  </a:tcPr>
+                </a:tc>
+              </a:tr>
+            </a:tbl>
+          </a:graphicData>
+        </a:graphic>
+      </p:graphicFrame>
+      <p:sp>
+        <p:nvSpPr>
+          <p:cNvPr id="6" name="Card"/>
+          <p:cNvSpPr/>
+          <p:nvPr/>
+        </p:nvSpPr>
+        <p:spPr>
+          <a:xfrm>
+            <a:off x="13990320" y="2240280"/>
+            <a:ext cx="4224528" cy="3282696"/>
+          </a:xfrm>
+          <a:prstGeom prst="rect">
+            <a:avLst/>
+          </a:prstGeom>
+          <a:solidFill>
+            <a:srgbClr val="F2F2F2"/>
+          </a:solidFill>
+          <a:ln>
+            <a:noFill/>
+          </a:ln>
+          <a:effectLst/>
+        </p:spPr>
+        <p:style>
+          <a:lnRef idx="1">
+            <a:schemeClr val="accent1"/>
+          </a:lnRef>
+          <a:fillRef idx="3">
+            <a:schemeClr val="accent1"/>
+          </a:fillRef>
+          <a:effectRef idx="2">
+            <a:schemeClr val="accent1"/>
+          </a:effectRef>
+          <a:fontRef idx="minor">
+            <a:schemeClr val="lt1"/>
+          </a:fontRef>
+        </p:style>
+        <p:txBody>
+          <a:bodyPr rtlCol="0" anchor="t" wrap="square" lIns="182880" rIns="182880" tIns="137160"/>
+          <a:lstStyle/>
+          <a:p>
+            <a:pPr algn="l"/>
+            <a:r>
+              <a:rPr sz="1600" b="1">
+                <a:solidFill>
+                  <a:srgbClr val="00563C"/>
+                </a:solidFill>
+                <a:latin typeface="Aptos"/>
+              </a:rPr>
+              <a:t>Sanctions if nothing is delivered</a:t>
+            </a:r>
+          </a:p>
+          <a:p>
+            <a:pPr algn="l">
+              <a:spcBef>
+                <a:spcPts val="800"/>
+              </a:spcBef>
+            </a:pPr>
+            <a:r>
+              <a:rPr sz="1300" b="1">
+                <a:solidFill>
+                  <a:srgbClr val="3C3C3B"/>
+                </a:solidFill>
+                <a:latin typeface="Aptos"/>
+              </a:rPr>
+              <a:t>Award and points stand: </a:t>
+            </a:r>
+            <a:r>
+              <a:rPr sz="1300" b="0">
+                <a:solidFill>
+                  <a:srgbClr val="3C3C3B"/>
+                </a:solidFill>
+                <a:latin typeface="Aptos"/>
+              </a:rPr>
+              <a:t>the sanction falls on the PB, not on the award or the score.</a:t>
+            </a:r>
+          </a:p>
+          <a:p>
+            <a:pPr algn="l">
+              <a:spcBef>
+                <a:spcPts val="800"/>
+              </a:spcBef>
+            </a:pPr>
+            <a:r>
+              <a:rPr sz="1300" b="1">
+                <a:solidFill>
+                  <a:srgbClr val="3C3C3B"/>
+                </a:solidFill>
+                <a:latin typeface="Aptos"/>
+              </a:rPr>
+              <a:t>Full PB call (Kiírás XIII.17; GYIK Q72): </a:t>
+            </a:r>
+            <a:r>
+              <a:rPr sz="1300" b="0">
+                <a:solidFill>
+                  <a:srgbClr val="3C3C3B"/>
+                </a:solidFill>
+                <a:latin typeface="Aptos"/>
+              </a:rPr>
+              <a:t>any unproven points commitment calls the whole PB, wind and BESS.</a:t>
+            </a:r>
+          </a:p>
+          <a:p>
+            <a:pPr algn="l">
+              <a:spcBef>
+                <a:spcPts val="800"/>
+              </a:spcBef>
+            </a:pPr>
+            <a:r>
+              <a:rPr sz="1300" b="1">
+                <a:solidFill>
+                  <a:srgbClr val="3C3C3B"/>
+                </a:solidFill>
+                <a:latin typeface="Aptos"/>
+              </a:rPr>
+              <a:t>Group exclusion (Kiírás VII.2 n; GYIK Q71): </a:t>
+            </a:r>
+            <a:r>
+              <a:rPr sz="1300" b="0">
+                <a:solidFill>
+                  <a:srgbClr val="3C3C3B"/>
+                </a:solidFill>
+                <a:latin typeface="Aptos"/>
+              </a:rPr>
+              <a:t>a called PB can exclude the group from capacity tenders for three years; it hits the group holding the SPV at the time of the call.</a:t>
+            </a:r>
+          </a:p>
+          <a:p>
+            <a:pPr algn="l">
+              <a:spcBef>
+                <a:spcPts val="800"/>
+              </a:spcBef>
+            </a:pPr>
+            <a:r>
+              <a:rPr sz="1300" b="1">
+                <a:solidFill>
+                  <a:srgbClr val="3C3C3B"/>
+                </a:solidFill>
+                <a:latin typeface="Aptos"/>
+              </a:rPr>
+              <a:t>Connection right kept (GYIK Q72): </a:t>
+            </a:r>
+            <a:r>
+              <a:rPr sz="1300" b="0">
+                <a:solidFill>
+                  <a:srgbClr val="3C3C3B"/>
+                </a:solidFill>
+                <a:latin typeface="Aptos"/>
+              </a:rPr>
+              <a:t>a full call does not take the connection right.</a:t>
+            </a:r>
+          </a:p>
+        </p:txBody>
+      </p:sp>
+      <p:sp>
+        <p:nvSpPr>
+          <p:cNvPr id="7" name="Footnote"/>
+          <p:cNvSpPr txBox="1"/>
+          <p:nvPr/>
+        </p:nvSpPr>
+        <p:spPr>
+          <a:xfrm>
+            <a:off x="4498848" y="9646920"/>
+            <a:ext cx="13167360" cy="640080"/>
+          </a:xfrm>
+          <a:prstGeom prst="rect">
+            <a:avLst/>
+          </a:prstGeom>
+          <a:noFill/>
+        </p:spPr>
+        <p:txBody>
+          <a:bodyPr wrap="square">
+            <a:spAutoFit/>
+          </a:bodyPr>
+          <a:lstStyle/>
+          <a:p>
+            <a:r>
+              <a:rPr sz="1100" b="0">
+                <a:solidFill>
+                  <a:srgbClr val="919191"/>
+                </a:solidFill>
+                <a:latin typeface="Aptos"/>
+              </a:rPr>
+              <a:t>Nothing delivered: the bid as submitted; after award no BESS, overbuild, municipal one-off or community contribution, and Chinese turbines and substation in capex. White labelling: the EU sale price at COD and the EU gearing are kept. RtB route unaffected. Base PB = pro-rata loss on the unbuilt overbuild. Zero bid for reference: COD IRR 49.6%, HTM IRR 11.9%.</a:t>
+            </a:r>
+          </a:p>
+          <a:p>
+            <a:r>
+              <a:rPr sz="1100" b="0">
+                <a:solidFill>
+                  <a:srgbClr val="919191"/>
+                </a:solidFill>
+                <a:latin typeface="Aptos"/>
+              </a:rPr>
+              <a:t>Source: Bora_Bid_Model.xlsm, 12 Oct 2026.</a:t>
+            </a:r>
+          </a:p>
+        </p:txBody>
+      </p:sp>
+    </p:spTree>
+  </p:cSld>
+  <p:clrMapOvr>
+    <a:masterClrMapping/>
+  </p:clrMapOvr>
+</p:sld>
+</file>
+
+<file path=ppt/slides/slide8.xml><?xml version="1.0" encoding="utf-8"?>
+<p:sld xmlns:a="http://schemas.openxmlformats.org/drawingml/2006/main" xmlns:p="http://schemas.openxmlformats.org/presentationml/2006/main" xmlns:r="http://schemas.openxmlformats.org/officeDocument/2006/relationships">
+  <p:cSld>
+    <p:spTree>
+      <p:nvGrpSpPr>
+        <p:cNvPr id="1" name=""/>
+        <p:cNvGrpSpPr/>
+        <p:nvPr/>
+      </p:nvGrpSpPr>
+      <p:grpSpPr/>
+      <p:sp>
+        <p:nvSpPr>
+          <p:cNvPr id="2" name="Title 1"/>
+          <p:cNvSpPr>
+            <a:spLocks noGrp="1"/>
+          </p:cNvSpPr>
+          <p:nvPr>
+            <p:ph type="title"/>
+          </p:nvPr>
+        </p:nvSpPr>
+        <p:spPr>
+          <a:xfrm>
+            <a:off x="4498848" y="182880"/>
+            <a:ext cx="12710160" cy="1097280"/>
+          </a:xfrm>
+        </p:spPr>
+        <p:txBody>
+          <a:bodyPr wrap="square"/>
+          <a:lstStyle/>
+          <a:p>
+            <a:r>
               <a:t>Unbuilt overbuild: both bids lose €2.8m of PB and 67.5 MVA of connection right pro rata; a full call is unresolved</a:t>
             </a:r>
           </a:p>

</xml_diff>